<commit_message>
Correct MLflow registration and review queue recency
</commit_message>
<xml_diff>
--- a/docs/SPC_ML_Demo_Walkthrough_Ready.pptx
+++ b/docs/SPC_ML_Demo_Walkthrough_Ready.pptx
@@ -2,34 +2,34 @@
 <file path=ppt/presentation.xml><?xml version="1.0" encoding="utf-8"?>
 <p:presentation xmlns:p="http://schemas.openxmlformats.org/presentationml/2006/main">
   <p:sldMasterIdLst>
-    <p:sldMasterId xmlns:r="http://schemas.openxmlformats.org/officeDocument/2006/relationships" id="2147483648" r:id="R0c511f2ee1be46f6"/>
+    <p:sldMasterId xmlns:r="http://schemas.openxmlformats.org/officeDocument/2006/relationships" id="2147483648" r:id="Rd6733f0f380043d4"/>
   </p:sldMasterIdLst>
   <p:notesMasterIdLst>
-    <p:notesMasterId xmlns:r="http://schemas.openxmlformats.org/officeDocument/2006/relationships" r:id="Ra161515377a54288"/>
+    <p:notesMasterId xmlns:r="http://schemas.openxmlformats.org/officeDocument/2006/relationships" r:id="R96ce68e2b358488a"/>
   </p:notesMasterIdLst>
   <p:sldIdLst>
-    <p:sldId xmlns:r="http://schemas.openxmlformats.org/officeDocument/2006/relationships" id="256" r:id="R833c683449af45be"/>
-    <p:sldId xmlns:r="http://schemas.openxmlformats.org/officeDocument/2006/relationships" id="257" r:id="R0b946c977d5c4fb4"/>
-    <p:sldId xmlns:r="http://schemas.openxmlformats.org/officeDocument/2006/relationships" id="258" r:id="R2e1b2d936abe47de"/>
-    <p:sldId xmlns:r="http://schemas.openxmlformats.org/officeDocument/2006/relationships" id="259" r:id="R6a63fd449b4e45a5"/>
-    <p:sldId xmlns:r="http://schemas.openxmlformats.org/officeDocument/2006/relationships" id="260" r:id="Rcf18ef346a984997"/>
-    <p:sldId xmlns:r="http://schemas.openxmlformats.org/officeDocument/2006/relationships" id="261" r:id="R3d6a891afdcb4338"/>
-    <p:sldId xmlns:r="http://schemas.openxmlformats.org/officeDocument/2006/relationships" id="262" r:id="R117a4f8016a14a9d"/>
-    <p:sldId xmlns:r="http://schemas.openxmlformats.org/officeDocument/2006/relationships" id="263" r:id="R02c0c48833d74921"/>
-    <p:sldId xmlns:r="http://schemas.openxmlformats.org/officeDocument/2006/relationships" id="264" r:id="Rf4392d0f2e1a41b8"/>
-    <p:sldId xmlns:r="http://schemas.openxmlformats.org/officeDocument/2006/relationships" id="265" r:id="R49d7fc315e894d8f"/>
-    <p:sldId xmlns:r="http://schemas.openxmlformats.org/officeDocument/2006/relationships" id="266" r:id="Rd44e01ece87f4fce"/>
-    <p:sldId xmlns:r="http://schemas.openxmlformats.org/officeDocument/2006/relationships" id="267" r:id="R4db20dde10d34701"/>
-    <p:sldId xmlns:r="http://schemas.openxmlformats.org/officeDocument/2006/relationships" id="268" r:id="R7023056a8a594d0f"/>
-    <p:sldId xmlns:r="http://schemas.openxmlformats.org/officeDocument/2006/relationships" id="269" r:id="Rbe72acda73034d3b"/>
-    <p:sldId xmlns:r="http://schemas.openxmlformats.org/officeDocument/2006/relationships" id="270" r:id="R197ac95eb4ba4a48"/>
-    <p:sldId xmlns:r="http://schemas.openxmlformats.org/officeDocument/2006/relationships" id="271" r:id="R8323b276ca5544a0"/>
-    <p:sldId xmlns:r="http://schemas.openxmlformats.org/officeDocument/2006/relationships" id="272" r:id="R12ec092b8be04cef"/>
-    <p:sldId xmlns:r="http://schemas.openxmlformats.org/officeDocument/2006/relationships" id="273" r:id="Rc2efa2d52ff6437a"/>
-    <p:sldId xmlns:r="http://schemas.openxmlformats.org/officeDocument/2006/relationships" id="274" r:id="R2898ef89a7544e03"/>
-    <p:sldId xmlns:r="http://schemas.openxmlformats.org/officeDocument/2006/relationships" id="275" r:id="R4944cc1f7ac74986"/>
-    <p:sldId xmlns:r="http://schemas.openxmlformats.org/officeDocument/2006/relationships" id="276" r:id="Re763065c468e41d4"/>
-    <p:sldId xmlns:r="http://schemas.openxmlformats.org/officeDocument/2006/relationships" id="277" r:id="R4a025e5bbdc64ed4"/>
+    <p:sldId xmlns:r="http://schemas.openxmlformats.org/officeDocument/2006/relationships" id="256" r:id="Rb7a1f5ba73904c65"/>
+    <p:sldId xmlns:r="http://schemas.openxmlformats.org/officeDocument/2006/relationships" id="257" r:id="R134a2f7c65df439d"/>
+    <p:sldId xmlns:r="http://schemas.openxmlformats.org/officeDocument/2006/relationships" id="258" r:id="R06dd37a39f924546"/>
+    <p:sldId xmlns:r="http://schemas.openxmlformats.org/officeDocument/2006/relationships" id="259" r:id="R29968dc184b5420f"/>
+    <p:sldId xmlns:r="http://schemas.openxmlformats.org/officeDocument/2006/relationships" id="260" r:id="R444fa34c31eb4dfa"/>
+    <p:sldId xmlns:r="http://schemas.openxmlformats.org/officeDocument/2006/relationships" id="261" r:id="Rf5b06d04b63446cf"/>
+    <p:sldId xmlns:r="http://schemas.openxmlformats.org/officeDocument/2006/relationships" id="262" r:id="R5bf7194ce07c4bc2"/>
+    <p:sldId xmlns:r="http://schemas.openxmlformats.org/officeDocument/2006/relationships" id="263" r:id="R9cb643be4ddf421e"/>
+    <p:sldId xmlns:r="http://schemas.openxmlformats.org/officeDocument/2006/relationships" id="264" r:id="Rb5752f2f609045e2"/>
+    <p:sldId xmlns:r="http://schemas.openxmlformats.org/officeDocument/2006/relationships" id="265" r:id="Ra160a86ef26041e1"/>
+    <p:sldId xmlns:r="http://schemas.openxmlformats.org/officeDocument/2006/relationships" id="266" r:id="R395ea5ea56c0435f"/>
+    <p:sldId xmlns:r="http://schemas.openxmlformats.org/officeDocument/2006/relationships" id="267" r:id="R210739d250504107"/>
+    <p:sldId xmlns:r="http://schemas.openxmlformats.org/officeDocument/2006/relationships" id="268" r:id="Ra59e62bbd325401b"/>
+    <p:sldId xmlns:r="http://schemas.openxmlformats.org/officeDocument/2006/relationships" id="269" r:id="R03347b42560244f5"/>
+    <p:sldId xmlns:r="http://schemas.openxmlformats.org/officeDocument/2006/relationships" id="270" r:id="R10c6f8e412964022"/>
+    <p:sldId xmlns:r="http://schemas.openxmlformats.org/officeDocument/2006/relationships" id="271" r:id="R4bd309af4afc4357"/>
+    <p:sldId xmlns:r="http://schemas.openxmlformats.org/officeDocument/2006/relationships" id="272" r:id="Ree42d281fb1f413b"/>
+    <p:sldId xmlns:r="http://schemas.openxmlformats.org/officeDocument/2006/relationships" id="273" r:id="Rfbb518f5433844c4"/>
+    <p:sldId xmlns:r="http://schemas.openxmlformats.org/officeDocument/2006/relationships" id="274" r:id="R4af0dbd5dc5c46bb"/>
+    <p:sldId xmlns:r="http://schemas.openxmlformats.org/officeDocument/2006/relationships" id="275" r:id="R4c907b7b93344c71"/>
+    <p:sldId xmlns:r="http://schemas.openxmlformats.org/officeDocument/2006/relationships" id="276" r:id="R3896fd4f7fc44e85"/>
+    <p:sldId xmlns:r="http://schemas.openxmlformats.org/officeDocument/2006/relationships" id="277" r:id="R715319233bdb4107"/>
   </p:sldIdLst>
   <p:sldSz cx="12192000" cy="6858000"/>
   <p:notesSz cx="6858000" cy="9144000"/>
@@ -1023,7 +1023,7 @@
           <a:lstStyle xmlns:a="http://schemas.openxmlformats.org/drawingml/2006/main"/>
           <a:p xmlns:a="http://schemas.openxmlformats.org/drawingml/2006/main">
             <a:r>
-              <a:t>Narrate the pipeline from the point of view of an analyst. The fictional input yields daily counts. Rules compute observations and a signal. The classifier is tested against the rules and the baseline, and is not needed when it loses. The separate count forecast may help planning if validated. Repeated signals are grouped for review. MLflow and optional tables record the run. A person investigates and decides whether to act.</a:t>
+              <a:t>Narrate the pipeline from the point of view of an analyst. The fictional input yields daily counts. Rules compute observations and a signal. The classifier is tested against the rules and the baseline, and is not needed when it loses. The separate count forecast may help planning if validated. Repeated signals are grouped for pending review. MLflow and optional tables record the run. In a pilot, a person would investigate and record whether to act. This notebook does not record that decision.</a:t>
             </a:r>
           </a:p>
         </p:txBody>
@@ -2001,7 +2001,7 @@
   </p:cSld>
   <p:clrMap bg1="lt1" tx1="dk1" bg2="lt2" tx2="dk2" accent1="accent1" accent2="accent2" accent3="accent3" accent4="accent4" accent5="accent5" accent6="accent6" hlink="hlink" folHlink="folHlink"/>
   <p:sldLayoutIdLst>
-    <p:sldLayoutId xmlns:r="http://schemas.openxmlformats.org/officeDocument/2006/relationships" id="2147483649" r:id="R897ccc8898584c6c"/>
+    <p:sldLayoutId xmlns:r="http://schemas.openxmlformats.org/officeDocument/2006/relationships" id="2147483649" r:id="R205d1eb740814c6c"/>
   </p:sldLayoutIdLst>
   <p:txStyles>
     <p:titleStyle>
@@ -3014,7 +3014,7 @@
           <p:cNvPr id="4" name="">
             <a:extLst xmlns:a="http://schemas.openxmlformats.org/drawingml/2006/main">
               <a:ext uri="{FF2B5EF4-FFF2-40B4-BE49-F238E27FC236}">
-                <a16:creationId xmlns:a16="http://schemas.microsoft.com/office/drawing/2014/main" id="{2D12BEC5-B2BB-4621-A288-BDD518CA8FF5}"/>
+                <a16:creationId xmlns:a16="http://schemas.microsoft.com/office/drawing/2014/main" id="{E3E873F0-081D-4656-A8AC-3217060A9AEB}"/>
               </a:ext>
             </a:extLst>
           </p:cNvPr>
@@ -3071,7 +3071,7 @@
           <p:cNvPr id="2" name="">
             <a:extLst xmlns:a="http://schemas.openxmlformats.org/drawingml/2006/main">
               <a:ext uri="{FF2B5EF4-FFF2-40B4-BE49-F238E27FC236}">
-                <a16:creationId xmlns:a16="http://schemas.microsoft.com/office/drawing/2014/main" id="{557620CA-46D9-4645-97AD-BD9B671312CF}"/>
+                <a16:creationId xmlns:a16="http://schemas.microsoft.com/office/drawing/2014/main" id="{C07DE56B-3A76-4F6C-81D1-E7AE0EF46851}"/>
               </a:ext>
             </a:extLst>
           </p:cNvPr>
@@ -3128,7 +3128,7 @@
           <p:cNvPr id="3" name="">
             <a:extLst xmlns:a="http://schemas.openxmlformats.org/drawingml/2006/main">
               <a:ext uri="{FF2B5EF4-FFF2-40B4-BE49-F238E27FC236}">
-                <a16:creationId xmlns:a16="http://schemas.microsoft.com/office/drawing/2014/main" id="{C4DC3DB1-1B6B-4C7A-A2D0-FBB601C34712}"/>
+                <a16:creationId xmlns:a16="http://schemas.microsoft.com/office/drawing/2014/main" id="{7E1C1059-9250-4B8F-A77C-F08F53FF51B9}"/>
               </a:ext>
             </a:extLst>
           </p:cNvPr>
@@ -3183,7 +3183,7 @@
     </p:spTree>
     <p:extLst>
       <p:ext uri="{BB962C8B-B14F-4D97-AF65-F5344CB8AC3E}">
-        <p14:creationId xmlns:p14="http://schemas.microsoft.com/office/powerpoint/2010/main" val="167383934"/>
+        <p14:creationId xmlns:p14="http://schemas.microsoft.com/office/powerpoint/2010/main" val="1505350317"/>
       </p:ext>
     </p:extLst>
   </p:cSld>
@@ -3214,7 +3214,7 @@
           <p:cNvPr id="13" name="">
             <a:extLst xmlns:a="http://schemas.openxmlformats.org/drawingml/2006/main">
               <a:ext uri="{FF2B5EF4-FFF2-40B4-BE49-F238E27FC236}">
-                <a16:creationId xmlns:a16="http://schemas.microsoft.com/office/drawing/2014/main" id="{D52301A3-3EB3-405D-8E2F-B9FDB5D91CEF}"/>
+                <a16:creationId xmlns:a16="http://schemas.microsoft.com/office/drawing/2014/main" id="{11F2FD37-106C-4820-9231-C455540D60D3}"/>
               </a:ext>
             </a:extLst>
           </p:cNvPr>
@@ -3271,7 +3271,7 @@
           <p:cNvPr id="2" name="">
             <a:extLst xmlns:a="http://schemas.openxmlformats.org/drawingml/2006/main">
               <a:ext uri="{FF2B5EF4-FFF2-40B4-BE49-F238E27FC236}">
-                <a16:creationId xmlns:a16="http://schemas.microsoft.com/office/drawing/2014/main" id="{874651E7-5B03-4C7C-8E2F-154D3F26CCEC}"/>
+                <a16:creationId xmlns:a16="http://schemas.microsoft.com/office/drawing/2014/main" id="{C6F385AF-4E7E-4357-90A9-762EA8FC5AA2}"/>
               </a:ext>
             </a:extLst>
           </p:cNvPr>
@@ -3328,7 +3328,7 @@
           <p:cNvPr id="3" name="">
             <a:extLst xmlns:a="http://schemas.openxmlformats.org/drawingml/2006/main">
               <a:ext uri="{FF2B5EF4-FFF2-40B4-BE49-F238E27FC236}">
-                <a16:creationId xmlns:a16="http://schemas.microsoft.com/office/drawing/2014/main" id="{DDDA3B75-B34F-4380-B246-0A978E1B544D}"/>
+                <a16:creationId xmlns:a16="http://schemas.microsoft.com/office/drawing/2014/main" id="{EF0F422D-6AD2-49EA-85DF-C3B90E073774}"/>
               </a:ext>
             </a:extLst>
           </p:cNvPr>
@@ -3385,7 +3385,7 @@
           <p:cNvPr id="4" name="">
             <a:extLst xmlns:a="http://schemas.openxmlformats.org/drawingml/2006/main">
               <a:ext uri="{FF2B5EF4-FFF2-40B4-BE49-F238E27FC236}">
-                <a16:creationId xmlns:a16="http://schemas.microsoft.com/office/drawing/2014/main" id="{D2D2E7E0-7D85-4D6A-B6D0-BA160AA5857E}"/>
+                <a16:creationId xmlns:a16="http://schemas.microsoft.com/office/drawing/2014/main" id="{A2BB4A66-1C65-4EBC-A111-4281B349CCBC}"/>
               </a:ext>
             </a:extLst>
           </p:cNvPr>
@@ -3442,7 +3442,7 @@
           <p:cNvPr id="5" name="">
             <a:extLst xmlns:a="http://schemas.openxmlformats.org/drawingml/2006/main">
               <a:ext uri="{FF2B5EF4-FFF2-40B4-BE49-F238E27FC236}">
-                <a16:creationId xmlns:a16="http://schemas.microsoft.com/office/drawing/2014/main" id="{52EF921A-3C60-4889-8C23-E34569385921}"/>
+                <a16:creationId xmlns:a16="http://schemas.microsoft.com/office/drawing/2014/main" id="{BC510073-C337-4649-916C-9ABAFF102C23}"/>
               </a:ext>
             </a:extLst>
           </p:cNvPr>
@@ -3499,7 +3499,7 @@
           <p:cNvPr id="6" name="">
             <a:extLst xmlns:a="http://schemas.openxmlformats.org/drawingml/2006/main">
               <a:ext uri="{FF2B5EF4-FFF2-40B4-BE49-F238E27FC236}">
-                <a16:creationId xmlns:a16="http://schemas.microsoft.com/office/drawing/2014/main" id="{FBE3F716-1B99-45B3-860C-9312B7A75249}"/>
+                <a16:creationId xmlns:a16="http://schemas.microsoft.com/office/drawing/2014/main" id="{167A32CF-CD2A-440F-BF1F-3113B5726057}"/>
               </a:ext>
             </a:extLst>
           </p:cNvPr>
@@ -3556,7 +3556,7 @@
           <p:cNvPr id="7" name="">
             <a:extLst xmlns:a="http://schemas.openxmlformats.org/drawingml/2006/main">
               <a:ext uri="{FF2B5EF4-FFF2-40B4-BE49-F238E27FC236}">
-                <a16:creationId xmlns:a16="http://schemas.microsoft.com/office/drawing/2014/main" id="{6F56BB12-D16E-4B51-8EEE-6E3143D7DBE0}"/>
+                <a16:creationId xmlns:a16="http://schemas.microsoft.com/office/drawing/2014/main" id="{6882C20E-74E3-4249-AACB-DE48745F0755}"/>
               </a:ext>
             </a:extLst>
           </p:cNvPr>
@@ -3613,7 +3613,7 @@
           <p:cNvPr id="8" name="">
             <a:extLst xmlns:a="http://schemas.openxmlformats.org/drawingml/2006/main">
               <a:ext uri="{FF2B5EF4-FFF2-40B4-BE49-F238E27FC236}">
-                <a16:creationId xmlns:a16="http://schemas.microsoft.com/office/drawing/2014/main" id="{9F54E94D-6B48-4EF7-B7D6-2C08D16C4731}"/>
+                <a16:creationId xmlns:a16="http://schemas.microsoft.com/office/drawing/2014/main" id="{C6676D64-52CD-4A48-95F2-7C3CFE74DC43}"/>
               </a:ext>
             </a:extLst>
           </p:cNvPr>
@@ -3670,7 +3670,7 @@
           <p:cNvPr id="9" name="">
             <a:extLst xmlns:a="http://schemas.openxmlformats.org/drawingml/2006/main">
               <a:ext uri="{FF2B5EF4-FFF2-40B4-BE49-F238E27FC236}">
-                <a16:creationId xmlns:a16="http://schemas.microsoft.com/office/drawing/2014/main" id="{74DA4B0C-91F6-4CED-AD67-86C354B88785}"/>
+                <a16:creationId xmlns:a16="http://schemas.microsoft.com/office/drawing/2014/main" id="{6C436A18-6A37-45AB-BC58-FA94D05AD9A6}"/>
               </a:ext>
             </a:extLst>
           </p:cNvPr>
@@ -3727,7 +3727,7 @@
           <p:cNvPr id="10" name="">
             <a:extLst xmlns:a="http://schemas.openxmlformats.org/drawingml/2006/main">
               <a:ext uri="{FF2B5EF4-FFF2-40B4-BE49-F238E27FC236}">
-                <a16:creationId xmlns:a16="http://schemas.microsoft.com/office/drawing/2014/main" id="{BFF74D6B-0690-4C45-9D1E-ADEAE03F99E2}"/>
+                <a16:creationId xmlns:a16="http://schemas.microsoft.com/office/drawing/2014/main" id="{B3A49041-E302-438B-B76C-16D27C44E82D}"/>
               </a:ext>
             </a:extLst>
           </p:cNvPr>
@@ -3784,7 +3784,7 @@
           <p:cNvPr id="11" name="">
             <a:extLst xmlns:a="http://schemas.openxmlformats.org/drawingml/2006/main">
               <a:ext uri="{FF2B5EF4-FFF2-40B4-BE49-F238E27FC236}">
-                <a16:creationId xmlns:a16="http://schemas.microsoft.com/office/drawing/2014/main" id="{A88A9CB6-3C3D-4FF8-B366-BE53B0618E38}"/>
+                <a16:creationId xmlns:a16="http://schemas.microsoft.com/office/drawing/2014/main" id="{6AD69ED6-D9AE-415E-A635-17F712C2D331}"/>
               </a:ext>
             </a:extLst>
           </p:cNvPr>
@@ -3841,7 +3841,7 @@
           <p:cNvPr id="12" name="">
             <a:extLst xmlns:a="http://schemas.openxmlformats.org/drawingml/2006/main">
               <a:ext uri="{FF2B5EF4-FFF2-40B4-BE49-F238E27FC236}">
-                <a16:creationId xmlns:a16="http://schemas.microsoft.com/office/drawing/2014/main" id="{496B7F48-8134-4E4A-A227-92DB1E56A5FE}"/>
+                <a16:creationId xmlns:a16="http://schemas.microsoft.com/office/drawing/2014/main" id="{AA4A2906-6797-445A-8CDF-B84237787904}"/>
               </a:ext>
             </a:extLst>
           </p:cNvPr>
@@ -3896,7 +3896,7 @@
     </p:spTree>
     <p:extLst>
       <p:ext uri="{BB962C8B-B14F-4D97-AF65-F5344CB8AC3E}">
-        <p14:creationId xmlns:p14="http://schemas.microsoft.com/office/powerpoint/2010/main" val="1384346068"/>
+        <p14:creationId xmlns:p14="http://schemas.microsoft.com/office/powerpoint/2010/main" val="389071557"/>
       </p:ext>
     </p:extLst>
   </p:cSld>
@@ -3927,7 +3927,7 @@
           <p:cNvPr id="13" name="">
             <a:extLst xmlns:a="http://schemas.openxmlformats.org/drawingml/2006/main">
               <a:ext uri="{FF2B5EF4-FFF2-40B4-BE49-F238E27FC236}">
-                <a16:creationId xmlns:a16="http://schemas.microsoft.com/office/drawing/2014/main" id="{B7D31D95-B258-45C2-9F3A-422925B332F5}"/>
+                <a16:creationId xmlns:a16="http://schemas.microsoft.com/office/drawing/2014/main" id="{F0B647C8-5A90-4515-B25A-EBDF33294DB8}"/>
               </a:ext>
             </a:extLst>
           </p:cNvPr>
@@ -3984,7 +3984,7 @@
           <p:cNvPr id="2" name="">
             <a:extLst xmlns:a="http://schemas.openxmlformats.org/drawingml/2006/main">
               <a:ext uri="{FF2B5EF4-FFF2-40B4-BE49-F238E27FC236}">
-                <a16:creationId xmlns:a16="http://schemas.microsoft.com/office/drawing/2014/main" id="{D23D0E9D-77E6-41A3-8232-8EE893577A6E}"/>
+                <a16:creationId xmlns:a16="http://schemas.microsoft.com/office/drawing/2014/main" id="{4BBA3B37-4024-4729-AC89-B3A3770C7E0D}"/>
               </a:ext>
             </a:extLst>
           </p:cNvPr>
@@ -4041,7 +4041,7 @@
           <p:cNvPr id="3" name="">
             <a:extLst xmlns:a="http://schemas.openxmlformats.org/drawingml/2006/main">
               <a:ext uri="{FF2B5EF4-FFF2-40B4-BE49-F238E27FC236}">
-                <a16:creationId xmlns:a16="http://schemas.microsoft.com/office/drawing/2014/main" id="{836FBEA8-11B0-498E-B7A5-A252C89FBC71}"/>
+                <a16:creationId xmlns:a16="http://schemas.microsoft.com/office/drawing/2014/main" id="{7286793B-C216-4E22-9D77-F4BAB5E0EC05}"/>
               </a:ext>
             </a:extLst>
           </p:cNvPr>
@@ -4098,7 +4098,7 @@
           <p:cNvPr id="4" name="">
             <a:extLst xmlns:a="http://schemas.openxmlformats.org/drawingml/2006/main">
               <a:ext uri="{FF2B5EF4-FFF2-40B4-BE49-F238E27FC236}">
-                <a16:creationId xmlns:a16="http://schemas.microsoft.com/office/drawing/2014/main" id="{4D13427C-082A-4D5E-9C7B-6EB169C7D764}"/>
+                <a16:creationId xmlns:a16="http://schemas.microsoft.com/office/drawing/2014/main" id="{30B60FBF-8AD1-479D-AB75-756C06660A8D}"/>
               </a:ext>
             </a:extLst>
           </p:cNvPr>
@@ -4155,7 +4155,7 @@
           <p:cNvPr id="5" name="">
             <a:extLst xmlns:a="http://schemas.openxmlformats.org/drawingml/2006/main">
               <a:ext uri="{FF2B5EF4-FFF2-40B4-BE49-F238E27FC236}">
-                <a16:creationId xmlns:a16="http://schemas.microsoft.com/office/drawing/2014/main" id="{FCAB1445-CA11-4B0A-86F8-8FDDCB448156}"/>
+                <a16:creationId xmlns:a16="http://schemas.microsoft.com/office/drawing/2014/main" id="{90D8E859-84DA-4CAA-A612-D255D1ECE961}"/>
               </a:ext>
             </a:extLst>
           </p:cNvPr>
@@ -4212,7 +4212,7 @@
           <p:cNvPr id="6" name="">
             <a:extLst xmlns:a="http://schemas.openxmlformats.org/drawingml/2006/main">
               <a:ext uri="{FF2B5EF4-FFF2-40B4-BE49-F238E27FC236}">
-                <a16:creationId xmlns:a16="http://schemas.microsoft.com/office/drawing/2014/main" id="{741F52B5-5650-451D-9D09-947A082B0D23}"/>
+                <a16:creationId xmlns:a16="http://schemas.microsoft.com/office/drawing/2014/main" id="{BF8E9399-84E6-4A52-BB5C-A036D15A52AD}"/>
               </a:ext>
             </a:extLst>
           </p:cNvPr>
@@ -4269,7 +4269,7 @@
           <p:cNvPr id="7" name="">
             <a:extLst xmlns:a="http://schemas.openxmlformats.org/drawingml/2006/main">
               <a:ext uri="{FF2B5EF4-FFF2-40B4-BE49-F238E27FC236}">
-                <a16:creationId xmlns:a16="http://schemas.microsoft.com/office/drawing/2014/main" id="{6087DC29-4139-46EE-B7B1-2CF0EBCB0CE0}"/>
+                <a16:creationId xmlns:a16="http://schemas.microsoft.com/office/drawing/2014/main" id="{77423CAA-FD45-44B5-AD1E-74F3BF7A057B}"/>
               </a:ext>
             </a:extLst>
           </p:cNvPr>
@@ -4326,7 +4326,7 @@
           <p:cNvPr id="8" name="">
             <a:extLst xmlns:a="http://schemas.openxmlformats.org/drawingml/2006/main">
               <a:ext uri="{FF2B5EF4-FFF2-40B4-BE49-F238E27FC236}">
-                <a16:creationId xmlns:a16="http://schemas.microsoft.com/office/drawing/2014/main" id="{689A5BB8-AB5E-4ABC-9D81-69E7090E3492}"/>
+                <a16:creationId xmlns:a16="http://schemas.microsoft.com/office/drawing/2014/main" id="{72E74775-B115-427F-9061-EA9F6E252F2A}"/>
               </a:ext>
             </a:extLst>
           </p:cNvPr>
@@ -4383,7 +4383,7 @@
           <p:cNvPr id="9" name="">
             <a:extLst xmlns:a="http://schemas.openxmlformats.org/drawingml/2006/main">
               <a:ext uri="{FF2B5EF4-FFF2-40B4-BE49-F238E27FC236}">
-                <a16:creationId xmlns:a16="http://schemas.microsoft.com/office/drawing/2014/main" id="{C58F731F-831E-4022-AAB1-812FDC4EF5CC}"/>
+                <a16:creationId xmlns:a16="http://schemas.microsoft.com/office/drawing/2014/main" id="{B0D07289-D548-42E0-AB21-A939AF9CAC5A}"/>
               </a:ext>
             </a:extLst>
           </p:cNvPr>
@@ -4440,7 +4440,7 @@
           <p:cNvPr id="10" name="">
             <a:extLst xmlns:a="http://schemas.openxmlformats.org/drawingml/2006/main">
               <a:ext uri="{FF2B5EF4-FFF2-40B4-BE49-F238E27FC236}">
-                <a16:creationId xmlns:a16="http://schemas.microsoft.com/office/drawing/2014/main" id="{D6BB46A9-17B4-4746-ADDD-B6674A669FFB}"/>
+                <a16:creationId xmlns:a16="http://schemas.microsoft.com/office/drawing/2014/main" id="{54E75774-BE09-4BC0-9504-E4012EC6DE09}"/>
               </a:ext>
             </a:extLst>
           </p:cNvPr>
@@ -4497,7 +4497,7 @@
           <p:cNvPr id="11" name="">
             <a:extLst xmlns:a="http://schemas.openxmlformats.org/drawingml/2006/main">
               <a:ext uri="{FF2B5EF4-FFF2-40B4-BE49-F238E27FC236}">
-                <a16:creationId xmlns:a16="http://schemas.microsoft.com/office/drawing/2014/main" id="{94CDE75C-395D-488D-BBC3-02E130A17C4F}"/>
+                <a16:creationId xmlns:a16="http://schemas.microsoft.com/office/drawing/2014/main" id="{544A460D-4EDB-4592-B815-420BE206F395}"/>
               </a:ext>
             </a:extLst>
           </p:cNvPr>
@@ -4554,7 +4554,7 @@
           <p:cNvPr id="12" name="">
             <a:extLst xmlns:a="http://schemas.openxmlformats.org/drawingml/2006/main">
               <a:ext uri="{FF2B5EF4-FFF2-40B4-BE49-F238E27FC236}">
-                <a16:creationId xmlns:a16="http://schemas.microsoft.com/office/drawing/2014/main" id="{3930BA29-A562-42E3-87B8-C15781C55F32}"/>
+                <a16:creationId xmlns:a16="http://schemas.microsoft.com/office/drawing/2014/main" id="{90935880-6D64-468B-B3E2-D6859702129B}"/>
               </a:ext>
             </a:extLst>
           </p:cNvPr>
@@ -4609,7 +4609,7 @@
     </p:spTree>
     <p:extLst>
       <p:ext uri="{BB962C8B-B14F-4D97-AF65-F5344CB8AC3E}">
-        <p14:creationId xmlns:p14="http://schemas.microsoft.com/office/powerpoint/2010/main" val="967630093"/>
+        <p14:creationId xmlns:p14="http://schemas.microsoft.com/office/powerpoint/2010/main" val="2038327918"/>
       </p:ext>
     </p:extLst>
   </p:cSld>
@@ -4640,7 +4640,7 @@
           <p:cNvPr id="13" name="">
             <a:extLst xmlns:a="http://schemas.openxmlformats.org/drawingml/2006/main">
               <a:ext uri="{FF2B5EF4-FFF2-40B4-BE49-F238E27FC236}">
-                <a16:creationId xmlns:a16="http://schemas.microsoft.com/office/drawing/2014/main" id="{930AF2C9-D47B-4C3E-ADA7-D9D7F55B2729}"/>
+                <a16:creationId xmlns:a16="http://schemas.microsoft.com/office/drawing/2014/main" id="{07E8AEC3-6128-497A-A0CA-60EA59F17E8B}"/>
               </a:ext>
             </a:extLst>
           </p:cNvPr>
@@ -4697,7 +4697,7 @@
           <p:cNvPr id="2" name="">
             <a:extLst xmlns:a="http://schemas.openxmlformats.org/drawingml/2006/main">
               <a:ext uri="{FF2B5EF4-FFF2-40B4-BE49-F238E27FC236}">
-                <a16:creationId xmlns:a16="http://schemas.microsoft.com/office/drawing/2014/main" id="{4114AE6F-DD77-486D-838C-107D5E5D136F}"/>
+                <a16:creationId xmlns:a16="http://schemas.microsoft.com/office/drawing/2014/main" id="{94EFE0A6-7115-4623-ADA8-55265C05F2F4}"/>
               </a:ext>
             </a:extLst>
           </p:cNvPr>
@@ -4754,7 +4754,7 @@
           <p:cNvPr id="3" name="">
             <a:extLst xmlns:a="http://schemas.openxmlformats.org/drawingml/2006/main">
               <a:ext uri="{FF2B5EF4-FFF2-40B4-BE49-F238E27FC236}">
-                <a16:creationId xmlns:a16="http://schemas.microsoft.com/office/drawing/2014/main" id="{D4EEB967-74CD-42E4-BEA3-E62A28972979}"/>
+                <a16:creationId xmlns:a16="http://schemas.microsoft.com/office/drawing/2014/main" id="{176EEF0B-7B6B-4353-803E-9D91DB9F0A5C}"/>
               </a:ext>
             </a:extLst>
           </p:cNvPr>
@@ -4811,7 +4811,7 @@
           <p:cNvPr id="4" name="">
             <a:extLst xmlns:a="http://schemas.openxmlformats.org/drawingml/2006/main">
               <a:ext uri="{FF2B5EF4-FFF2-40B4-BE49-F238E27FC236}">
-                <a16:creationId xmlns:a16="http://schemas.microsoft.com/office/drawing/2014/main" id="{4E36CD9F-1661-4F94-9189-42ABF444A9BF}"/>
+                <a16:creationId xmlns:a16="http://schemas.microsoft.com/office/drawing/2014/main" id="{2AA120C4-3F87-426C-8488-1431815F6DEB}"/>
               </a:ext>
             </a:extLst>
           </p:cNvPr>
@@ -4868,7 +4868,7 @@
           <p:cNvPr id="5" name="">
             <a:extLst xmlns:a="http://schemas.openxmlformats.org/drawingml/2006/main">
               <a:ext uri="{FF2B5EF4-FFF2-40B4-BE49-F238E27FC236}">
-                <a16:creationId xmlns:a16="http://schemas.microsoft.com/office/drawing/2014/main" id="{96E60F5A-E4AE-42E6-ACD7-A7E14EC7A733}"/>
+                <a16:creationId xmlns:a16="http://schemas.microsoft.com/office/drawing/2014/main" id="{6DF52C77-497F-40E8-BD2B-0F454268B2F8}"/>
               </a:ext>
             </a:extLst>
           </p:cNvPr>
@@ -4925,7 +4925,7 @@
           <p:cNvPr id="6" name="">
             <a:extLst xmlns:a="http://schemas.openxmlformats.org/drawingml/2006/main">
               <a:ext uri="{FF2B5EF4-FFF2-40B4-BE49-F238E27FC236}">
-                <a16:creationId xmlns:a16="http://schemas.microsoft.com/office/drawing/2014/main" id="{97B7FA43-4A41-4808-83DA-64D9CA664B85}"/>
+                <a16:creationId xmlns:a16="http://schemas.microsoft.com/office/drawing/2014/main" id="{0F7218B7-09D1-42B2-A104-807DC039309C}"/>
               </a:ext>
             </a:extLst>
           </p:cNvPr>
@@ -4972,7 +4972,7 @@
                 <a:ea typeface="Bitstream Charter"/>
                 <a:cs typeface="Bitstream Charter"/>
               </a:rPr>
-              <a:t>Draw the control chart, a table of classifier hits and misses, and actual versus predicted counts.</a:t>
+              <a:t>Draw the control chart, a confusion matrix of classifier hits and misses, and actual versus predicted counts.</a:t>
             </a:r>
           </a:p>
         </p:txBody>
@@ -4982,7 +4982,7 @@
           <p:cNvPr id="7" name="">
             <a:extLst xmlns:a="http://schemas.openxmlformats.org/drawingml/2006/main">
               <a:ext uri="{FF2B5EF4-FFF2-40B4-BE49-F238E27FC236}">
-                <a16:creationId xmlns:a16="http://schemas.microsoft.com/office/drawing/2014/main" id="{BB3473D1-5E04-4FFC-A8C1-3B5D1AEA4A33}"/>
+                <a16:creationId xmlns:a16="http://schemas.microsoft.com/office/drawing/2014/main" id="{3ACA8670-5B4E-4C7B-95A0-1D3AC5FC5241}"/>
               </a:ext>
             </a:extLst>
           </p:cNvPr>
@@ -5039,7 +5039,7 @@
           <p:cNvPr id="8" name="">
             <a:extLst xmlns:a="http://schemas.openxmlformats.org/drawingml/2006/main">
               <a:ext uri="{FF2B5EF4-FFF2-40B4-BE49-F238E27FC236}">
-                <a16:creationId xmlns:a16="http://schemas.microsoft.com/office/drawing/2014/main" id="{7284895F-0EFF-4A32-AF5C-23F668E1229D}"/>
+                <a16:creationId xmlns:a16="http://schemas.microsoft.com/office/drawing/2014/main" id="{F609E242-2626-464C-BDF2-80299FD7BABF}"/>
               </a:ext>
             </a:extLst>
           </p:cNvPr>
@@ -5096,7 +5096,7 @@
           <p:cNvPr id="9" name="">
             <a:extLst xmlns:a="http://schemas.openxmlformats.org/drawingml/2006/main">
               <a:ext uri="{FF2B5EF4-FFF2-40B4-BE49-F238E27FC236}">
-                <a16:creationId xmlns:a16="http://schemas.microsoft.com/office/drawing/2014/main" id="{6FC3A69E-E0E6-4F48-92BD-BC21E50010AA}"/>
+                <a16:creationId xmlns:a16="http://schemas.microsoft.com/office/drawing/2014/main" id="{9B4682EB-1A2C-4475-8396-2C09B4831997}"/>
               </a:ext>
             </a:extLst>
           </p:cNvPr>
@@ -5153,7 +5153,7 @@
           <p:cNvPr id="10" name="">
             <a:extLst xmlns:a="http://schemas.openxmlformats.org/drawingml/2006/main">
               <a:ext uri="{FF2B5EF4-FFF2-40B4-BE49-F238E27FC236}">
-                <a16:creationId xmlns:a16="http://schemas.microsoft.com/office/drawing/2014/main" id="{C0C1A172-B3D7-469A-8218-6E83678C2B84}"/>
+                <a16:creationId xmlns:a16="http://schemas.microsoft.com/office/drawing/2014/main" id="{BB58B308-8E5C-477B-917C-D18D8B361B7D}"/>
               </a:ext>
             </a:extLst>
           </p:cNvPr>
@@ -5210,7 +5210,7 @@
           <p:cNvPr id="11" name="">
             <a:extLst xmlns:a="http://schemas.openxmlformats.org/drawingml/2006/main">
               <a:ext uri="{FF2B5EF4-FFF2-40B4-BE49-F238E27FC236}">
-                <a16:creationId xmlns:a16="http://schemas.microsoft.com/office/drawing/2014/main" id="{41AC105A-0947-4AA4-BFF9-A92EFD48A452}"/>
+                <a16:creationId xmlns:a16="http://schemas.microsoft.com/office/drawing/2014/main" id="{45D0B1C5-9152-4F54-AD6E-D99848326910}"/>
               </a:ext>
             </a:extLst>
           </p:cNvPr>
@@ -5267,7 +5267,7 @@
           <p:cNvPr id="12" name="">
             <a:extLst xmlns:a="http://schemas.openxmlformats.org/drawingml/2006/main">
               <a:ext uri="{FF2B5EF4-FFF2-40B4-BE49-F238E27FC236}">
-                <a16:creationId xmlns:a16="http://schemas.microsoft.com/office/drawing/2014/main" id="{74796112-1BE3-49A0-A154-47EB3DE0B132}"/>
+                <a16:creationId xmlns:a16="http://schemas.microsoft.com/office/drawing/2014/main" id="{6E04347A-894E-460C-B8BA-F4B995606A8A}"/>
               </a:ext>
             </a:extLst>
           </p:cNvPr>
@@ -5322,7 +5322,7 @@
     </p:spTree>
     <p:extLst>
       <p:ext uri="{BB962C8B-B14F-4D97-AF65-F5344CB8AC3E}">
-        <p14:creationId xmlns:p14="http://schemas.microsoft.com/office/powerpoint/2010/main" val="589444751"/>
+        <p14:creationId xmlns:p14="http://schemas.microsoft.com/office/powerpoint/2010/main" val="1660821016"/>
       </p:ext>
     </p:extLst>
   </p:cSld>
@@ -5353,7 +5353,7 @@
           <p:cNvPr id="13" name="">
             <a:extLst xmlns:a="http://schemas.openxmlformats.org/drawingml/2006/main">
               <a:ext uri="{FF2B5EF4-FFF2-40B4-BE49-F238E27FC236}">
-                <a16:creationId xmlns:a16="http://schemas.microsoft.com/office/drawing/2014/main" id="{DD40BF94-AF68-4BCB-A90A-78E01E19BDF2}"/>
+                <a16:creationId xmlns:a16="http://schemas.microsoft.com/office/drawing/2014/main" id="{D6B34627-BABE-4520-B178-B95AEED31BF1}"/>
               </a:ext>
             </a:extLst>
           </p:cNvPr>
@@ -5410,7 +5410,7 @@
           <p:cNvPr id="2" name="">
             <a:extLst xmlns:a="http://schemas.openxmlformats.org/drawingml/2006/main">
               <a:ext uri="{FF2B5EF4-FFF2-40B4-BE49-F238E27FC236}">
-                <a16:creationId xmlns:a16="http://schemas.microsoft.com/office/drawing/2014/main" id="{41E3ECCF-EADE-478E-BBD3-6BEB7905892E}"/>
+                <a16:creationId xmlns:a16="http://schemas.microsoft.com/office/drawing/2014/main" id="{4FC1E671-4F98-442A-AE4E-9EB1FE00DB27}"/>
               </a:ext>
             </a:extLst>
           </p:cNvPr>
@@ -5467,7 +5467,7 @@
           <p:cNvPr id="3" name="">
             <a:extLst xmlns:a="http://schemas.openxmlformats.org/drawingml/2006/main">
               <a:ext uri="{FF2B5EF4-FFF2-40B4-BE49-F238E27FC236}">
-                <a16:creationId xmlns:a16="http://schemas.microsoft.com/office/drawing/2014/main" id="{5F2085EA-A49C-47D0-A516-3B10C01DD526}"/>
+                <a16:creationId xmlns:a16="http://schemas.microsoft.com/office/drawing/2014/main" id="{7D26CCA1-59AB-4160-8686-69B1DBFD536F}"/>
               </a:ext>
             </a:extLst>
           </p:cNvPr>
@@ -5524,7 +5524,7 @@
           <p:cNvPr id="4" name="">
             <a:extLst xmlns:a="http://schemas.openxmlformats.org/drawingml/2006/main">
               <a:ext uri="{FF2B5EF4-FFF2-40B4-BE49-F238E27FC236}">
-                <a16:creationId xmlns:a16="http://schemas.microsoft.com/office/drawing/2014/main" id="{D96AF1A8-84FB-4480-982F-0F388C7E7124}"/>
+                <a16:creationId xmlns:a16="http://schemas.microsoft.com/office/drawing/2014/main" id="{A8A265E0-3263-4132-9B95-49A74257A3A3}"/>
               </a:ext>
             </a:extLst>
           </p:cNvPr>
@@ -5581,7 +5581,7 @@
           <p:cNvPr id="5" name="">
             <a:extLst xmlns:a="http://schemas.openxmlformats.org/drawingml/2006/main">
               <a:ext uri="{FF2B5EF4-FFF2-40B4-BE49-F238E27FC236}">
-                <a16:creationId xmlns:a16="http://schemas.microsoft.com/office/drawing/2014/main" id="{FF6A47B1-B6A0-4113-8859-DF287FADB3ED}"/>
+                <a16:creationId xmlns:a16="http://schemas.microsoft.com/office/drawing/2014/main" id="{90679DE1-686F-4463-85C6-86A73D5B5E8E}"/>
               </a:ext>
             </a:extLst>
           </p:cNvPr>
@@ -5638,7 +5638,7 @@
           <p:cNvPr id="6" name="">
             <a:extLst xmlns:a="http://schemas.openxmlformats.org/drawingml/2006/main">
               <a:ext uri="{FF2B5EF4-FFF2-40B4-BE49-F238E27FC236}">
-                <a16:creationId xmlns:a16="http://schemas.microsoft.com/office/drawing/2014/main" id="{A4794CE7-DDA5-4C18-B313-174235C8A20D}"/>
+                <a16:creationId xmlns:a16="http://schemas.microsoft.com/office/drawing/2014/main" id="{3A0BA942-3A7F-4D08-BDA5-B3A7B97DDF1F}"/>
               </a:ext>
             </a:extLst>
           </p:cNvPr>
@@ -5695,7 +5695,7 @@
           <p:cNvPr id="7" name="">
             <a:extLst xmlns:a="http://schemas.openxmlformats.org/drawingml/2006/main">
               <a:ext uri="{FF2B5EF4-FFF2-40B4-BE49-F238E27FC236}">
-                <a16:creationId xmlns:a16="http://schemas.microsoft.com/office/drawing/2014/main" id="{38E8F575-B053-443A-A052-1F76F602DFBE}"/>
+                <a16:creationId xmlns:a16="http://schemas.microsoft.com/office/drawing/2014/main" id="{59B3DACB-0725-456B-BF21-F8DAE687B7E5}"/>
               </a:ext>
             </a:extLst>
           </p:cNvPr>
@@ -5752,7 +5752,7 @@
           <p:cNvPr id="8" name="">
             <a:extLst xmlns:a="http://schemas.openxmlformats.org/drawingml/2006/main">
               <a:ext uri="{FF2B5EF4-FFF2-40B4-BE49-F238E27FC236}">
-                <a16:creationId xmlns:a16="http://schemas.microsoft.com/office/drawing/2014/main" id="{24A28992-F233-4C64-B132-BB4EEFB474D8}"/>
+                <a16:creationId xmlns:a16="http://schemas.microsoft.com/office/drawing/2014/main" id="{B11CC230-24B3-416A-AF8D-3A0F6908C8D9}"/>
               </a:ext>
             </a:extLst>
           </p:cNvPr>
@@ -5809,7 +5809,7 @@
           <p:cNvPr id="9" name="">
             <a:extLst xmlns:a="http://schemas.openxmlformats.org/drawingml/2006/main">
               <a:ext uri="{FF2B5EF4-FFF2-40B4-BE49-F238E27FC236}">
-                <a16:creationId xmlns:a16="http://schemas.microsoft.com/office/drawing/2014/main" id="{69722714-CB0C-4444-A657-B059AC8E306A}"/>
+                <a16:creationId xmlns:a16="http://schemas.microsoft.com/office/drawing/2014/main" id="{5576801B-DB03-4D1F-9699-57DABBE66CAA}"/>
               </a:ext>
             </a:extLst>
           </p:cNvPr>
@@ -5866,7 +5866,7 @@
           <p:cNvPr id="10" name="">
             <a:extLst xmlns:a="http://schemas.openxmlformats.org/drawingml/2006/main">
               <a:ext uri="{FF2B5EF4-FFF2-40B4-BE49-F238E27FC236}">
-                <a16:creationId xmlns:a16="http://schemas.microsoft.com/office/drawing/2014/main" id="{07C71CE1-9091-41EB-A649-E3568146D8B9}"/>
+                <a16:creationId xmlns:a16="http://schemas.microsoft.com/office/drawing/2014/main" id="{27D0DC90-6E59-4DDB-A136-48501F519362}"/>
               </a:ext>
             </a:extLst>
           </p:cNvPr>
@@ -5913,7 +5913,7 @@
                 <a:ea typeface="Bitstream Charter"/>
                 <a:cs typeface="Bitstream Charter"/>
               </a:rPr>
-              <a:t>479 flagged windows consolidate into 30 episodes on this synthetic run. The visible queue shows the latest 15.</a:t>
+              <a:t>479 flagged windows consolidate into 30 episodes on this synthetic run. The visible queue shows 15 episodes with the latest signal dates.</a:t>
             </a:r>
           </a:p>
         </p:txBody>
@@ -5923,7 +5923,7 @@
           <p:cNvPr id="11" name="">
             <a:extLst xmlns:a="http://schemas.openxmlformats.org/drawingml/2006/main">
               <a:ext uri="{FF2B5EF4-FFF2-40B4-BE49-F238E27FC236}">
-                <a16:creationId xmlns:a16="http://schemas.microsoft.com/office/drawing/2014/main" id="{5B10680A-C09A-4B60-BEE1-1758CCA3138B}"/>
+                <a16:creationId xmlns:a16="http://schemas.microsoft.com/office/drawing/2014/main" id="{E891BC61-464A-434C-8872-BE93482A0AF2}"/>
               </a:ext>
             </a:extLst>
           </p:cNvPr>
@@ -5980,7 +5980,7 @@
           <p:cNvPr id="12" name="">
             <a:extLst xmlns:a="http://schemas.openxmlformats.org/drawingml/2006/main">
               <a:ext uri="{FF2B5EF4-FFF2-40B4-BE49-F238E27FC236}">
-                <a16:creationId xmlns:a16="http://schemas.microsoft.com/office/drawing/2014/main" id="{EA3DCA69-B6D9-42F6-944B-A0421F48EEBA}"/>
+                <a16:creationId xmlns:a16="http://schemas.microsoft.com/office/drawing/2014/main" id="{3AC64767-BC22-463D-A64B-46C2C065BC97}"/>
               </a:ext>
             </a:extLst>
           </p:cNvPr>
@@ -6035,7 +6035,7 @@
     </p:spTree>
     <p:extLst>
       <p:ext uri="{BB962C8B-B14F-4D97-AF65-F5344CB8AC3E}">
-        <p14:creationId xmlns:p14="http://schemas.microsoft.com/office/powerpoint/2010/main" val="71219005"/>
+        <p14:creationId xmlns:p14="http://schemas.microsoft.com/office/powerpoint/2010/main" val="2012597719"/>
       </p:ext>
     </p:extLst>
   </p:cSld>
@@ -6066,7 +6066,7 @@
           <p:cNvPr id="13" name="">
             <a:extLst xmlns:a="http://schemas.openxmlformats.org/drawingml/2006/main">
               <a:ext uri="{FF2B5EF4-FFF2-40B4-BE49-F238E27FC236}">
-                <a16:creationId xmlns:a16="http://schemas.microsoft.com/office/drawing/2014/main" id="{8E2F3F9F-16CD-4A3A-875E-5B7B46C714C8}"/>
+                <a16:creationId xmlns:a16="http://schemas.microsoft.com/office/drawing/2014/main" id="{9FCC5A28-450A-4454-9FAF-4E17E2825B46}"/>
               </a:ext>
             </a:extLst>
           </p:cNvPr>
@@ -6123,7 +6123,7 @@
           <p:cNvPr id="2" name="">
             <a:extLst xmlns:a="http://schemas.openxmlformats.org/drawingml/2006/main">
               <a:ext uri="{FF2B5EF4-FFF2-40B4-BE49-F238E27FC236}">
-                <a16:creationId xmlns:a16="http://schemas.microsoft.com/office/drawing/2014/main" id="{89DFAFA9-83BF-4DAA-ACB5-BEE4DAA31703}"/>
+                <a16:creationId xmlns:a16="http://schemas.microsoft.com/office/drawing/2014/main" id="{51828536-F8EE-441A-99A1-F72293B60355}"/>
               </a:ext>
             </a:extLst>
           </p:cNvPr>
@@ -6180,7 +6180,7 @@
           <p:cNvPr id="3" name="">
             <a:extLst xmlns:a="http://schemas.openxmlformats.org/drawingml/2006/main">
               <a:ext uri="{FF2B5EF4-FFF2-40B4-BE49-F238E27FC236}">
-                <a16:creationId xmlns:a16="http://schemas.microsoft.com/office/drawing/2014/main" id="{4566BF48-703A-463F-96A8-85512CDAD1AA}"/>
+                <a16:creationId xmlns:a16="http://schemas.microsoft.com/office/drawing/2014/main" id="{F6F01C83-3D7F-40F5-889F-3D273AF15B56}"/>
               </a:ext>
             </a:extLst>
           </p:cNvPr>
@@ -6237,7 +6237,7 @@
           <p:cNvPr id="4" name="">
             <a:extLst xmlns:a="http://schemas.openxmlformats.org/drawingml/2006/main">
               <a:ext uri="{FF2B5EF4-FFF2-40B4-BE49-F238E27FC236}">
-                <a16:creationId xmlns:a16="http://schemas.microsoft.com/office/drawing/2014/main" id="{2AD1F4E5-DDB5-4103-9FD1-CC3EE474E317}"/>
+                <a16:creationId xmlns:a16="http://schemas.microsoft.com/office/drawing/2014/main" id="{D80D8CAC-BBFE-4AE3-8BF2-0EDBB530BEFE}"/>
               </a:ext>
             </a:extLst>
           </p:cNvPr>
@@ -6294,7 +6294,7 @@
           <p:cNvPr id="5" name="">
             <a:extLst xmlns:a="http://schemas.openxmlformats.org/drawingml/2006/main">
               <a:ext uri="{FF2B5EF4-FFF2-40B4-BE49-F238E27FC236}">
-                <a16:creationId xmlns:a16="http://schemas.microsoft.com/office/drawing/2014/main" id="{68520C6F-A4E9-459A-946A-8D71EE22BD44}"/>
+                <a16:creationId xmlns:a16="http://schemas.microsoft.com/office/drawing/2014/main" id="{73FCF644-956A-4FF6-8399-CEADF06F37B7}"/>
               </a:ext>
             </a:extLst>
           </p:cNvPr>
@@ -6351,7 +6351,7 @@
           <p:cNvPr id="6" name="">
             <a:extLst xmlns:a="http://schemas.openxmlformats.org/drawingml/2006/main">
               <a:ext uri="{FF2B5EF4-FFF2-40B4-BE49-F238E27FC236}">
-                <a16:creationId xmlns:a16="http://schemas.microsoft.com/office/drawing/2014/main" id="{25D67B96-5A67-4B0E-AB87-664922B5C11F}"/>
+                <a16:creationId xmlns:a16="http://schemas.microsoft.com/office/drawing/2014/main" id="{4C3A5134-9D71-4F71-8A8D-EC875562F525}"/>
               </a:ext>
             </a:extLst>
           </p:cNvPr>
@@ -6408,7 +6408,7 @@
           <p:cNvPr id="7" name="">
             <a:extLst xmlns:a="http://schemas.openxmlformats.org/drawingml/2006/main">
               <a:ext uri="{FF2B5EF4-FFF2-40B4-BE49-F238E27FC236}">
-                <a16:creationId xmlns:a16="http://schemas.microsoft.com/office/drawing/2014/main" id="{F5789233-8BC1-47E3-830A-44B07B873DB4}"/>
+                <a16:creationId xmlns:a16="http://schemas.microsoft.com/office/drawing/2014/main" id="{5F611DF6-AE37-4488-879E-42B87FEA6100}"/>
               </a:ext>
             </a:extLst>
           </p:cNvPr>
@@ -6465,7 +6465,7 @@
           <p:cNvPr id="8" name="">
             <a:extLst xmlns:a="http://schemas.openxmlformats.org/drawingml/2006/main">
               <a:ext uri="{FF2B5EF4-FFF2-40B4-BE49-F238E27FC236}">
-                <a16:creationId xmlns:a16="http://schemas.microsoft.com/office/drawing/2014/main" id="{C48ACAFA-2200-4FAE-8C7B-AC2A02E7CB6F}"/>
+                <a16:creationId xmlns:a16="http://schemas.microsoft.com/office/drawing/2014/main" id="{63DCBA53-ACD2-4EB6-9485-95293C885CFB}"/>
               </a:ext>
             </a:extLst>
           </p:cNvPr>
@@ -6522,7 +6522,7 @@
           <p:cNvPr id="9" name="">
             <a:extLst xmlns:a="http://schemas.openxmlformats.org/drawingml/2006/main">
               <a:ext uri="{FF2B5EF4-FFF2-40B4-BE49-F238E27FC236}">
-                <a16:creationId xmlns:a16="http://schemas.microsoft.com/office/drawing/2014/main" id="{35390E86-996D-4395-986C-BA72A1BEB655}"/>
+                <a16:creationId xmlns:a16="http://schemas.microsoft.com/office/drawing/2014/main" id="{8FB7E031-B406-4D81-92B2-3675B10620BA}"/>
               </a:ext>
             </a:extLst>
           </p:cNvPr>
@@ -6579,7 +6579,7 @@
           <p:cNvPr id="10" name="">
             <a:extLst xmlns:a="http://schemas.openxmlformats.org/drawingml/2006/main">
               <a:ext uri="{FF2B5EF4-FFF2-40B4-BE49-F238E27FC236}">
-                <a16:creationId xmlns:a16="http://schemas.microsoft.com/office/drawing/2014/main" id="{DF979131-ABD2-4856-A6FC-34C4C3D381A2}"/>
+                <a16:creationId xmlns:a16="http://schemas.microsoft.com/office/drawing/2014/main" id="{D5B16BD6-3AD8-41E5-BF87-ACB5F8BAFAC4}"/>
               </a:ext>
             </a:extLst>
           </p:cNvPr>
@@ -6626,7 +6626,7 @@
                 <a:ea typeface="Bitstream Charter"/>
                 <a:cs typeface="Bitstream Charter"/>
               </a:rPr>
-              <a:t>In Databricks, look for a run ID and two logged model artifacts. Registration only happens if UC_MODEL_NAME is filled in.</a:t>
+              <a:t>In Databricks, look for a run ID and two logged model URIs. Registration only happens if UC_MODEL_NAME is filled in.</a:t>
             </a:r>
           </a:p>
         </p:txBody>
@@ -6636,7 +6636,7 @@
           <p:cNvPr id="11" name="">
             <a:extLst xmlns:a="http://schemas.openxmlformats.org/drawingml/2006/main">
               <a:ext uri="{FF2B5EF4-FFF2-40B4-BE49-F238E27FC236}">
-                <a16:creationId xmlns:a16="http://schemas.microsoft.com/office/drawing/2014/main" id="{98D117D9-313C-4CC0-ACF7-21BDC7EEC8CF}"/>
+                <a16:creationId xmlns:a16="http://schemas.microsoft.com/office/drawing/2014/main" id="{5A019A35-686D-411A-8EE8-417BDE96C7B1}"/>
               </a:ext>
             </a:extLst>
           </p:cNvPr>
@@ -6693,7 +6693,7 @@
           <p:cNvPr id="12" name="">
             <a:extLst xmlns:a="http://schemas.openxmlformats.org/drawingml/2006/main">
               <a:ext uri="{FF2B5EF4-FFF2-40B4-BE49-F238E27FC236}">
-                <a16:creationId xmlns:a16="http://schemas.microsoft.com/office/drawing/2014/main" id="{8E234CE4-8906-4C4B-9171-60FBB369216B}"/>
+                <a16:creationId xmlns:a16="http://schemas.microsoft.com/office/drawing/2014/main" id="{F4C98BF4-0F7B-4185-B906-B6F9771B06DA}"/>
               </a:ext>
             </a:extLst>
           </p:cNvPr>
@@ -6748,7 +6748,7 @@
     </p:spTree>
     <p:extLst>
       <p:ext uri="{BB962C8B-B14F-4D97-AF65-F5344CB8AC3E}">
-        <p14:creationId xmlns:p14="http://schemas.microsoft.com/office/powerpoint/2010/main" val="496644724"/>
+        <p14:creationId xmlns:p14="http://schemas.microsoft.com/office/powerpoint/2010/main" val="689562487"/>
       </p:ext>
     </p:extLst>
   </p:cSld>
@@ -6779,7 +6779,7 @@
           <p:cNvPr id="13" name="">
             <a:extLst xmlns:a="http://schemas.openxmlformats.org/drawingml/2006/main">
               <a:ext uri="{FF2B5EF4-FFF2-40B4-BE49-F238E27FC236}">
-                <a16:creationId xmlns:a16="http://schemas.microsoft.com/office/drawing/2014/main" id="{02A28E24-E983-471A-8E16-5F7B57B92E29}"/>
+                <a16:creationId xmlns:a16="http://schemas.microsoft.com/office/drawing/2014/main" id="{9786674E-1451-4B66-B000-DE3A8343D6C0}"/>
               </a:ext>
             </a:extLst>
           </p:cNvPr>
@@ -6836,7 +6836,7 @@
           <p:cNvPr id="2" name="">
             <a:extLst xmlns:a="http://schemas.openxmlformats.org/drawingml/2006/main">
               <a:ext uri="{FF2B5EF4-FFF2-40B4-BE49-F238E27FC236}">
-                <a16:creationId xmlns:a16="http://schemas.microsoft.com/office/drawing/2014/main" id="{91A845F9-7234-46DB-A0BC-CD486D0FB97D}"/>
+                <a16:creationId xmlns:a16="http://schemas.microsoft.com/office/drawing/2014/main" id="{164DE90A-8B5C-42B1-96F2-5F94086A0D1F}"/>
               </a:ext>
             </a:extLst>
           </p:cNvPr>
@@ -6893,7 +6893,7 @@
           <p:cNvPr id="3" name="">
             <a:extLst xmlns:a="http://schemas.openxmlformats.org/drawingml/2006/main">
               <a:ext uri="{FF2B5EF4-FFF2-40B4-BE49-F238E27FC236}">
-                <a16:creationId xmlns:a16="http://schemas.microsoft.com/office/drawing/2014/main" id="{06C13BC7-6323-4744-B658-99EC3B8591F1}"/>
+                <a16:creationId xmlns:a16="http://schemas.microsoft.com/office/drawing/2014/main" id="{D96AC551-113D-425B-BF00-5BCC0A051B8A}"/>
               </a:ext>
             </a:extLst>
           </p:cNvPr>
@@ -6950,7 +6950,7 @@
           <p:cNvPr id="4" name="">
             <a:extLst xmlns:a="http://schemas.openxmlformats.org/drawingml/2006/main">
               <a:ext uri="{FF2B5EF4-FFF2-40B4-BE49-F238E27FC236}">
-                <a16:creationId xmlns:a16="http://schemas.microsoft.com/office/drawing/2014/main" id="{6C9DD72D-C599-4CFA-A993-29E4EDA7CDC2}"/>
+                <a16:creationId xmlns:a16="http://schemas.microsoft.com/office/drawing/2014/main" id="{22BB01B8-3A30-4DD9-ACDE-A112F6D9B653}"/>
               </a:ext>
             </a:extLst>
           </p:cNvPr>
@@ -7007,7 +7007,7 @@
           <p:cNvPr id="5" name="">
             <a:extLst xmlns:a="http://schemas.openxmlformats.org/drawingml/2006/main">
               <a:ext uri="{FF2B5EF4-FFF2-40B4-BE49-F238E27FC236}">
-                <a16:creationId xmlns:a16="http://schemas.microsoft.com/office/drawing/2014/main" id="{4BA04423-9231-4829-9BAC-A35990E6DBE7}"/>
+                <a16:creationId xmlns:a16="http://schemas.microsoft.com/office/drawing/2014/main" id="{4861A07F-BE1E-482E-8AC0-3454E0600B8D}"/>
               </a:ext>
             </a:extLst>
           </p:cNvPr>
@@ -7064,7 +7064,7 @@
           <p:cNvPr id="6" name="">
             <a:extLst xmlns:a="http://schemas.openxmlformats.org/drawingml/2006/main">
               <a:ext uri="{FF2B5EF4-FFF2-40B4-BE49-F238E27FC236}">
-                <a16:creationId xmlns:a16="http://schemas.microsoft.com/office/drawing/2014/main" id="{7EBFD7ED-7DE0-400B-9366-E7E14334F140}"/>
+                <a16:creationId xmlns:a16="http://schemas.microsoft.com/office/drawing/2014/main" id="{7BCE48F8-F85C-41A0-981D-672E08FD1BF5}"/>
               </a:ext>
             </a:extLst>
           </p:cNvPr>
@@ -7121,7 +7121,7 @@
           <p:cNvPr id="7" name="">
             <a:extLst xmlns:a="http://schemas.openxmlformats.org/drawingml/2006/main">
               <a:ext uri="{FF2B5EF4-FFF2-40B4-BE49-F238E27FC236}">
-                <a16:creationId xmlns:a16="http://schemas.microsoft.com/office/drawing/2014/main" id="{E8B465B1-24D4-4E6E-9E16-78A0CED136C5}"/>
+                <a16:creationId xmlns:a16="http://schemas.microsoft.com/office/drawing/2014/main" id="{9B76D9CB-37B3-4148-9648-E530579B6336}"/>
               </a:ext>
             </a:extLst>
           </p:cNvPr>
@@ -7178,7 +7178,7 @@
           <p:cNvPr id="8" name="">
             <a:extLst xmlns:a="http://schemas.openxmlformats.org/drawingml/2006/main">
               <a:ext uri="{FF2B5EF4-FFF2-40B4-BE49-F238E27FC236}">
-                <a16:creationId xmlns:a16="http://schemas.microsoft.com/office/drawing/2014/main" id="{BFA33E48-B2BD-494F-8C66-7524F2C0E825}"/>
+                <a16:creationId xmlns:a16="http://schemas.microsoft.com/office/drawing/2014/main" id="{A88142C4-DF37-4C91-B4FF-0CBDAB3FB376}"/>
               </a:ext>
             </a:extLst>
           </p:cNvPr>
@@ -7235,7 +7235,7 @@
           <p:cNvPr id="9" name="">
             <a:extLst xmlns:a="http://schemas.openxmlformats.org/drawingml/2006/main">
               <a:ext uri="{FF2B5EF4-FFF2-40B4-BE49-F238E27FC236}">
-                <a16:creationId xmlns:a16="http://schemas.microsoft.com/office/drawing/2014/main" id="{D1D97A04-EFC6-4519-B646-FD17078AB8A7}"/>
+                <a16:creationId xmlns:a16="http://schemas.microsoft.com/office/drawing/2014/main" id="{B7DF7083-54D5-41C5-A935-A1D35BEE8A40}"/>
               </a:ext>
             </a:extLst>
           </p:cNvPr>
@@ -7292,7 +7292,7 @@
           <p:cNvPr id="10" name="">
             <a:extLst xmlns:a="http://schemas.openxmlformats.org/drawingml/2006/main">
               <a:ext uri="{FF2B5EF4-FFF2-40B4-BE49-F238E27FC236}">
-                <a16:creationId xmlns:a16="http://schemas.microsoft.com/office/drawing/2014/main" id="{3364595A-2513-4F2C-97EB-68067C2A3671}"/>
+                <a16:creationId xmlns:a16="http://schemas.microsoft.com/office/drawing/2014/main" id="{98C847E6-20D9-446B-878A-FBB5BC44066D}"/>
               </a:ext>
             </a:extLst>
           </p:cNvPr>
@@ -7349,7 +7349,7 @@
           <p:cNvPr id="11" name="">
             <a:extLst xmlns:a="http://schemas.openxmlformats.org/drawingml/2006/main">
               <a:ext uri="{FF2B5EF4-FFF2-40B4-BE49-F238E27FC236}">
-                <a16:creationId xmlns:a16="http://schemas.microsoft.com/office/drawing/2014/main" id="{50E1EEDB-7AB2-40DA-9973-B18B27E3AA0A}"/>
+                <a16:creationId xmlns:a16="http://schemas.microsoft.com/office/drawing/2014/main" id="{97CABF37-5F13-4CE8-8F24-A7975D25B030}"/>
               </a:ext>
             </a:extLst>
           </p:cNvPr>
@@ -7406,7 +7406,7 @@
           <p:cNvPr id="12" name="">
             <a:extLst xmlns:a="http://schemas.openxmlformats.org/drawingml/2006/main">
               <a:ext uri="{FF2B5EF4-FFF2-40B4-BE49-F238E27FC236}">
-                <a16:creationId xmlns:a16="http://schemas.microsoft.com/office/drawing/2014/main" id="{B6E0AAA2-D34F-4E54-B420-FFDF42AC27DF}"/>
+                <a16:creationId xmlns:a16="http://schemas.microsoft.com/office/drawing/2014/main" id="{4E759F3E-E176-4E4C-B661-443BDA1160BF}"/>
               </a:ext>
             </a:extLst>
           </p:cNvPr>
@@ -7461,7 +7461,7 @@
     </p:spTree>
     <p:extLst>
       <p:ext uri="{BB962C8B-B14F-4D97-AF65-F5344CB8AC3E}">
-        <p14:creationId xmlns:p14="http://schemas.microsoft.com/office/powerpoint/2010/main" val="71465275"/>
+        <p14:creationId xmlns:p14="http://schemas.microsoft.com/office/powerpoint/2010/main" val="1037132997"/>
       </p:ext>
     </p:extLst>
   </p:cSld>
@@ -7492,7 +7492,7 @@
           <p:cNvPr id="10" name="">
             <a:extLst xmlns:a="http://schemas.openxmlformats.org/drawingml/2006/main">
               <a:ext uri="{FF2B5EF4-FFF2-40B4-BE49-F238E27FC236}">
-                <a16:creationId xmlns:a16="http://schemas.microsoft.com/office/drawing/2014/main" id="{8EFBE6BB-4DB7-4AD4-8BED-BF03BC3D912B}"/>
+                <a16:creationId xmlns:a16="http://schemas.microsoft.com/office/drawing/2014/main" id="{18E4AAD8-7A80-42FE-B80E-450B0064E0E2}"/>
               </a:ext>
             </a:extLst>
           </p:cNvPr>
@@ -7549,7 +7549,7 @@
           <p:cNvPr id="2" name="">
             <a:extLst xmlns:a="http://schemas.openxmlformats.org/drawingml/2006/main">
               <a:ext uri="{FF2B5EF4-FFF2-40B4-BE49-F238E27FC236}">
-                <a16:creationId xmlns:a16="http://schemas.microsoft.com/office/drawing/2014/main" id="{9881E18C-0075-4DB0-87ED-DC0C3A90FB5B}"/>
+                <a16:creationId xmlns:a16="http://schemas.microsoft.com/office/drawing/2014/main" id="{BD410CC5-5014-43F0-AAB4-7EB812DEBC32}"/>
               </a:ext>
             </a:extLst>
           </p:cNvPr>
@@ -7606,7 +7606,7 @@
           <p:cNvPr id="3" name="">
             <a:extLst xmlns:a="http://schemas.openxmlformats.org/drawingml/2006/main">
               <a:ext uri="{FF2B5EF4-FFF2-40B4-BE49-F238E27FC236}">
-                <a16:creationId xmlns:a16="http://schemas.microsoft.com/office/drawing/2014/main" id="{0493E5F7-057B-41E9-B6FA-FFBD64D1F197}"/>
+                <a16:creationId xmlns:a16="http://schemas.microsoft.com/office/drawing/2014/main" id="{8A381E90-CB9D-458A-AC46-E5B40A864EDD}"/>
               </a:ext>
             </a:extLst>
           </p:cNvPr>
@@ -7663,7 +7663,7 @@
           <p:cNvPr id="4" name="">
             <a:extLst xmlns:a="http://schemas.openxmlformats.org/drawingml/2006/main">
               <a:ext uri="{FF2B5EF4-FFF2-40B4-BE49-F238E27FC236}">
-                <a16:creationId xmlns:a16="http://schemas.microsoft.com/office/drawing/2014/main" id="{A18470C8-EB94-48F0-A01D-D550F7A54D64}"/>
+                <a16:creationId xmlns:a16="http://schemas.microsoft.com/office/drawing/2014/main" id="{3429B1F1-E803-489E-B00A-FA97BDE77E5E}"/>
               </a:ext>
             </a:extLst>
           </p:cNvPr>
@@ -7720,7 +7720,7 @@
           <p:cNvPr id="5" name="">
             <a:extLst xmlns:a="http://schemas.openxmlformats.org/drawingml/2006/main">
               <a:ext uri="{FF2B5EF4-FFF2-40B4-BE49-F238E27FC236}">
-                <a16:creationId xmlns:a16="http://schemas.microsoft.com/office/drawing/2014/main" id="{C5619752-BCB5-488E-A8F3-89B8A2434C9B}"/>
+                <a16:creationId xmlns:a16="http://schemas.microsoft.com/office/drawing/2014/main" id="{35C3940A-197C-49A3-BCA0-0292EA1B17F4}"/>
               </a:ext>
             </a:extLst>
           </p:cNvPr>
@@ -7777,7 +7777,7 @@
           <p:cNvPr id="6" name="">
             <a:extLst xmlns:a="http://schemas.openxmlformats.org/drawingml/2006/main">
               <a:ext uri="{FF2B5EF4-FFF2-40B4-BE49-F238E27FC236}">
-                <a16:creationId xmlns:a16="http://schemas.microsoft.com/office/drawing/2014/main" id="{DF0E65A0-0529-4C2F-8B37-45EEABD8DE81}"/>
+                <a16:creationId xmlns:a16="http://schemas.microsoft.com/office/drawing/2014/main" id="{E28A4621-CFE5-489A-85DE-271E3DC940FE}"/>
               </a:ext>
             </a:extLst>
           </p:cNvPr>
@@ -7885,7 +7885,7 @@
           <p:cNvPr id="7" name="">
             <a:extLst xmlns:a="http://schemas.openxmlformats.org/drawingml/2006/main">
               <a:ext uri="{FF2B5EF4-FFF2-40B4-BE49-F238E27FC236}">
-                <a16:creationId xmlns:a16="http://schemas.microsoft.com/office/drawing/2014/main" id="{668159F1-8721-42A8-A7B8-20A8C777A71E}"/>
+                <a16:creationId xmlns:a16="http://schemas.microsoft.com/office/drawing/2014/main" id="{2B962AD3-F1CF-412B-BCE8-4B2C19889D42}"/>
               </a:ext>
             </a:extLst>
           </p:cNvPr>
@@ -7942,7 +7942,7 @@
           <p:cNvPr id="8" name="">
             <a:extLst xmlns:a="http://schemas.openxmlformats.org/drawingml/2006/main">
               <a:ext uri="{FF2B5EF4-FFF2-40B4-BE49-F238E27FC236}">
-                <a16:creationId xmlns:a16="http://schemas.microsoft.com/office/drawing/2014/main" id="{6B731283-4C55-44B5-9D9F-0CD95EE548F3}"/>
+                <a16:creationId xmlns:a16="http://schemas.microsoft.com/office/drawing/2014/main" id="{CDFEF416-7305-44D9-BC3B-2637B2425854}"/>
               </a:ext>
             </a:extLst>
           </p:cNvPr>
@@ -8050,7 +8050,7 @@
           <p:cNvPr id="9" name="">
             <a:extLst xmlns:a="http://schemas.openxmlformats.org/drawingml/2006/main">
               <a:ext uri="{FF2B5EF4-FFF2-40B4-BE49-F238E27FC236}">
-                <a16:creationId xmlns:a16="http://schemas.microsoft.com/office/drawing/2014/main" id="{05CD5B8A-9868-4241-80B7-50E66DBF943B}"/>
+                <a16:creationId xmlns:a16="http://schemas.microsoft.com/office/drawing/2014/main" id="{7A8CCDB0-0780-4076-81E1-1A9B648679F3}"/>
               </a:ext>
             </a:extLst>
           </p:cNvPr>
@@ -8105,7 +8105,7 @@
     </p:spTree>
     <p:extLst>
       <p:ext uri="{BB962C8B-B14F-4D97-AF65-F5344CB8AC3E}">
-        <p14:creationId xmlns:p14="http://schemas.microsoft.com/office/powerpoint/2010/main" val="1546938617"/>
+        <p14:creationId xmlns:p14="http://schemas.microsoft.com/office/powerpoint/2010/main" val="47939383"/>
       </p:ext>
     </p:extLst>
   </p:cSld>
@@ -8136,7 +8136,7 @@
           <p:cNvPr id="11" name="">
             <a:extLst xmlns:a="http://schemas.openxmlformats.org/drawingml/2006/main">
               <a:ext uri="{FF2B5EF4-FFF2-40B4-BE49-F238E27FC236}">
-                <a16:creationId xmlns:a16="http://schemas.microsoft.com/office/drawing/2014/main" id="{D74B3F11-9921-4010-BCDB-75958FDC599F}"/>
+                <a16:creationId xmlns:a16="http://schemas.microsoft.com/office/drawing/2014/main" id="{19E1152A-8667-4079-ADFF-F42B9B4976C1}"/>
               </a:ext>
             </a:extLst>
           </p:cNvPr>
@@ -8193,7 +8193,7 @@
           <p:cNvPr id="2" name="">
             <a:extLst xmlns:a="http://schemas.openxmlformats.org/drawingml/2006/main">
               <a:ext uri="{FF2B5EF4-FFF2-40B4-BE49-F238E27FC236}">
-                <a16:creationId xmlns:a16="http://schemas.microsoft.com/office/drawing/2014/main" id="{41B6F9F1-F6A7-4B15-9A9F-ADD2B4C597E5}"/>
+                <a16:creationId xmlns:a16="http://schemas.microsoft.com/office/drawing/2014/main" id="{546104A9-C8BB-4C0E-9B5C-1F545C6A736F}"/>
               </a:ext>
             </a:extLst>
           </p:cNvPr>
@@ -8250,7 +8250,7 @@
           <p:cNvPr id="3" name="">
             <a:extLst xmlns:a="http://schemas.openxmlformats.org/drawingml/2006/main">
               <a:ext uri="{FF2B5EF4-FFF2-40B4-BE49-F238E27FC236}">
-                <a16:creationId xmlns:a16="http://schemas.microsoft.com/office/drawing/2014/main" id="{F59F6FE0-3E40-4000-A8F4-C8FE3DC06BCA}"/>
+                <a16:creationId xmlns:a16="http://schemas.microsoft.com/office/drawing/2014/main" id="{C75A21BA-3D19-42A8-93D1-F2713C29C744}"/>
               </a:ext>
             </a:extLst>
           </p:cNvPr>
@@ -8307,7 +8307,7 @@
           <p:cNvPr id="4" name="">
             <a:extLst xmlns:a="http://schemas.openxmlformats.org/drawingml/2006/main">
               <a:ext uri="{FF2B5EF4-FFF2-40B4-BE49-F238E27FC236}">
-                <a16:creationId xmlns:a16="http://schemas.microsoft.com/office/drawing/2014/main" id="{DCB408C3-F854-43B6-B5CE-1E2CD231328E}"/>
+                <a16:creationId xmlns:a16="http://schemas.microsoft.com/office/drawing/2014/main" id="{1C8FCD0D-99C6-4455-B376-074E4ECC1B8E}"/>
               </a:ext>
             </a:extLst>
           </p:cNvPr>
@@ -8364,7 +8364,7 @@
           <p:cNvPr id="5" name="">
             <a:extLst xmlns:a="http://schemas.openxmlformats.org/drawingml/2006/main">
               <a:ext uri="{FF2B5EF4-FFF2-40B4-BE49-F238E27FC236}">
-                <a16:creationId xmlns:a16="http://schemas.microsoft.com/office/drawing/2014/main" id="{AA38CED5-3C49-4D3A-874E-D318364ACCCC}"/>
+                <a16:creationId xmlns:a16="http://schemas.microsoft.com/office/drawing/2014/main" id="{E9E450AB-682B-418F-AA59-43BE6EB45E77}"/>
               </a:ext>
             </a:extLst>
           </p:cNvPr>
@@ -8421,7 +8421,7 @@
           <p:cNvPr id="6" name="">
             <a:extLst xmlns:a="http://schemas.openxmlformats.org/drawingml/2006/main">
               <a:ext uri="{FF2B5EF4-FFF2-40B4-BE49-F238E27FC236}">
-                <a16:creationId xmlns:a16="http://schemas.microsoft.com/office/drawing/2014/main" id="{91809C3F-983E-4856-86A7-39B296E76D11}"/>
+                <a16:creationId xmlns:a16="http://schemas.microsoft.com/office/drawing/2014/main" id="{8100784E-87F3-4348-84E2-AE0DB067CF54}"/>
               </a:ext>
             </a:extLst>
           </p:cNvPr>
@@ -8478,7 +8478,7 @@
           <p:cNvPr id="7" name="">
             <a:extLst xmlns:a="http://schemas.openxmlformats.org/drawingml/2006/main">
               <a:ext uri="{FF2B5EF4-FFF2-40B4-BE49-F238E27FC236}">
-                <a16:creationId xmlns:a16="http://schemas.microsoft.com/office/drawing/2014/main" id="{9965107F-4D0A-4BB7-81C8-897A7AE11CB9}"/>
+                <a16:creationId xmlns:a16="http://schemas.microsoft.com/office/drawing/2014/main" id="{5EBAB742-66D2-40FE-812B-D550ED6B5168}"/>
               </a:ext>
             </a:extLst>
           </p:cNvPr>
@@ -8535,7 +8535,7 @@
           <p:cNvPr id="8" name="">
             <a:extLst xmlns:a="http://schemas.openxmlformats.org/drawingml/2006/main">
               <a:ext uri="{FF2B5EF4-FFF2-40B4-BE49-F238E27FC236}">
-                <a16:creationId xmlns:a16="http://schemas.microsoft.com/office/drawing/2014/main" id="{7F2DCFF0-60A0-4A76-BD55-DCB2A21FBBFD}"/>
+                <a16:creationId xmlns:a16="http://schemas.microsoft.com/office/drawing/2014/main" id="{40C9752C-355A-48AF-9939-8F0B4BB563EC}"/>
               </a:ext>
             </a:extLst>
           </p:cNvPr>
@@ -8592,7 +8592,7 @@
           <p:cNvPr id="9" name="">
             <a:extLst xmlns:a="http://schemas.openxmlformats.org/drawingml/2006/main">
               <a:ext uri="{FF2B5EF4-FFF2-40B4-BE49-F238E27FC236}">
-                <a16:creationId xmlns:a16="http://schemas.microsoft.com/office/drawing/2014/main" id="{3705F813-23D0-45CA-918C-BD5024ABF2A4}"/>
+                <a16:creationId xmlns:a16="http://schemas.microsoft.com/office/drawing/2014/main" id="{3E6D71FF-3431-44F6-9ADD-3CA05303D542}"/>
               </a:ext>
             </a:extLst>
           </p:cNvPr>
@@ -8649,7 +8649,7 @@
           <p:cNvPr id="10" name="">
             <a:extLst xmlns:a="http://schemas.openxmlformats.org/drawingml/2006/main">
               <a:ext uri="{FF2B5EF4-FFF2-40B4-BE49-F238E27FC236}">
-                <a16:creationId xmlns:a16="http://schemas.microsoft.com/office/drawing/2014/main" id="{7257C432-F691-4B49-B36E-5A775E7C92EF}"/>
+                <a16:creationId xmlns:a16="http://schemas.microsoft.com/office/drawing/2014/main" id="{711BA45E-4974-4764-B718-9BCB44C6BDA8}"/>
               </a:ext>
             </a:extLst>
           </p:cNvPr>
@@ -8696,7 +8696,7 @@
                 <a:ea typeface="Bitstream Charter"/>
                 <a:cs typeface="Bitstream Charter"/>
               </a:rPr>
-              <a:t>Group persistent flags, have an analyst investigate, and retain inputs, code revision, model run and disposition.</a:t>
+              <a:t>Group persistent flags into a pending review list. A pilot would add analyst investigation and recorded dispositions.</a:t>
             </a:r>
           </a:p>
         </p:txBody>
@@ -8704,7 +8704,7 @@
     </p:spTree>
     <p:extLst>
       <p:ext uri="{BB962C8B-B14F-4D97-AF65-F5344CB8AC3E}">
-        <p14:creationId xmlns:p14="http://schemas.microsoft.com/office/powerpoint/2010/main" val="766019583"/>
+        <p14:creationId xmlns:p14="http://schemas.microsoft.com/office/powerpoint/2010/main" val="870971791"/>
       </p:ext>
     </p:extLst>
   </p:cSld>
@@ -8735,7 +8735,7 @@
           <p:cNvPr id="9" name="">
             <a:extLst xmlns:a="http://schemas.openxmlformats.org/drawingml/2006/main">
               <a:ext uri="{FF2B5EF4-FFF2-40B4-BE49-F238E27FC236}">
-                <a16:creationId xmlns:a16="http://schemas.microsoft.com/office/drawing/2014/main" id="{59110116-C358-41D1-94F5-2A0C342D2173}"/>
+                <a16:creationId xmlns:a16="http://schemas.microsoft.com/office/drawing/2014/main" id="{AFCFFB30-4AF8-41DA-A714-E8AE69CCC9AC}"/>
               </a:ext>
             </a:extLst>
           </p:cNvPr>
@@ -8792,7 +8792,7 @@
           <p:cNvPr id="2" name="">
             <a:extLst xmlns:a="http://schemas.openxmlformats.org/drawingml/2006/main">
               <a:ext uri="{FF2B5EF4-FFF2-40B4-BE49-F238E27FC236}">
-                <a16:creationId xmlns:a16="http://schemas.microsoft.com/office/drawing/2014/main" id="{CD14FBC1-5660-4C72-82E3-D00D36A9F1C4}"/>
+                <a16:creationId xmlns:a16="http://schemas.microsoft.com/office/drawing/2014/main" id="{1E871B35-73D5-4D3D-AEA6-EF6C395FB42A}"/>
               </a:ext>
             </a:extLst>
           </p:cNvPr>
@@ -8849,7 +8849,7 @@
           <p:cNvPr id="3" name="">
             <a:extLst xmlns:a="http://schemas.openxmlformats.org/drawingml/2006/main">
               <a:ext uri="{FF2B5EF4-FFF2-40B4-BE49-F238E27FC236}">
-                <a16:creationId xmlns:a16="http://schemas.microsoft.com/office/drawing/2014/main" id="{A905E1BF-E2D6-4A34-B7D6-135166A0DA55}"/>
+                <a16:creationId xmlns:a16="http://schemas.microsoft.com/office/drawing/2014/main" id="{0967759C-F403-490D-9410-9C83BC084D28}"/>
               </a:ext>
             </a:extLst>
           </p:cNvPr>
@@ -8906,7 +8906,7 @@
           <p:cNvPr id="4" name="">
             <a:extLst xmlns:a="http://schemas.openxmlformats.org/drawingml/2006/main">
               <a:ext uri="{FF2B5EF4-FFF2-40B4-BE49-F238E27FC236}">
-                <a16:creationId xmlns:a16="http://schemas.microsoft.com/office/drawing/2014/main" id="{127106E0-F816-4AB8-A34D-606F1FEF87B3}"/>
+                <a16:creationId xmlns:a16="http://schemas.microsoft.com/office/drawing/2014/main" id="{D9CB539D-67F9-4594-979A-4A1BE29314DA}"/>
               </a:ext>
             </a:extLst>
           </p:cNvPr>
@@ -8963,7 +8963,7 @@
           <p:cNvPr id="5" name="">
             <a:extLst xmlns:a="http://schemas.openxmlformats.org/drawingml/2006/main">
               <a:ext uri="{FF2B5EF4-FFF2-40B4-BE49-F238E27FC236}">
-                <a16:creationId xmlns:a16="http://schemas.microsoft.com/office/drawing/2014/main" id="{667C1AEB-C65B-402C-9E69-1AF3EF1F86C4}"/>
+                <a16:creationId xmlns:a16="http://schemas.microsoft.com/office/drawing/2014/main" id="{8CC48D48-28E9-4910-81CE-DE6CAB65380D}"/>
               </a:ext>
             </a:extLst>
           </p:cNvPr>
@@ -9020,7 +9020,7 @@
           <p:cNvPr id="6" name="">
             <a:extLst xmlns:a="http://schemas.openxmlformats.org/drawingml/2006/main">
               <a:ext uri="{FF2B5EF4-FFF2-40B4-BE49-F238E27FC236}">
-                <a16:creationId xmlns:a16="http://schemas.microsoft.com/office/drawing/2014/main" id="{12B82B84-AD3A-4971-A32C-5976970BFA2B}"/>
+                <a16:creationId xmlns:a16="http://schemas.microsoft.com/office/drawing/2014/main" id="{9FC974AD-BF0B-4456-9576-665EE1CDAE8E}"/>
               </a:ext>
             </a:extLst>
           </p:cNvPr>
@@ -9077,7 +9077,7 @@
           <p:cNvPr id="7" name="">
             <a:extLst xmlns:a="http://schemas.openxmlformats.org/drawingml/2006/main">
               <a:ext uri="{FF2B5EF4-FFF2-40B4-BE49-F238E27FC236}">
-                <a16:creationId xmlns:a16="http://schemas.microsoft.com/office/drawing/2014/main" id="{3FDC0848-FDA1-4116-9403-38524277E627}"/>
+                <a16:creationId xmlns:a16="http://schemas.microsoft.com/office/drawing/2014/main" id="{EE4FE0CB-4824-4DC5-9F1C-9655F3E7DE5C}"/>
               </a:ext>
             </a:extLst>
           </p:cNvPr>
@@ -9134,7 +9134,7 @@
           <p:cNvPr id="8" name="">
             <a:extLst xmlns:a="http://schemas.openxmlformats.org/drawingml/2006/main">
               <a:ext uri="{FF2B5EF4-FFF2-40B4-BE49-F238E27FC236}">
-                <a16:creationId xmlns:a16="http://schemas.microsoft.com/office/drawing/2014/main" id="{8083E4B6-8378-4D08-9FB2-24F90E3080CF}"/>
+                <a16:creationId xmlns:a16="http://schemas.microsoft.com/office/drawing/2014/main" id="{649FA507-65DA-4C40-A529-DE3D0D15DE7E}"/>
               </a:ext>
             </a:extLst>
           </p:cNvPr>
@@ -9189,7 +9189,7 @@
     </p:spTree>
     <p:extLst>
       <p:ext uri="{BB962C8B-B14F-4D97-AF65-F5344CB8AC3E}">
-        <p14:creationId xmlns:p14="http://schemas.microsoft.com/office/powerpoint/2010/main" val="449186518"/>
+        <p14:creationId xmlns:p14="http://schemas.microsoft.com/office/powerpoint/2010/main" val="314178886"/>
       </p:ext>
     </p:extLst>
   </p:cSld>
@@ -9220,7 +9220,7 @@
           <p:cNvPr id="9" name="">
             <a:extLst xmlns:a="http://schemas.openxmlformats.org/drawingml/2006/main">
               <a:ext uri="{FF2B5EF4-FFF2-40B4-BE49-F238E27FC236}">
-                <a16:creationId xmlns:a16="http://schemas.microsoft.com/office/drawing/2014/main" id="{88D9C51D-749A-4162-ABD2-9D18FBACF280}"/>
+                <a16:creationId xmlns:a16="http://schemas.microsoft.com/office/drawing/2014/main" id="{7080BA11-3850-4313-9ABA-D2DC2EF89833}"/>
               </a:ext>
             </a:extLst>
           </p:cNvPr>
@@ -9277,7 +9277,7 @@
           <p:cNvPr id="2" name="">
             <a:extLst xmlns:a="http://schemas.openxmlformats.org/drawingml/2006/main">
               <a:ext uri="{FF2B5EF4-FFF2-40B4-BE49-F238E27FC236}">
-                <a16:creationId xmlns:a16="http://schemas.microsoft.com/office/drawing/2014/main" id="{BA5EC808-C39E-46A4-9171-E7F57D6AF497}"/>
+                <a16:creationId xmlns:a16="http://schemas.microsoft.com/office/drawing/2014/main" id="{B0952060-AFE5-44EA-A104-8C06DB522C4A}"/>
               </a:ext>
             </a:extLst>
           </p:cNvPr>
@@ -9334,7 +9334,7 @@
           <p:cNvPr id="3" name="">
             <a:extLst xmlns:a="http://schemas.openxmlformats.org/drawingml/2006/main">
               <a:ext uri="{FF2B5EF4-FFF2-40B4-BE49-F238E27FC236}">
-                <a16:creationId xmlns:a16="http://schemas.microsoft.com/office/drawing/2014/main" id="{3DAB7E55-1626-4716-AE85-69DECE82A51B}"/>
+                <a16:creationId xmlns:a16="http://schemas.microsoft.com/office/drawing/2014/main" id="{355BB077-0A43-4589-92F1-9C47A063AF22}"/>
               </a:ext>
             </a:extLst>
           </p:cNvPr>
@@ -9391,7 +9391,7 @@
           <p:cNvPr id="4" name="">
             <a:extLst xmlns:a="http://schemas.openxmlformats.org/drawingml/2006/main">
               <a:ext uri="{FF2B5EF4-FFF2-40B4-BE49-F238E27FC236}">
-                <a16:creationId xmlns:a16="http://schemas.microsoft.com/office/drawing/2014/main" id="{4187B665-FA8E-413E-AD4B-2A5691A29C53}"/>
+                <a16:creationId xmlns:a16="http://schemas.microsoft.com/office/drawing/2014/main" id="{B1AEFF23-1E06-4B30-A70D-03873D61BC57}"/>
               </a:ext>
             </a:extLst>
           </p:cNvPr>
@@ -9448,7 +9448,7 @@
           <p:cNvPr id="5" name="">
             <a:extLst xmlns:a="http://schemas.openxmlformats.org/drawingml/2006/main">
               <a:ext uri="{FF2B5EF4-FFF2-40B4-BE49-F238E27FC236}">
-                <a16:creationId xmlns:a16="http://schemas.microsoft.com/office/drawing/2014/main" id="{99A70638-5D9E-4466-B867-F7FD6CB46C63}"/>
+                <a16:creationId xmlns:a16="http://schemas.microsoft.com/office/drawing/2014/main" id="{374B8B23-C478-4C29-8417-44B12DEED46F}"/>
               </a:ext>
             </a:extLst>
           </p:cNvPr>
@@ -9505,7 +9505,7 @@
           <p:cNvPr id="6" name="">
             <a:extLst xmlns:a="http://schemas.openxmlformats.org/drawingml/2006/main">
               <a:ext uri="{FF2B5EF4-FFF2-40B4-BE49-F238E27FC236}">
-                <a16:creationId xmlns:a16="http://schemas.microsoft.com/office/drawing/2014/main" id="{AC7EC406-6AD6-409B-B374-78A5453401A6}"/>
+                <a16:creationId xmlns:a16="http://schemas.microsoft.com/office/drawing/2014/main" id="{F9FC9817-20DA-4EFA-8BD4-D1354C982907}"/>
               </a:ext>
             </a:extLst>
           </p:cNvPr>
@@ -9562,7 +9562,7 @@
           <p:cNvPr id="7" name="">
             <a:extLst xmlns:a="http://schemas.openxmlformats.org/drawingml/2006/main">
               <a:ext uri="{FF2B5EF4-FFF2-40B4-BE49-F238E27FC236}">
-                <a16:creationId xmlns:a16="http://schemas.microsoft.com/office/drawing/2014/main" id="{4779008B-3D12-4A5B-BB2E-54D79C75DB48}"/>
+                <a16:creationId xmlns:a16="http://schemas.microsoft.com/office/drawing/2014/main" id="{F6409980-7C6D-4E3C-BB07-EF7BBD6F6AEA}"/>
               </a:ext>
             </a:extLst>
           </p:cNvPr>
@@ -9619,7 +9619,7 @@
           <p:cNvPr id="8" name="">
             <a:extLst xmlns:a="http://schemas.openxmlformats.org/drawingml/2006/main">
               <a:ext uri="{FF2B5EF4-FFF2-40B4-BE49-F238E27FC236}">
-                <a16:creationId xmlns:a16="http://schemas.microsoft.com/office/drawing/2014/main" id="{14D04B06-F486-4CCF-8165-41E29899FB87}"/>
+                <a16:creationId xmlns:a16="http://schemas.microsoft.com/office/drawing/2014/main" id="{65C04F43-60B1-4AF3-8FB9-59F6E9D1A7C0}"/>
               </a:ext>
             </a:extLst>
           </p:cNvPr>
@@ -9674,7 +9674,7 @@
     </p:spTree>
     <p:extLst>
       <p:ext uri="{BB962C8B-B14F-4D97-AF65-F5344CB8AC3E}">
-        <p14:creationId xmlns:p14="http://schemas.microsoft.com/office/powerpoint/2010/main" val="1005920024"/>
+        <p14:creationId xmlns:p14="http://schemas.microsoft.com/office/powerpoint/2010/main" val="1495623152"/>
       </p:ext>
     </p:extLst>
   </p:cSld>
@@ -9705,7 +9705,7 @@
           <p:cNvPr id="8" name="">
             <a:extLst xmlns:a="http://schemas.openxmlformats.org/drawingml/2006/main">
               <a:ext uri="{FF2B5EF4-FFF2-40B4-BE49-F238E27FC236}">
-                <a16:creationId xmlns:a16="http://schemas.microsoft.com/office/drawing/2014/main" id="{464B5A10-1288-41E9-AF16-227F5DC7694A}"/>
+                <a16:creationId xmlns:a16="http://schemas.microsoft.com/office/drawing/2014/main" id="{B5C08D4E-A379-4454-A3B3-0B1F6A0ABA98}"/>
               </a:ext>
             </a:extLst>
           </p:cNvPr>
@@ -9762,7 +9762,7 @@
           <p:cNvPr id="2" name="">
             <a:extLst xmlns:a="http://schemas.openxmlformats.org/drawingml/2006/main">
               <a:ext uri="{FF2B5EF4-FFF2-40B4-BE49-F238E27FC236}">
-                <a16:creationId xmlns:a16="http://schemas.microsoft.com/office/drawing/2014/main" id="{F9A3B518-A5CB-46D3-BD21-2219E8B0836E}"/>
+                <a16:creationId xmlns:a16="http://schemas.microsoft.com/office/drawing/2014/main" id="{95ADE7D7-4B17-49D0-8CFF-082FC4B73471}"/>
               </a:ext>
             </a:extLst>
           </p:cNvPr>
@@ -9819,7 +9819,7 @@
           <p:cNvPr id="3" name="">
             <a:extLst xmlns:a="http://schemas.openxmlformats.org/drawingml/2006/main">
               <a:ext uri="{FF2B5EF4-FFF2-40B4-BE49-F238E27FC236}">
-                <a16:creationId xmlns:a16="http://schemas.microsoft.com/office/drawing/2014/main" id="{1E99001C-2059-47A6-A160-084AFEDBD3D9}"/>
+                <a16:creationId xmlns:a16="http://schemas.microsoft.com/office/drawing/2014/main" id="{D0DFF58F-F755-4279-B279-D8F9B33A3F12}"/>
               </a:ext>
             </a:extLst>
           </p:cNvPr>
@@ -9876,7 +9876,7 @@
           <p:cNvPr id="4" name="">
             <a:extLst xmlns:a="http://schemas.openxmlformats.org/drawingml/2006/main">
               <a:ext uri="{FF2B5EF4-FFF2-40B4-BE49-F238E27FC236}">
-                <a16:creationId xmlns:a16="http://schemas.microsoft.com/office/drawing/2014/main" id="{550CDC52-F59C-4B3D-85A9-F560E9C5805C}"/>
+                <a16:creationId xmlns:a16="http://schemas.microsoft.com/office/drawing/2014/main" id="{F574C29F-9DAA-4748-BB14-721D1678AE47}"/>
               </a:ext>
             </a:extLst>
           </p:cNvPr>
@@ -9933,7 +9933,7 @@
           <p:cNvPr id="5" name="">
             <a:extLst xmlns:a="http://schemas.openxmlformats.org/drawingml/2006/main">
               <a:ext uri="{FF2B5EF4-FFF2-40B4-BE49-F238E27FC236}">
-                <a16:creationId xmlns:a16="http://schemas.microsoft.com/office/drawing/2014/main" id="{9B4C2391-CB49-474A-9D1D-3B8E87290902}"/>
+                <a16:creationId xmlns:a16="http://schemas.microsoft.com/office/drawing/2014/main" id="{1A6B397E-C683-4E3D-82CB-3637349E3F70}"/>
               </a:ext>
             </a:extLst>
           </p:cNvPr>
@@ -9997,7 +9997,7 @@
         </p:xfrm>
         <a:graphic xmlns:a="http://schemas.openxmlformats.org/drawingml/2006/main">
           <a:graphicData uri="http://schemas.openxmlformats.org/drawingml/2006/chart">
-            <c:chart xmlns:r="http://schemas.openxmlformats.org/officeDocument/2006/relationships" xmlns:c="http://schemas.openxmlformats.org/drawingml/2006/chart" r:id="R65a9fbcf2d7a4c07"/>
+            <c:chart xmlns:r="http://schemas.openxmlformats.org/officeDocument/2006/relationships" xmlns:c="http://schemas.openxmlformats.org/drawingml/2006/chart" r:id="Rf937fcb106664484"/>
           </a:graphicData>
         </a:graphic>
       </p:graphicFrame>
@@ -10006,7 +10006,7 @@
           <p:cNvPr id="7" name="">
             <a:extLst xmlns:a="http://schemas.openxmlformats.org/drawingml/2006/main">
               <a:ext uri="{FF2B5EF4-FFF2-40B4-BE49-F238E27FC236}">
-                <a16:creationId xmlns:a16="http://schemas.microsoft.com/office/drawing/2014/main" id="{73BFD6E2-4AE2-4589-A206-25EF93848626}"/>
+                <a16:creationId xmlns:a16="http://schemas.microsoft.com/office/drawing/2014/main" id="{0DD3BAA6-F21B-4898-995F-7125ADC75849}"/>
               </a:ext>
             </a:extLst>
           </p:cNvPr>
@@ -10061,7 +10061,7 @@
     </p:spTree>
     <p:extLst>
       <p:ext uri="{BB962C8B-B14F-4D97-AF65-F5344CB8AC3E}">
-        <p14:creationId xmlns:p14="http://schemas.microsoft.com/office/powerpoint/2010/main" val="544307740"/>
+        <p14:creationId xmlns:p14="http://schemas.microsoft.com/office/powerpoint/2010/main" val="1515030984"/>
       </p:ext>
     </p:extLst>
   </p:cSld>
@@ -10092,7 +10092,7 @@
           <p:cNvPr id="19" name="">
             <a:extLst xmlns:a="http://schemas.openxmlformats.org/drawingml/2006/main">
               <a:ext uri="{FF2B5EF4-FFF2-40B4-BE49-F238E27FC236}">
-                <a16:creationId xmlns:a16="http://schemas.microsoft.com/office/drawing/2014/main" id="{E1B9D80F-6174-48FB-ACCF-60C0B1B80B10}"/>
+                <a16:creationId xmlns:a16="http://schemas.microsoft.com/office/drawing/2014/main" id="{29085843-1FF2-4117-BD7F-93FBA285F11A}"/>
               </a:ext>
             </a:extLst>
           </p:cNvPr>
@@ -10149,7 +10149,7 @@
           <p:cNvPr id="2" name="">
             <a:extLst xmlns:a="http://schemas.openxmlformats.org/drawingml/2006/main">
               <a:ext uri="{FF2B5EF4-FFF2-40B4-BE49-F238E27FC236}">
-                <a16:creationId xmlns:a16="http://schemas.microsoft.com/office/drawing/2014/main" id="{199A33D9-6F23-4FF1-9B89-48D0E8845BFD}"/>
+                <a16:creationId xmlns:a16="http://schemas.microsoft.com/office/drawing/2014/main" id="{B51D1768-45B8-4E5B-91B9-CC43BFD45A99}"/>
               </a:ext>
             </a:extLst>
           </p:cNvPr>
@@ -10206,7 +10206,7 @@
           <p:cNvPr id="3" name="">
             <a:extLst xmlns:a="http://schemas.openxmlformats.org/drawingml/2006/main">
               <a:ext uri="{FF2B5EF4-FFF2-40B4-BE49-F238E27FC236}">
-                <a16:creationId xmlns:a16="http://schemas.microsoft.com/office/drawing/2014/main" id="{AE57B190-60EC-4FE7-A6D9-3E4AF3CC8761}"/>
+                <a16:creationId xmlns:a16="http://schemas.microsoft.com/office/drawing/2014/main" id="{891A4C3B-D6FD-4B78-BD43-58108577C606}"/>
               </a:ext>
             </a:extLst>
           </p:cNvPr>
@@ -10263,7 +10263,7 @@
           <p:cNvPr id="4" name="">
             <a:extLst xmlns:a="http://schemas.openxmlformats.org/drawingml/2006/main">
               <a:ext uri="{FF2B5EF4-FFF2-40B4-BE49-F238E27FC236}">
-                <a16:creationId xmlns:a16="http://schemas.microsoft.com/office/drawing/2014/main" id="{FA962D53-8D83-4496-BE52-CA9868050244}"/>
+                <a16:creationId xmlns:a16="http://schemas.microsoft.com/office/drawing/2014/main" id="{31AE9675-6125-4DF6-9ADE-E093EBA54979}"/>
               </a:ext>
             </a:extLst>
           </p:cNvPr>
@@ -10320,7 +10320,7 @@
           <p:cNvPr id="5" name="">
             <a:extLst xmlns:a="http://schemas.openxmlformats.org/drawingml/2006/main">
               <a:ext uri="{FF2B5EF4-FFF2-40B4-BE49-F238E27FC236}">
-                <a16:creationId xmlns:a16="http://schemas.microsoft.com/office/drawing/2014/main" id="{67AA2462-E928-4839-8B50-F646D4BAEBEB}"/>
+                <a16:creationId xmlns:a16="http://schemas.microsoft.com/office/drawing/2014/main" id="{4C6EA42C-BA27-4656-86A5-5680ED9292D7}"/>
               </a:ext>
             </a:extLst>
           </p:cNvPr>
@@ -10377,7 +10377,7 @@
           <p:cNvPr id="6" name="">
             <a:extLst xmlns:a="http://schemas.openxmlformats.org/drawingml/2006/main">
               <a:ext uri="{FF2B5EF4-FFF2-40B4-BE49-F238E27FC236}">
-                <a16:creationId xmlns:a16="http://schemas.microsoft.com/office/drawing/2014/main" id="{8BBB05E4-171C-4F67-AA64-50F84697611D}"/>
+                <a16:creationId xmlns:a16="http://schemas.microsoft.com/office/drawing/2014/main" id="{B49964E4-9168-442C-ABFD-E99B24256936}"/>
               </a:ext>
             </a:extLst>
           </p:cNvPr>
@@ -10434,7 +10434,7 @@
           <p:cNvPr id="7" name="">
             <a:extLst xmlns:a="http://schemas.openxmlformats.org/drawingml/2006/main">
               <a:ext uri="{FF2B5EF4-FFF2-40B4-BE49-F238E27FC236}">
-                <a16:creationId xmlns:a16="http://schemas.microsoft.com/office/drawing/2014/main" id="{C0843D92-A28A-4C00-8F41-9B58EE268C4B}"/>
+                <a16:creationId xmlns:a16="http://schemas.microsoft.com/office/drawing/2014/main" id="{9EBC71F1-8AED-4DAD-9287-C67EFCB88957}"/>
               </a:ext>
             </a:extLst>
           </p:cNvPr>
@@ -10491,7 +10491,7 @@
           <p:cNvPr id="8" name="">
             <a:extLst xmlns:a="http://schemas.openxmlformats.org/drawingml/2006/main">
               <a:ext uri="{FF2B5EF4-FFF2-40B4-BE49-F238E27FC236}">
-                <a16:creationId xmlns:a16="http://schemas.microsoft.com/office/drawing/2014/main" id="{2A0AAC9A-6384-4606-8C5A-3748EDED9E18}"/>
+                <a16:creationId xmlns:a16="http://schemas.microsoft.com/office/drawing/2014/main" id="{BE2C052D-E2DA-47AC-BD92-4DC9EAD6BCAE}"/>
               </a:ext>
             </a:extLst>
           </p:cNvPr>
@@ -10548,7 +10548,7 @@
           <p:cNvPr id="9" name="">
             <a:extLst xmlns:a="http://schemas.openxmlformats.org/drawingml/2006/main">
               <a:ext uri="{FF2B5EF4-FFF2-40B4-BE49-F238E27FC236}">
-                <a16:creationId xmlns:a16="http://schemas.microsoft.com/office/drawing/2014/main" id="{24E17604-613F-4FCB-95B4-1A11242A8A10}"/>
+                <a16:creationId xmlns:a16="http://schemas.microsoft.com/office/drawing/2014/main" id="{B221EFCA-6DF3-4A78-BF1A-AF756B6E6945}"/>
               </a:ext>
             </a:extLst>
           </p:cNvPr>
@@ -10605,7 +10605,7 @@
           <p:cNvPr id="10" name="">
             <a:extLst xmlns:a="http://schemas.openxmlformats.org/drawingml/2006/main">
               <a:ext uri="{FF2B5EF4-FFF2-40B4-BE49-F238E27FC236}">
-                <a16:creationId xmlns:a16="http://schemas.microsoft.com/office/drawing/2014/main" id="{16500989-3B6C-4B58-8E51-36CC5E37E313}"/>
+                <a16:creationId xmlns:a16="http://schemas.microsoft.com/office/drawing/2014/main" id="{F8F56783-2637-4414-92C3-45F24EB71160}"/>
               </a:ext>
             </a:extLst>
           </p:cNvPr>
@@ -10662,7 +10662,7 @@
           <p:cNvPr id="11" name="">
             <a:extLst xmlns:a="http://schemas.openxmlformats.org/drawingml/2006/main">
               <a:ext uri="{FF2B5EF4-FFF2-40B4-BE49-F238E27FC236}">
-                <a16:creationId xmlns:a16="http://schemas.microsoft.com/office/drawing/2014/main" id="{5387F153-ABFD-4726-8D5A-085C803EC6BF}"/>
+                <a16:creationId xmlns:a16="http://schemas.microsoft.com/office/drawing/2014/main" id="{94CE033C-89D6-40A2-9766-AB32E4AFF2C1}"/>
               </a:ext>
             </a:extLst>
           </p:cNvPr>
@@ -10719,7 +10719,7 @@
           <p:cNvPr id="12" name="">
             <a:extLst xmlns:a="http://schemas.openxmlformats.org/drawingml/2006/main">
               <a:ext uri="{FF2B5EF4-FFF2-40B4-BE49-F238E27FC236}">
-                <a16:creationId xmlns:a16="http://schemas.microsoft.com/office/drawing/2014/main" id="{39E502A0-523D-4647-B9B9-09DD2F86A78E}"/>
+                <a16:creationId xmlns:a16="http://schemas.microsoft.com/office/drawing/2014/main" id="{9929E120-C998-481E-A1C4-2427BFBB3AB6}"/>
               </a:ext>
             </a:extLst>
           </p:cNvPr>
@@ -10776,7 +10776,7 @@
           <p:cNvPr id="13" name="">
             <a:extLst xmlns:a="http://schemas.openxmlformats.org/drawingml/2006/main">
               <a:ext uri="{FF2B5EF4-FFF2-40B4-BE49-F238E27FC236}">
-                <a16:creationId xmlns:a16="http://schemas.microsoft.com/office/drawing/2014/main" id="{747AF3F8-CB4F-4941-9D62-7CA01550F6AF}"/>
+                <a16:creationId xmlns:a16="http://schemas.microsoft.com/office/drawing/2014/main" id="{4E0EE196-5455-4C7C-8002-06F6AE3BC2FC}"/>
               </a:ext>
             </a:extLst>
           </p:cNvPr>
@@ -10833,7 +10833,7 @@
           <p:cNvPr id="14" name="">
             <a:extLst xmlns:a="http://schemas.openxmlformats.org/drawingml/2006/main">
               <a:ext uri="{FF2B5EF4-FFF2-40B4-BE49-F238E27FC236}">
-                <a16:creationId xmlns:a16="http://schemas.microsoft.com/office/drawing/2014/main" id="{7FCCDD36-5285-448A-86EB-E2EBCBAC92EC}"/>
+                <a16:creationId xmlns:a16="http://schemas.microsoft.com/office/drawing/2014/main" id="{3AADE749-1D7D-42ED-9E1B-EA7E26A7E6D4}"/>
               </a:ext>
             </a:extLst>
           </p:cNvPr>
@@ -10890,7 +10890,7 @@
           <p:cNvPr id="15" name="">
             <a:extLst xmlns:a="http://schemas.openxmlformats.org/drawingml/2006/main">
               <a:ext uri="{FF2B5EF4-FFF2-40B4-BE49-F238E27FC236}">
-                <a16:creationId xmlns:a16="http://schemas.microsoft.com/office/drawing/2014/main" id="{826DE8B5-3EA2-4C87-99A9-BDA49CA023FC}"/>
+                <a16:creationId xmlns:a16="http://schemas.microsoft.com/office/drawing/2014/main" id="{07DEB484-D09C-45C5-85C5-E534AF3E8799}"/>
               </a:ext>
             </a:extLst>
           </p:cNvPr>
@@ -10947,7 +10947,7 @@
           <p:cNvPr id="16" name="">
             <a:extLst xmlns:a="http://schemas.openxmlformats.org/drawingml/2006/main">
               <a:ext uri="{FF2B5EF4-FFF2-40B4-BE49-F238E27FC236}">
-                <a16:creationId xmlns:a16="http://schemas.microsoft.com/office/drawing/2014/main" id="{CEB9D3B6-9CCA-407D-9A7E-874B10782540}"/>
+                <a16:creationId xmlns:a16="http://schemas.microsoft.com/office/drawing/2014/main" id="{C783FD9E-CA54-4064-BDD0-E54249F2A383}"/>
               </a:ext>
             </a:extLst>
           </p:cNvPr>
@@ -11004,7 +11004,7 @@
           <p:cNvPr id="17" name="">
             <a:extLst xmlns:a="http://schemas.openxmlformats.org/drawingml/2006/main">
               <a:ext uri="{FF2B5EF4-FFF2-40B4-BE49-F238E27FC236}">
-                <a16:creationId xmlns:a16="http://schemas.microsoft.com/office/drawing/2014/main" id="{6014E249-0BA3-4258-8252-B09C0AAF70F7}"/>
+                <a16:creationId xmlns:a16="http://schemas.microsoft.com/office/drawing/2014/main" id="{E1972C7B-5E03-4DFF-999F-F6B840799336}"/>
               </a:ext>
             </a:extLst>
           </p:cNvPr>
@@ -11061,7 +11061,7 @@
           <p:cNvPr id="18" name="">
             <a:extLst xmlns:a="http://schemas.openxmlformats.org/drawingml/2006/main">
               <a:ext uri="{FF2B5EF4-FFF2-40B4-BE49-F238E27FC236}">
-                <a16:creationId xmlns:a16="http://schemas.microsoft.com/office/drawing/2014/main" id="{472C9A00-53ED-40B3-9354-2516AF29A43D}"/>
+                <a16:creationId xmlns:a16="http://schemas.microsoft.com/office/drawing/2014/main" id="{D5DD00BF-D1C8-4720-B7E0-F5289ACEA1D0}"/>
               </a:ext>
             </a:extLst>
           </p:cNvPr>
@@ -11116,7 +11116,7 @@
     </p:spTree>
     <p:extLst>
       <p:ext uri="{BB962C8B-B14F-4D97-AF65-F5344CB8AC3E}">
-        <p14:creationId xmlns:p14="http://schemas.microsoft.com/office/powerpoint/2010/main" val="681690130"/>
+        <p14:creationId xmlns:p14="http://schemas.microsoft.com/office/powerpoint/2010/main" val="559298773"/>
       </p:ext>
     </p:extLst>
   </p:cSld>
@@ -11147,7 +11147,7 @@
           <p:cNvPr id="19" name="">
             <a:extLst xmlns:a="http://schemas.openxmlformats.org/drawingml/2006/main">
               <a:ext uri="{FF2B5EF4-FFF2-40B4-BE49-F238E27FC236}">
-                <a16:creationId xmlns:a16="http://schemas.microsoft.com/office/drawing/2014/main" id="{F0FC4AA7-71EB-4FBB-BB58-5437907213DA}"/>
+                <a16:creationId xmlns:a16="http://schemas.microsoft.com/office/drawing/2014/main" id="{A76A0B15-1961-4A4C-8BA7-14DBB11EE22A}"/>
               </a:ext>
             </a:extLst>
           </p:cNvPr>
@@ -11204,7 +11204,7 @@
           <p:cNvPr id="2" name="">
             <a:extLst xmlns:a="http://schemas.openxmlformats.org/drawingml/2006/main">
               <a:ext uri="{FF2B5EF4-FFF2-40B4-BE49-F238E27FC236}">
-                <a16:creationId xmlns:a16="http://schemas.microsoft.com/office/drawing/2014/main" id="{44C252AE-2A34-4705-9B25-4376B029F0F1}"/>
+                <a16:creationId xmlns:a16="http://schemas.microsoft.com/office/drawing/2014/main" id="{C25BB302-D848-47BB-9210-7DA6F597F75B}"/>
               </a:ext>
             </a:extLst>
           </p:cNvPr>
@@ -11261,7 +11261,7 @@
           <p:cNvPr id="3" name="">
             <a:extLst xmlns:a="http://schemas.openxmlformats.org/drawingml/2006/main">
               <a:ext uri="{FF2B5EF4-FFF2-40B4-BE49-F238E27FC236}">
-                <a16:creationId xmlns:a16="http://schemas.microsoft.com/office/drawing/2014/main" id="{2128A2E7-E439-4CB2-9951-2F22123846B7}"/>
+                <a16:creationId xmlns:a16="http://schemas.microsoft.com/office/drawing/2014/main" id="{24A32B5E-4941-4A1A-BCB3-8E0ED46E8C94}"/>
               </a:ext>
             </a:extLst>
           </p:cNvPr>
@@ -11318,7 +11318,7 @@
           <p:cNvPr id="4" name="">
             <a:extLst xmlns:a="http://schemas.openxmlformats.org/drawingml/2006/main">
               <a:ext uri="{FF2B5EF4-FFF2-40B4-BE49-F238E27FC236}">
-                <a16:creationId xmlns:a16="http://schemas.microsoft.com/office/drawing/2014/main" id="{F4474FFD-4167-404F-98B4-DFA7C4D42BA9}"/>
+                <a16:creationId xmlns:a16="http://schemas.microsoft.com/office/drawing/2014/main" id="{C15836D5-474F-4DD2-9B31-7441C6342563}"/>
               </a:ext>
             </a:extLst>
           </p:cNvPr>
@@ -11375,7 +11375,7 @@
           <p:cNvPr id="5" name="">
             <a:extLst xmlns:a="http://schemas.openxmlformats.org/drawingml/2006/main">
               <a:ext uri="{FF2B5EF4-FFF2-40B4-BE49-F238E27FC236}">
-                <a16:creationId xmlns:a16="http://schemas.microsoft.com/office/drawing/2014/main" id="{45668A52-5EAA-4EF8-B89A-922FAA97C383}"/>
+                <a16:creationId xmlns:a16="http://schemas.microsoft.com/office/drawing/2014/main" id="{BF86FF6B-2ED8-4674-A2A9-67E6F1CA9137}"/>
               </a:ext>
             </a:extLst>
           </p:cNvPr>
@@ -11432,7 +11432,7 @@
           <p:cNvPr id="6" name="">
             <a:extLst xmlns:a="http://schemas.openxmlformats.org/drawingml/2006/main">
               <a:ext uri="{FF2B5EF4-FFF2-40B4-BE49-F238E27FC236}">
-                <a16:creationId xmlns:a16="http://schemas.microsoft.com/office/drawing/2014/main" id="{DF908BF8-5AFB-49A2-908D-889F424F647D}"/>
+                <a16:creationId xmlns:a16="http://schemas.microsoft.com/office/drawing/2014/main" id="{9611A019-D945-4F91-A082-5D586C99DCBF}"/>
               </a:ext>
             </a:extLst>
           </p:cNvPr>
@@ -11489,7 +11489,7 @@
           <p:cNvPr id="7" name="">
             <a:extLst xmlns:a="http://schemas.openxmlformats.org/drawingml/2006/main">
               <a:ext uri="{FF2B5EF4-FFF2-40B4-BE49-F238E27FC236}">
-                <a16:creationId xmlns:a16="http://schemas.microsoft.com/office/drawing/2014/main" id="{2E30175C-1E81-465E-9E4F-59E62D23955F}"/>
+                <a16:creationId xmlns:a16="http://schemas.microsoft.com/office/drawing/2014/main" id="{16F22151-6334-418C-8AEF-6B0E6C5D51DF}"/>
               </a:ext>
             </a:extLst>
           </p:cNvPr>
@@ -11546,7 +11546,7 @@
           <p:cNvPr id="8" name="">
             <a:extLst xmlns:a="http://schemas.openxmlformats.org/drawingml/2006/main">
               <a:ext uri="{FF2B5EF4-FFF2-40B4-BE49-F238E27FC236}">
-                <a16:creationId xmlns:a16="http://schemas.microsoft.com/office/drawing/2014/main" id="{7364F3D2-264D-4099-8964-EAB5A146AB6D}"/>
+                <a16:creationId xmlns:a16="http://schemas.microsoft.com/office/drawing/2014/main" id="{406DD0F5-B40F-4EDF-84C1-0ABDD4D921EE}"/>
               </a:ext>
             </a:extLst>
           </p:cNvPr>
@@ -11603,7 +11603,7 @@
           <p:cNvPr id="9" name="">
             <a:extLst xmlns:a="http://schemas.openxmlformats.org/drawingml/2006/main">
               <a:ext uri="{FF2B5EF4-FFF2-40B4-BE49-F238E27FC236}">
-                <a16:creationId xmlns:a16="http://schemas.microsoft.com/office/drawing/2014/main" id="{440BF71A-CB88-498F-8721-8E43559C9026}"/>
+                <a16:creationId xmlns:a16="http://schemas.microsoft.com/office/drawing/2014/main" id="{89E4342C-94D3-484E-B1E2-AE425D1A692D}"/>
               </a:ext>
             </a:extLst>
           </p:cNvPr>
@@ -11660,7 +11660,7 @@
           <p:cNvPr id="10" name="">
             <a:extLst xmlns:a="http://schemas.openxmlformats.org/drawingml/2006/main">
               <a:ext uri="{FF2B5EF4-FFF2-40B4-BE49-F238E27FC236}">
-                <a16:creationId xmlns:a16="http://schemas.microsoft.com/office/drawing/2014/main" id="{A22E3A94-07B6-42B4-9FD0-2F4D0C2CCB8F}"/>
+                <a16:creationId xmlns:a16="http://schemas.microsoft.com/office/drawing/2014/main" id="{F2EBEAD9-9CA6-4116-8D54-BD55D2833381}"/>
               </a:ext>
             </a:extLst>
           </p:cNvPr>
@@ -11717,7 +11717,7 @@
           <p:cNvPr id="11" name="">
             <a:extLst xmlns:a="http://schemas.openxmlformats.org/drawingml/2006/main">
               <a:ext uri="{FF2B5EF4-FFF2-40B4-BE49-F238E27FC236}">
-                <a16:creationId xmlns:a16="http://schemas.microsoft.com/office/drawing/2014/main" id="{3240947E-04C7-4913-A8A0-1DA6405EB389}"/>
+                <a16:creationId xmlns:a16="http://schemas.microsoft.com/office/drawing/2014/main" id="{76259CFF-A9A2-4B89-874D-3E67471862BC}"/>
               </a:ext>
             </a:extLst>
           </p:cNvPr>
@@ -11774,7 +11774,7 @@
           <p:cNvPr id="12" name="">
             <a:extLst xmlns:a="http://schemas.openxmlformats.org/drawingml/2006/main">
               <a:ext uri="{FF2B5EF4-FFF2-40B4-BE49-F238E27FC236}">
-                <a16:creationId xmlns:a16="http://schemas.microsoft.com/office/drawing/2014/main" id="{3A582CB9-20AD-4EF8-BE0E-C99F27F336A6}"/>
+                <a16:creationId xmlns:a16="http://schemas.microsoft.com/office/drawing/2014/main" id="{72098B1C-6781-49EF-9525-615D5D5D167E}"/>
               </a:ext>
             </a:extLst>
           </p:cNvPr>
@@ -11831,7 +11831,7 @@
           <p:cNvPr id="13" name="">
             <a:extLst xmlns:a="http://schemas.openxmlformats.org/drawingml/2006/main">
               <a:ext uri="{FF2B5EF4-FFF2-40B4-BE49-F238E27FC236}">
-                <a16:creationId xmlns:a16="http://schemas.microsoft.com/office/drawing/2014/main" id="{B81C8ACD-F24E-410C-B0D4-30F6216144A1}"/>
+                <a16:creationId xmlns:a16="http://schemas.microsoft.com/office/drawing/2014/main" id="{82128F5C-8540-46A6-A2B4-962772AF7115}"/>
               </a:ext>
             </a:extLst>
           </p:cNvPr>
@@ -11888,7 +11888,7 @@
           <p:cNvPr id="14" name="">
             <a:extLst xmlns:a="http://schemas.openxmlformats.org/drawingml/2006/main">
               <a:ext uri="{FF2B5EF4-FFF2-40B4-BE49-F238E27FC236}">
-                <a16:creationId xmlns:a16="http://schemas.microsoft.com/office/drawing/2014/main" id="{8275172B-9D0D-4518-B4EF-BFC419961E21}"/>
+                <a16:creationId xmlns:a16="http://schemas.microsoft.com/office/drawing/2014/main" id="{A9212560-D82D-4416-9B48-BF9E53E9FFBE}"/>
               </a:ext>
             </a:extLst>
           </p:cNvPr>
@@ -11945,7 +11945,7 @@
           <p:cNvPr id="15" name="">
             <a:extLst xmlns:a="http://schemas.openxmlformats.org/drawingml/2006/main">
               <a:ext uri="{FF2B5EF4-FFF2-40B4-BE49-F238E27FC236}">
-                <a16:creationId xmlns:a16="http://schemas.microsoft.com/office/drawing/2014/main" id="{876FAE01-4D99-44E2-8CDA-7972404FBF09}"/>
+                <a16:creationId xmlns:a16="http://schemas.microsoft.com/office/drawing/2014/main" id="{FEB2F7E1-2055-4B3D-9DCE-C52635AD69E2}"/>
               </a:ext>
             </a:extLst>
           </p:cNvPr>
@@ -12002,7 +12002,7 @@
           <p:cNvPr id="16" name="">
             <a:extLst xmlns:a="http://schemas.openxmlformats.org/drawingml/2006/main">
               <a:ext uri="{FF2B5EF4-FFF2-40B4-BE49-F238E27FC236}">
-                <a16:creationId xmlns:a16="http://schemas.microsoft.com/office/drawing/2014/main" id="{549617E3-7ADC-43EC-9CF2-D287A15F921A}"/>
+                <a16:creationId xmlns:a16="http://schemas.microsoft.com/office/drawing/2014/main" id="{816D68A3-EFD1-489B-B8BA-E6DD687C389D}"/>
               </a:ext>
             </a:extLst>
           </p:cNvPr>
@@ -12059,7 +12059,7 @@
           <p:cNvPr id="17" name="">
             <a:extLst xmlns:a="http://schemas.openxmlformats.org/drawingml/2006/main">
               <a:ext uri="{FF2B5EF4-FFF2-40B4-BE49-F238E27FC236}">
-                <a16:creationId xmlns:a16="http://schemas.microsoft.com/office/drawing/2014/main" id="{A7169991-58AB-4D71-988F-DAB26CAAF456}"/>
+                <a16:creationId xmlns:a16="http://schemas.microsoft.com/office/drawing/2014/main" id="{31314363-417C-4CCF-8E9C-85DFADEC17FC}"/>
               </a:ext>
             </a:extLst>
           </p:cNvPr>
@@ -12116,7 +12116,7 @@
           <p:cNvPr id="18" name="">
             <a:extLst xmlns:a="http://schemas.openxmlformats.org/drawingml/2006/main">
               <a:ext uri="{FF2B5EF4-FFF2-40B4-BE49-F238E27FC236}">
-                <a16:creationId xmlns:a16="http://schemas.microsoft.com/office/drawing/2014/main" id="{B59A2645-A0FB-4E9A-95B3-A2407E6E37F0}"/>
+                <a16:creationId xmlns:a16="http://schemas.microsoft.com/office/drawing/2014/main" id="{21F6F212-DBA8-4AF4-A3DA-451339C0AE00}"/>
               </a:ext>
             </a:extLst>
           </p:cNvPr>
@@ -12171,7 +12171,7 @@
     </p:spTree>
     <p:extLst>
       <p:ext uri="{BB962C8B-B14F-4D97-AF65-F5344CB8AC3E}">
-        <p14:creationId xmlns:p14="http://schemas.microsoft.com/office/powerpoint/2010/main" val="676694133"/>
+        <p14:creationId xmlns:p14="http://schemas.microsoft.com/office/powerpoint/2010/main" val="2070173445"/>
       </p:ext>
     </p:extLst>
   </p:cSld>
@@ -12202,7 +12202,7 @@
           <p:cNvPr id="9" name="">
             <a:extLst xmlns:a="http://schemas.openxmlformats.org/drawingml/2006/main">
               <a:ext uri="{FF2B5EF4-FFF2-40B4-BE49-F238E27FC236}">
-                <a16:creationId xmlns:a16="http://schemas.microsoft.com/office/drawing/2014/main" id="{00631776-8C9F-4EBD-A3FA-C526D3EE9961}"/>
+                <a16:creationId xmlns:a16="http://schemas.microsoft.com/office/drawing/2014/main" id="{01F9FF6D-0D8B-4762-B10C-906ABA3BE235}"/>
               </a:ext>
             </a:extLst>
           </p:cNvPr>
@@ -12259,7 +12259,7 @@
           <p:cNvPr id="2" name="">
             <a:extLst xmlns:a="http://schemas.openxmlformats.org/drawingml/2006/main">
               <a:ext uri="{FF2B5EF4-FFF2-40B4-BE49-F238E27FC236}">
-                <a16:creationId xmlns:a16="http://schemas.microsoft.com/office/drawing/2014/main" id="{D92D5E9D-D30C-4D76-AEE2-CD5A8A78CF72}"/>
+                <a16:creationId xmlns:a16="http://schemas.microsoft.com/office/drawing/2014/main" id="{EF351708-3BAB-4BBE-BBDC-881BAAA9AF8B}"/>
               </a:ext>
             </a:extLst>
           </p:cNvPr>
@@ -12316,7 +12316,7 @@
           <p:cNvPr id="3" name="">
             <a:extLst xmlns:a="http://schemas.openxmlformats.org/drawingml/2006/main">
               <a:ext uri="{FF2B5EF4-FFF2-40B4-BE49-F238E27FC236}">
-                <a16:creationId xmlns:a16="http://schemas.microsoft.com/office/drawing/2014/main" id="{6F5874A4-09E7-49E1-9D51-23FD695767E6}"/>
+                <a16:creationId xmlns:a16="http://schemas.microsoft.com/office/drawing/2014/main" id="{40770B68-7303-403B-BEC1-4B801F4C3C22}"/>
               </a:ext>
             </a:extLst>
           </p:cNvPr>
@@ -12373,7 +12373,7 @@
           <p:cNvPr id="4" name="">
             <a:extLst xmlns:a="http://schemas.openxmlformats.org/drawingml/2006/main">
               <a:ext uri="{FF2B5EF4-FFF2-40B4-BE49-F238E27FC236}">
-                <a16:creationId xmlns:a16="http://schemas.microsoft.com/office/drawing/2014/main" id="{FD269523-16A4-4185-B273-52EB8DC45947}"/>
+                <a16:creationId xmlns:a16="http://schemas.microsoft.com/office/drawing/2014/main" id="{FB2C0B80-96F7-4B54-92AC-A88CE3CCC85E}"/>
               </a:ext>
             </a:extLst>
           </p:cNvPr>
@@ -12430,7 +12430,7 @@
           <p:cNvPr id="5" name="">
             <a:extLst xmlns:a="http://schemas.openxmlformats.org/drawingml/2006/main">
               <a:ext uri="{FF2B5EF4-FFF2-40B4-BE49-F238E27FC236}">
-                <a16:creationId xmlns:a16="http://schemas.microsoft.com/office/drawing/2014/main" id="{CD13EEB4-3B46-475A-8E7B-F41B2753FE8D}"/>
+                <a16:creationId xmlns:a16="http://schemas.microsoft.com/office/drawing/2014/main" id="{6B27188F-75C2-411A-8552-7D971490ED8F}"/>
               </a:ext>
             </a:extLst>
           </p:cNvPr>
@@ -12487,7 +12487,7 @@
           <p:cNvPr id="6" name="">
             <a:extLst xmlns:a="http://schemas.openxmlformats.org/drawingml/2006/main">
               <a:ext uri="{FF2B5EF4-FFF2-40B4-BE49-F238E27FC236}">
-                <a16:creationId xmlns:a16="http://schemas.microsoft.com/office/drawing/2014/main" id="{1B27A721-7F3C-4465-856C-3DDC43DFBC18}"/>
+                <a16:creationId xmlns:a16="http://schemas.microsoft.com/office/drawing/2014/main" id="{C4C3A1F7-DDD5-4A3A-BEBF-CFD99F412624}"/>
               </a:ext>
             </a:extLst>
           </p:cNvPr>
@@ -12544,7 +12544,7 @@
           <p:cNvPr id="7" name="">
             <a:extLst xmlns:a="http://schemas.openxmlformats.org/drawingml/2006/main">
               <a:ext uri="{FF2B5EF4-FFF2-40B4-BE49-F238E27FC236}">
-                <a16:creationId xmlns:a16="http://schemas.microsoft.com/office/drawing/2014/main" id="{9D51EF34-A5A5-4302-89CF-CD70C634B335}"/>
+                <a16:creationId xmlns:a16="http://schemas.microsoft.com/office/drawing/2014/main" id="{1214E5D3-5652-4058-BFF3-683BADB344CB}"/>
               </a:ext>
             </a:extLst>
           </p:cNvPr>
@@ -12601,7 +12601,7 @@
           <p:cNvPr id="8" name="">
             <a:extLst xmlns:a="http://schemas.openxmlformats.org/drawingml/2006/main">
               <a:ext uri="{FF2B5EF4-FFF2-40B4-BE49-F238E27FC236}">
-                <a16:creationId xmlns:a16="http://schemas.microsoft.com/office/drawing/2014/main" id="{1F955A73-8749-4447-BBD6-5FBCF1D37606}"/>
+                <a16:creationId xmlns:a16="http://schemas.microsoft.com/office/drawing/2014/main" id="{8B27450A-69A7-499C-A7D8-91BBEA950672}"/>
               </a:ext>
             </a:extLst>
           </p:cNvPr>
@@ -12656,7 +12656,7 @@
     </p:spTree>
     <p:extLst>
       <p:ext uri="{BB962C8B-B14F-4D97-AF65-F5344CB8AC3E}">
-        <p14:creationId xmlns:p14="http://schemas.microsoft.com/office/powerpoint/2010/main" val="1683047368"/>
+        <p14:creationId xmlns:p14="http://schemas.microsoft.com/office/powerpoint/2010/main" val="477564556"/>
       </p:ext>
     </p:extLst>
   </p:cSld>
@@ -12687,7 +12687,7 @@
           <p:cNvPr id="11" name="">
             <a:extLst xmlns:a="http://schemas.openxmlformats.org/drawingml/2006/main">
               <a:ext uri="{FF2B5EF4-FFF2-40B4-BE49-F238E27FC236}">
-                <a16:creationId xmlns:a16="http://schemas.microsoft.com/office/drawing/2014/main" id="{4226536A-5BA4-4D58-946A-17F30B73D7D3}"/>
+                <a16:creationId xmlns:a16="http://schemas.microsoft.com/office/drawing/2014/main" id="{82FF83A7-4A86-4733-8987-0391DB0D4E80}"/>
               </a:ext>
             </a:extLst>
           </p:cNvPr>
@@ -12744,7 +12744,7 @@
           <p:cNvPr id="2" name="">
             <a:extLst xmlns:a="http://schemas.openxmlformats.org/drawingml/2006/main">
               <a:ext uri="{FF2B5EF4-FFF2-40B4-BE49-F238E27FC236}">
-                <a16:creationId xmlns:a16="http://schemas.microsoft.com/office/drawing/2014/main" id="{577FACDC-A533-468B-B1AE-1B04017D682F}"/>
+                <a16:creationId xmlns:a16="http://schemas.microsoft.com/office/drawing/2014/main" id="{AD00635F-160D-454C-A77F-F16B29ED4EA1}"/>
               </a:ext>
             </a:extLst>
           </p:cNvPr>
@@ -12801,7 +12801,7 @@
           <p:cNvPr id="3" name="">
             <a:extLst xmlns:a="http://schemas.openxmlformats.org/drawingml/2006/main">
               <a:ext uri="{FF2B5EF4-FFF2-40B4-BE49-F238E27FC236}">
-                <a16:creationId xmlns:a16="http://schemas.microsoft.com/office/drawing/2014/main" id="{D7150FDC-7052-426E-9888-7F89034379EA}"/>
+                <a16:creationId xmlns:a16="http://schemas.microsoft.com/office/drawing/2014/main" id="{C6F88D08-4B36-4FA7-8FEE-6C4749BF5139}"/>
               </a:ext>
             </a:extLst>
           </p:cNvPr>
@@ -12858,7 +12858,7 @@
           <p:cNvPr id="4" name="">
             <a:extLst xmlns:a="http://schemas.openxmlformats.org/drawingml/2006/main">
               <a:ext uri="{FF2B5EF4-FFF2-40B4-BE49-F238E27FC236}">
-                <a16:creationId xmlns:a16="http://schemas.microsoft.com/office/drawing/2014/main" id="{C1E13CC8-A59F-4071-AC9D-75CEFF2E02AF}"/>
+                <a16:creationId xmlns:a16="http://schemas.microsoft.com/office/drawing/2014/main" id="{B7A28C25-7B86-4156-944C-36C0B2EB4FED}"/>
               </a:ext>
             </a:extLst>
           </p:cNvPr>
@@ -12915,7 +12915,7 @@
           <p:cNvPr id="5" name="">
             <a:extLst xmlns:a="http://schemas.openxmlformats.org/drawingml/2006/main">
               <a:ext uri="{FF2B5EF4-FFF2-40B4-BE49-F238E27FC236}">
-                <a16:creationId xmlns:a16="http://schemas.microsoft.com/office/drawing/2014/main" id="{8F7B8ADC-9AEA-4978-9D78-4A7362BE8CB0}"/>
+                <a16:creationId xmlns:a16="http://schemas.microsoft.com/office/drawing/2014/main" id="{6211C571-3AAD-40CE-A39E-9DEA10576891}"/>
               </a:ext>
             </a:extLst>
           </p:cNvPr>
@@ -12972,7 +12972,7 @@
           <p:cNvPr id="6" name="">
             <a:extLst xmlns:a="http://schemas.openxmlformats.org/drawingml/2006/main">
               <a:ext uri="{FF2B5EF4-FFF2-40B4-BE49-F238E27FC236}">
-                <a16:creationId xmlns:a16="http://schemas.microsoft.com/office/drawing/2014/main" id="{F099E03C-9442-4975-8E35-287A04025BA8}"/>
+                <a16:creationId xmlns:a16="http://schemas.microsoft.com/office/drawing/2014/main" id="{413D44F5-B04F-41BE-8226-F2F8BF68493A}"/>
               </a:ext>
             </a:extLst>
           </p:cNvPr>
@@ -13029,7 +13029,7 @@
           <p:cNvPr id="7" name="">
             <a:extLst xmlns:a="http://schemas.openxmlformats.org/drawingml/2006/main">
               <a:ext uri="{FF2B5EF4-FFF2-40B4-BE49-F238E27FC236}">
-                <a16:creationId xmlns:a16="http://schemas.microsoft.com/office/drawing/2014/main" id="{F6479B5E-770B-4E39-8D40-D6FA3E17CAAB}"/>
+                <a16:creationId xmlns:a16="http://schemas.microsoft.com/office/drawing/2014/main" id="{46DA8C5A-1225-45A5-BEBD-964BC9D02401}"/>
               </a:ext>
             </a:extLst>
           </p:cNvPr>
@@ -13086,7 +13086,7 @@
           <p:cNvPr id="8" name="">
             <a:extLst xmlns:a="http://schemas.openxmlformats.org/drawingml/2006/main">
               <a:ext uri="{FF2B5EF4-FFF2-40B4-BE49-F238E27FC236}">
-                <a16:creationId xmlns:a16="http://schemas.microsoft.com/office/drawing/2014/main" id="{F634859A-1897-46BE-AA41-DE4C7669D036}"/>
+                <a16:creationId xmlns:a16="http://schemas.microsoft.com/office/drawing/2014/main" id="{8779ED53-3F39-4160-B7B9-39686AA57CEF}"/>
               </a:ext>
             </a:extLst>
           </p:cNvPr>
@@ -13143,7 +13143,7 @@
           <p:cNvPr id="9" name="">
             <a:extLst xmlns:a="http://schemas.openxmlformats.org/drawingml/2006/main">
               <a:ext uri="{FF2B5EF4-FFF2-40B4-BE49-F238E27FC236}">
-                <a16:creationId xmlns:a16="http://schemas.microsoft.com/office/drawing/2014/main" id="{5E293D84-AFCD-4529-BDDE-E86CE1735108}"/>
+                <a16:creationId xmlns:a16="http://schemas.microsoft.com/office/drawing/2014/main" id="{AA0BED44-4059-41F6-9E9F-2E416E17A0CE}"/>
               </a:ext>
             </a:extLst>
           </p:cNvPr>
@@ -13200,7 +13200,7 @@
           <p:cNvPr id="10" name="">
             <a:extLst xmlns:a="http://schemas.openxmlformats.org/drawingml/2006/main">
               <a:ext uri="{FF2B5EF4-FFF2-40B4-BE49-F238E27FC236}">
-                <a16:creationId xmlns:a16="http://schemas.microsoft.com/office/drawing/2014/main" id="{B4460297-F683-4ACD-9D07-AF26CBBED57E}"/>
+                <a16:creationId xmlns:a16="http://schemas.microsoft.com/office/drawing/2014/main" id="{473E54BC-6231-40E4-8FF7-5100CDD2D20B}"/>
               </a:ext>
             </a:extLst>
           </p:cNvPr>
@@ -13255,7 +13255,7 @@
     </p:spTree>
     <p:extLst>
       <p:ext uri="{BB962C8B-B14F-4D97-AF65-F5344CB8AC3E}">
-        <p14:creationId xmlns:p14="http://schemas.microsoft.com/office/powerpoint/2010/main" val="1017223209"/>
+        <p14:creationId xmlns:p14="http://schemas.microsoft.com/office/powerpoint/2010/main" val="774216027"/>
       </p:ext>
     </p:extLst>
   </p:cSld>
@@ -13286,7 +13286,7 @@
           <p:cNvPr id="10" name="">
             <a:extLst xmlns:a="http://schemas.openxmlformats.org/drawingml/2006/main">
               <a:ext uri="{FF2B5EF4-FFF2-40B4-BE49-F238E27FC236}">
-                <a16:creationId xmlns:a16="http://schemas.microsoft.com/office/drawing/2014/main" id="{089EAD73-25E9-4805-AF9B-35B0D086E713}"/>
+                <a16:creationId xmlns:a16="http://schemas.microsoft.com/office/drawing/2014/main" id="{9AB25555-7037-45EB-8FE9-74989C9C60CF}"/>
               </a:ext>
             </a:extLst>
           </p:cNvPr>
@@ -13343,7 +13343,7 @@
           <p:cNvPr id="2" name="">
             <a:extLst xmlns:a="http://schemas.openxmlformats.org/drawingml/2006/main">
               <a:ext uri="{FF2B5EF4-FFF2-40B4-BE49-F238E27FC236}">
-                <a16:creationId xmlns:a16="http://schemas.microsoft.com/office/drawing/2014/main" id="{2EE58FB7-3A48-4CEA-99D3-7B4A423949F2}"/>
+                <a16:creationId xmlns:a16="http://schemas.microsoft.com/office/drawing/2014/main" id="{023203B2-FE3B-4B96-980D-5256E45C5D5C}"/>
               </a:ext>
             </a:extLst>
           </p:cNvPr>
@@ -13400,7 +13400,7 @@
           <p:cNvPr id="3" name="">
             <a:extLst xmlns:a="http://schemas.openxmlformats.org/drawingml/2006/main">
               <a:ext uri="{FF2B5EF4-FFF2-40B4-BE49-F238E27FC236}">
-                <a16:creationId xmlns:a16="http://schemas.microsoft.com/office/drawing/2014/main" id="{F83EE762-16A0-4593-84D0-29CAFD09D9CF}"/>
+                <a16:creationId xmlns:a16="http://schemas.microsoft.com/office/drawing/2014/main" id="{5F031F0F-C653-442F-992B-BF6DC1F675D9}"/>
               </a:ext>
             </a:extLst>
           </p:cNvPr>
@@ -13457,7 +13457,7 @@
           <p:cNvPr id="4" name="">
             <a:extLst xmlns:a="http://schemas.openxmlformats.org/drawingml/2006/main">
               <a:ext uri="{FF2B5EF4-FFF2-40B4-BE49-F238E27FC236}">
-                <a16:creationId xmlns:a16="http://schemas.microsoft.com/office/drawing/2014/main" id="{04073ECC-06F7-485D-9CB3-126A5883B1BA}"/>
+                <a16:creationId xmlns:a16="http://schemas.microsoft.com/office/drawing/2014/main" id="{21DE002A-7B83-41D3-A16B-A7B17EEB45F5}"/>
               </a:ext>
             </a:extLst>
           </p:cNvPr>
@@ -13514,7 +13514,7 @@
           <p:cNvPr id="5" name="">
             <a:extLst xmlns:a="http://schemas.openxmlformats.org/drawingml/2006/main">
               <a:ext uri="{FF2B5EF4-FFF2-40B4-BE49-F238E27FC236}">
-                <a16:creationId xmlns:a16="http://schemas.microsoft.com/office/drawing/2014/main" id="{3E6E829F-4AFD-49FB-929D-8EEFE7EFEE23}"/>
+                <a16:creationId xmlns:a16="http://schemas.microsoft.com/office/drawing/2014/main" id="{EA5A4B71-9378-480F-89B4-1B05D0D09A77}"/>
               </a:ext>
             </a:extLst>
           </p:cNvPr>
@@ -13571,7 +13571,7 @@
           <p:cNvPr id="6" name="">
             <a:extLst xmlns:a="http://schemas.openxmlformats.org/drawingml/2006/main">
               <a:ext uri="{FF2B5EF4-FFF2-40B4-BE49-F238E27FC236}">
-                <a16:creationId xmlns:a16="http://schemas.microsoft.com/office/drawing/2014/main" id="{C890F229-98AF-4965-90C5-2F1FFDFC2460}"/>
+                <a16:creationId xmlns:a16="http://schemas.microsoft.com/office/drawing/2014/main" id="{996C924B-86C1-4F79-B3DB-8F36380C2A30}"/>
               </a:ext>
             </a:extLst>
           </p:cNvPr>
@@ -13656,7 +13656,7 @@
           <p:cNvPr id="7" name="">
             <a:extLst xmlns:a="http://schemas.openxmlformats.org/drawingml/2006/main">
               <a:ext uri="{FF2B5EF4-FFF2-40B4-BE49-F238E27FC236}">
-                <a16:creationId xmlns:a16="http://schemas.microsoft.com/office/drawing/2014/main" id="{3DDE69C5-FEBA-4FDD-8367-1E4D46FC2BF0}"/>
+                <a16:creationId xmlns:a16="http://schemas.microsoft.com/office/drawing/2014/main" id="{9CDC13F3-DC85-4E69-B728-FDF653661E61}"/>
               </a:ext>
             </a:extLst>
           </p:cNvPr>
@@ -13713,7 +13713,7 @@
           <p:cNvPr id="8" name="">
             <a:extLst xmlns:a="http://schemas.openxmlformats.org/drawingml/2006/main">
               <a:ext uri="{FF2B5EF4-FFF2-40B4-BE49-F238E27FC236}">
-                <a16:creationId xmlns:a16="http://schemas.microsoft.com/office/drawing/2014/main" id="{74C89B27-8423-4EA2-8F0B-2D847976BE87}"/>
+                <a16:creationId xmlns:a16="http://schemas.microsoft.com/office/drawing/2014/main" id="{D3C2F343-A078-4024-B96F-386DD0174DEC}"/>
               </a:ext>
             </a:extLst>
           </p:cNvPr>
@@ -13798,7 +13798,7 @@
           <p:cNvPr id="9" name="">
             <a:extLst xmlns:a="http://schemas.openxmlformats.org/drawingml/2006/main">
               <a:ext uri="{FF2B5EF4-FFF2-40B4-BE49-F238E27FC236}">
-                <a16:creationId xmlns:a16="http://schemas.microsoft.com/office/drawing/2014/main" id="{C93C836B-B730-4DE6-93D6-261C1624B25B}"/>
+                <a16:creationId xmlns:a16="http://schemas.microsoft.com/office/drawing/2014/main" id="{059D5B56-0DF3-452D-9EB0-342ED6439466}"/>
               </a:ext>
             </a:extLst>
           </p:cNvPr>
@@ -13853,7 +13853,7 @@
     </p:spTree>
     <p:extLst>
       <p:ext uri="{BB962C8B-B14F-4D97-AF65-F5344CB8AC3E}">
-        <p14:creationId xmlns:p14="http://schemas.microsoft.com/office/powerpoint/2010/main" val="641360757"/>
+        <p14:creationId xmlns:p14="http://schemas.microsoft.com/office/powerpoint/2010/main" val="1945948430"/>
       </p:ext>
     </p:extLst>
   </p:cSld>
@@ -13884,7 +13884,7 @@
           <p:cNvPr id="9" name="">
             <a:extLst xmlns:a="http://schemas.openxmlformats.org/drawingml/2006/main">
               <a:ext uri="{FF2B5EF4-FFF2-40B4-BE49-F238E27FC236}">
-                <a16:creationId xmlns:a16="http://schemas.microsoft.com/office/drawing/2014/main" id="{504FB66F-39BF-44F0-B5BF-D3B4631F4F46}"/>
+                <a16:creationId xmlns:a16="http://schemas.microsoft.com/office/drawing/2014/main" id="{6C0E5F37-A964-4863-9BAA-517FD3D08F51}"/>
               </a:ext>
             </a:extLst>
           </p:cNvPr>
@@ -13941,7 +13941,7 @@
           <p:cNvPr id="2" name="">
             <a:extLst xmlns:a="http://schemas.openxmlformats.org/drawingml/2006/main">
               <a:ext uri="{FF2B5EF4-FFF2-40B4-BE49-F238E27FC236}">
-                <a16:creationId xmlns:a16="http://schemas.microsoft.com/office/drawing/2014/main" id="{F8576B73-26BA-463D-B359-3BFB32684E41}"/>
+                <a16:creationId xmlns:a16="http://schemas.microsoft.com/office/drawing/2014/main" id="{0EDFCF03-FACB-47F2-B1BC-0BD0471D7C35}"/>
               </a:ext>
             </a:extLst>
           </p:cNvPr>
@@ -13998,7 +13998,7 @@
           <p:cNvPr id="3" name="">
             <a:extLst xmlns:a="http://schemas.openxmlformats.org/drawingml/2006/main">
               <a:ext uri="{FF2B5EF4-FFF2-40B4-BE49-F238E27FC236}">
-                <a16:creationId xmlns:a16="http://schemas.microsoft.com/office/drawing/2014/main" id="{764F7F5E-CEEA-4E04-91A3-98D7321A60EF}"/>
+                <a16:creationId xmlns:a16="http://schemas.microsoft.com/office/drawing/2014/main" id="{CF815B48-3182-4948-A87C-0ADF1C09E54D}"/>
               </a:ext>
             </a:extLst>
           </p:cNvPr>
@@ -14055,7 +14055,7 @@
           <p:cNvPr id="4" name="">
             <a:extLst xmlns:a="http://schemas.openxmlformats.org/drawingml/2006/main">
               <a:ext uri="{FF2B5EF4-FFF2-40B4-BE49-F238E27FC236}">
-                <a16:creationId xmlns:a16="http://schemas.microsoft.com/office/drawing/2014/main" id="{028F9387-2877-4E95-878C-8231D84F9F91}"/>
+                <a16:creationId xmlns:a16="http://schemas.microsoft.com/office/drawing/2014/main" id="{D698A180-8F4E-4CD8-A2DF-128D45234C79}"/>
               </a:ext>
             </a:extLst>
           </p:cNvPr>
@@ -14112,7 +14112,7 @@
           <p:cNvPr id="5" name="">
             <a:extLst xmlns:a="http://schemas.openxmlformats.org/drawingml/2006/main">
               <a:ext uri="{FF2B5EF4-FFF2-40B4-BE49-F238E27FC236}">
-                <a16:creationId xmlns:a16="http://schemas.microsoft.com/office/drawing/2014/main" id="{B7E53026-78A8-4C6D-B955-B03CD048EDB5}"/>
+                <a16:creationId xmlns:a16="http://schemas.microsoft.com/office/drawing/2014/main" id="{A1FDC57D-8FD0-4A19-AA09-F29AF1797178}"/>
               </a:ext>
             </a:extLst>
           </p:cNvPr>
@@ -14169,7 +14169,7 @@
           <p:cNvPr id="6" name="">
             <a:extLst xmlns:a="http://schemas.openxmlformats.org/drawingml/2006/main">
               <a:ext uri="{FF2B5EF4-FFF2-40B4-BE49-F238E27FC236}">
-                <a16:creationId xmlns:a16="http://schemas.microsoft.com/office/drawing/2014/main" id="{62446807-303D-4AB3-A4D4-ED7BE3E23537}"/>
+                <a16:creationId xmlns:a16="http://schemas.microsoft.com/office/drawing/2014/main" id="{105A2207-6220-4866-ACCC-95775282996D}"/>
               </a:ext>
             </a:extLst>
           </p:cNvPr>
@@ -14226,7 +14226,7 @@
           <p:cNvPr id="7" name="">
             <a:extLst xmlns:a="http://schemas.openxmlformats.org/drawingml/2006/main">
               <a:ext uri="{FF2B5EF4-FFF2-40B4-BE49-F238E27FC236}">
-                <a16:creationId xmlns:a16="http://schemas.microsoft.com/office/drawing/2014/main" id="{77F5DB2C-C310-427A-A495-00308887675D}"/>
+                <a16:creationId xmlns:a16="http://schemas.microsoft.com/office/drawing/2014/main" id="{36400334-33C9-4715-87E4-0E111746F30B}"/>
               </a:ext>
             </a:extLst>
           </p:cNvPr>
@@ -14283,7 +14283,7 @@
           <p:cNvPr id="8" name="">
             <a:extLst xmlns:a="http://schemas.openxmlformats.org/drawingml/2006/main">
               <a:ext uri="{FF2B5EF4-FFF2-40B4-BE49-F238E27FC236}">
-                <a16:creationId xmlns:a16="http://schemas.microsoft.com/office/drawing/2014/main" id="{402E9059-B170-4B03-9700-496BD33EB578}"/>
+                <a16:creationId xmlns:a16="http://schemas.microsoft.com/office/drawing/2014/main" id="{241893B8-2681-4D4C-9C82-57CE0733038C}"/>
               </a:ext>
             </a:extLst>
           </p:cNvPr>
@@ -14338,7 +14338,7 @@
     </p:spTree>
     <p:extLst>
       <p:ext uri="{BB962C8B-B14F-4D97-AF65-F5344CB8AC3E}">
-        <p14:creationId xmlns:p14="http://schemas.microsoft.com/office/powerpoint/2010/main" val="243840552"/>
+        <p14:creationId xmlns:p14="http://schemas.microsoft.com/office/powerpoint/2010/main" val="1052093894"/>
       </p:ext>
     </p:extLst>
   </p:cSld>
@@ -14369,7 +14369,7 @@
           <p:cNvPr id="13" name="">
             <a:extLst xmlns:a="http://schemas.openxmlformats.org/drawingml/2006/main">
               <a:ext uri="{FF2B5EF4-FFF2-40B4-BE49-F238E27FC236}">
-                <a16:creationId xmlns:a16="http://schemas.microsoft.com/office/drawing/2014/main" id="{EB0271D8-9195-4A6E-9E23-B1D96D46FB40}"/>
+                <a16:creationId xmlns:a16="http://schemas.microsoft.com/office/drawing/2014/main" id="{507E216A-5546-452B-A33F-B69D655F2CEA}"/>
               </a:ext>
             </a:extLst>
           </p:cNvPr>
@@ -14426,7 +14426,7 @@
           <p:cNvPr id="2" name="">
             <a:extLst xmlns:a="http://schemas.openxmlformats.org/drawingml/2006/main">
               <a:ext uri="{FF2B5EF4-FFF2-40B4-BE49-F238E27FC236}">
-                <a16:creationId xmlns:a16="http://schemas.microsoft.com/office/drawing/2014/main" id="{81AE8277-14F5-4545-8FD1-EF12BD59BDD7}"/>
+                <a16:creationId xmlns:a16="http://schemas.microsoft.com/office/drawing/2014/main" id="{574284A7-E55D-4E96-869A-6F6D7AB77934}"/>
               </a:ext>
             </a:extLst>
           </p:cNvPr>
@@ -14483,7 +14483,7 @@
           <p:cNvPr id="3" name="">
             <a:extLst xmlns:a="http://schemas.openxmlformats.org/drawingml/2006/main">
               <a:ext uri="{FF2B5EF4-FFF2-40B4-BE49-F238E27FC236}">
-                <a16:creationId xmlns:a16="http://schemas.microsoft.com/office/drawing/2014/main" id="{F5F01E35-C358-46A5-9B3F-B84901321008}"/>
+                <a16:creationId xmlns:a16="http://schemas.microsoft.com/office/drawing/2014/main" id="{8C6A1C49-5D4D-43FB-B17A-6F50042ED839}"/>
               </a:ext>
             </a:extLst>
           </p:cNvPr>
@@ -14540,7 +14540,7 @@
           <p:cNvPr id="4" name="">
             <a:extLst xmlns:a="http://schemas.openxmlformats.org/drawingml/2006/main">
               <a:ext uri="{FF2B5EF4-FFF2-40B4-BE49-F238E27FC236}">
-                <a16:creationId xmlns:a16="http://schemas.microsoft.com/office/drawing/2014/main" id="{CAAF6242-F339-4D08-86D2-F58C4CB7E83C}"/>
+                <a16:creationId xmlns:a16="http://schemas.microsoft.com/office/drawing/2014/main" id="{18878A78-CF08-490A-A820-FEE4303C406F}"/>
               </a:ext>
             </a:extLst>
           </p:cNvPr>
@@ -14597,7 +14597,7 @@
           <p:cNvPr id="5" name="">
             <a:extLst xmlns:a="http://schemas.openxmlformats.org/drawingml/2006/main">
               <a:ext uri="{FF2B5EF4-FFF2-40B4-BE49-F238E27FC236}">
-                <a16:creationId xmlns:a16="http://schemas.microsoft.com/office/drawing/2014/main" id="{092E5446-91E8-4F6B-84E0-49A312019AC3}"/>
+                <a16:creationId xmlns:a16="http://schemas.microsoft.com/office/drawing/2014/main" id="{56E8C438-3B58-4B0F-9352-A65A668FD5B1}"/>
               </a:ext>
             </a:extLst>
           </p:cNvPr>
@@ -14654,7 +14654,7 @@
           <p:cNvPr id="6" name="">
             <a:extLst xmlns:a="http://schemas.openxmlformats.org/drawingml/2006/main">
               <a:ext uri="{FF2B5EF4-FFF2-40B4-BE49-F238E27FC236}">
-                <a16:creationId xmlns:a16="http://schemas.microsoft.com/office/drawing/2014/main" id="{16BD9F9E-0A51-4FE5-97F5-777DA323A61D}"/>
+                <a16:creationId xmlns:a16="http://schemas.microsoft.com/office/drawing/2014/main" id="{E712C7D2-C727-4685-A4BD-B2B5E1D29229}"/>
               </a:ext>
             </a:extLst>
           </p:cNvPr>
@@ -14711,7 +14711,7 @@
           <p:cNvPr id="7" name="">
             <a:extLst xmlns:a="http://schemas.openxmlformats.org/drawingml/2006/main">
               <a:ext uri="{FF2B5EF4-FFF2-40B4-BE49-F238E27FC236}">
-                <a16:creationId xmlns:a16="http://schemas.microsoft.com/office/drawing/2014/main" id="{5E010070-6E68-4195-AFF0-7853280A53EC}"/>
+                <a16:creationId xmlns:a16="http://schemas.microsoft.com/office/drawing/2014/main" id="{F4600A5E-FDAC-437E-BCB0-47E6B0B4189F}"/>
               </a:ext>
             </a:extLst>
           </p:cNvPr>
@@ -14768,7 +14768,7 @@
           <p:cNvPr id="8" name="">
             <a:extLst xmlns:a="http://schemas.openxmlformats.org/drawingml/2006/main">
               <a:ext uri="{FF2B5EF4-FFF2-40B4-BE49-F238E27FC236}">
-                <a16:creationId xmlns:a16="http://schemas.microsoft.com/office/drawing/2014/main" id="{DACEFC64-0BC2-469F-A93A-88FB8A9855E2}"/>
+                <a16:creationId xmlns:a16="http://schemas.microsoft.com/office/drawing/2014/main" id="{C9957B4F-F7D0-428D-9790-1C565EDB5952}"/>
               </a:ext>
             </a:extLst>
           </p:cNvPr>
@@ -14825,7 +14825,7 @@
           <p:cNvPr id="9" name="">
             <a:extLst xmlns:a="http://schemas.openxmlformats.org/drawingml/2006/main">
               <a:ext uri="{FF2B5EF4-FFF2-40B4-BE49-F238E27FC236}">
-                <a16:creationId xmlns:a16="http://schemas.microsoft.com/office/drawing/2014/main" id="{B72C9B12-8FA7-4E3B-BB70-14B6BBB28F94}"/>
+                <a16:creationId xmlns:a16="http://schemas.microsoft.com/office/drawing/2014/main" id="{134D4A60-542A-4D9A-BD76-45482B549A59}"/>
               </a:ext>
             </a:extLst>
           </p:cNvPr>
@@ -14882,7 +14882,7 @@
           <p:cNvPr id="10" name="">
             <a:extLst xmlns:a="http://schemas.openxmlformats.org/drawingml/2006/main">
               <a:ext uri="{FF2B5EF4-FFF2-40B4-BE49-F238E27FC236}">
-                <a16:creationId xmlns:a16="http://schemas.microsoft.com/office/drawing/2014/main" id="{ECB17020-D6B1-47C5-B30A-8F2D3814766E}"/>
+                <a16:creationId xmlns:a16="http://schemas.microsoft.com/office/drawing/2014/main" id="{B6E5615A-4D32-438B-91B6-B12E9ABBFA4F}"/>
               </a:ext>
             </a:extLst>
           </p:cNvPr>
@@ -14939,7 +14939,7 @@
           <p:cNvPr id="11" name="">
             <a:extLst xmlns:a="http://schemas.openxmlformats.org/drawingml/2006/main">
               <a:ext uri="{FF2B5EF4-FFF2-40B4-BE49-F238E27FC236}">
-                <a16:creationId xmlns:a16="http://schemas.microsoft.com/office/drawing/2014/main" id="{AC42A732-6751-4C70-B49F-FACC75F5A392}"/>
+                <a16:creationId xmlns:a16="http://schemas.microsoft.com/office/drawing/2014/main" id="{62542164-641C-4CA2-80D9-EEFB5015E0FC}"/>
               </a:ext>
             </a:extLst>
           </p:cNvPr>
@@ -14996,7 +14996,7 @@
           <p:cNvPr id="12" name="">
             <a:extLst xmlns:a="http://schemas.openxmlformats.org/drawingml/2006/main">
               <a:ext uri="{FF2B5EF4-FFF2-40B4-BE49-F238E27FC236}">
-                <a16:creationId xmlns:a16="http://schemas.microsoft.com/office/drawing/2014/main" id="{555E1A99-181D-4F20-8D72-17EBEED11981}"/>
+                <a16:creationId xmlns:a16="http://schemas.microsoft.com/office/drawing/2014/main" id="{E7E512B1-C73C-4D1B-9EDF-B784903D27F8}"/>
               </a:ext>
             </a:extLst>
           </p:cNvPr>
@@ -15051,7 +15051,7 @@
     </p:spTree>
     <p:extLst>
       <p:ext uri="{BB962C8B-B14F-4D97-AF65-F5344CB8AC3E}">
-        <p14:creationId xmlns:p14="http://schemas.microsoft.com/office/powerpoint/2010/main" val="608852249"/>
+        <p14:creationId xmlns:p14="http://schemas.microsoft.com/office/powerpoint/2010/main" val="511608742"/>
       </p:ext>
     </p:extLst>
   </p:cSld>
@@ -15082,7 +15082,7 @@
           <p:cNvPr id="13" name="">
             <a:extLst xmlns:a="http://schemas.openxmlformats.org/drawingml/2006/main">
               <a:ext uri="{FF2B5EF4-FFF2-40B4-BE49-F238E27FC236}">
-                <a16:creationId xmlns:a16="http://schemas.microsoft.com/office/drawing/2014/main" id="{57122E52-C208-409F-8CF6-1B330DADD8E5}"/>
+                <a16:creationId xmlns:a16="http://schemas.microsoft.com/office/drawing/2014/main" id="{75593A89-2AC3-49FE-A094-A16BD8BBB942}"/>
               </a:ext>
             </a:extLst>
           </p:cNvPr>
@@ -15139,7 +15139,7 @@
           <p:cNvPr id="2" name="">
             <a:extLst xmlns:a="http://schemas.openxmlformats.org/drawingml/2006/main">
               <a:ext uri="{FF2B5EF4-FFF2-40B4-BE49-F238E27FC236}">
-                <a16:creationId xmlns:a16="http://schemas.microsoft.com/office/drawing/2014/main" id="{C943D5E6-7001-4EB2-96A9-90BD2AE58D28}"/>
+                <a16:creationId xmlns:a16="http://schemas.microsoft.com/office/drawing/2014/main" id="{B2F1C5EA-72FD-485D-A66C-F9AD0DA5EB3F}"/>
               </a:ext>
             </a:extLst>
           </p:cNvPr>
@@ -15196,7 +15196,7 @@
           <p:cNvPr id="3" name="">
             <a:extLst xmlns:a="http://schemas.openxmlformats.org/drawingml/2006/main">
               <a:ext uri="{FF2B5EF4-FFF2-40B4-BE49-F238E27FC236}">
-                <a16:creationId xmlns:a16="http://schemas.microsoft.com/office/drawing/2014/main" id="{2C247111-2E7E-4A85-93FF-48489BB15C6D}"/>
+                <a16:creationId xmlns:a16="http://schemas.microsoft.com/office/drawing/2014/main" id="{1A79207C-C939-4E20-8265-EB83D9FAC5EE}"/>
               </a:ext>
             </a:extLst>
           </p:cNvPr>
@@ -15253,7 +15253,7 @@
           <p:cNvPr id="4" name="">
             <a:extLst xmlns:a="http://schemas.openxmlformats.org/drawingml/2006/main">
               <a:ext uri="{FF2B5EF4-FFF2-40B4-BE49-F238E27FC236}">
-                <a16:creationId xmlns:a16="http://schemas.microsoft.com/office/drawing/2014/main" id="{56FEA429-3385-4042-B474-AD7B94A0F469}"/>
+                <a16:creationId xmlns:a16="http://schemas.microsoft.com/office/drawing/2014/main" id="{92393DC3-8A51-4C18-B9F6-FA14ED799755}"/>
               </a:ext>
             </a:extLst>
           </p:cNvPr>
@@ -15310,7 +15310,7 @@
           <p:cNvPr id="5" name="">
             <a:extLst xmlns:a="http://schemas.openxmlformats.org/drawingml/2006/main">
               <a:ext uri="{FF2B5EF4-FFF2-40B4-BE49-F238E27FC236}">
-                <a16:creationId xmlns:a16="http://schemas.microsoft.com/office/drawing/2014/main" id="{99D56178-4588-48D4-B164-44F0EF64B99C}"/>
+                <a16:creationId xmlns:a16="http://schemas.microsoft.com/office/drawing/2014/main" id="{818C75E8-8575-412C-A5F2-4120861C8F84}"/>
               </a:ext>
             </a:extLst>
           </p:cNvPr>
@@ -15367,7 +15367,7 @@
           <p:cNvPr id="6" name="">
             <a:extLst xmlns:a="http://schemas.openxmlformats.org/drawingml/2006/main">
               <a:ext uri="{FF2B5EF4-FFF2-40B4-BE49-F238E27FC236}">
-                <a16:creationId xmlns:a16="http://schemas.microsoft.com/office/drawing/2014/main" id="{03754FC2-B8A7-41F4-AA6B-0D14C2504BD8}"/>
+                <a16:creationId xmlns:a16="http://schemas.microsoft.com/office/drawing/2014/main" id="{D9EB4553-45B5-4CE9-9CC5-22E055428603}"/>
               </a:ext>
             </a:extLst>
           </p:cNvPr>
@@ -15424,7 +15424,7 @@
           <p:cNvPr id="7" name="">
             <a:extLst xmlns:a="http://schemas.openxmlformats.org/drawingml/2006/main">
               <a:ext uri="{FF2B5EF4-FFF2-40B4-BE49-F238E27FC236}">
-                <a16:creationId xmlns:a16="http://schemas.microsoft.com/office/drawing/2014/main" id="{D333B588-7DE0-4496-A78D-CB7121163275}"/>
+                <a16:creationId xmlns:a16="http://schemas.microsoft.com/office/drawing/2014/main" id="{98103DBB-A99E-4F60-A5C5-D8FCA6DC5F27}"/>
               </a:ext>
             </a:extLst>
           </p:cNvPr>
@@ -15481,7 +15481,7 @@
           <p:cNvPr id="8" name="">
             <a:extLst xmlns:a="http://schemas.openxmlformats.org/drawingml/2006/main">
               <a:ext uri="{FF2B5EF4-FFF2-40B4-BE49-F238E27FC236}">
-                <a16:creationId xmlns:a16="http://schemas.microsoft.com/office/drawing/2014/main" id="{3E0397A2-7969-4CD6-89BF-1EFCD1A0BF47}"/>
+                <a16:creationId xmlns:a16="http://schemas.microsoft.com/office/drawing/2014/main" id="{7D62B5B6-73F8-41C3-89F4-7C12D3B96B4E}"/>
               </a:ext>
             </a:extLst>
           </p:cNvPr>
@@ -15538,7 +15538,7 @@
           <p:cNvPr id="9" name="">
             <a:extLst xmlns:a="http://schemas.openxmlformats.org/drawingml/2006/main">
               <a:ext uri="{FF2B5EF4-FFF2-40B4-BE49-F238E27FC236}">
-                <a16:creationId xmlns:a16="http://schemas.microsoft.com/office/drawing/2014/main" id="{65A6AF30-CA8A-4AB0-A6DA-C40EEB0911A8}"/>
+                <a16:creationId xmlns:a16="http://schemas.microsoft.com/office/drawing/2014/main" id="{AC92526F-E2C6-40A7-AC2D-EEB34DDB94DD}"/>
               </a:ext>
             </a:extLst>
           </p:cNvPr>
@@ -15595,7 +15595,7 @@
           <p:cNvPr id="10" name="">
             <a:extLst xmlns:a="http://schemas.openxmlformats.org/drawingml/2006/main">
               <a:ext uri="{FF2B5EF4-FFF2-40B4-BE49-F238E27FC236}">
-                <a16:creationId xmlns:a16="http://schemas.microsoft.com/office/drawing/2014/main" id="{F42BAEC7-A4AD-42DF-889C-FA7AFCFCA06B}"/>
+                <a16:creationId xmlns:a16="http://schemas.microsoft.com/office/drawing/2014/main" id="{3F1170B1-9866-4C6A-8843-87C337A273C2}"/>
               </a:ext>
             </a:extLst>
           </p:cNvPr>
@@ -15652,7 +15652,7 @@
           <p:cNvPr id="11" name="">
             <a:extLst xmlns:a="http://schemas.openxmlformats.org/drawingml/2006/main">
               <a:ext uri="{FF2B5EF4-FFF2-40B4-BE49-F238E27FC236}">
-                <a16:creationId xmlns:a16="http://schemas.microsoft.com/office/drawing/2014/main" id="{8FA8AA68-207F-4BB1-824D-3A365C5C28CE}"/>
+                <a16:creationId xmlns:a16="http://schemas.microsoft.com/office/drawing/2014/main" id="{BD74FB48-10B9-458D-B977-DA1B177A4BDE}"/>
               </a:ext>
             </a:extLst>
           </p:cNvPr>
@@ -15709,7 +15709,7 @@
           <p:cNvPr id="12" name="">
             <a:extLst xmlns:a="http://schemas.openxmlformats.org/drawingml/2006/main">
               <a:ext uri="{FF2B5EF4-FFF2-40B4-BE49-F238E27FC236}">
-                <a16:creationId xmlns:a16="http://schemas.microsoft.com/office/drawing/2014/main" id="{3B1C3055-F9D1-49CB-A3C0-A08ED744A088}"/>
+                <a16:creationId xmlns:a16="http://schemas.microsoft.com/office/drawing/2014/main" id="{B956B19A-7FF0-4CD3-8849-F82C4DED1FD4}"/>
               </a:ext>
             </a:extLst>
           </p:cNvPr>
@@ -15764,7 +15764,7 @@
     </p:spTree>
     <p:extLst>
       <p:ext uri="{BB962C8B-B14F-4D97-AF65-F5344CB8AC3E}">
-        <p14:creationId xmlns:p14="http://schemas.microsoft.com/office/powerpoint/2010/main" val="906583865"/>
+        <p14:creationId xmlns:p14="http://schemas.microsoft.com/office/powerpoint/2010/main" val="1579564285"/>
       </p:ext>
     </p:extLst>
   </p:cSld>
@@ -15795,7 +15795,7 @@
           <p:cNvPr id="13" name="">
             <a:extLst xmlns:a="http://schemas.openxmlformats.org/drawingml/2006/main">
               <a:ext uri="{FF2B5EF4-FFF2-40B4-BE49-F238E27FC236}">
-                <a16:creationId xmlns:a16="http://schemas.microsoft.com/office/drawing/2014/main" id="{00AC94DA-ED0A-4CF8-A822-AA0AD8FD977E}"/>
+                <a16:creationId xmlns:a16="http://schemas.microsoft.com/office/drawing/2014/main" id="{A2013349-F1C9-4375-86B4-0A827E34D9BE}"/>
               </a:ext>
             </a:extLst>
           </p:cNvPr>
@@ -15852,7 +15852,7 @@
           <p:cNvPr id="2" name="">
             <a:extLst xmlns:a="http://schemas.openxmlformats.org/drawingml/2006/main">
               <a:ext uri="{FF2B5EF4-FFF2-40B4-BE49-F238E27FC236}">
-                <a16:creationId xmlns:a16="http://schemas.microsoft.com/office/drawing/2014/main" id="{A56CA1F1-0F22-4D4E-874A-2C5026AEDF1E}"/>
+                <a16:creationId xmlns:a16="http://schemas.microsoft.com/office/drawing/2014/main" id="{6F017E79-F62B-4085-BE97-FE9846D55470}"/>
               </a:ext>
             </a:extLst>
           </p:cNvPr>
@@ -15909,7 +15909,7 @@
           <p:cNvPr id="3" name="">
             <a:extLst xmlns:a="http://schemas.openxmlformats.org/drawingml/2006/main">
               <a:ext uri="{FF2B5EF4-FFF2-40B4-BE49-F238E27FC236}">
-                <a16:creationId xmlns:a16="http://schemas.microsoft.com/office/drawing/2014/main" id="{8C13358B-F156-479F-9ABA-C8950D6A507D}"/>
+                <a16:creationId xmlns:a16="http://schemas.microsoft.com/office/drawing/2014/main" id="{3FB062C3-A4D8-4230-BF22-48AEF029DC64}"/>
               </a:ext>
             </a:extLst>
           </p:cNvPr>
@@ -15966,7 +15966,7 @@
           <p:cNvPr id="4" name="">
             <a:extLst xmlns:a="http://schemas.openxmlformats.org/drawingml/2006/main">
               <a:ext uri="{FF2B5EF4-FFF2-40B4-BE49-F238E27FC236}">
-                <a16:creationId xmlns:a16="http://schemas.microsoft.com/office/drawing/2014/main" id="{01AE1EEF-60EB-4DB5-89A9-E4C0D49B35D4}"/>
+                <a16:creationId xmlns:a16="http://schemas.microsoft.com/office/drawing/2014/main" id="{E2CC7DC5-041A-422F-8CE8-61B7C3C6CDB6}"/>
               </a:ext>
             </a:extLst>
           </p:cNvPr>
@@ -16023,7 +16023,7 @@
           <p:cNvPr id="5" name="">
             <a:extLst xmlns:a="http://schemas.openxmlformats.org/drawingml/2006/main">
               <a:ext uri="{FF2B5EF4-FFF2-40B4-BE49-F238E27FC236}">
-                <a16:creationId xmlns:a16="http://schemas.microsoft.com/office/drawing/2014/main" id="{E00C27AC-5584-428D-8E5C-F33B014DA0DD}"/>
+                <a16:creationId xmlns:a16="http://schemas.microsoft.com/office/drawing/2014/main" id="{E927099C-2FEC-4710-99FF-547C69383DDC}"/>
               </a:ext>
             </a:extLst>
           </p:cNvPr>
@@ -16080,7 +16080,7 @@
           <p:cNvPr id="6" name="">
             <a:extLst xmlns:a="http://schemas.openxmlformats.org/drawingml/2006/main">
               <a:ext uri="{FF2B5EF4-FFF2-40B4-BE49-F238E27FC236}">
-                <a16:creationId xmlns:a16="http://schemas.microsoft.com/office/drawing/2014/main" id="{74438F85-C8A8-483D-9269-7EC4250D1C7E}"/>
+                <a16:creationId xmlns:a16="http://schemas.microsoft.com/office/drawing/2014/main" id="{8DBE1BBB-8B71-40C6-A9BB-638FA4995306}"/>
               </a:ext>
             </a:extLst>
           </p:cNvPr>
@@ -16137,7 +16137,7 @@
           <p:cNvPr id="7" name="">
             <a:extLst xmlns:a="http://schemas.openxmlformats.org/drawingml/2006/main">
               <a:ext uri="{FF2B5EF4-FFF2-40B4-BE49-F238E27FC236}">
-                <a16:creationId xmlns:a16="http://schemas.microsoft.com/office/drawing/2014/main" id="{AA5F1759-89AD-49EE-B51D-E343A63A090F}"/>
+                <a16:creationId xmlns:a16="http://schemas.microsoft.com/office/drawing/2014/main" id="{C3380812-99C6-434B-AFB0-8C25DF7C5EEC}"/>
               </a:ext>
             </a:extLst>
           </p:cNvPr>
@@ -16194,7 +16194,7 @@
           <p:cNvPr id="8" name="">
             <a:extLst xmlns:a="http://schemas.openxmlformats.org/drawingml/2006/main">
               <a:ext uri="{FF2B5EF4-FFF2-40B4-BE49-F238E27FC236}">
-                <a16:creationId xmlns:a16="http://schemas.microsoft.com/office/drawing/2014/main" id="{C691927D-ACA6-4494-9C0E-4B31DCB1562B}"/>
+                <a16:creationId xmlns:a16="http://schemas.microsoft.com/office/drawing/2014/main" id="{74B13D82-48B4-4A79-A5FF-7843715BA4F3}"/>
               </a:ext>
             </a:extLst>
           </p:cNvPr>
@@ -16251,7 +16251,7 @@
           <p:cNvPr id="9" name="">
             <a:extLst xmlns:a="http://schemas.openxmlformats.org/drawingml/2006/main">
               <a:ext uri="{FF2B5EF4-FFF2-40B4-BE49-F238E27FC236}">
-                <a16:creationId xmlns:a16="http://schemas.microsoft.com/office/drawing/2014/main" id="{B089CD46-AACA-4920-83B7-F4C6DC9BD510}"/>
+                <a16:creationId xmlns:a16="http://schemas.microsoft.com/office/drawing/2014/main" id="{71792A3F-D1C3-4831-A63B-6D876990F2A7}"/>
               </a:ext>
             </a:extLst>
           </p:cNvPr>
@@ -16308,7 +16308,7 @@
           <p:cNvPr id="10" name="">
             <a:extLst xmlns:a="http://schemas.openxmlformats.org/drawingml/2006/main">
               <a:ext uri="{FF2B5EF4-FFF2-40B4-BE49-F238E27FC236}">
-                <a16:creationId xmlns:a16="http://schemas.microsoft.com/office/drawing/2014/main" id="{2233C310-EACD-4B3A-965E-32E1D15899F8}"/>
+                <a16:creationId xmlns:a16="http://schemas.microsoft.com/office/drawing/2014/main" id="{320754A8-511C-485A-9C1F-DCBF3289DFB9}"/>
               </a:ext>
             </a:extLst>
           </p:cNvPr>
@@ -16365,7 +16365,7 @@
           <p:cNvPr id="11" name="">
             <a:extLst xmlns:a="http://schemas.openxmlformats.org/drawingml/2006/main">
               <a:ext uri="{FF2B5EF4-FFF2-40B4-BE49-F238E27FC236}">
-                <a16:creationId xmlns:a16="http://schemas.microsoft.com/office/drawing/2014/main" id="{0D768807-DBBC-4729-B9EE-9DC279326A59}"/>
+                <a16:creationId xmlns:a16="http://schemas.microsoft.com/office/drawing/2014/main" id="{2C534821-5B76-4F02-99B5-A18DD90D5B24}"/>
               </a:ext>
             </a:extLst>
           </p:cNvPr>
@@ -16422,7 +16422,7 @@
           <p:cNvPr id="12" name="">
             <a:extLst xmlns:a="http://schemas.openxmlformats.org/drawingml/2006/main">
               <a:ext uri="{FF2B5EF4-FFF2-40B4-BE49-F238E27FC236}">
-                <a16:creationId xmlns:a16="http://schemas.microsoft.com/office/drawing/2014/main" id="{43CF24F4-5009-4581-989B-9641ECB8F116}"/>
+                <a16:creationId xmlns:a16="http://schemas.microsoft.com/office/drawing/2014/main" id="{90FDD2F0-9450-49BE-AC80-A2D75FFD4BD9}"/>
               </a:ext>
             </a:extLst>
           </p:cNvPr>
@@ -16477,7 +16477,7 @@
     </p:spTree>
     <p:extLst>
       <p:ext uri="{BB962C8B-B14F-4D97-AF65-F5344CB8AC3E}">
-        <p14:creationId xmlns:p14="http://schemas.microsoft.com/office/powerpoint/2010/main" val="1424587404"/>
+        <p14:creationId xmlns:p14="http://schemas.microsoft.com/office/powerpoint/2010/main" val="745824216"/>
       </p:ext>
     </p:extLst>
   </p:cSld>
@@ -16508,7 +16508,7 @@
           <p:cNvPr id="13" name="">
             <a:extLst xmlns:a="http://schemas.openxmlformats.org/drawingml/2006/main">
               <a:ext uri="{FF2B5EF4-FFF2-40B4-BE49-F238E27FC236}">
-                <a16:creationId xmlns:a16="http://schemas.microsoft.com/office/drawing/2014/main" id="{05B70F16-056C-474B-868D-721ED799FD3F}"/>
+                <a16:creationId xmlns:a16="http://schemas.microsoft.com/office/drawing/2014/main" id="{E0DE194F-A72A-4FBF-8CD1-F9D1BBFB6C3B}"/>
               </a:ext>
             </a:extLst>
           </p:cNvPr>
@@ -16565,7 +16565,7 @@
           <p:cNvPr id="2" name="">
             <a:extLst xmlns:a="http://schemas.openxmlformats.org/drawingml/2006/main">
               <a:ext uri="{FF2B5EF4-FFF2-40B4-BE49-F238E27FC236}">
-                <a16:creationId xmlns:a16="http://schemas.microsoft.com/office/drawing/2014/main" id="{8CABBF5B-B91D-4A87-BDFB-32E2CA46901E}"/>
+                <a16:creationId xmlns:a16="http://schemas.microsoft.com/office/drawing/2014/main" id="{A7056BB7-3074-4D34-9FEB-71A0EAAD0EBF}"/>
               </a:ext>
             </a:extLst>
           </p:cNvPr>
@@ -16622,7 +16622,7 @@
           <p:cNvPr id="3" name="">
             <a:extLst xmlns:a="http://schemas.openxmlformats.org/drawingml/2006/main">
               <a:ext uri="{FF2B5EF4-FFF2-40B4-BE49-F238E27FC236}">
-                <a16:creationId xmlns:a16="http://schemas.microsoft.com/office/drawing/2014/main" id="{B6587C35-A6DB-4F95-A273-56FFB5377892}"/>
+                <a16:creationId xmlns:a16="http://schemas.microsoft.com/office/drawing/2014/main" id="{5B1F6414-558B-4546-8208-C3D99DB30C7F}"/>
               </a:ext>
             </a:extLst>
           </p:cNvPr>
@@ -16679,7 +16679,7 @@
           <p:cNvPr id="4" name="">
             <a:extLst xmlns:a="http://schemas.openxmlformats.org/drawingml/2006/main">
               <a:ext uri="{FF2B5EF4-FFF2-40B4-BE49-F238E27FC236}">
-                <a16:creationId xmlns:a16="http://schemas.microsoft.com/office/drawing/2014/main" id="{24E5A760-F616-4579-8CC8-E4E67788C80B}"/>
+                <a16:creationId xmlns:a16="http://schemas.microsoft.com/office/drawing/2014/main" id="{6E086E2F-D092-467C-98CC-F707F4C2DC8A}"/>
               </a:ext>
             </a:extLst>
           </p:cNvPr>
@@ -16736,7 +16736,7 @@
           <p:cNvPr id="5" name="">
             <a:extLst xmlns:a="http://schemas.openxmlformats.org/drawingml/2006/main">
               <a:ext uri="{FF2B5EF4-FFF2-40B4-BE49-F238E27FC236}">
-                <a16:creationId xmlns:a16="http://schemas.microsoft.com/office/drawing/2014/main" id="{C7AD0511-4EF1-48CB-9A42-0FF0826A3618}"/>
+                <a16:creationId xmlns:a16="http://schemas.microsoft.com/office/drawing/2014/main" id="{E7B34054-DD96-4DA7-904D-E0D9D013B673}"/>
               </a:ext>
             </a:extLst>
           </p:cNvPr>
@@ -16793,7 +16793,7 @@
           <p:cNvPr id="6" name="">
             <a:extLst xmlns:a="http://schemas.openxmlformats.org/drawingml/2006/main">
               <a:ext uri="{FF2B5EF4-FFF2-40B4-BE49-F238E27FC236}">
-                <a16:creationId xmlns:a16="http://schemas.microsoft.com/office/drawing/2014/main" id="{1BCA9A28-2B50-4880-9502-EC32CA7D2842}"/>
+                <a16:creationId xmlns:a16="http://schemas.microsoft.com/office/drawing/2014/main" id="{CA3E705F-36E5-45DB-9DAD-2D5F280E877A}"/>
               </a:ext>
             </a:extLst>
           </p:cNvPr>
@@ -16850,7 +16850,7 @@
           <p:cNvPr id="7" name="">
             <a:extLst xmlns:a="http://schemas.openxmlformats.org/drawingml/2006/main">
               <a:ext uri="{FF2B5EF4-FFF2-40B4-BE49-F238E27FC236}">
-                <a16:creationId xmlns:a16="http://schemas.microsoft.com/office/drawing/2014/main" id="{F896F5FF-B90D-4AA4-A843-72862AD18DA1}"/>
+                <a16:creationId xmlns:a16="http://schemas.microsoft.com/office/drawing/2014/main" id="{C999DB7F-C448-4AE7-A786-70DC82BFBD1E}"/>
               </a:ext>
             </a:extLst>
           </p:cNvPr>
@@ -16907,7 +16907,7 @@
           <p:cNvPr id="8" name="">
             <a:extLst xmlns:a="http://schemas.openxmlformats.org/drawingml/2006/main">
               <a:ext uri="{FF2B5EF4-FFF2-40B4-BE49-F238E27FC236}">
-                <a16:creationId xmlns:a16="http://schemas.microsoft.com/office/drawing/2014/main" id="{F7EB160C-CBC8-433E-80CE-12F22061AA27}"/>
+                <a16:creationId xmlns:a16="http://schemas.microsoft.com/office/drawing/2014/main" id="{987638ED-4040-4310-93A4-FA7D28482BBD}"/>
               </a:ext>
             </a:extLst>
           </p:cNvPr>
@@ -16964,7 +16964,7 @@
           <p:cNvPr id="9" name="">
             <a:extLst xmlns:a="http://schemas.openxmlformats.org/drawingml/2006/main">
               <a:ext uri="{FF2B5EF4-FFF2-40B4-BE49-F238E27FC236}">
-                <a16:creationId xmlns:a16="http://schemas.microsoft.com/office/drawing/2014/main" id="{8EA16449-D12E-4745-86B0-313FAEA1CA75}"/>
+                <a16:creationId xmlns:a16="http://schemas.microsoft.com/office/drawing/2014/main" id="{E34180D3-C5C7-4124-AF2A-8A1BCF4F347C}"/>
               </a:ext>
             </a:extLst>
           </p:cNvPr>
@@ -17021,7 +17021,7 @@
           <p:cNvPr id="10" name="">
             <a:extLst xmlns:a="http://schemas.openxmlformats.org/drawingml/2006/main">
               <a:ext uri="{FF2B5EF4-FFF2-40B4-BE49-F238E27FC236}">
-                <a16:creationId xmlns:a16="http://schemas.microsoft.com/office/drawing/2014/main" id="{55138F74-C11D-4E2E-95F9-FCABE1DC285E}"/>
+                <a16:creationId xmlns:a16="http://schemas.microsoft.com/office/drawing/2014/main" id="{5A927F16-C723-40E8-B598-67898A180FEA}"/>
               </a:ext>
             </a:extLst>
           </p:cNvPr>
@@ -17078,7 +17078,7 @@
           <p:cNvPr id="11" name="">
             <a:extLst xmlns:a="http://schemas.openxmlformats.org/drawingml/2006/main">
               <a:ext uri="{FF2B5EF4-FFF2-40B4-BE49-F238E27FC236}">
-                <a16:creationId xmlns:a16="http://schemas.microsoft.com/office/drawing/2014/main" id="{37239ABE-13D6-4B7B-B6AD-0C80911AE142}"/>
+                <a16:creationId xmlns:a16="http://schemas.microsoft.com/office/drawing/2014/main" id="{EBDDD28B-F9C4-476D-A28D-953B582F494E}"/>
               </a:ext>
             </a:extLst>
           </p:cNvPr>
@@ -17135,7 +17135,7 @@
           <p:cNvPr id="12" name="">
             <a:extLst xmlns:a="http://schemas.openxmlformats.org/drawingml/2006/main">
               <a:ext uri="{FF2B5EF4-FFF2-40B4-BE49-F238E27FC236}">
-                <a16:creationId xmlns:a16="http://schemas.microsoft.com/office/drawing/2014/main" id="{E019D150-865C-4607-B894-6132C2E8C39B}"/>
+                <a16:creationId xmlns:a16="http://schemas.microsoft.com/office/drawing/2014/main" id="{B494C0FB-1CDA-4258-8E9F-981EDDDDC62E}"/>
               </a:ext>
             </a:extLst>
           </p:cNvPr>
@@ -17190,7 +17190,7 @@
     </p:spTree>
     <p:extLst>
       <p:ext uri="{BB962C8B-B14F-4D97-AF65-F5344CB8AC3E}">
-        <p14:creationId xmlns:p14="http://schemas.microsoft.com/office/powerpoint/2010/main" val="1815248668"/>
+        <p14:creationId xmlns:p14="http://schemas.microsoft.com/office/powerpoint/2010/main" val="1507807830"/>
       </p:ext>
     </p:extLst>
   </p:cSld>

</xml_diff>

<commit_message>
Reconcile oral demo claims with reproducible local results
</commit_message>
<xml_diff>
--- a/docs/SPC_ML_Demo_Walkthrough_Ready.pptx
+++ b/docs/SPC_ML_Demo_Walkthrough_Ready.pptx
@@ -2,34 +2,34 @@
 <file path=ppt/presentation.xml><?xml version="1.0" encoding="utf-8"?>
 <p:presentation xmlns:p="http://schemas.openxmlformats.org/presentationml/2006/main">
   <p:sldMasterIdLst>
-    <p:sldMasterId xmlns:r="http://schemas.openxmlformats.org/officeDocument/2006/relationships" id="2147483648" r:id="Rd6733f0f380043d4"/>
+    <p:sldMasterId xmlns:r="http://schemas.openxmlformats.org/officeDocument/2006/relationships" id="2147483648" r:id="Rbdedf4f1c2fc4efa"/>
   </p:sldMasterIdLst>
   <p:notesMasterIdLst>
-    <p:notesMasterId xmlns:r="http://schemas.openxmlformats.org/officeDocument/2006/relationships" r:id="R96ce68e2b358488a"/>
+    <p:notesMasterId xmlns:r="http://schemas.openxmlformats.org/officeDocument/2006/relationships" r:id="Rf7cb1a4d13eb47ce"/>
   </p:notesMasterIdLst>
   <p:sldIdLst>
-    <p:sldId xmlns:r="http://schemas.openxmlformats.org/officeDocument/2006/relationships" id="256" r:id="Rb7a1f5ba73904c65"/>
-    <p:sldId xmlns:r="http://schemas.openxmlformats.org/officeDocument/2006/relationships" id="257" r:id="R134a2f7c65df439d"/>
-    <p:sldId xmlns:r="http://schemas.openxmlformats.org/officeDocument/2006/relationships" id="258" r:id="R06dd37a39f924546"/>
-    <p:sldId xmlns:r="http://schemas.openxmlformats.org/officeDocument/2006/relationships" id="259" r:id="R29968dc184b5420f"/>
-    <p:sldId xmlns:r="http://schemas.openxmlformats.org/officeDocument/2006/relationships" id="260" r:id="R444fa34c31eb4dfa"/>
-    <p:sldId xmlns:r="http://schemas.openxmlformats.org/officeDocument/2006/relationships" id="261" r:id="Rf5b06d04b63446cf"/>
-    <p:sldId xmlns:r="http://schemas.openxmlformats.org/officeDocument/2006/relationships" id="262" r:id="R5bf7194ce07c4bc2"/>
-    <p:sldId xmlns:r="http://schemas.openxmlformats.org/officeDocument/2006/relationships" id="263" r:id="R9cb643be4ddf421e"/>
-    <p:sldId xmlns:r="http://schemas.openxmlformats.org/officeDocument/2006/relationships" id="264" r:id="Rb5752f2f609045e2"/>
-    <p:sldId xmlns:r="http://schemas.openxmlformats.org/officeDocument/2006/relationships" id="265" r:id="Ra160a86ef26041e1"/>
-    <p:sldId xmlns:r="http://schemas.openxmlformats.org/officeDocument/2006/relationships" id="266" r:id="R395ea5ea56c0435f"/>
-    <p:sldId xmlns:r="http://schemas.openxmlformats.org/officeDocument/2006/relationships" id="267" r:id="R210739d250504107"/>
-    <p:sldId xmlns:r="http://schemas.openxmlformats.org/officeDocument/2006/relationships" id="268" r:id="Ra59e62bbd325401b"/>
-    <p:sldId xmlns:r="http://schemas.openxmlformats.org/officeDocument/2006/relationships" id="269" r:id="R03347b42560244f5"/>
-    <p:sldId xmlns:r="http://schemas.openxmlformats.org/officeDocument/2006/relationships" id="270" r:id="R10c6f8e412964022"/>
-    <p:sldId xmlns:r="http://schemas.openxmlformats.org/officeDocument/2006/relationships" id="271" r:id="R4bd309af4afc4357"/>
-    <p:sldId xmlns:r="http://schemas.openxmlformats.org/officeDocument/2006/relationships" id="272" r:id="Ree42d281fb1f413b"/>
-    <p:sldId xmlns:r="http://schemas.openxmlformats.org/officeDocument/2006/relationships" id="273" r:id="Rfbb518f5433844c4"/>
-    <p:sldId xmlns:r="http://schemas.openxmlformats.org/officeDocument/2006/relationships" id="274" r:id="R4af0dbd5dc5c46bb"/>
-    <p:sldId xmlns:r="http://schemas.openxmlformats.org/officeDocument/2006/relationships" id="275" r:id="R4c907b7b93344c71"/>
-    <p:sldId xmlns:r="http://schemas.openxmlformats.org/officeDocument/2006/relationships" id="276" r:id="R3896fd4f7fc44e85"/>
-    <p:sldId xmlns:r="http://schemas.openxmlformats.org/officeDocument/2006/relationships" id="277" r:id="R715319233bdb4107"/>
+    <p:sldId xmlns:r="http://schemas.openxmlformats.org/officeDocument/2006/relationships" id="256" r:id="R7cb9d567bab0472a"/>
+    <p:sldId xmlns:r="http://schemas.openxmlformats.org/officeDocument/2006/relationships" id="257" r:id="Rb3262b16e48c4fce"/>
+    <p:sldId xmlns:r="http://schemas.openxmlformats.org/officeDocument/2006/relationships" id="258" r:id="R154d9024eec44597"/>
+    <p:sldId xmlns:r="http://schemas.openxmlformats.org/officeDocument/2006/relationships" id="259" r:id="R4821b5ff02c24732"/>
+    <p:sldId xmlns:r="http://schemas.openxmlformats.org/officeDocument/2006/relationships" id="260" r:id="Rb5265c8835f748bd"/>
+    <p:sldId xmlns:r="http://schemas.openxmlformats.org/officeDocument/2006/relationships" id="261" r:id="R201ecddd8a1247fa"/>
+    <p:sldId xmlns:r="http://schemas.openxmlformats.org/officeDocument/2006/relationships" id="262" r:id="R7e8d71988c604e63"/>
+    <p:sldId xmlns:r="http://schemas.openxmlformats.org/officeDocument/2006/relationships" id="263" r:id="R4ace0f979e814f5d"/>
+    <p:sldId xmlns:r="http://schemas.openxmlformats.org/officeDocument/2006/relationships" id="264" r:id="R4439395985f442a2"/>
+    <p:sldId xmlns:r="http://schemas.openxmlformats.org/officeDocument/2006/relationships" id="265" r:id="Rda7b8b2336394ce7"/>
+    <p:sldId xmlns:r="http://schemas.openxmlformats.org/officeDocument/2006/relationships" id="266" r:id="Rd2652a4ffb324680"/>
+    <p:sldId xmlns:r="http://schemas.openxmlformats.org/officeDocument/2006/relationships" id="267" r:id="Rf25e2eadda7c422f"/>
+    <p:sldId xmlns:r="http://schemas.openxmlformats.org/officeDocument/2006/relationships" id="268" r:id="R4aa30fcdfbbc4940"/>
+    <p:sldId xmlns:r="http://schemas.openxmlformats.org/officeDocument/2006/relationships" id="269" r:id="R866797a2b0924ffa"/>
+    <p:sldId xmlns:r="http://schemas.openxmlformats.org/officeDocument/2006/relationships" id="270" r:id="R3a538856ad864979"/>
+    <p:sldId xmlns:r="http://schemas.openxmlformats.org/officeDocument/2006/relationships" id="271" r:id="Rc845fb6719b0460f"/>
+    <p:sldId xmlns:r="http://schemas.openxmlformats.org/officeDocument/2006/relationships" id="272" r:id="Rf0191c5894b94cca"/>
+    <p:sldId xmlns:r="http://schemas.openxmlformats.org/officeDocument/2006/relationships" id="273" r:id="Re5a2e3edef6b45d6"/>
+    <p:sldId xmlns:r="http://schemas.openxmlformats.org/officeDocument/2006/relationships" id="274" r:id="R9fdb2d1c7e75401c"/>
+    <p:sldId xmlns:r="http://schemas.openxmlformats.org/officeDocument/2006/relationships" id="275" r:id="R4c668b8f6af34b87"/>
+    <p:sldId xmlns:r="http://schemas.openxmlformats.org/officeDocument/2006/relationships" id="276" r:id="R258eaa44a7794e80"/>
+    <p:sldId xmlns:r="http://schemas.openxmlformats.org/officeDocument/2006/relationships" id="277" r:id="R8e806f99479549d1"/>
   </p:sldIdLst>
   <p:sldSz cx="12192000" cy="6858000"/>
   <p:notesSz cx="6858000" cy="9144000"/>
@@ -533,7 +533,7 @@
           <a:lstStyle xmlns:a="http://schemas.openxmlformats.org/drawingml/2006/main"/>
           <a:p xmlns:a="http://schemas.openxmlformats.org/drawingml/2006/main">
             <a:r>
-              <a:t>Show the training/test dates and the assert that windows do not overlap. Explain base rates: 78.1 percent of test windows are signal. The 0.929 AUC measures ranking; it does not override the baseline or the fact that the label is deterministic from the same window. The 50 quiet windows include 3 false positives and 47 true negatives; 56 of 178 rule signals are missed by the classifier.</a:t>
+              <a:t>Show the training/test dates and the assert that windows do not overlap. Explain base rates: 78.1 percent of test windows are signal. The 0.917 AUC measures ranking; it does not override the baseline or the fact that the label is deterministic from the same window. The 50 quiet windows include 4 false positives and 46 true negatives; 53 of 178 rule signals are missed by the classifier. The split separates 25-day measurement windows. Earlier 90-day reference histories can overlap training history. All inputs still precede the run date. Local Python 3.12.14, scikit-learn 1.9.1, NumPy 2.5.3, pandas 2.3.3. See requirements-demo-lock.txt. Use the actual presentation run if its results differ.</a:t>
             </a:r>
           </a:p>
         </p:txBody>
@@ -953,7 +953,7 @@
           <a:lstStyle xmlns:a="http://schemas.openxmlformats.org/drawingml/2006/main"/>
           <a:p xmlns:a="http://schemas.openxmlformats.org/drawingml/2006/main">
             <a:r>
-              <a:t>Read these scores from the reproducible seeded notebook. Classifier test labels are 78.1 percent positive, so the always-signal baseline is strong. Accuracy 74.1 percent fails that comparison despite AUC 0.929. The one-day forecast MAE 8.85 counts beats the five-day trailing mean MAE 9.73 counts on synthetic held-out dates only. Neither comparison proves operational benefit at USCIS.</a:t>
+              <a:t>Read these scores from the reproducible seeded notebook. Classifier test labels are 78.1 percent positive, so the always-signal baseline is strong. Accuracy 75.0 percent fails that comparison despite AUC 0.917. The one-day forecast MAE 8.85 counts beats the five-day trailing mean MAE 9.73 counts on synthetic held-out dates only. Neither comparison proves operational benefit at USCIS. Local Python 3.12.14, scikit-learn 1.9.1, NumPy 2.5.3, pandas 2.3.3. See requirements-demo-lock.txt. Use the actual presentation run if its results differ.</a:t>
             </a:r>
           </a:p>
         </p:txBody>
@@ -1093,7 +1093,7 @@
           <a:lstStyle xmlns:a="http://schemas.openxmlformats.org/drawingml/2006/main"/>
           <a:p xmlns:a="http://schemas.openxmlformats.org/drawingml/2006/main">
             <a:r>
-              <a:t>The supplied USCIS notebook documents real-data exploration, five-day forecasting, rule-label classification, anomaly detection, upstream lineage and alert-volume mitigation. It describes a 37-per-day alert problem and changes intended to reduce repeated or stale triggers. These are design and implementation descriptions in the supplied notebook. We have not independently verified operational outcomes or measured staff time saved. The AttainX synthetic notebook narrows scope to the reproducible live walkthrough.</a:t>
+              <a:t>The supplied private SPC Predictive Modeling reference documents five-day forecasting, rule-label classification, anomaly detection and upstream lineage. Section 11 and the closing Phase 11/Phase 12 notes describe assessment and stale retraining-trigger fixes, but explicitly list downstream alert consolidation and suppression as future work. These are statements in the reference, not independently verified deployment evidence. No measured postchange alert reduction or staff time saved was supplied. The reference stays outside this public repository. The AttainX notebook illustrates a smaller synthetic workflow.</a:t>
             </a:r>
           </a:p>
         </p:txBody>
@@ -1443,7 +1443,7 @@
           <a:lstStyle xmlns:a="http://schemas.openxmlformats.org/drawingml/2006/main"/>
           <a:p xmlns:a="http://schemas.openxmlformats.org/drawingml/2006/main">
             <a:r>
-              <a:t>Suggested sequence: say synthetic scope aloud; execute notebook from the top; pause at rule flags, ML baselines, forecast MAE, review queue, and MLflow/Delta if configured. The classifier does not merit replacing the known rules on this test. The one-day forecast has a small synthetic advantage that invites a bounded pilot, not deployment. Emphasize the USCIS reference as the source of design ideas and a distinct environment. No additional claim of measured USCIS benefit has been supplied.</a:t>
+              <a:t>Suggested sequence: say synthetic scope aloud; execute notebook from the top; pause at rule flags, ML baselines, forecast MAE, review queue, and MLflow/Delta if configured. The classifier does not merit replacing the known rules on this test. The one-day forecast has a small synthetic advantage that invites a bounded pilot, not deployment. Emphasize the USCIS reference as the source of design ideas and a distinct environment. No additional claim of measured USCIS benefit has been supplied. Separate documented retraining-trigger fixes from downstream alert consolidation and suppression, which the reference lists as future work.</a:t>
             </a:r>
           </a:p>
         </p:txBody>
@@ -1723,7 +1723,7 @@
           <a:lstStyle xmlns:a="http://schemas.openxmlformats.org/drawingml/2006/main"/>
           <a:p xmlns:a="http://schemas.openxmlformats.org/drawingml/2006/main">
             <a:r>
-              <a:t>Point to SEED, WINDOW, BASELINE_DAYS, OUTPUT_SCHEMA and UC_MODEL_NAME. Explain that defaults allow a first run without write permissions. The rules are demo parameters requiring calibration for an actual mission series.</a:t>
+              <a:t>Point to SEED, WINDOW, BASELINE_DAYS, OUTPUT_SCHEMA and UC_MODEL_NAME. Empty destination names disable Delta writes and model registration. MLflow still needs experiment write access when installed. The rules are demo parameters requiring calibration for an actual mission series. Databricks experiment guidance: https://docs.databricks.com/aws/en/mlflow/experiments</a:t>
             </a:r>
           </a:p>
         </p:txBody>
@@ -1933,7 +1933,7 @@
           <a:lstStyle xmlns:a="http://schemas.openxmlformats.org/drawingml/2006/main"/>
           <a:p xmlns:a="http://schemas.openxmlformats.org/drawingml/2006/main">
             <a:r>
-              <a:t>Point to the slice selecting prior values, baseline slice, and signal_detected = xmr or cusum or ewma. The script checks the OR invariant. A 52.3 percent overall rate means a signal is a triage input here, not a rare alarm.</a:t>
+              <a:t>Point to the slice selecting prior values, baseline slice, and signal_detected = xmr or cusum or ewma. The script checks the OR invariant. A 52.3 percent overall rate means a signal is a triage input here, not a rare alarm. XmR estimates limits from the 25-day measurement window. CUSUM and EWMA use the earlier 90-day reference.</a:t>
             </a:r>
           </a:p>
         </p:txBody>
@@ -2001,7 +2001,7 @@
   </p:cSld>
   <p:clrMap bg1="lt1" tx1="dk1" bg2="lt2" tx2="dk2" accent1="accent1" accent2="accent2" accent3="accent3" accent4="accent4" accent5="accent5" accent6="accent6" hlink="hlink" folHlink="folHlink"/>
   <p:sldLayoutIdLst>
-    <p:sldLayoutId xmlns:r="http://schemas.openxmlformats.org/officeDocument/2006/relationships" id="2147483649" r:id="R205d1eb740814c6c"/>
+    <p:sldLayoutId xmlns:r="http://schemas.openxmlformats.org/officeDocument/2006/relationships" id="2147483649" r:id="Rb1ade57b9a554897"/>
   </p:sldLayoutIdLst>
   <p:txStyles>
     <p:titleStyle>
@@ -3043,6 +3043,7 @@
           <a:lstStyle xmlns:a="http://schemas.openxmlformats.org/drawingml/2006/main"/>
           <a:p xmlns:a="http://schemas.openxmlformats.org/drawingml/2006/main">
             <a:pPr>
+              <a:buNone/>
               <a:defRPr sz="3975" b="1">
                 <a:solidFill>
                   <a:srgbClr val="FFFFFF"/>
@@ -3100,6 +3101,7 @@
           <a:lstStyle xmlns:a="http://schemas.openxmlformats.org/drawingml/2006/main"/>
           <a:p xmlns:a="http://schemas.openxmlformats.org/drawingml/2006/main">
             <a:pPr>
+              <a:buNone/>
               <a:defRPr sz="2325" b="0">
                 <a:solidFill>
                   <a:srgbClr val="E2EFEF"/>
@@ -3157,6 +3159,7 @@
           <a:lstStyle xmlns:a="http://schemas.openxmlformats.org/drawingml/2006/main"/>
           <a:p xmlns:a="http://schemas.openxmlformats.org/drawingml/2006/main">
             <a:pPr>
+              <a:buNone/>
               <a:defRPr sz="1575" b="0">
                 <a:solidFill>
                   <a:srgbClr val="FFFFFF"/>
@@ -3243,6 +3246,7 @@
           <a:lstStyle xmlns:a="http://schemas.openxmlformats.org/drawingml/2006/main"/>
           <a:p xmlns:a="http://schemas.openxmlformats.org/drawingml/2006/main">
             <a:pPr>
+              <a:buNone/>
               <a:defRPr sz="1200" b="1">
                 <a:solidFill>
                   <a:srgbClr val="B45136"/>
@@ -3300,6 +3304,7 @@
           <a:lstStyle xmlns:a="http://schemas.openxmlformats.org/drawingml/2006/main"/>
           <a:p xmlns:a="http://schemas.openxmlformats.org/drawingml/2006/main">
             <a:pPr>
+              <a:buNone/>
               <a:defRPr sz="3075" b="1">
                 <a:solidFill>
                   <a:srgbClr val="153246"/>
@@ -3357,6 +3362,7 @@
           <a:lstStyle xmlns:a="http://schemas.openxmlformats.org/drawingml/2006/main"/>
           <a:p xmlns:a="http://schemas.openxmlformats.org/drawingml/2006/main">
             <a:pPr>
+              <a:buNone/>
               <a:defRPr sz="1050" b="0">
                 <a:solidFill>
                   <a:srgbClr val="526675"/>
@@ -3414,6 +3420,7 @@
           <a:lstStyle xmlns:a="http://schemas.openxmlformats.org/drawingml/2006/main"/>
           <a:p xmlns:a="http://schemas.openxmlformats.org/drawingml/2006/main">
             <a:pPr>
+              <a:buNone/>
               <a:defRPr sz="1050" b="0">
                 <a:solidFill>
                   <a:srgbClr val="526675"/>
@@ -3471,6 +3478,7 @@
           <a:lstStyle xmlns:a="http://schemas.openxmlformats.org/drawingml/2006/main"/>
           <a:p xmlns:a="http://schemas.openxmlformats.org/drawingml/2006/main">
             <a:pPr>
+              <a:buNone/>
               <a:defRPr sz="1725" b="1">
                 <a:solidFill>
                   <a:srgbClr val="087F77"/>
@@ -3528,6 +3536,7 @@
           <a:lstStyle xmlns:a="http://schemas.openxmlformats.org/drawingml/2006/main"/>
           <a:p xmlns:a="http://schemas.openxmlformats.org/drawingml/2006/main">
             <a:pPr>
+              <a:buNone/>
               <a:defRPr sz="1950" b="0">
                 <a:solidFill>
                   <a:srgbClr val="153246"/>
@@ -3585,6 +3594,7 @@
           <a:lstStyle xmlns:a="http://schemas.openxmlformats.org/drawingml/2006/main"/>
           <a:p xmlns:a="http://schemas.openxmlformats.org/drawingml/2006/main">
             <a:pPr>
+              <a:buNone/>
               <a:defRPr sz="1725" b="1">
                 <a:solidFill>
                   <a:srgbClr val="087F77"/>
@@ -3642,6 +3652,7 @@
           <a:lstStyle xmlns:a="http://schemas.openxmlformats.org/drawingml/2006/main"/>
           <a:p xmlns:a="http://schemas.openxmlformats.org/drawingml/2006/main">
             <a:pPr>
+              <a:buNone/>
               <a:defRPr sz="1800" b="0">
                 <a:solidFill>
                   <a:srgbClr val="153246"/>
@@ -3699,6 +3710,7 @@
           <a:lstStyle xmlns:a="http://schemas.openxmlformats.org/drawingml/2006/main"/>
           <a:p xmlns:a="http://schemas.openxmlformats.org/drawingml/2006/main">
             <a:pPr>
+              <a:buNone/>
               <a:defRPr sz="1725" b="1">
                 <a:solidFill>
                   <a:srgbClr val="B45136"/>
@@ -3756,6 +3768,7 @@
           <a:lstStyle xmlns:a="http://schemas.openxmlformats.org/drawingml/2006/main"/>
           <a:p xmlns:a="http://schemas.openxmlformats.org/drawingml/2006/main">
             <a:pPr>
+              <a:buNone/>
               <a:defRPr sz="1950" b="0">
                 <a:solidFill>
                   <a:srgbClr val="153246"/>
@@ -3774,7 +3787,29 @@
                 <a:ea typeface="Bitstream Charter"/>
                 <a:cs typeface="Bitstream Charter"/>
               </a:rPr>
-              <a:t>The held-out set has 228 labeled windows. Accuracy is 74.1%, while always predicting signal scores 78.1%.</a:t>
+              <a:t>The held-out set has 228 labeled windows. Accuracy is </a:t>
+            </a:r>
+            <a:r>
+              <a:rPr sz="1950" b="0">
+                <a:solidFill>
+                  <a:srgbClr val="153246"/>
+                </a:solidFill>
+                <a:latin typeface="Bitstream Charter"/>
+                <a:ea typeface="Bitstream Charter"/>
+                <a:cs typeface="Bitstream Charter"/>
+              </a:rPr>
+              <a:t>75.0%</a:t>
+            </a:r>
+            <a:r>
+              <a:rPr sz="1950" b="0">
+                <a:solidFill>
+                  <a:srgbClr val="153246"/>
+                </a:solidFill>
+                <a:latin typeface="Bitstream Charter"/>
+                <a:ea typeface="Bitstream Charter"/>
+                <a:cs typeface="Bitstream Charter"/>
+              </a:rPr>
+              <a:t>, while always predicting signal scores 78.1%.</a:t>
             </a:r>
           </a:p>
         </p:txBody>
@@ -3813,6 +3848,7 @@
           <a:lstStyle xmlns:a="http://schemas.openxmlformats.org/drawingml/2006/main"/>
           <a:p xmlns:a="http://schemas.openxmlformats.org/drawingml/2006/main">
             <a:pPr>
+              <a:buNone/>
               <a:defRPr sz="1725" b="1">
                 <a:solidFill>
                   <a:srgbClr val="B45136"/>
@@ -3870,6 +3906,7 @@
           <a:lstStyle xmlns:a="http://schemas.openxmlformats.org/drawingml/2006/main"/>
           <a:p xmlns:a="http://schemas.openxmlformats.org/drawingml/2006/main">
             <a:pPr>
+              <a:buNone/>
               <a:defRPr sz="1800" b="0">
                 <a:solidFill>
                   <a:srgbClr val="153246"/>
@@ -3956,6 +3993,7 @@
           <a:lstStyle xmlns:a="http://schemas.openxmlformats.org/drawingml/2006/main"/>
           <a:p xmlns:a="http://schemas.openxmlformats.org/drawingml/2006/main">
             <a:pPr>
+              <a:buNone/>
               <a:defRPr sz="1200" b="1">
                 <a:solidFill>
                   <a:srgbClr val="B45136"/>
@@ -4013,6 +4051,7 @@
           <a:lstStyle xmlns:a="http://schemas.openxmlformats.org/drawingml/2006/main"/>
           <a:p xmlns:a="http://schemas.openxmlformats.org/drawingml/2006/main">
             <a:pPr>
+              <a:buNone/>
               <a:defRPr sz="3075" b="1">
                 <a:solidFill>
                   <a:srgbClr val="153246"/>
@@ -4070,6 +4109,7 @@
           <a:lstStyle xmlns:a="http://schemas.openxmlformats.org/drawingml/2006/main"/>
           <a:p xmlns:a="http://schemas.openxmlformats.org/drawingml/2006/main">
             <a:pPr>
+              <a:buNone/>
               <a:defRPr sz="1050" b="0">
                 <a:solidFill>
                   <a:srgbClr val="526675"/>
@@ -4127,6 +4167,7 @@
           <a:lstStyle xmlns:a="http://schemas.openxmlformats.org/drawingml/2006/main"/>
           <a:p xmlns:a="http://schemas.openxmlformats.org/drawingml/2006/main">
             <a:pPr>
+              <a:buNone/>
               <a:defRPr sz="1050" b="0">
                 <a:solidFill>
                   <a:srgbClr val="526675"/>
@@ -4184,6 +4225,7 @@
           <a:lstStyle xmlns:a="http://schemas.openxmlformats.org/drawingml/2006/main"/>
           <a:p xmlns:a="http://schemas.openxmlformats.org/drawingml/2006/main">
             <a:pPr>
+              <a:buNone/>
               <a:defRPr sz="1725" b="1">
                 <a:solidFill>
                   <a:srgbClr val="087F77"/>
@@ -4241,6 +4283,7 @@
           <a:lstStyle xmlns:a="http://schemas.openxmlformats.org/drawingml/2006/main"/>
           <a:p xmlns:a="http://schemas.openxmlformats.org/drawingml/2006/main">
             <a:pPr>
+              <a:buNone/>
               <a:defRPr sz="1950" b="0">
                 <a:solidFill>
                   <a:srgbClr val="153246"/>
@@ -4298,6 +4341,7 @@
           <a:lstStyle xmlns:a="http://schemas.openxmlformats.org/drawingml/2006/main"/>
           <a:p xmlns:a="http://schemas.openxmlformats.org/drawingml/2006/main">
             <a:pPr>
+              <a:buNone/>
               <a:defRPr sz="1725" b="1">
                 <a:solidFill>
                   <a:srgbClr val="087F77"/>
@@ -4355,6 +4399,7 @@
           <a:lstStyle xmlns:a="http://schemas.openxmlformats.org/drawingml/2006/main"/>
           <a:p xmlns:a="http://schemas.openxmlformats.org/drawingml/2006/main">
             <a:pPr>
+              <a:buNone/>
               <a:defRPr sz="1800" b="0">
                 <a:solidFill>
                   <a:srgbClr val="153246"/>
@@ -4412,6 +4457,7 @@
           <a:lstStyle xmlns:a="http://schemas.openxmlformats.org/drawingml/2006/main"/>
           <a:p xmlns:a="http://schemas.openxmlformats.org/drawingml/2006/main">
             <a:pPr>
+              <a:buNone/>
               <a:defRPr sz="1725" b="1">
                 <a:solidFill>
                   <a:srgbClr val="B45136"/>
@@ -4469,6 +4515,7 @@
           <a:lstStyle xmlns:a="http://schemas.openxmlformats.org/drawingml/2006/main"/>
           <a:p xmlns:a="http://schemas.openxmlformats.org/drawingml/2006/main">
             <a:pPr>
+              <a:buNone/>
               <a:defRPr sz="1950" b="0">
                 <a:solidFill>
                   <a:srgbClr val="153246"/>
@@ -4526,6 +4573,7 @@
           <a:lstStyle xmlns:a="http://schemas.openxmlformats.org/drawingml/2006/main"/>
           <a:p xmlns:a="http://schemas.openxmlformats.org/drawingml/2006/main">
             <a:pPr>
+              <a:buNone/>
               <a:defRPr sz="1725" b="1">
                 <a:solidFill>
                   <a:srgbClr val="B45136"/>
@@ -4583,6 +4631,7 @@
           <a:lstStyle xmlns:a="http://schemas.openxmlformats.org/drawingml/2006/main"/>
           <a:p xmlns:a="http://schemas.openxmlformats.org/drawingml/2006/main">
             <a:pPr>
+              <a:buNone/>
               <a:defRPr sz="1800" b="0">
                 <a:solidFill>
                   <a:srgbClr val="153246"/>
@@ -4669,6 +4718,7 @@
           <a:lstStyle xmlns:a="http://schemas.openxmlformats.org/drawingml/2006/main"/>
           <a:p xmlns:a="http://schemas.openxmlformats.org/drawingml/2006/main">
             <a:pPr>
+              <a:buNone/>
               <a:defRPr sz="1200" b="1">
                 <a:solidFill>
                   <a:srgbClr val="B45136"/>
@@ -4726,6 +4776,7 @@
           <a:lstStyle xmlns:a="http://schemas.openxmlformats.org/drawingml/2006/main"/>
           <a:p xmlns:a="http://schemas.openxmlformats.org/drawingml/2006/main">
             <a:pPr>
+              <a:buNone/>
               <a:defRPr sz="3075" b="1">
                 <a:solidFill>
                   <a:srgbClr val="153246"/>
@@ -4783,6 +4834,7 @@
           <a:lstStyle xmlns:a="http://schemas.openxmlformats.org/drawingml/2006/main"/>
           <a:p xmlns:a="http://schemas.openxmlformats.org/drawingml/2006/main">
             <a:pPr>
+              <a:buNone/>
               <a:defRPr sz="1050" b="0">
                 <a:solidFill>
                   <a:srgbClr val="526675"/>
@@ -4840,6 +4892,7 @@
           <a:lstStyle xmlns:a="http://schemas.openxmlformats.org/drawingml/2006/main"/>
           <a:p xmlns:a="http://schemas.openxmlformats.org/drawingml/2006/main">
             <a:pPr>
+              <a:buNone/>
               <a:defRPr sz="1050" b="0">
                 <a:solidFill>
                   <a:srgbClr val="526675"/>
@@ -4897,6 +4950,7 @@
           <a:lstStyle xmlns:a="http://schemas.openxmlformats.org/drawingml/2006/main"/>
           <a:p xmlns:a="http://schemas.openxmlformats.org/drawingml/2006/main">
             <a:pPr>
+              <a:buNone/>
               <a:defRPr sz="1725" b="1">
                 <a:solidFill>
                   <a:srgbClr val="087F77"/>
@@ -4954,6 +5008,7 @@
           <a:lstStyle xmlns:a="http://schemas.openxmlformats.org/drawingml/2006/main"/>
           <a:p xmlns:a="http://schemas.openxmlformats.org/drawingml/2006/main">
             <a:pPr>
+              <a:buNone/>
               <a:defRPr sz="1950" b="0">
                 <a:solidFill>
                   <a:srgbClr val="153246"/>
@@ -5011,6 +5066,7 @@
           <a:lstStyle xmlns:a="http://schemas.openxmlformats.org/drawingml/2006/main"/>
           <a:p xmlns:a="http://schemas.openxmlformats.org/drawingml/2006/main">
             <a:pPr>
+              <a:buNone/>
               <a:defRPr sz="1725" b="1">
                 <a:solidFill>
                   <a:srgbClr val="087F77"/>
@@ -5068,6 +5124,7 @@
           <a:lstStyle xmlns:a="http://schemas.openxmlformats.org/drawingml/2006/main"/>
           <a:p xmlns:a="http://schemas.openxmlformats.org/drawingml/2006/main">
             <a:pPr>
+              <a:buNone/>
               <a:defRPr sz="1800" b="0">
                 <a:solidFill>
                   <a:srgbClr val="153246"/>
@@ -5125,6 +5182,7 @@
           <a:lstStyle xmlns:a="http://schemas.openxmlformats.org/drawingml/2006/main"/>
           <a:p xmlns:a="http://schemas.openxmlformats.org/drawingml/2006/main">
             <a:pPr>
+              <a:buNone/>
               <a:defRPr sz="1725" b="1">
                 <a:solidFill>
                   <a:srgbClr val="B45136"/>
@@ -5182,6 +5240,7 @@
           <a:lstStyle xmlns:a="http://schemas.openxmlformats.org/drawingml/2006/main"/>
           <a:p xmlns:a="http://schemas.openxmlformats.org/drawingml/2006/main">
             <a:pPr>
+              <a:buNone/>
               <a:defRPr sz="1950" b="0">
                 <a:solidFill>
                   <a:srgbClr val="153246"/>
@@ -5239,6 +5298,7 @@
           <a:lstStyle xmlns:a="http://schemas.openxmlformats.org/drawingml/2006/main"/>
           <a:p xmlns:a="http://schemas.openxmlformats.org/drawingml/2006/main">
             <a:pPr>
+              <a:buNone/>
               <a:defRPr sz="1725" b="1">
                 <a:solidFill>
                   <a:srgbClr val="B45136"/>
@@ -5296,6 +5356,7 @@
           <a:lstStyle xmlns:a="http://schemas.openxmlformats.org/drawingml/2006/main"/>
           <a:p xmlns:a="http://schemas.openxmlformats.org/drawingml/2006/main">
             <a:pPr>
+              <a:buNone/>
               <a:defRPr sz="1800" b="0">
                 <a:solidFill>
                   <a:srgbClr val="153246"/>
@@ -5382,6 +5443,7 @@
           <a:lstStyle xmlns:a="http://schemas.openxmlformats.org/drawingml/2006/main"/>
           <a:p xmlns:a="http://schemas.openxmlformats.org/drawingml/2006/main">
             <a:pPr>
+              <a:buNone/>
               <a:defRPr sz="1200" b="1">
                 <a:solidFill>
                   <a:srgbClr val="B45136"/>
@@ -5439,6 +5501,7 @@
           <a:lstStyle xmlns:a="http://schemas.openxmlformats.org/drawingml/2006/main"/>
           <a:p xmlns:a="http://schemas.openxmlformats.org/drawingml/2006/main">
             <a:pPr>
+              <a:buNone/>
               <a:defRPr sz="3075" b="1">
                 <a:solidFill>
                   <a:srgbClr val="153246"/>
@@ -5496,6 +5559,7 @@
           <a:lstStyle xmlns:a="http://schemas.openxmlformats.org/drawingml/2006/main"/>
           <a:p xmlns:a="http://schemas.openxmlformats.org/drawingml/2006/main">
             <a:pPr>
+              <a:buNone/>
               <a:defRPr sz="1050" b="0">
                 <a:solidFill>
                   <a:srgbClr val="526675"/>
@@ -5553,6 +5617,7 @@
           <a:lstStyle xmlns:a="http://schemas.openxmlformats.org/drawingml/2006/main"/>
           <a:p xmlns:a="http://schemas.openxmlformats.org/drawingml/2006/main">
             <a:pPr>
+              <a:buNone/>
               <a:defRPr sz="1050" b="0">
                 <a:solidFill>
                   <a:srgbClr val="526675"/>
@@ -5610,6 +5675,7 @@
           <a:lstStyle xmlns:a="http://schemas.openxmlformats.org/drawingml/2006/main"/>
           <a:p xmlns:a="http://schemas.openxmlformats.org/drawingml/2006/main">
             <a:pPr>
+              <a:buNone/>
               <a:defRPr sz="1725" b="1">
                 <a:solidFill>
                   <a:srgbClr val="087F77"/>
@@ -5667,6 +5733,7 @@
           <a:lstStyle xmlns:a="http://schemas.openxmlformats.org/drawingml/2006/main"/>
           <a:p xmlns:a="http://schemas.openxmlformats.org/drawingml/2006/main">
             <a:pPr>
+              <a:buNone/>
               <a:defRPr sz="1950" b="0">
                 <a:solidFill>
                   <a:srgbClr val="153246"/>
@@ -5724,6 +5791,7 @@
           <a:lstStyle xmlns:a="http://schemas.openxmlformats.org/drawingml/2006/main"/>
           <a:p xmlns:a="http://schemas.openxmlformats.org/drawingml/2006/main">
             <a:pPr>
+              <a:buNone/>
               <a:defRPr sz="1725" b="1">
                 <a:solidFill>
                   <a:srgbClr val="087F77"/>
@@ -5781,6 +5849,7 @@
           <a:lstStyle xmlns:a="http://schemas.openxmlformats.org/drawingml/2006/main"/>
           <a:p xmlns:a="http://schemas.openxmlformats.org/drawingml/2006/main">
             <a:pPr>
+              <a:buNone/>
               <a:defRPr sz="1800" b="0">
                 <a:solidFill>
                   <a:srgbClr val="153246"/>
@@ -5838,6 +5907,7 @@
           <a:lstStyle xmlns:a="http://schemas.openxmlformats.org/drawingml/2006/main"/>
           <a:p xmlns:a="http://schemas.openxmlformats.org/drawingml/2006/main">
             <a:pPr>
+              <a:buNone/>
               <a:defRPr sz="1725" b="1">
                 <a:solidFill>
                   <a:srgbClr val="B45136"/>
@@ -5895,6 +5965,7 @@
           <a:lstStyle xmlns:a="http://schemas.openxmlformats.org/drawingml/2006/main"/>
           <a:p xmlns:a="http://schemas.openxmlformats.org/drawingml/2006/main">
             <a:pPr>
+              <a:buNone/>
               <a:defRPr sz="1950" b="0">
                 <a:solidFill>
                   <a:srgbClr val="153246"/>
@@ -5952,6 +6023,7 @@
           <a:lstStyle xmlns:a="http://schemas.openxmlformats.org/drawingml/2006/main"/>
           <a:p xmlns:a="http://schemas.openxmlformats.org/drawingml/2006/main">
             <a:pPr>
+              <a:buNone/>
               <a:defRPr sz="1725" b="1">
                 <a:solidFill>
                   <a:srgbClr val="B45136"/>
@@ -6009,6 +6081,7 @@
           <a:lstStyle xmlns:a="http://schemas.openxmlformats.org/drawingml/2006/main"/>
           <a:p xmlns:a="http://schemas.openxmlformats.org/drawingml/2006/main">
             <a:pPr>
+              <a:buNone/>
               <a:defRPr sz="1800" b="0">
                 <a:solidFill>
                   <a:srgbClr val="153246"/>
@@ -6095,6 +6168,7 @@
           <a:lstStyle xmlns:a="http://schemas.openxmlformats.org/drawingml/2006/main"/>
           <a:p xmlns:a="http://schemas.openxmlformats.org/drawingml/2006/main">
             <a:pPr>
+              <a:buNone/>
               <a:defRPr sz="1200" b="1">
                 <a:solidFill>
                   <a:srgbClr val="B45136"/>
@@ -6152,6 +6226,7 @@
           <a:lstStyle xmlns:a="http://schemas.openxmlformats.org/drawingml/2006/main"/>
           <a:p xmlns:a="http://schemas.openxmlformats.org/drawingml/2006/main">
             <a:pPr>
+              <a:buNone/>
               <a:defRPr sz="3075" b="1">
                 <a:solidFill>
                   <a:srgbClr val="153246"/>
@@ -6209,6 +6284,7 @@
           <a:lstStyle xmlns:a="http://schemas.openxmlformats.org/drawingml/2006/main"/>
           <a:p xmlns:a="http://schemas.openxmlformats.org/drawingml/2006/main">
             <a:pPr>
+              <a:buNone/>
               <a:defRPr sz="1050" b="0">
                 <a:solidFill>
                   <a:srgbClr val="526675"/>
@@ -6266,6 +6342,7 @@
           <a:lstStyle xmlns:a="http://schemas.openxmlformats.org/drawingml/2006/main"/>
           <a:p xmlns:a="http://schemas.openxmlformats.org/drawingml/2006/main">
             <a:pPr>
+              <a:buNone/>
               <a:defRPr sz="1050" b="0">
                 <a:solidFill>
                   <a:srgbClr val="526675"/>
@@ -6323,6 +6400,7 @@
           <a:lstStyle xmlns:a="http://schemas.openxmlformats.org/drawingml/2006/main"/>
           <a:p xmlns:a="http://schemas.openxmlformats.org/drawingml/2006/main">
             <a:pPr>
+              <a:buNone/>
               <a:defRPr sz="1725" b="1">
                 <a:solidFill>
                   <a:srgbClr val="087F77"/>
@@ -6380,6 +6458,7 @@
           <a:lstStyle xmlns:a="http://schemas.openxmlformats.org/drawingml/2006/main"/>
           <a:p xmlns:a="http://schemas.openxmlformats.org/drawingml/2006/main">
             <a:pPr>
+              <a:buNone/>
               <a:defRPr sz="1950" b="0">
                 <a:solidFill>
                   <a:srgbClr val="153246"/>
@@ -6437,6 +6516,7 @@
           <a:lstStyle xmlns:a="http://schemas.openxmlformats.org/drawingml/2006/main"/>
           <a:p xmlns:a="http://schemas.openxmlformats.org/drawingml/2006/main">
             <a:pPr>
+              <a:buNone/>
               <a:defRPr sz="1725" b="1">
                 <a:solidFill>
                   <a:srgbClr val="087F77"/>
@@ -6494,6 +6574,7 @@
           <a:lstStyle xmlns:a="http://schemas.openxmlformats.org/drawingml/2006/main"/>
           <a:p xmlns:a="http://schemas.openxmlformats.org/drawingml/2006/main">
             <a:pPr>
+              <a:buNone/>
               <a:defRPr sz="1800" b="0">
                 <a:solidFill>
                   <a:srgbClr val="153246"/>
@@ -6551,6 +6632,7 @@
           <a:lstStyle xmlns:a="http://schemas.openxmlformats.org/drawingml/2006/main"/>
           <a:p xmlns:a="http://schemas.openxmlformats.org/drawingml/2006/main">
             <a:pPr>
+              <a:buNone/>
               <a:defRPr sz="1725" b="1">
                 <a:solidFill>
                   <a:srgbClr val="B45136"/>
@@ -6608,6 +6690,7 @@
           <a:lstStyle xmlns:a="http://schemas.openxmlformats.org/drawingml/2006/main"/>
           <a:p xmlns:a="http://schemas.openxmlformats.org/drawingml/2006/main">
             <a:pPr>
+              <a:buNone/>
               <a:defRPr sz="1950" b="0">
                 <a:solidFill>
                   <a:srgbClr val="153246"/>
@@ -6665,6 +6748,7 @@
           <a:lstStyle xmlns:a="http://schemas.openxmlformats.org/drawingml/2006/main"/>
           <a:p xmlns:a="http://schemas.openxmlformats.org/drawingml/2006/main">
             <a:pPr>
+              <a:buNone/>
               <a:defRPr sz="1725" b="1">
                 <a:solidFill>
                   <a:srgbClr val="B45136"/>
@@ -6722,6 +6806,7 @@
           <a:lstStyle xmlns:a="http://schemas.openxmlformats.org/drawingml/2006/main"/>
           <a:p xmlns:a="http://schemas.openxmlformats.org/drawingml/2006/main">
             <a:pPr>
+              <a:buNone/>
               <a:defRPr sz="1800" b="0">
                 <a:solidFill>
                   <a:srgbClr val="153246"/>
@@ -6808,6 +6893,7 @@
           <a:lstStyle xmlns:a="http://schemas.openxmlformats.org/drawingml/2006/main"/>
           <a:p xmlns:a="http://schemas.openxmlformats.org/drawingml/2006/main">
             <a:pPr>
+              <a:buNone/>
               <a:defRPr sz="1200" b="1">
                 <a:solidFill>
                   <a:srgbClr val="B45136"/>
@@ -6865,6 +6951,7 @@
           <a:lstStyle xmlns:a="http://schemas.openxmlformats.org/drawingml/2006/main"/>
           <a:p xmlns:a="http://schemas.openxmlformats.org/drawingml/2006/main">
             <a:pPr>
+              <a:buNone/>
               <a:defRPr sz="3075" b="1">
                 <a:solidFill>
                   <a:srgbClr val="153246"/>
@@ -6922,6 +7009,7 @@
           <a:lstStyle xmlns:a="http://schemas.openxmlformats.org/drawingml/2006/main"/>
           <a:p xmlns:a="http://schemas.openxmlformats.org/drawingml/2006/main">
             <a:pPr>
+              <a:buNone/>
               <a:defRPr sz="1050" b="0">
                 <a:solidFill>
                   <a:srgbClr val="526675"/>
@@ -6979,6 +7067,7 @@
           <a:lstStyle xmlns:a="http://schemas.openxmlformats.org/drawingml/2006/main"/>
           <a:p xmlns:a="http://schemas.openxmlformats.org/drawingml/2006/main">
             <a:pPr>
+              <a:buNone/>
               <a:defRPr sz="1050" b="0">
                 <a:solidFill>
                   <a:srgbClr val="526675"/>
@@ -7036,6 +7125,7 @@
           <a:lstStyle xmlns:a="http://schemas.openxmlformats.org/drawingml/2006/main"/>
           <a:p xmlns:a="http://schemas.openxmlformats.org/drawingml/2006/main">
             <a:pPr>
+              <a:buNone/>
               <a:defRPr sz="1725" b="1">
                 <a:solidFill>
                   <a:srgbClr val="087F77"/>
@@ -7093,6 +7183,7 @@
           <a:lstStyle xmlns:a="http://schemas.openxmlformats.org/drawingml/2006/main"/>
           <a:p xmlns:a="http://schemas.openxmlformats.org/drawingml/2006/main">
             <a:pPr>
+              <a:buNone/>
               <a:defRPr sz="1950" b="0">
                 <a:solidFill>
                   <a:srgbClr val="153246"/>
@@ -7150,6 +7241,7 @@
           <a:lstStyle xmlns:a="http://schemas.openxmlformats.org/drawingml/2006/main"/>
           <a:p xmlns:a="http://schemas.openxmlformats.org/drawingml/2006/main">
             <a:pPr>
+              <a:buNone/>
               <a:defRPr sz="1725" b="1">
                 <a:solidFill>
                   <a:srgbClr val="087F77"/>
@@ -7207,6 +7299,7 @@
           <a:lstStyle xmlns:a="http://schemas.openxmlformats.org/drawingml/2006/main"/>
           <a:p xmlns:a="http://schemas.openxmlformats.org/drawingml/2006/main">
             <a:pPr>
+              <a:buNone/>
               <a:defRPr sz="1800" b="0">
                 <a:solidFill>
                   <a:srgbClr val="153246"/>
@@ -7264,6 +7357,7 @@
           <a:lstStyle xmlns:a="http://schemas.openxmlformats.org/drawingml/2006/main"/>
           <a:p xmlns:a="http://schemas.openxmlformats.org/drawingml/2006/main">
             <a:pPr>
+              <a:buNone/>
               <a:defRPr sz="1725" b="1">
                 <a:solidFill>
                   <a:srgbClr val="B45136"/>
@@ -7321,6 +7415,7 @@
           <a:lstStyle xmlns:a="http://schemas.openxmlformats.org/drawingml/2006/main"/>
           <a:p xmlns:a="http://schemas.openxmlformats.org/drawingml/2006/main">
             <a:pPr>
+              <a:buNone/>
               <a:defRPr sz="1950" b="0">
                 <a:solidFill>
                   <a:srgbClr val="153246"/>
@@ -7378,6 +7473,7 @@
           <a:lstStyle xmlns:a="http://schemas.openxmlformats.org/drawingml/2006/main"/>
           <a:p xmlns:a="http://schemas.openxmlformats.org/drawingml/2006/main">
             <a:pPr>
+              <a:buNone/>
               <a:defRPr sz="1725" b="1">
                 <a:solidFill>
                   <a:srgbClr val="B45136"/>
@@ -7435,6 +7531,7 @@
           <a:lstStyle xmlns:a="http://schemas.openxmlformats.org/drawingml/2006/main"/>
           <a:p xmlns:a="http://schemas.openxmlformats.org/drawingml/2006/main">
             <a:pPr>
+              <a:buNone/>
               <a:defRPr sz="1800" b="0">
                 <a:solidFill>
                   <a:srgbClr val="153246"/>
@@ -7521,6 +7618,7 @@
           <a:lstStyle xmlns:a="http://schemas.openxmlformats.org/drawingml/2006/main"/>
           <a:p xmlns:a="http://schemas.openxmlformats.org/drawingml/2006/main">
             <a:pPr>
+              <a:buNone/>
               <a:defRPr sz="1200" b="1">
                 <a:solidFill>
                   <a:srgbClr val="B45136"/>
@@ -7578,6 +7676,7 @@
           <a:lstStyle xmlns:a="http://schemas.openxmlformats.org/drawingml/2006/main"/>
           <a:p xmlns:a="http://schemas.openxmlformats.org/drawingml/2006/main">
             <a:pPr>
+              <a:buNone/>
               <a:defRPr sz="3075" b="1">
                 <a:solidFill>
                   <a:srgbClr val="153246"/>
@@ -7635,6 +7734,7 @@
           <a:lstStyle xmlns:a="http://schemas.openxmlformats.org/drawingml/2006/main"/>
           <a:p xmlns:a="http://schemas.openxmlformats.org/drawingml/2006/main">
             <a:pPr>
+              <a:buNone/>
               <a:defRPr sz="1050" b="0">
                 <a:solidFill>
                   <a:srgbClr val="526675"/>
@@ -7692,6 +7792,7 @@
           <a:lstStyle xmlns:a="http://schemas.openxmlformats.org/drawingml/2006/main"/>
           <a:p xmlns:a="http://schemas.openxmlformats.org/drawingml/2006/main">
             <a:pPr>
+              <a:buNone/>
               <a:defRPr sz="1050" b="0">
                 <a:solidFill>
                   <a:srgbClr val="526675"/>
@@ -7749,6 +7850,7 @@
           <a:lstStyle xmlns:a="http://schemas.openxmlformats.org/drawingml/2006/main"/>
           <a:p xmlns:a="http://schemas.openxmlformats.org/drawingml/2006/main">
             <a:pPr>
+              <a:buNone/>
               <a:defRPr sz="1725" b="1">
                 <a:solidFill>
                   <a:srgbClr val="087F77"/>
@@ -7806,6 +7908,7 @@
           <a:lstStyle xmlns:a="http://schemas.openxmlformats.org/drawingml/2006/main"/>
           <a:p xmlns:a="http://schemas.openxmlformats.org/drawingml/2006/main">
             <a:pPr>
+              <a:buNone/>
               <a:defRPr sz="2025" b="0">
                 <a:solidFill>
                   <a:srgbClr val="153246"/>
@@ -7824,11 +7927,23 @@
                 <a:ea typeface="Bitstream Charter"/>
                 <a:cs typeface="Bitstream Charter"/>
               </a:rPr>
-              <a:t>74.1% accuracy</a:t>
-            </a:r>
-          </a:p>
-          <a:p xmlns:a="http://schemas.openxmlformats.org/drawingml/2006/main">
-            <a:pPr>
+              <a:t>75.0%</a:t>
+            </a:r>
+            <a:r>
+              <a:rPr sz="2025" b="0">
+                <a:solidFill>
+                  <a:srgbClr val="153246"/>
+                </a:solidFill>
+                <a:latin typeface="Bitstream Charter"/>
+                <a:ea typeface="Bitstream Charter"/>
+                <a:cs typeface="Bitstream Charter"/>
+              </a:rPr>
+              <a:t> accuracy</a:t>
+            </a:r>
+          </a:p>
+          <a:p xmlns:a="http://schemas.openxmlformats.org/drawingml/2006/main">
+            <a:pPr>
+              <a:buNone/>
               <a:defRPr sz="2025" b="0">
                 <a:solidFill>
                   <a:srgbClr val="153246"/>
@@ -7857,6 +7972,7 @@
           </a:p>
           <a:p xmlns:a="http://schemas.openxmlformats.org/drawingml/2006/main">
             <a:pPr>
+              <a:buNone/>
               <a:defRPr sz="2025" b="0">
                 <a:solidFill>
                   <a:srgbClr val="153246"/>
@@ -7914,6 +8030,7 @@
           <a:lstStyle xmlns:a="http://schemas.openxmlformats.org/drawingml/2006/main"/>
           <a:p xmlns:a="http://schemas.openxmlformats.org/drawingml/2006/main">
             <a:pPr>
+              <a:buNone/>
               <a:defRPr sz="1725" b="1">
                 <a:solidFill>
                   <a:srgbClr val="B45136"/>
@@ -7971,6 +8088,7 @@
           <a:lstStyle xmlns:a="http://schemas.openxmlformats.org/drawingml/2006/main"/>
           <a:p xmlns:a="http://schemas.openxmlformats.org/drawingml/2006/main">
             <a:pPr>
+              <a:buNone/>
               <a:defRPr sz="2025" b="0">
                 <a:solidFill>
                   <a:srgbClr val="153246"/>
@@ -7994,6 +8112,7 @@
           </a:p>
           <a:p xmlns:a="http://schemas.openxmlformats.org/drawingml/2006/main">
             <a:pPr>
+              <a:buNone/>
               <a:defRPr sz="2025" b="0">
                 <a:solidFill>
                   <a:srgbClr val="153246"/>
@@ -8022,6 +8141,7 @@
           </a:p>
           <a:p xmlns:a="http://schemas.openxmlformats.org/drawingml/2006/main">
             <a:pPr>
+              <a:buNone/>
               <a:defRPr sz="2025" b="0">
                 <a:solidFill>
                   <a:srgbClr val="153246"/>
@@ -8079,6 +8199,7 @@
           <a:lstStyle xmlns:a="http://schemas.openxmlformats.org/drawingml/2006/main"/>
           <a:p xmlns:a="http://schemas.openxmlformats.org/drawingml/2006/main">
             <a:pPr>
+              <a:buNone/>
               <a:defRPr sz="1650" b="0">
                 <a:solidFill>
                   <a:srgbClr val="526675"/>
@@ -8165,6 +8286,7 @@
           <a:lstStyle xmlns:a="http://schemas.openxmlformats.org/drawingml/2006/main"/>
           <a:p xmlns:a="http://schemas.openxmlformats.org/drawingml/2006/main">
             <a:pPr>
+              <a:buNone/>
               <a:defRPr sz="1200" b="1">
                 <a:solidFill>
                   <a:srgbClr val="B45136"/>
@@ -8222,6 +8344,7 @@
           <a:lstStyle xmlns:a="http://schemas.openxmlformats.org/drawingml/2006/main"/>
           <a:p xmlns:a="http://schemas.openxmlformats.org/drawingml/2006/main">
             <a:pPr>
+              <a:buNone/>
               <a:defRPr sz="3075" b="1">
                 <a:solidFill>
                   <a:srgbClr val="153246"/>
@@ -8279,6 +8402,7 @@
           <a:lstStyle xmlns:a="http://schemas.openxmlformats.org/drawingml/2006/main"/>
           <a:p xmlns:a="http://schemas.openxmlformats.org/drawingml/2006/main">
             <a:pPr>
+              <a:buNone/>
               <a:defRPr sz="1050" b="0">
                 <a:solidFill>
                   <a:srgbClr val="526675"/>
@@ -8336,6 +8460,7 @@
           <a:lstStyle xmlns:a="http://schemas.openxmlformats.org/drawingml/2006/main"/>
           <a:p xmlns:a="http://schemas.openxmlformats.org/drawingml/2006/main">
             <a:pPr>
+              <a:buNone/>
               <a:defRPr sz="1050" b="0">
                 <a:solidFill>
                   <a:srgbClr val="526675"/>
@@ -8393,6 +8518,7 @@
           <a:lstStyle xmlns:a="http://schemas.openxmlformats.org/drawingml/2006/main"/>
           <a:p xmlns:a="http://schemas.openxmlformats.org/drawingml/2006/main">
             <a:pPr>
+              <a:buNone/>
               <a:defRPr sz="1725" b="1">
                 <a:solidFill>
                   <a:srgbClr val="087F77"/>
@@ -8450,6 +8576,7 @@
           <a:lstStyle xmlns:a="http://schemas.openxmlformats.org/drawingml/2006/main"/>
           <a:p xmlns:a="http://schemas.openxmlformats.org/drawingml/2006/main">
             <a:pPr>
+              <a:buNone/>
               <a:defRPr sz="1875" b="0">
                 <a:solidFill>
                   <a:srgbClr val="153246"/>
@@ -8507,6 +8634,7 @@
           <a:lstStyle xmlns:a="http://schemas.openxmlformats.org/drawingml/2006/main"/>
           <a:p xmlns:a="http://schemas.openxmlformats.org/drawingml/2006/main">
             <a:pPr>
+              <a:buNone/>
               <a:defRPr sz="1725" b="1">
                 <a:solidFill>
                   <a:srgbClr val="087F77"/>
@@ -8564,6 +8692,7 @@
           <a:lstStyle xmlns:a="http://schemas.openxmlformats.org/drawingml/2006/main"/>
           <a:p xmlns:a="http://schemas.openxmlformats.org/drawingml/2006/main">
             <a:pPr>
+              <a:buNone/>
               <a:defRPr sz="1875" b="0">
                 <a:solidFill>
                   <a:srgbClr val="153246"/>
@@ -8621,6 +8750,7 @@
           <a:lstStyle xmlns:a="http://schemas.openxmlformats.org/drawingml/2006/main"/>
           <a:p xmlns:a="http://schemas.openxmlformats.org/drawingml/2006/main">
             <a:pPr>
+              <a:buNone/>
               <a:defRPr sz="1725" b="1">
                 <a:solidFill>
                   <a:srgbClr val="087F77"/>
@@ -8678,6 +8808,7 @@
           <a:lstStyle xmlns:a="http://schemas.openxmlformats.org/drawingml/2006/main"/>
           <a:p xmlns:a="http://schemas.openxmlformats.org/drawingml/2006/main">
             <a:pPr>
+              <a:buNone/>
               <a:defRPr sz="1875" b="0">
                 <a:solidFill>
                   <a:srgbClr val="153246"/>
@@ -8764,6 +8895,7 @@
           <a:lstStyle xmlns:a="http://schemas.openxmlformats.org/drawingml/2006/main"/>
           <a:p xmlns:a="http://schemas.openxmlformats.org/drawingml/2006/main">
             <a:pPr>
+              <a:buNone/>
               <a:defRPr sz="1200" b="1">
                 <a:solidFill>
                   <a:srgbClr val="B45136"/>
@@ -8821,6 +8953,7 @@
           <a:lstStyle xmlns:a="http://schemas.openxmlformats.org/drawingml/2006/main"/>
           <a:p xmlns:a="http://schemas.openxmlformats.org/drawingml/2006/main">
             <a:pPr>
+              <a:buNone/>
               <a:defRPr sz="3075" b="1">
                 <a:solidFill>
                   <a:srgbClr val="153246"/>
@@ -8878,6 +9011,7 @@
           <a:lstStyle xmlns:a="http://schemas.openxmlformats.org/drawingml/2006/main"/>
           <a:p xmlns:a="http://schemas.openxmlformats.org/drawingml/2006/main">
             <a:pPr>
+              <a:buNone/>
               <a:defRPr sz="1050" b="0">
                 <a:solidFill>
                   <a:srgbClr val="526675"/>
@@ -8935,6 +9069,7 @@
           <a:lstStyle xmlns:a="http://schemas.openxmlformats.org/drawingml/2006/main"/>
           <a:p xmlns:a="http://schemas.openxmlformats.org/drawingml/2006/main">
             <a:pPr>
+              <a:buNone/>
               <a:defRPr sz="1050" b="0">
                 <a:solidFill>
                   <a:srgbClr val="526675"/>
@@ -8992,6 +9127,7 @@
           <a:lstStyle xmlns:a="http://schemas.openxmlformats.org/drawingml/2006/main"/>
           <a:p xmlns:a="http://schemas.openxmlformats.org/drawingml/2006/main">
             <a:pPr>
+              <a:buNone/>
               <a:defRPr sz="1875" b="1">
                 <a:solidFill>
                   <a:srgbClr val="087F77"/>
@@ -9049,6 +9185,7 @@
           <a:lstStyle xmlns:a="http://schemas.openxmlformats.org/drawingml/2006/main"/>
           <a:p xmlns:a="http://schemas.openxmlformats.org/drawingml/2006/main">
             <a:pPr>
+              <a:buNone/>
               <a:defRPr sz="2025" b="0">
                 <a:solidFill>
                   <a:srgbClr val="153246"/>
@@ -9106,6 +9243,7 @@
           <a:lstStyle xmlns:a="http://schemas.openxmlformats.org/drawingml/2006/main"/>
           <a:p xmlns:a="http://schemas.openxmlformats.org/drawingml/2006/main">
             <a:pPr>
+              <a:buNone/>
               <a:defRPr sz="1875" b="1">
                 <a:solidFill>
                   <a:srgbClr val="B45136"/>
@@ -9163,6 +9301,7 @@
           <a:lstStyle xmlns:a="http://schemas.openxmlformats.org/drawingml/2006/main"/>
           <a:p xmlns:a="http://schemas.openxmlformats.org/drawingml/2006/main">
             <a:pPr>
+              <a:buNone/>
               <a:defRPr sz="2025" b="0">
                 <a:solidFill>
                   <a:srgbClr val="153246"/>
@@ -9181,7 +9320,7 @@
                 <a:ea typeface="Bitstream Charter"/>
                 <a:cs typeface="Bitstream Charter"/>
               </a:rPr>
-              <a:t>The notebook documents fixes for repeated alerts and stale retraining triggers. No measured post-change reduction or staff time saved was supplied.</a:t>
+              <a:t>The reference documents stale retraining-trigger fixes. Downstream alert grouping remains planned. No measured alert reduction or staff time saved was supplied.</a:t>
             </a:r>
           </a:p>
         </p:txBody>
@@ -9249,6 +9388,7 @@
           <a:lstStyle xmlns:a="http://schemas.openxmlformats.org/drawingml/2006/main"/>
           <a:p xmlns:a="http://schemas.openxmlformats.org/drawingml/2006/main">
             <a:pPr>
+              <a:buNone/>
               <a:defRPr sz="1200" b="1">
                 <a:solidFill>
                   <a:srgbClr val="B45136"/>
@@ -9306,6 +9446,7 @@
           <a:lstStyle xmlns:a="http://schemas.openxmlformats.org/drawingml/2006/main"/>
           <a:p xmlns:a="http://schemas.openxmlformats.org/drawingml/2006/main">
             <a:pPr>
+              <a:buNone/>
               <a:defRPr sz="3075" b="1">
                 <a:solidFill>
                   <a:srgbClr val="153246"/>
@@ -9363,6 +9504,7 @@
           <a:lstStyle xmlns:a="http://schemas.openxmlformats.org/drawingml/2006/main"/>
           <a:p xmlns:a="http://schemas.openxmlformats.org/drawingml/2006/main">
             <a:pPr>
+              <a:buNone/>
               <a:defRPr sz="1050" b="0">
                 <a:solidFill>
                   <a:srgbClr val="526675"/>
@@ -9420,6 +9562,7 @@
           <a:lstStyle xmlns:a="http://schemas.openxmlformats.org/drawingml/2006/main"/>
           <a:p xmlns:a="http://schemas.openxmlformats.org/drawingml/2006/main">
             <a:pPr>
+              <a:buNone/>
               <a:defRPr sz="1050" b="0">
                 <a:solidFill>
                   <a:srgbClr val="526675"/>
@@ -9477,6 +9620,7 @@
           <a:lstStyle xmlns:a="http://schemas.openxmlformats.org/drawingml/2006/main"/>
           <a:p xmlns:a="http://schemas.openxmlformats.org/drawingml/2006/main">
             <a:pPr>
+              <a:buNone/>
               <a:defRPr sz="1725" b="1">
                 <a:solidFill>
                   <a:srgbClr val="087F77"/>
@@ -9534,6 +9678,7 @@
           <a:lstStyle xmlns:a="http://schemas.openxmlformats.org/drawingml/2006/main"/>
           <a:p xmlns:a="http://schemas.openxmlformats.org/drawingml/2006/main">
             <a:pPr>
+              <a:buNone/>
               <a:defRPr sz="1875" b="0">
                 <a:solidFill>
                   <a:srgbClr val="153246"/>
@@ -9591,6 +9736,7 @@
           <a:lstStyle xmlns:a="http://schemas.openxmlformats.org/drawingml/2006/main"/>
           <a:p xmlns:a="http://schemas.openxmlformats.org/drawingml/2006/main">
             <a:pPr>
+              <a:buNone/>
               <a:defRPr sz="1725" b="1">
                 <a:solidFill>
                   <a:srgbClr val="087F77"/>
@@ -9648,6 +9794,7 @@
           <a:lstStyle xmlns:a="http://schemas.openxmlformats.org/drawingml/2006/main"/>
           <a:p xmlns:a="http://schemas.openxmlformats.org/drawingml/2006/main">
             <a:pPr>
+              <a:buNone/>
               <a:defRPr sz="1875" b="0">
                 <a:solidFill>
                   <a:srgbClr val="153246"/>
@@ -9734,6 +9881,7 @@
           <a:lstStyle xmlns:a="http://schemas.openxmlformats.org/drawingml/2006/main"/>
           <a:p xmlns:a="http://schemas.openxmlformats.org/drawingml/2006/main">
             <a:pPr>
+              <a:buNone/>
               <a:defRPr sz="1200" b="1">
                 <a:solidFill>
                   <a:srgbClr val="B45136"/>
@@ -9791,6 +9939,7 @@
           <a:lstStyle xmlns:a="http://schemas.openxmlformats.org/drawingml/2006/main"/>
           <a:p xmlns:a="http://schemas.openxmlformats.org/drawingml/2006/main">
             <a:pPr>
+              <a:buNone/>
               <a:defRPr sz="3075" b="1">
                 <a:solidFill>
                   <a:srgbClr val="153246"/>
@@ -9848,6 +9997,7 @@
           <a:lstStyle xmlns:a="http://schemas.openxmlformats.org/drawingml/2006/main"/>
           <a:p xmlns:a="http://schemas.openxmlformats.org/drawingml/2006/main">
             <a:pPr>
+              <a:buNone/>
               <a:defRPr sz="1050" b="0">
                 <a:solidFill>
                   <a:srgbClr val="526675"/>
@@ -9905,6 +10055,7 @@
           <a:lstStyle xmlns:a="http://schemas.openxmlformats.org/drawingml/2006/main"/>
           <a:p xmlns:a="http://schemas.openxmlformats.org/drawingml/2006/main">
             <a:pPr>
+              <a:buNone/>
               <a:defRPr sz="1050" b="0">
                 <a:solidFill>
                   <a:srgbClr val="526675"/>
@@ -9962,6 +10113,7 @@
           <a:lstStyle xmlns:a="http://schemas.openxmlformats.org/drawingml/2006/main"/>
           <a:p xmlns:a="http://schemas.openxmlformats.org/drawingml/2006/main">
             <a:pPr>
+              <a:buNone/>
               <a:defRPr sz="2250" b="1">
                 <a:solidFill>
                   <a:srgbClr val="153246"/>
@@ -9987,7 +10139,7 @@
       </p:sp>
       <p:graphicFrame>
         <p:nvGraphicFramePr>
-          <p:cNvPr id="13" name="Chart"/>
+          <p:cNvPr id="15" name="Chart"/>
           <p:cNvGraphicFramePr/>
           <p:nvPr/>
         </p:nvGraphicFramePr>
@@ -9997,7 +10149,7 @@
         </p:xfrm>
         <a:graphic xmlns:a="http://schemas.openxmlformats.org/drawingml/2006/main">
           <a:graphicData uri="http://schemas.openxmlformats.org/drawingml/2006/chart">
-            <c:chart xmlns:r="http://schemas.openxmlformats.org/officeDocument/2006/relationships" xmlns:c="http://schemas.openxmlformats.org/drawingml/2006/chart" r:id="Rf937fcb106664484"/>
+            <c:chart xmlns:r="http://schemas.openxmlformats.org/officeDocument/2006/relationships" xmlns:c="http://schemas.openxmlformats.org/drawingml/2006/chart" r:id="Raaafe6b311654068"/>
           </a:graphicData>
         </a:graphic>
       </p:graphicFrame>
@@ -10035,6 +10187,7 @@
           <a:lstStyle xmlns:a="http://schemas.openxmlformats.org/drawingml/2006/main"/>
           <a:p xmlns:a="http://schemas.openxmlformats.org/drawingml/2006/main">
             <a:pPr>
+              <a:buNone/>
               <a:defRPr sz="1575" b="0">
                 <a:solidFill>
                   <a:srgbClr val="526675"/>
@@ -10121,6 +10274,7 @@
           <a:lstStyle xmlns:a="http://schemas.openxmlformats.org/drawingml/2006/main"/>
           <a:p xmlns:a="http://schemas.openxmlformats.org/drawingml/2006/main">
             <a:pPr>
+              <a:buNone/>
               <a:defRPr sz="1200" b="1">
                 <a:solidFill>
                   <a:srgbClr val="B45136"/>
@@ -10178,6 +10332,7 @@
           <a:lstStyle xmlns:a="http://schemas.openxmlformats.org/drawingml/2006/main"/>
           <a:p xmlns:a="http://schemas.openxmlformats.org/drawingml/2006/main">
             <a:pPr>
+              <a:buNone/>
               <a:defRPr sz="3075" b="1">
                 <a:solidFill>
                   <a:srgbClr val="153246"/>
@@ -10235,6 +10390,7 @@
           <a:lstStyle xmlns:a="http://schemas.openxmlformats.org/drawingml/2006/main"/>
           <a:p xmlns:a="http://schemas.openxmlformats.org/drawingml/2006/main">
             <a:pPr>
+              <a:buNone/>
               <a:defRPr sz="1050" b="0">
                 <a:solidFill>
                   <a:srgbClr val="526675"/>
@@ -10292,6 +10448,7 @@
           <a:lstStyle xmlns:a="http://schemas.openxmlformats.org/drawingml/2006/main"/>
           <a:p xmlns:a="http://schemas.openxmlformats.org/drawingml/2006/main">
             <a:pPr>
+              <a:buNone/>
               <a:defRPr sz="1050" b="0">
                 <a:solidFill>
                   <a:srgbClr val="526675"/>
@@ -10349,6 +10506,7 @@
           <a:lstStyle xmlns:a="http://schemas.openxmlformats.org/drawingml/2006/main"/>
           <a:p xmlns:a="http://schemas.openxmlformats.org/drawingml/2006/main">
             <a:pPr>
+              <a:buNone/>
               <a:defRPr sz="1500" b="1">
                 <a:solidFill>
                   <a:srgbClr val="087F77"/>
@@ -10406,6 +10564,7 @@
           <a:lstStyle xmlns:a="http://schemas.openxmlformats.org/drawingml/2006/main"/>
           <a:p xmlns:a="http://schemas.openxmlformats.org/drawingml/2006/main">
             <a:pPr>
+              <a:buNone/>
               <a:defRPr sz="1500" b="0">
                 <a:solidFill>
                   <a:srgbClr val="153246"/>
@@ -10463,6 +10622,7 @@
           <a:lstStyle xmlns:a="http://schemas.openxmlformats.org/drawingml/2006/main"/>
           <a:p xmlns:a="http://schemas.openxmlformats.org/drawingml/2006/main">
             <a:pPr>
+              <a:buNone/>
               <a:defRPr sz="1500" b="1">
                 <a:solidFill>
                   <a:srgbClr val="087F77"/>
@@ -10520,6 +10680,7 @@
           <a:lstStyle xmlns:a="http://schemas.openxmlformats.org/drawingml/2006/main"/>
           <a:p xmlns:a="http://schemas.openxmlformats.org/drawingml/2006/main">
             <a:pPr>
+              <a:buNone/>
               <a:defRPr sz="1500" b="0">
                 <a:solidFill>
                   <a:srgbClr val="153246"/>
@@ -10577,6 +10738,7 @@
           <a:lstStyle xmlns:a="http://schemas.openxmlformats.org/drawingml/2006/main"/>
           <a:p xmlns:a="http://schemas.openxmlformats.org/drawingml/2006/main">
             <a:pPr>
+              <a:buNone/>
               <a:defRPr sz="1500" b="1">
                 <a:solidFill>
                   <a:srgbClr val="087F77"/>
@@ -10634,6 +10796,7 @@
           <a:lstStyle xmlns:a="http://schemas.openxmlformats.org/drawingml/2006/main"/>
           <a:p xmlns:a="http://schemas.openxmlformats.org/drawingml/2006/main">
             <a:pPr>
+              <a:buNone/>
               <a:defRPr sz="1500" b="0">
                 <a:solidFill>
                   <a:srgbClr val="153246"/>
@@ -10691,6 +10854,7 @@
           <a:lstStyle xmlns:a="http://schemas.openxmlformats.org/drawingml/2006/main"/>
           <a:p xmlns:a="http://schemas.openxmlformats.org/drawingml/2006/main">
             <a:pPr>
+              <a:buNone/>
               <a:defRPr sz="1500" b="1">
                 <a:solidFill>
                   <a:srgbClr val="087F77"/>
@@ -10748,6 +10912,7 @@
           <a:lstStyle xmlns:a="http://schemas.openxmlformats.org/drawingml/2006/main"/>
           <a:p xmlns:a="http://schemas.openxmlformats.org/drawingml/2006/main">
             <a:pPr>
+              <a:buNone/>
               <a:defRPr sz="1500" b="0">
                 <a:solidFill>
                   <a:srgbClr val="153246"/>
@@ -10805,6 +10970,7 @@
           <a:lstStyle xmlns:a="http://schemas.openxmlformats.org/drawingml/2006/main"/>
           <a:p xmlns:a="http://schemas.openxmlformats.org/drawingml/2006/main">
             <a:pPr>
+              <a:buNone/>
               <a:defRPr sz="1500" b="1">
                 <a:solidFill>
                   <a:srgbClr val="087F77"/>
@@ -10862,6 +11028,7 @@
           <a:lstStyle xmlns:a="http://schemas.openxmlformats.org/drawingml/2006/main"/>
           <a:p xmlns:a="http://schemas.openxmlformats.org/drawingml/2006/main">
             <a:pPr>
+              <a:buNone/>
               <a:defRPr sz="1500" b="0">
                 <a:solidFill>
                   <a:srgbClr val="153246"/>
@@ -10919,6 +11086,7 @@
           <a:lstStyle xmlns:a="http://schemas.openxmlformats.org/drawingml/2006/main"/>
           <a:p xmlns:a="http://schemas.openxmlformats.org/drawingml/2006/main">
             <a:pPr>
+              <a:buNone/>
               <a:defRPr sz="1500" b="1">
                 <a:solidFill>
                   <a:srgbClr val="087F77"/>
@@ -10976,6 +11144,7 @@
           <a:lstStyle xmlns:a="http://schemas.openxmlformats.org/drawingml/2006/main"/>
           <a:p xmlns:a="http://schemas.openxmlformats.org/drawingml/2006/main">
             <a:pPr>
+              <a:buNone/>
               <a:defRPr sz="1500" b="0">
                 <a:solidFill>
                   <a:srgbClr val="153246"/>
@@ -11033,6 +11202,7 @@
           <a:lstStyle xmlns:a="http://schemas.openxmlformats.org/drawingml/2006/main"/>
           <a:p xmlns:a="http://schemas.openxmlformats.org/drawingml/2006/main">
             <a:pPr>
+              <a:buNone/>
               <a:defRPr sz="1500" b="1">
                 <a:solidFill>
                   <a:srgbClr val="087F77"/>
@@ -11090,6 +11260,7 @@
           <a:lstStyle xmlns:a="http://schemas.openxmlformats.org/drawingml/2006/main"/>
           <a:p xmlns:a="http://schemas.openxmlformats.org/drawingml/2006/main">
             <a:pPr>
+              <a:buNone/>
               <a:defRPr sz="1500" b="0">
                 <a:solidFill>
                   <a:srgbClr val="153246"/>
@@ -11176,6 +11347,7 @@
           <a:lstStyle xmlns:a="http://schemas.openxmlformats.org/drawingml/2006/main"/>
           <a:p xmlns:a="http://schemas.openxmlformats.org/drawingml/2006/main">
             <a:pPr>
+              <a:buNone/>
               <a:defRPr sz="1200" b="1">
                 <a:solidFill>
                   <a:srgbClr val="B45136"/>
@@ -11233,6 +11405,7 @@
           <a:lstStyle xmlns:a="http://schemas.openxmlformats.org/drawingml/2006/main"/>
           <a:p xmlns:a="http://schemas.openxmlformats.org/drawingml/2006/main">
             <a:pPr>
+              <a:buNone/>
               <a:defRPr sz="3075" b="1">
                 <a:solidFill>
                   <a:srgbClr val="153246"/>
@@ -11290,6 +11463,7 @@
           <a:lstStyle xmlns:a="http://schemas.openxmlformats.org/drawingml/2006/main"/>
           <a:p xmlns:a="http://schemas.openxmlformats.org/drawingml/2006/main">
             <a:pPr>
+              <a:buNone/>
               <a:defRPr sz="1050" b="0">
                 <a:solidFill>
                   <a:srgbClr val="526675"/>
@@ -11347,6 +11521,7 @@
           <a:lstStyle xmlns:a="http://schemas.openxmlformats.org/drawingml/2006/main"/>
           <a:p xmlns:a="http://schemas.openxmlformats.org/drawingml/2006/main">
             <a:pPr>
+              <a:buNone/>
               <a:defRPr sz="1050" b="0">
                 <a:solidFill>
                   <a:srgbClr val="526675"/>
@@ -11404,6 +11579,7 @@
           <a:lstStyle xmlns:a="http://schemas.openxmlformats.org/drawingml/2006/main"/>
           <a:p xmlns:a="http://schemas.openxmlformats.org/drawingml/2006/main">
             <a:pPr>
+              <a:buNone/>
               <a:defRPr sz="1500" b="1">
                 <a:solidFill>
                   <a:srgbClr val="087F77"/>
@@ -11461,6 +11637,7 @@
           <a:lstStyle xmlns:a="http://schemas.openxmlformats.org/drawingml/2006/main"/>
           <a:p xmlns:a="http://schemas.openxmlformats.org/drawingml/2006/main">
             <a:pPr>
+              <a:buNone/>
               <a:defRPr sz="1500" b="0">
                 <a:solidFill>
                   <a:srgbClr val="153246"/>
@@ -11518,6 +11695,7 @@
           <a:lstStyle xmlns:a="http://schemas.openxmlformats.org/drawingml/2006/main"/>
           <a:p xmlns:a="http://schemas.openxmlformats.org/drawingml/2006/main">
             <a:pPr>
+              <a:buNone/>
               <a:defRPr sz="1500" b="1">
                 <a:solidFill>
                   <a:srgbClr val="087F77"/>
@@ -11575,6 +11753,7 @@
           <a:lstStyle xmlns:a="http://schemas.openxmlformats.org/drawingml/2006/main"/>
           <a:p xmlns:a="http://schemas.openxmlformats.org/drawingml/2006/main">
             <a:pPr>
+              <a:buNone/>
               <a:defRPr sz="1500" b="0">
                 <a:solidFill>
                   <a:srgbClr val="153246"/>
@@ -11632,6 +11811,7 @@
           <a:lstStyle xmlns:a="http://schemas.openxmlformats.org/drawingml/2006/main"/>
           <a:p xmlns:a="http://schemas.openxmlformats.org/drawingml/2006/main">
             <a:pPr>
+              <a:buNone/>
               <a:defRPr sz="1500" b="1">
                 <a:solidFill>
                   <a:srgbClr val="087F77"/>
@@ -11689,6 +11869,7 @@
           <a:lstStyle xmlns:a="http://schemas.openxmlformats.org/drawingml/2006/main"/>
           <a:p xmlns:a="http://schemas.openxmlformats.org/drawingml/2006/main">
             <a:pPr>
+              <a:buNone/>
               <a:defRPr sz="1500" b="0">
                 <a:solidFill>
                   <a:srgbClr val="153246"/>
@@ -11746,6 +11927,7 @@
           <a:lstStyle xmlns:a="http://schemas.openxmlformats.org/drawingml/2006/main"/>
           <a:p xmlns:a="http://schemas.openxmlformats.org/drawingml/2006/main">
             <a:pPr>
+              <a:buNone/>
               <a:defRPr sz="1500" b="1">
                 <a:solidFill>
                   <a:srgbClr val="087F77"/>
@@ -11803,6 +11985,7 @@
           <a:lstStyle xmlns:a="http://schemas.openxmlformats.org/drawingml/2006/main"/>
           <a:p xmlns:a="http://schemas.openxmlformats.org/drawingml/2006/main">
             <a:pPr>
+              <a:buNone/>
               <a:defRPr sz="1500" b="0">
                 <a:solidFill>
                   <a:srgbClr val="153246"/>
@@ -11860,6 +12043,7 @@
           <a:lstStyle xmlns:a="http://schemas.openxmlformats.org/drawingml/2006/main"/>
           <a:p xmlns:a="http://schemas.openxmlformats.org/drawingml/2006/main">
             <a:pPr>
+              <a:buNone/>
               <a:defRPr sz="1500" b="1">
                 <a:solidFill>
                   <a:srgbClr val="087F77"/>
@@ -11917,6 +12101,7 @@
           <a:lstStyle xmlns:a="http://schemas.openxmlformats.org/drawingml/2006/main"/>
           <a:p xmlns:a="http://schemas.openxmlformats.org/drawingml/2006/main">
             <a:pPr>
+              <a:buNone/>
               <a:defRPr sz="1500" b="0">
                 <a:solidFill>
                   <a:srgbClr val="153246"/>
@@ -11974,6 +12159,7 @@
           <a:lstStyle xmlns:a="http://schemas.openxmlformats.org/drawingml/2006/main"/>
           <a:p xmlns:a="http://schemas.openxmlformats.org/drawingml/2006/main">
             <a:pPr>
+              <a:buNone/>
               <a:defRPr sz="1500" b="1">
                 <a:solidFill>
                   <a:srgbClr val="087F77"/>
@@ -12031,6 +12217,7 @@
           <a:lstStyle xmlns:a="http://schemas.openxmlformats.org/drawingml/2006/main"/>
           <a:p xmlns:a="http://schemas.openxmlformats.org/drawingml/2006/main">
             <a:pPr>
+              <a:buNone/>
               <a:defRPr sz="1500" b="0">
                 <a:solidFill>
                   <a:srgbClr val="153246"/>
@@ -12088,6 +12275,7 @@
           <a:lstStyle xmlns:a="http://schemas.openxmlformats.org/drawingml/2006/main"/>
           <a:p xmlns:a="http://schemas.openxmlformats.org/drawingml/2006/main">
             <a:pPr>
+              <a:buNone/>
               <a:defRPr sz="1500" b="1">
                 <a:solidFill>
                   <a:srgbClr val="087F77"/>
@@ -12145,6 +12333,7 @@
           <a:lstStyle xmlns:a="http://schemas.openxmlformats.org/drawingml/2006/main"/>
           <a:p xmlns:a="http://schemas.openxmlformats.org/drawingml/2006/main">
             <a:pPr>
+              <a:buNone/>
               <a:defRPr sz="1500" b="0">
                 <a:solidFill>
                   <a:srgbClr val="153246"/>
@@ -12231,6 +12420,7 @@
           <a:lstStyle xmlns:a="http://schemas.openxmlformats.org/drawingml/2006/main"/>
           <a:p xmlns:a="http://schemas.openxmlformats.org/drawingml/2006/main">
             <a:pPr>
+              <a:buNone/>
               <a:defRPr sz="1200" b="1">
                 <a:solidFill>
                   <a:srgbClr val="B45136"/>
@@ -12288,6 +12478,7 @@
           <a:lstStyle xmlns:a="http://schemas.openxmlformats.org/drawingml/2006/main"/>
           <a:p xmlns:a="http://schemas.openxmlformats.org/drawingml/2006/main">
             <a:pPr>
+              <a:buNone/>
               <a:defRPr sz="3075" b="1">
                 <a:solidFill>
                   <a:srgbClr val="153246"/>
@@ -12345,6 +12536,7 @@
           <a:lstStyle xmlns:a="http://schemas.openxmlformats.org/drawingml/2006/main"/>
           <a:p xmlns:a="http://schemas.openxmlformats.org/drawingml/2006/main">
             <a:pPr>
+              <a:buNone/>
               <a:defRPr sz="1050" b="0">
                 <a:solidFill>
                   <a:srgbClr val="526675"/>
@@ -12402,6 +12594,7 @@
           <a:lstStyle xmlns:a="http://schemas.openxmlformats.org/drawingml/2006/main"/>
           <a:p xmlns:a="http://schemas.openxmlformats.org/drawingml/2006/main">
             <a:pPr>
+              <a:buNone/>
               <a:defRPr sz="1050" b="0">
                 <a:solidFill>
                   <a:srgbClr val="526675"/>
@@ -12459,6 +12652,7 @@
           <a:lstStyle xmlns:a="http://schemas.openxmlformats.org/drawingml/2006/main"/>
           <a:p xmlns:a="http://schemas.openxmlformats.org/drawingml/2006/main">
             <a:pPr>
+              <a:buNone/>
               <a:defRPr sz="2475" b="1">
                 <a:solidFill>
                   <a:srgbClr val="153246"/>
@@ -12516,6 +12710,7 @@
           <a:lstStyle xmlns:a="http://schemas.openxmlformats.org/drawingml/2006/main"/>
           <a:p xmlns:a="http://schemas.openxmlformats.org/drawingml/2006/main">
             <a:pPr>
+              <a:buNone/>
               <a:defRPr sz="2250" b="0">
                 <a:solidFill>
                   <a:srgbClr val="B45136"/>
@@ -12573,6 +12768,7 @@
           <a:lstStyle xmlns:a="http://schemas.openxmlformats.org/drawingml/2006/main"/>
           <a:p xmlns:a="http://schemas.openxmlformats.org/drawingml/2006/main">
             <a:pPr>
+              <a:buNone/>
               <a:defRPr sz="2175" b="0">
                 <a:solidFill>
                   <a:srgbClr val="087F77"/>
@@ -12591,7 +12787,7 @@
                 <a:ea typeface="Bitstream Charter"/>
                 <a:cs typeface="Bitstream Charter"/>
               </a:rPr>
-              <a:t>The forecast earns further testing. USCIS documented lineage and alert-noise fixes offer a pattern other agencies can validate.</a:t>
+              <a:t>The forecast merits further testing. The reference offers lineage and retraining design ideas, with alert grouping still planned.</a:t>
             </a:r>
           </a:p>
         </p:txBody>
@@ -12630,6 +12826,7 @@
           <a:lstStyle xmlns:a="http://schemas.openxmlformats.org/drawingml/2006/main"/>
           <a:p xmlns:a="http://schemas.openxmlformats.org/drawingml/2006/main">
             <a:pPr>
+              <a:buNone/>
               <a:defRPr sz="1800" b="0">
                 <a:solidFill>
                   <a:srgbClr val="526675"/>
@@ -12716,6 +12913,7 @@
           <a:lstStyle xmlns:a="http://schemas.openxmlformats.org/drawingml/2006/main"/>
           <a:p xmlns:a="http://schemas.openxmlformats.org/drawingml/2006/main">
             <a:pPr>
+              <a:buNone/>
               <a:defRPr sz="1200" b="1">
                 <a:solidFill>
                   <a:srgbClr val="B45136"/>
@@ -12773,6 +12971,7 @@
           <a:lstStyle xmlns:a="http://schemas.openxmlformats.org/drawingml/2006/main"/>
           <a:p xmlns:a="http://schemas.openxmlformats.org/drawingml/2006/main">
             <a:pPr>
+              <a:buNone/>
               <a:defRPr sz="3075" b="1">
                 <a:solidFill>
                   <a:srgbClr val="153246"/>
@@ -12830,6 +13029,7 @@
           <a:lstStyle xmlns:a="http://schemas.openxmlformats.org/drawingml/2006/main"/>
           <a:p xmlns:a="http://schemas.openxmlformats.org/drawingml/2006/main">
             <a:pPr>
+              <a:buNone/>
               <a:defRPr sz="1050" b="0">
                 <a:solidFill>
                   <a:srgbClr val="526675"/>
@@ -12887,6 +13087,7 @@
           <a:lstStyle xmlns:a="http://schemas.openxmlformats.org/drawingml/2006/main"/>
           <a:p xmlns:a="http://schemas.openxmlformats.org/drawingml/2006/main">
             <a:pPr>
+              <a:buNone/>
               <a:defRPr sz="1050" b="0">
                 <a:solidFill>
                   <a:srgbClr val="526675"/>
@@ -12944,6 +13145,7 @@
           <a:lstStyle xmlns:a="http://schemas.openxmlformats.org/drawingml/2006/main"/>
           <a:p xmlns:a="http://schemas.openxmlformats.org/drawingml/2006/main">
             <a:pPr>
+              <a:buNone/>
               <a:defRPr sz="1725" b="1">
                 <a:solidFill>
                   <a:srgbClr val="087F77"/>
@@ -13001,6 +13203,7 @@
           <a:lstStyle xmlns:a="http://schemas.openxmlformats.org/drawingml/2006/main"/>
           <a:p xmlns:a="http://schemas.openxmlformats.org/drawingml/2006/main">
             <a:pPr>
+              <a:buNone/>
               <a:defRPr sz="1875" b="0">
                 <a:solidFill>
                   <a:srgbClr val="153246"/>
@@ -13058,6 +13261,7 @@
           <a:lstStyle xmlns:a="http://schemas.openxmlformats.org/drawingml/2006/main"/>
           <a:p xmlns:a="http://schemas.openxmlformats.org/drawingml/2006/main">
             <a:pPr>
+              <a:buNone/>
               <a:defRPr sz="1725" b="1">
                 <a:solidFill>
                   <a:srgbClr val="087F77"/>
@@ -13115,6 +13319,7 @@
           <a:lstStyle xmlns:a="http://schemas.openxmlformats.org/drawingml/2006/main"/>
           <a:p xmlns:a="http://schemas.openxmlformats.org/drawingml/2006/main">
             <a:pPr>
+              <a:buNone/>
               <a:defRPr sz="1875" b="0">
                 <a:solidFill>
                   <a:srgbClr val="153246"/>
@@ -13172,6 +13377,7 @@
           <a:lstStyle xmlns:a="http://schemas.openxmlformats.org/drawingml/2006/main"/>
           <a:p xmlns:a="http://schemas.openxmlformats.org/drawingml/2006/main">
             <a:pPr>
+              <a:buNone/>
               <a:defRPr sz="1725" b="1">
                 <a:solidFill>
                   <a:srgbClr val="087F77"/>
@@ -13229,6 +13435,7 @@
           <a:lstStyle xmlns:a="http://schemas.openxmlformats.org/drawingml/2006/main"/>
           <a:p xmlns:a="http://schemas.openxmlformats.org/drawingml/2006/main">
             <a:pPr>
+              <a:buNone/>
               <a:defRPr sz="1875" b="0">
                 <a:solidFill>
                   <a:srgbClr val="153246"/>
@@ -13315,6 +13522,7 @@
           <a:lstStyle xmlns:a="http://schemas.openxmlformats.org/drawingml/2006/main"/>
           <a:p xmlns:a="http://schemas.openxmlformats.org/drawingml/2006/main">
             <a:pPr>
+              <a:buNone/>
               <a:defRPr sz="1200" b="1">
                 <a:solidFill>
                   <a:srgbClr val="B45136"/>
@@ -13372,6 +13580,7 @@
           <a:lstStyle xmlns:a="http://schemas.openxmlformats.org/drawingml/2006/main"/>
           <a:p xmlns:a="http://schemas.openxmlformats.org/drawingml/2006/main">
             <a:pPr>
+              <a:buNone/>
               <a:defRPr sz="3075" b="1">
                 <a:solidFill>
                   <a:srgbClr val="153246"/>
@@ -13429,6 +13638,7 @@
           <a:lstStyle xmlns:a="http://schemas.openxmlformats.org/drawingml/2006/main"/>
           <a:p xmlns:a="http://schemas.openxmlformats.org/drawingml/2006/main">
             <a:pPr>
+              <a:buNone/>
               <a:defRPr sz="1050" b="0">
                 <a:solidFill>
                   <a:srgbClr val="526675"/>
@@ -13486,6 +13696,7 @@
           <a:lstStyle xmlns:a="http://schemas.openxmlformats.org/drawingml/2006/main"/>
           <a:p xmlns:a="http://schemas.openxmlformats.org/drawingml/2006/main">
             <a:pPr>
+              <a:buNone/>
               <a:defRPr sz="1050" b="0">
                 <a:solidFill>
                   <a:srgbClr val="526675"/>
@@ -13543,6 +13754,7 @@
           <a:lstStyle xmlns:a="http://schemas.openxmlformats.org/drawingml/2006/main"/>
           <a:p xmlns:a="http://schemas.openxmlformats.org/drawingml/2006/main">
             <a:pPr>
+              <a:buNone/>
               <a:defRPr sz="1725" b="1">
                 <a:solidFill>
                   <a:srgbClr val="087F77"/>
@@ -13600,6 +13812,7 @@
           <a:lstStyle xmlns:a="http://schemas.openxmlformats.org/drawingml/2006/main"/>
           <a:p xmlns:a="http://schemas.openxmlformats.org/drawingml/2006/main">
             <a:pPr>
+              <a:buNone/>
               <a:defRPr sz="2025" b="0">
                 <a:solidFill>
                   <a:srgbClr val="153246"/>
@@ -13628,6 +13841,7 @@
           </a:p>
           <a:p xmlns:a="http://schemas.openxmlformats.org/drawingml/2006/main">
             <a:pPr>
+              <a:buNone/>
               <a:defRPr sz="2025" b="0">
                 <a:solidFill>
                   <a:srgbClr val="153246"/>
@@ -13685,6 +13899,7 @@
           <a:lstStyle xmlns:a="http://schemas.openxmlformats.org/drawingml/2006/main"/>
           <a:p xmlns:a="http://schemas.openxmlformats.org/drawingml/2006/main">
             <a:pPr>
+              <a:buNone/>
               <a:defRPr sz="1725" b="1">
                 <a:solidFill>
                   <a:srgbClr val="B45136"/>
@@ -13742,6 +13957,7 @@
           <a:lstStyle xmlns:a="http://schemas.openxmlformats.org/drawingml/2006/main"/>
           <a:p xmlns:a="http://schemas.openxmlformats.org/drawingml/2006/main">
             <a:pPr>
+              <a:buNone/>
               <a:defRPr sz="2025" b="0">
                 <a:solidFill>
                   <a:srgbClr val="153246"/>
@@ -13770,6 +13986,7 @@
           </a:p>
           <a:p xmlns:a="http://schemas.openxmlformats.org/drawingml/2006/main">
             <a:pPr>
+              <a:buNone/>
               <a:defRPr sz="2025" b="0">
                 <a:solidFill>
                   <a:srgbClr val="153246"/>
@@ -13827,6 +14044,7 @@
           <a:lstStyle xmlns:a="http://schemas.openxmlformats.org/drawingml/2006/main"/>
           <a:p xmlns:a="http://schemas.openxmlformats.org/drawingml/2006/main">
             <a:pPr>
+              <a:buNone/>
               <a:defRPr sz="1725" b="0">
                 <a:solidFill>
                   <a:srgbClr val="526675"/>
@@ -13913,6 +14131,7 @@
           <a:lstStyle xmlns:a="http://schemas.openxmlformats.org/drawingml/2006/main"/>
           <a:p xmlns:a="http://schemas.openxmlformats.org/drawingml/2006/main">
             <a:pPr>
+              <a:buNone/>
               <a:defRPr sz="1200" b="1">
                 <a:solidFill>
                   <a:srgbClr val="B45136"/>
@@ -13970,6 +14189,7 @@
           <a:lstStyle xmlns:a="http://schemas.openxmlformats.org/drawingml/2006/main"/>
           <a:p xmlns:a="http://schemas.openxmlformats.org/drawingml/2006/main">
             <a:pPr>
+              <a:buNone/>
               <a:defRPr sz="3075" b="1">
                 <a:solidFill>
                   <a:srgbClr val="153246"/>
@@ -14027,6 +14247,7 @@
           <a:lstStyle xmlns:a="http://schemas.openxmlformats.org/drawingml/2006/main"/>
           <a:p xmlns:a="http://schemas.openxmlformats.org/drawingml/2006/main">
             <a:pPr>
+              <a:buNone/>
               <a:defRPr sz="1050" b="0">
                 <a:solidFill>
                   <a:srgbClr val="526675"/>
@@ -14084,6 +14305,7 @@
           <a:lstStyle xmlns:a="http://schemas.openxmlformats.org/drawingml/2006/main"/>
           <a:p xmlns:a="http://schemas.openxmlformats.org/drawingml/2006/main">
             <a:pPr>
+              <a:buNone/>
               <a:defRPr sz="1050" b="0">
                 <a:solidFill>
                   <a:srgbClr val="526675"/>
@@ -14141,6 +14363,7 @@
           <a:lstStyle xmlns:a="http://schemas.openxmlformats.org/drawingml/2006/main"/>
           <a:p xmlns:a="http://schemas.openxmlformats.org/drawingml/2006/main">
             <a:pPr>
+              <a:buNone/>
               <a:defRPr sz="1725" b="1">
                 <a:solidFill>
                   <a:srgbClr val="087F77"/>
@@ -14198,6 +14421,7 @@
           <a:lstStyle xmlns:a="http://schemas.openxmlformats.org/drawingml/2006/main"/>
           <a:p xmlns:a="http://schemas.openxmlformats.org/drawingml/2006/main">
             <a:pPr>
+              <a:buNone/>
               <a:defRPr sz="1875" b="0">
                 <a:solidFill>
                   <a:srgbClr val="153246"/>
@@ -14255,6 +14479,7 @@
           <a:lstStyle xmlns:a="http://schemas.openxmlformats.org/drawingml/2006/main"/>
           <a:p xmlns:a="http://schemas.openxmlformats.org/drawingml/2006/main">
             <a:pPr>
+              <a:buNone/>
               <a:defRPr sz="1725" b="1">
                 <a:solidFill>
                   <a:srgbClr val="087F77"/>
@@ -14312,6 +14537,7 @@
           <a:lstStyle xmlns:a="http://schemas.openxmlformats.org/drawingml/2006/main"/>
           <a:p xmlns:a="http://schemas.openxmlformats.org/drawingml/2006/main">
             <a:pPr>
+              <a:buNone/>
               <a:defRPr sz="1875" b="0">
                 <a:solidFill>
                   <a:srgbClr val="153246"/>
@@ -14398,6 +14624,7 @@
           <a:lstStyle xmlns:a="http://schemas.openxmlformats.org/drawingml/2006/main"/>
           <a:p xmlns:a="http://schemas.openxmlformats.org/drawingml/2006/main">
             <a:pPr>
+              <a:buNone/>
               <a:defRPr sz="1200" b="1">
                 <a:solidFill>
                   <a:srgbClr val="B45136"/>
@@ -14455,6 +14682,7 @@
           <a:lstStyle xmlns:a="http://schemas.openxmlformats.org/drawingml/2006/main"/>
           <a:p xmlns:a="http://schemas.openxmlformats.org/drawingml/2006/main">
             <a:pPr>
+              <a:buNone/>
               <a:defRPr sz="3075" b="1">
                 <a:solidFill>
                   <a:srgbClr val="153246"/>
@@ -14512,6 +14740,7 @@
           <a:lstStyle xmlns:a="http://schemas.openxmlformats.org/drawingml/2006/main"/>
           <a:p xmlns:a="http://schemas.openxmlformats.org/drawingml/2006/main">
             <a:pPr>
+              <a:buNone/>
               <a:defRPr sz="1050" b="0">
                 <a:solidFill>
                   <a:srgbClr val="526675"/>
@@ -14569,6 +14798,7 @@
           <a:lstStyle xmlns:a="http://schemas.openxmlformats.org/drawingml/2006/main"/>
           <a:p xmlns:a="http://schemas.openxmlformats.org/drawingml/2006/main">
             <a:pPr>
+              <a:buNone/>
               <a:defRPr sz="1050" b="0">
                 <a:solidFill>
                   <a:srgbClr val="526675"/>
@@ -14626,6 +14856,7 @@
           <a:lstStyle xmlns:a="http://schemas.openxmlformats.org/drawingml/2006/main"/>
           <a:p xmlns:a="http://schemas.openxmlformats.org/drawingml/2006/main">
             <a:pPr>
+              <a:buNone/>
               <a:defRPr sz="1725" b="1">
                 <a:solidFill>
                   <a:srgbClr val="087F77"/>
@@ -14683,6 +14914,7 @@
           <a:lstStyle xmlns:a="http://schemas.openxmlformats.org/drawingml/2006/main"/>
           <a:p xmlns:a="http://schemas.openxmlformats.org/drawingml/2006/main">
             <a:pPr>
+              <a:buNone/>
               <a:defRPr sz="1950" b="0">
                 <a:solidFill>
                   <a:srgbClr val="153246"/>
@@ -14701,7 +14933,7 @@
                 <a:ea typeface="Bitstream Charter"/>
                 <a:cs typeface="Bitstream Charter"/>
               </a:rPr>
-              <a:t>Set how much past data each check reads and whether the demo saves any tables or models.</a:t>
+              <a:t>Set the history length and optional Delta or registry destinations. MLflow logs models when available.</a:t>
             </a:r>
           </a:p>
         </p:txBody>
@@ -14740,6 +14972,7 @@
           <a:lstStyle xmlns:a="http://schemas.openxmlformats.org/drawingml/2006/main"/>
           <a:p xmlns:a="http://schemas.openxmlformats.org/drawingml/2006/main">
             <a:pPr>
+              <a:buNone/>
               <a:defRPr sz="1725" b="1">
                 <a:solidFill>
                   <a:srgbClr val="087F77"/>
@@ -14797,6 +15030,7 @@
           <a:lstStyle xmlns:a="http://schemas.openxmlformats.org/drawingml/2006/main"/>
           <a:p xmlns:a="http://schemas.openxmlformats.org/drawingml/2006/main">
             <a:pPr>
+              <a:buNone/>
               <a:defRPr sz="1800" b="0">
                 <a:solidFill>
                   <a:srgbClr val="153246"/>
@@ -14854,6 +15088,7 @@
           <a:lstStyle xmlns:a="http://schemas.openxmlformats.org/drawingml/2006/main"/>
           <a:p xmlns:a="http://schemas.openxmlformats.org/drawingml/2006/main">
             <a:pPr>
+              <a:buNone/>
               <a:defRPr sz="1725" b="1">
                 <a:solidFill>
                   <a:srgbClr val="B45136"/>
@@ -14911,6 +15146,7 @@
           <a:lstStyle xmlns:a="http://schemas.openxmlformats.org/drawingml/2006/main"/>
           <a:p xmlns:a="http://schemas.openxmlformats.org/drawingml/2006/main">
             <a:pPr>
+              <a:buNone/>
               <a:defRPr sz="1950" b="0">
                 <a:solidFill>
                   <a:srgbClr val="153246"/>
@@ -14968,6 +15204,7 @@
           <a:lstStyle xmlns:a="http://schemas.openxmlformats.org/drawingml/2006/main"/>
           <a:p xmlns:a="http://schemas.openxmlformats.org/drawingml/2006/main">
             <a:pPr>
+              <a:buNone/>
               <a:defRPr sz="1725" b="1">
                 <a:solidFill>
                   <a:srgbClr val="B45136"/>
@@ -15025,6 +15262,7 @@
           <a:lstStyle xmlns:a="http://schemas.openxmlformats.org/drawingml/2006/main"/>
           <a:p xmlns:a="http://schemas.openxmlformats.org/drawingml/2006/main">
             <a:pPr>
+              <a:buNone/>
               <a:defRPr sz="1800" b="0">
                 <a:solidFill>
                   <a:srgbClr val="153246"/>
@@ -15111,6 +15349,7 @@
           <a:lstStyle xmlns:a="http://schemas.openxmlformats.org/drawingml/2006/main"/>
           <a:p xmlns:a="http://schemas.openxmlformats.org/drawingml/2006/main">
             <a:pPr>
+              <a:buNone/>
               <a:defRPr sz="1200" b="1">
                 <a:solidFill>
                   <a:srgbClr val="B45136"/>
@@ -15168,6 +15407,7 @@
           <a:lstStyle xmlns:a="http://schemas.openxmlformats.org/drawingml/2006/main"/>
           <a:p xmlns:a="http://schemas.openxmlformats.org/drawingml/2006/main">
             <a:pPr>
+              <a:buNone/>
               <a:defRPr sz="3075" b="1">
                 <a:solidFill>
                   <a:srgbClr val="153246"/>
@@ -15225,6 +15465,7 @@
           <a:lstStyle xmlns:a="http://schemas.openxmlformats.org/drawingml/2006/main"/>
           <a:p xmlns:a="http://schemas.openxmlformats.org/drawingml/2006/main">
             <a:pPr>
+              <a:buNone/>
               <a:defRPr sz="1050" b="0">
                 <a:solidFill>
                   <a:srgbClr val="526675"/>
@@ -15282,6 +15523,7 @@
           <a:lstStyle xmlns:a="http://schemas.openxmlformats.org/drawingml/2006/main"/>
           <a:p xmlns:a="http://schemas.openxmlformats.org/drawingml/2006/main">
             <a:pPr>
+              <a:buNone/>
               <a:defRPr sz="1050" b="0">
                 <a:solidFill>
                   <a:srgbClr val="526675"/>
@@ -15339,6 +15581,7 @@
           <a:lstStyle xmlns:a="http://schemas.openxmlformats.org/drawingml/2006/main"/>
           <a:p xmlns:a="http://schemas.openxmlformats.org/drawingml/2006/main">
             <a:pPr>
+              <a:buNone/>
               <a:defRPr sz="1725" b="1">
                 <a:solidFill>
                   <a:srgbClr val="087F77"/>
@@ -15396,6 +15639,7 @@
           <a:lstStyle xmlns:a="http://schemas.openxmlformats.org/drawingml/2006/main"/>
           <a:p xmlns:a="http://schemas.openxmlformats.org/drawingml/2006/main">
             <a:pPr>
+              <a:buNone/>
               <a:defRPr sz="1950" b="0">
                 <a:solidFill>
                   <a:srgbClr val="153246"/>
@@ -15453,6 +15697,7 @@
           <a:lstStyle xmlns:a="http://schemas.openxmlformats.org/drawingml/2006/main"/>
           <a:p xmlns:a="http://schemas.openxmlformats.org/drawingml/2006/main">
             <a:pPr>
+              <a:buNone/>
               <a:defRPr sz="1725" b="1">
                 <a:solidFill>
                   <a:srgbClr val="087F77"/>
@@ -15510,6 +15755,7 @@
           <a:lstStyle xmlns:a="http://schemas.openxmlformats.org/drawingml/2006/main"/>
           <a:p xmlns:a="http://schemas.openxmlformats.org/drawingml/2006/main">
             <a:pPr>
+              <a:buNone/>
               <a:defRPr sz="1800" b="0">
                 <a:solidFill>
                   <a:srgbClr val="153246"/>
@@ -15567,6 +15813,7 @@
           <a:lstStyle xmlns:a="http://schemas.openxmlformats.org/drawingml/2006/main"/>
           <a:p xmlns:a="http://schemas.openxmlformats.org/drawingml/2006/main">
             <a:pPr>
+              <a:buNone/>
               <a:defRPr sz="1725" b="1">
                 <a:solidFill>
                   <a:srgbClr val="B45136"/>
@@ -15624,6 +15871,7 @@
           <a:lstStyle xmlns:a="http://schemas.openxmlformats.org/drawingml/2006/main"/>
           <a:p xmlns:a="http://schemas.openxmlformats.org/drawingml/2006/main">
             <a:pPr>
+              <a:buNone/>
               <a:defRPr sz="1950" b="0">
                 <a:solidFill>
                   <a:srgbClr val="153246"/>
@@ -15681,6 +15929,7 @@
           <a:lstStyle xmlns:a="http://schemas.openxmlformats.org/drawingml/2006/main"/>
           <a:p xmlns:a="http://schemas.openxmlformats.org/drawingml/2006/main">
             <a:pPr>
+              <a:buNone/>
               <a:defRPr sz="1725" b="1">
                 <a:solidFill>
                   <a:srgbClr val="B45136"/>
@@ -15738,6 +15987,7 @@
           <a:lstStyle xmlns:a="http://schemas.openxmlformats.org/drawingml/2006/main"/>
           <a:p xmlns:a="http://schemas.openxmlformats.org/drawingml/2006/main">
             <a:pPr>
+              <a:buNone/>
               <a:defRPr sz="1800" b="0">
                 <a:solidFill>
                   <a:srgbClr val="153246"/>
@@ -15824,6 +16074,7 @@
           <a:lstStyle xmlns:a="http://schemas.openxmlformats.org/drawingml/2006/main"/>
           <a:p xmlns:a="http://schemas.openxmlformats.org/drawingml/2006/main">
             <a:pPr>
+              <a:buNone/>
               <a:defRPr sz="1200" b="1">
                 <a:solidFill>
                   <a:srgbClr val="B45136"/>
@@ -15881,6 +16132,7 @@
           <a:lstStyle xmlns:a="http://schemas.openxmlformats.org/drawingml/2006/main"/>
           <a:p xmlns:a="http://schemas.openxmlformats.org/drawingml/2006/main">
             <a:pPr>
+              <a:buNone/>
               <a:defRPr sz="3075" b="1">
                 <a:solidFill>
                   <a:srgbClr val="153246"/>
@@ -15938,6 +16190,7 @@
           <a:lstStyle xmlns:a="http://schemas.openxmlformats.org/drawingml/2006/main"/>
           <a:p xmlns:a="http://schemas.openxmlformats.org/drawingml/2006/main">
             <a:pPr>
+              <a:buNone/>
               <a:defRPr sz="1050" b="0">
                 <a:solidFill>
                   <a:srgbClr val="526675"/>
@@ -15995,6 +16248,7 @@
           <a:lstStyle xmlns:a="http://schemas.openxmlformats.org/drawingml/2006/main"/>
           <a:p xmlns:a="http://schemas.openxmlformats.org/drawingml/2006/main">
             <a:pPr>
+              <a:buNone/>
               <a:defRPr sz="1050" b="0">
                 <a:solidFill>
                   <a:srgbClr val="526675"/>
@@ -16052,6 +16306,7 @@
           <a:lstStyle xmlns:a="http://schemas.openxmlformats.org/drawingml/2006/main"/>
           <a:p xmlns:a="http://schemas.openxmlformats.org/drawingml/2006/main">
             <a:pPr>
+              <a:buNone/>
               <a:defRPr sz="1725" b="1">
                 <a:solidFill>
                   <a:srgbClr val="087F77"/>
@@ -16109,6 +16364,7 @@
           <a:lstStyle xmlns:a="http://schemas.openxmlformats.org/drawingml/2006/main"/>
           <a:p xmlns:a="http://schemas.openxmlformats.org/drawingml/2006/main">
             <a:pPr>
+              <a:buNone/>
               <a:defRPr sz="1950" b="0">
                 <a:solidFill>
                   <a:srgbClr val="153246"/>
@@ -16166,6 +16422,7 @@
           <a:lstStyle xmlns:a="http://schemas.openxmlformats.org/drawingml/2006/main"/>
           <a:p xmlns:a="http://schemas.openxmlformats.org/drawingml/2006/main">
             <a:pPr>
+              <a:buNone/>
               <a:defRPr sz="1725" b="1">
                 <a:solidFill>
                   <a:srgbClr val="087F77"/>
@@ -16223,6 +16480,7 @@
           <a:lstStyle xmlns:a="http://schemas.openxmlformats.org/drawingml/2006/main"/>
           <a:p xmlns:a="http://schemas.openxmlformats.org/drawingml/2006/main">
             <a:pPr>
+              <a:buNone/>
               <a:defRPr sz="1800" b="0">
                 <a:solidFill>
                   <a:srgbClr val="153246"/>
@@ -16280,6 +16538,7 @@
           <a:lstStyle xmlns:a="http://schemas.openxmlformats.org/drawingml/2006/main"/>
           <a:p xmlns:a="http://schemas.openxmlformats.org/drawingml/2006/main">
             <a:pPr>
+              <a:buNone/>
               <a:defRPr sz="1725" b="1">
                 <a:solidFill>
                   <a:srgbClr val="B45136"/>
@@ -16337,6 +16596,7 @@
           <a:lstStyle xmlns:a="http://schemas.openxmlformats.org/drawingml/2006/main"/>
           <a:p xmlns:a="http://schemas.openxmlformats.org/drawingml/2006/main">
             <a:pPr>
+              <a:buNone/>
               <a:defRPr sz="1950" b="0">
                 <a:solidFill>
                   <a:srgbClr val="153246"/>
@@ -16394,6 +16654,7 @@
           <a:lstStyle xmlns:a="http://schemas.openxmlformats.org/drawingml/2006/main"/>
           <a:p xmlns:a="http://schemas.openxmlformats.org/drawingml/2006/main">
             <a:pPr>
+              <a:buNone/>
               <a:defRPr sz="1725" b="1">
                 <a:solidFill>
                   <a:srgbClr val="B45136"/>
@@ -16451,6 +16712,7 @@
           <a:lstStyle xmlns:a="http://schemas.openxmlformats.org/drawingml/2006/main"/>
           <a:p xmlns:a="http://schemas.openxmlformats.org/drawingml/2006/main">
             <a:pPr>
+              <a:buNone/>
               <a:defRPr sz="1800" b="0">
                 <a:solidFill>
                   <a:srgbClr val="153246"/>
@@ -16537,6 +16799,7 @@
           <a:lstStyle xmlns:a="http://schemas.openxmlformats.org/drawingml/2006/main"/>
           <a:p xmlns:a="http://schemas.openxmlformats.org/drawingml/2006/main">
             <a:pPr>
+              <a:buNone/>
               <a:defRPr sz="1200" b="1">
                 <a:solidFill>
                   <a:srgbClr val="B45136"/>
@@ -16594,6 +16857,7 @@
           <a:lstStyle xmlns:a="http://schemas.openxmlformats.org/drawingml/2006/main"/>
           <a:p xmlns:a="http://schemas.openxmlformats.org/drawingml/2006/main">
             <a:pPr>
+              <a:buNone/>
               <a:defRPr sz="3075" b="1">
                 <a:solidFill>
                   <a:srgbClr val="153246"/>
@@ -16651,6 +16915,7 @@
           <a:lstStyle xmlns:a="http://schemas.openxmlformats.org/drawingml/2006/main"/>
           <a:p xmlns:a="http://schemas.openxmlformats.org/drawingml/2006/main">
             <a:pPr>
+              <a:buNone/>
               <a:defRPr sz="1050" b="0">
                 <a:solidFill>
                   <a:srgbClr val="526675"/>
@@ -16708,6 +16973,7 @@
           <a:lstStyle xmlns:a="http://schemas.openxmlformats.org/drawingml/2006/main"/>
           <a:p xmlns:a="http://schemas.openxmlformats.org/drawingml/2006/main">
             <a:pPr>
+              <a:buNone/>
               <a:defRPr sz="1050" b="0">
                 <a:solidFill>
                   <a:srgbClr val="526675"/>
@@ -16765,6 +17031,7 @@
           <a:lstStyle xmlns:a="http://schemas.openxmlformats.org/drawingml/2006/main"/>
           <a:p xmlns:a="http://schemas.openxmlformats.org/drawingml/2006/main">
             <a:pPr>
+              <a:buNone/>
               <a:defRPr sz="1725" b="1">
                 <a:solidFill>
                   <a:srgbClr val="087F77"/>
@@ -16822,6 +17089,7 @@
           <a:lstStyle xmlns:a="http://schemas.openxmlformats.org/drawingml/2006/main"/>
           <a:p xmlns:a="http://schemas.openxmlformats.org/drawingml/2006/main">
             <a:pPr>
+              <a:buNone/>
               <a:defRPr sz="1950" b="0">
                 <a:solidFill>
                   <a:srgbClr val="153246"/>
@@ -16879,6 +17147,7 @@
           <a:lstStyle xmlns:a="http://schemas.openxmlformats.org/drawingml/2006/main"/>
           <a:p xmlns:a="http://schemas.openxmlformats.org/drawingml/2006/main">
             <a:pPr>
+              <a:buNone/>
               <a:defRPr sz="1725" b="1">
                 <a:solidFill>
                   <a:srgbClr val="087F77"/>
@@ -16936,6 +17205,7 @@
           <a:lstStyle xmlns:a="http://schemas.openxmlformats.org/drawingml/2006/main"/>
           <a:p xmlns:a="http://schemas.openxmlformats.org/drawingml/2006/main">
             <a:pPr>
+              <a:buNone/>
               <a:defRPr sz="1800" b="0">
                 <a:solidFill>
                   <a:srgbClr val="153246"/>
@@ -16993,6 +17263,7 @@
           <a:lstStyle xmlns:a="http://schemas.openxmlformats.org/drawingml/2006/main"/>
           <a:p xmlns:a="http://schemas.openxmlformats.org/drawingml/2006/main">
             <a:pPr>
+              <a:buNone/>
               <a:defRPr sz="1725" b="1">
                 <a:solidFill>
                   <a:srgbClr val="B45136"/>
@@ -17050,6 +17321,7 @@
           <a:lstStyle xmlns:a="http://schemas.openxmlformats.org/drawingml/2006/main"/>
           <a:p xmlns:a="http://schemas.openxmlformats.org/drawingml/2006/main">
             <a:pPr>
+              <a:buNone/>
               <a:defRPr sz="1950" b="0">
                 <a:solidFill>
                   <a:srgbClr val="153246"/>
@@ -17107,6 +17379,7 @@
           <a:lstStyle xmlns:a="http://schemas.openxmlformats.org/drawingml/2006/main"/>
           <a:p xmlns:a="http://schemas.openxmlformats.org/drawingml/2006/main">
             <a:pPr>
+              <a:buNone/>
               <a:defRPr sz="1725" b="1">
                 <a:solidFill>
                   <a:srgbClr val="B45136"/>
@@ -17164,6 +17437,7 @@
           <a:lstStyle xmlns:a="http://schemas.openxmlformats.org/drawingml/2006/main"/>
           <a:p xmlns:a="http://schemas.openxmlformats.org/drawingml/2006/main">
             <a:pPr>
+              <a:buNone/>
               <a:defRPr sz="1800" b="0">
                 <a:solidFill>
                   <a:srgbClr val="153246"/>

</xml_diff>

<commit_message>
Revise demo wording and document USCIS capability gaps
</commit_message>
<xml_diff>
--- a/docs/SPC_ML_Demo_Walkthrough_Ready.pptx
+++ b/docs/SPC_ML_Demo_Walkthrough_Ready.pptx
@@ -2,34 +2,34 @@
 <file path=ppt/presentation.xml><?xml version="1.0" encoding="utf-8"?>
 <p:presentation xmlns:p="http://schemas.openxmlformats.org/presentationml/2006/main">
   <p:sldMasterIdLst>
-    <p:sldMasterId xmlns:r="http://schemas.openxmlformats.org/officeDocument/2006/relationships" id="2147483648" r:id="Rbdedf4f1c2fc4efa"/>
+    <p:sldMasterId xmlns:r="http://schemas.openxmlformats.org/officeDocument/2006/relationships" id="2147483648" r:id="R2f25c07c1a2340ee"/>
   </p:sldMasterIdLst>
   <p:notesMasterIdLst>
-    <p:notesMasterId xmlns:r="http://schemas.openxmlformats.org/officeDocument/2006/relationships" r:id="Rf7cb1a4d13eb47ce"/>
+    <p:notesMasterId xmlns:r="http://schemas.openxmlformats.org/officeDocument/2006/relationships" r:id="R3a9327079cc44b1c"/>
   </p:notesMasterIdLst>
   <p:sldIdLst>
-    <p:sldId xmlns:r="http://schemas.openxmlformats.org/officeDocument/2006/relationships" id="256" r:id="R7cb9d567bab0472a"/>
-    <p:sldId xmlns:r="http://schemas.openxmlformats.org/officeDocument/2006/relationships" id="257" r:id="Rb3262b16e48c4fce"/>
-    <p:sldId xmlns:r="http://schemas.openxmlformats.org/officeDocument/2006/relationships" id="258" r:id="R154d9024eec44597"/>
-    <p:sldId xmlns:r="http://schemas.openxmlformats.org/officeDocument/2006/relationships" id="259" r:id="R4821b5ff02c24732"/>
-    <p:sldId xmlns:r="http://schemas.openxmlformats.org/officeDocument/2006/relationships" id="260" r:id="Rb5265c8835f748bd"/>
-    <p:sldId xmlns:r="http://schemas.openxmlformats.org/officeDocument/2006/relationships" id="261" r:id="R201ecddd8a1247fa"/>
-    <p:sldId xmlns:r="http://schemas.openxmlformats.org/officeDocument/2006/relationships" id="262" r:id="R7e8d71988c604e63"/>
-    <p:sldId xmlns:r="http://schemas.openxmlformats.org/officeDocument/2006/relationships" id="263" r:id="R4ace0f979e814f5d"/>
-    <p:sldId xmlns:r="http://schemas.openxmlformats.org/officeDocument/2006/relationships" id="264" r:id="R4439395985f442a2"/>
-    <p:sldId xmlns:r="http://schemas.openxmlformats.org/officeDocument/2006/relationships" id="265" r:id="Rda7b8b2336394ce7"/>
-    <p:sldId xmlns:r="http://schemas.openxmlformats.org/officeDocument/2006/relationships" id="266" r:id="Rd2652a4ffb324680"/>
-    <p:sldId xmlns:r="http://schemas.openxmlformats.org/officeDocument/2006/relationships" id="267" r:id="Rf25e2eadda7c422f"/>
-    <p:sldId xmlns:r="http://schemas.openxmlformats.org/officeDocument/2006/relationships" id="268" r:id="R4aa30fcdfbbc4940"/>
-    <p:sldId xmlns:r="http://schemas.openxmlformats.org/officeDocument/2006/relationships" id="269" r:id="R866797a2b0924ffa"/>
-    <p:sldId xmlns:r="http://schemas.openxmlformats.org/officeDocument/2006/relationships" id="270" r:id="R3a538856ad864979"/>
-    <p:sldId xmlns:r="http://schemas.openxmlformats.org/officeDocument/2006/relationships" id="271" r:id="Rc845fb6719b0460f"/>
-    <p:sldId xmlns:r="http://schemas.openxmlformats.org/officeDocument/2006/relationships" id="272" r:id="Rf0191c5894b94cca"/>
-    <p:sldId xmlns:r="http://schemas.openxmlformats.org/officeDocument/2006/relationships" id="273" r:id="Re5a2e3edef6b45d6"/>
-    <p:sldId xmlns:r="http://schemas.openxmlformats.org/officeDocument/2006/relationships" id="274" r:id="R9fdb2d1c7e75401c"/>
-    <p:sldId xmlns:r="http://schemas.openxmlformats.org/officeDocument/2006/relationships" id="275" r:id="R4c668b8f6af34b87"/>
-    <p:sldId xmlns:r="http://schemas.openxmlformats.org/officeDocument/2006/relationships" id="276" r:id="R258eaa44a7794e80"/>
-    <p:sldId xmlns:r="http://schemas.openxmlformats.org/officeDocument/2006/relationships" id="277" r:id="R8e806f99479549d1"/>
+    <p:sldId xmlns:r="http://schemas.openxmlformats.org/officeDocument/2006/relationships" id="256" r:id="R8ee79e8cde044011"/>
+    <p:sldId xmlns:r="http://schemas.openxmlformats.org/officeDocument/2006/relationships" id="257" r:id="Rf93e1d9679f24280"/>
+    <p:sldId xmlns:r="http://schemas.openxmlformats.org/officeDocument/2006/relationships" id="258" r:id="R9db50050c9084933"/>
+    <p:sldId xmlns:r="http://schemas.openxmlformats.org/officeDocument/2006/relationships" id="259" r:id="R54f535a73d2646d7"/>
+    <p:sldId xmlns:r="http://schemas.openxmlformats.org/officeDocument/2006/relationships" id="260" r:id="R912bbff34e8440e6"/>
+    <p:sldId xmlns:r="http://schemas.openxmlformats.org/officeDocument/2006/relationships" id="261" r:id="R9fcea69722e446d3"/>
+    <p:sldId xmlns:r="http://schemas.openxmlformats.org/officeDocument/2006/relationships" id="262" r:id="R06bf748d1c2c4238"/>
+    <p:sldId xmlns:r="http://schemas.openxmlformats.org/officeDocument/2006/relationships" id="263" r:id="R37a62a0f2f384fca"/>
+    <p:sldId xmlns:r="http://schemas.openxmlformats.org/officeDocument/2006/relationships" id="264" r:id="R330f5c706934457b"/>
+    <p:sldId xmlns:r="http://schemas.openxmlformats.org/officeDocument/2006/relationships" id="265" r:id="R20de8bc11ce24ac1"/>
+    <p:sldId xmlns:r="http://schemas.openxmlformats.org/officeDocument/2006/relationships" id="266" r:id="R3e278e6bad6f4ad8"/>
+    <p:sldId xmlns:r="http://schemas.openxmlformats.org/officeDocument/2006/relationships" id="267" r:id="R609d1837c0f94f48"/>
+    <p:sldId xmlns:r="http://schemas.openxmlformats.org/officeDocument/2006/relationships" id="268" r:id="Rd5b73fc641b84c01"/>
+    <p:sldId xmlns:r="http://schemas.openxmlformats.org/officeDocument/2006/relationships" id="269" r:id="R2b7ac97444ee4ea5"/>
+    <p:sldId xmlns:r="http://schemas.openxmlformats.org/officeDocument/2006/relationships" id="270" r:id="R8eda9a6f94154851"/>
+    <p:sldId xmlns:r="http://schemas.openxmlformats.org/officeDocument/2006/relationships" id="271" r:id="R938d7ea6e8d64ca7"/>
+    <p:sldId xmlns:r="http://schemas.openxmlformats.org/officeDocument/2006/relationships" id="272" r:id="R820ed1f7147e42a9"/>
+    <p:sldId xmlns:r="http://schemas.openxmlformats.org/officeDocument/2006/relationships" id="273" r:id="Rcc85f048204e4ac3"/>
+    <p:sldId xmlns:r="http://schemas.openxmlformats.org/officeDocument/2006/relationships" id="274" r:id="Ra0805976a14c473d"/>
+    <p:sldId xmlns:r="http://schemas.openxmlformats.org/officeDocument/2006/relationships" id="275" r:id="R6eb9450bd63c4b76"/>
+    <p:sldId xmlns:r="http://schemas.openxmlformats.org/officeDocument/2006/relationships" id="276" r:id="Rd943ce67ba2e4b2a"/>
+    <p:sldId xmlns:r="http://schemas.openxmlformats.org/officeDocument/2006/relationships" id="277" r:id="Reedc166d97d04fb6"/>
   </p:sldIdLst>
   <p:sldSz cx="12192000" cy="6858000"/>
   <p:notesSz cx="6858000" cy="9144000"/>
@@ -463,7 +463,7 @@
           <a:lstStyle xmlns:a="http://schemas.openxmlformats.org/drawingml/2006/main"/>
           <a:p xmlns:a="http://schemas.openxmlformats.org/drawingml/2006/main">
             <a:r>
-              <a:t>Open with the distinction: this deck explains a working synthetic AttainX notebook. It is a companion to a live Databricks run, not proof of production results. No USCIS data or production artifact is used.</a:t>
+              <a:t>Open with the distinction: this deck explains a working AttainX demo notebook. It is a companion to a live Databricks run, not proof of production results. No USCIS data or production artifact is used.</a:t>
             </a:r>
           </a:p>
         </p:txBody>
@@ -953,7 +953,7 @@
           <a:lstStyle xmlns:a="http://schemas.openxmlformats.org/drawingml/2006/main"/>
           <a:p xmlns:a="http://schemas.openxmlformats.org/drawingml/2006/main">
             <a:r>
-              <a:t>Read these scores from the reproducible seeded notebook. Classifier test labels are 78.1 percent positive, so the always-signal baseline is strong. Accuracy 75.0 percent fails that comparison despite AUC 0.917. The one-day forecast MAE 8.85 counts beats the five-day trailing mean MAE 9.73 counts on synthetic held-out dates only. Neither comparison proves operational benefit at USCIS. Local Python 3.12.14, scikit-learn 1.9.1, NumPy 2.5.3, pandas 2.3.3. See requirements-demo-lock.txt. Use the actual presentation run if its results differ.</a:t>
+              <a:t>Read these scores from the reproducible seeded notebook. Classifier test labels are 78.1 percent positive, so the always-signal baseline is strong. Accuracy 75.0 percent fails that comparison despite AUC 0.917. The one-day forecast MAE 8.85 counts beats the five-day trailing mean MAE 9.73 counts on held-out demo dates only. Neither comparison proves operational benefit at USCIS. Local Python 3.12.14, scikit-learn 1.9.1, NumPy 2.5.3, pandas 2.3.3. See requirements-demo-lock.txt. Use the actual presentation run if its results differ.</a:t>
             </a:r>
           </a:p>
         </p:txBody>
@@ -1093,7 +1093,7 @@
           <a:lstStyle xmlns:a="http://schemas.openxmlformats.org/drawingml/2006/main"/>
           <a:p xmlns:a="http://schemas.openxmlformats.org/drawingml/2006/main">
             <a:r>
-              <a:t>The supplied private SPC Predictive Modeling reference documents five-day forecasting, rule-label classification, anomaly detection and upstream lineage. Section 11 and the closing Phase 11/Phase 12 notes describe assessment and stale retraining-trigger fixes, but explicitly list downstream alert consolidation and suppression as future work. These are statements in the reference, not independently verified deployment evidence. No measured postchange alert reduction or staff time saved was supplied. The reference stays outside this public repository. The AttainX notebook illustrates a smaller synthetic workflow.</a:t>
+              <a:t>The supplied private SPC Predictive Modeling reference documents five-day forecasting, rule-label classification, anomaly detection and upstream lineage. Section 11 and the closing Phase 11/Phase 12 notes describe assessment and stale retraining-trigger fixes, but explicitly list downstream alert consolidation and suppression as future work. These are statements in the reference, not independently verified deployment evidence. No measured postchange alert reduction or staff time saved was supplied. The reference stays outside this public repository. The AttainX notebook illustrates a smaller demo workflow.</a:t>
             </a:r>
           </a:p>
         </p:txBody>
@@ -1373,7 +1373,7 @@
           <a:lstStyle xmlns:a="http://schemas.openxmlformats.org/drawingml/2006/main"/>
           <a:p xmlns:a="http://schemas.openxmlformats.org/drawingml/2006/main">
             <a:r>
-              <a:t>Q8 and Q9 need reproducible code, data format and platform migration plan, not a neutrality claim. Q10 model promotion and rollback are procedures to implement and test. Q11 analyst override and disposition must be demonstrated if claimed. Q12 asks for an actual prior engagement where AI was rejected, which this synthetic demonstration cannot replace; obtain a verified example from the team. Q13 ATO requires agency review and continuous monitoring within the appropriate boundary. Q14 knowledge transfer should be an exercise run by the receiving team.</a:t>
+              <a:t>Q8 and Q9 need reproducible code, data format and platform migration plan, not a neutrality claim. Q10 model promotion and rollback are procedures to implement and test. Q11 analyst override and disposition must be demonstrated if claimed. Q12 asks for an actual prior engagement where AI was rejected, which this demonstration using fictional counts cannot replace; obtain a verified example from the team. Q13 ATO requires agency review and continuous monitoring within the appropriate boundary. Q14 knowledge transfer should be an exercise run by the receiving team.</a:t>
             </a:r>
           </a:p>
         </p:txBody>
@@ -1443,7 +1443,7 @@
           <a:lstStyle xmlns:a="http://schemas.openxmlformats.org/drawingml/2006/main"/>
           <a:p xmlns:a="http://schemas.openxmlformats.org/drawingml/2006/main">
             <a:r>
-              <a:t>Suggested sequence: say synthetic scope aloud; execute notebook from the top; pause at rule flags, ML baselines, forecast MAE, review queue, and MLflow/Delta if configured. The classifier does not merit replacing the known rules on this test. The one-day forecast has a small synthetic advantage that invites a bounded pilot, not deployment. Emphasize the USCIS reference as the source of design ideas and a distinct environment. No additional claim of measured USCIS benefit has been supplied. Separate documented retraining-trigger fixes from downstream alert consolidation and suppression, which the reference lists as future work.</a:t>
+              <a:t>Suggested sequence: state that the counts are fictional; execute notebook from the top; pause at rule flags, ML baselines, forecast MAE, review queue, and MLflow/Delta if configured. The classifier does not merit replacing the known rules on this test. The one-day forecast has a small advantage on demo data that invites a bounded pilot, not deployment. Emphasize the USCIS reference as the source of design ideas and a distinct environment. No additional claim of measured USCIS benefit has been supplied. Separate documented retraining-trigger fixes from downstream alert consolidation and suppression, which the reference lists as future work.</a:t>
             </a:r>
           </a:p>
         </p:txBody>
@@ -1583,7 +1583,7 @@
           <a:lstStyle xmlns:a="http://schemas.openxmlformats.org/drawingml/2006/main"/>
           <a:p xmlns:a="http://schemas.openxmlformats.org/drawingml/2006/main">
             <a:r>
-              <a:t>Keep two models separate. The classifier estimates a label produced by the SPC rules on the same historical window. It is an experiment in rule imitation, not advance warning. The regressor predicts the next business day's count using yesterday's known information. That second task is genuinely forward-looking but only validated on synthetic data.</a:t>
+              <a:t>Keep two models separate. The classifier estimates a label produced by the SPC rules on the same historical window. It is an experiment in rule imitation, not advance warning. The regressor predicts the next business day's count using yesterday's known information. That second task is genuinely forward-looking but only validated on fictional data.</a:t>
             </a:r>
           </a:p>
         </p:txBody>
@@ -1653,7 +1653,7 @@
           <a:lstStyle xmlns:a="http://schemas.openxmlformats.org/drawingml/2006/main"/>
           <a:p xmlns:a="http://schemas.openxmlformats.org/drawingml/2006/main">
             <a:r>
-              <a:t>This is fabricated operational data in an AttainX notebook. It runs locally with the optional MLflow and Spark cells skipped; in Databricks, MLflow and managed Delta need access and a separate live verification. The reference USCIS notebook shows a broader design. Do not use this synthetic score as a real USCIS outcome. A live run and comparison with baselines are the relevant evidence.</a:t>
+              <a:t>This is fabricated operational data in an AttainX notebook. It runs locally with the optional MLflow and Spark cells skipped; in Databricks, MLflow and managed Delta need access and a separate live verification. The reference USCIS notebook shows a broader design. Do not use this demo score as a real USCIS outcome. A live run and comparison with baselines are the relevant evidence.</a:t>
             </a:r>
           </a:p>
         </p:txBody>
@@ -2001,7 +2001,7 @@
   </p:cSld>
   <p:clrMap bg1="lt1" tx1="dk1" bg2="lt2" tx2="dk2" accent1="accent1" accent2="accent2" accent3="accent3" accent4="accent4" accent5="accent5" accent6="accent6" hlink="hlink" folHlink="folHlink"/>
   <p:sldLayoutIdLst>
-    <p:sldLayoutId xmlns:r="http://schemas.openxmlformats.org/officeDocument/2006/relationships" id="2147483649" r:id="Rb1ade57b9a554897"/>
+    <p:sldLayoutId xmlns:r="http://schemas.openxmlformats.org/officeDocument/2006/relationships" id="2147483649" r:id="R3d1e22bdcdaa488e"/>
   </p:sldLayoutIdLst>
   <p:txStyles>
     <p:titleStyle>
@@ -3178,7 +3178,7 @@
                 <a:ea typeface="Bitstream Charter"/>
                 <a:cs typeface="Bitstream Charter"/>
               </a:rPr>
-              <a:t>AttainX synthetic example  •  Presenter companion for the live oral demo</a:t>
+              <a:t>AttainX example with fictional data  •  Presenter companion for the live oral demo</a:t>
             </a:r>
           </a:p>
         </p:txBody>
@@ -3381,7 +3381,7 @@
                 <a:ea typeface="Bitstream Charter"/>
                 <a:cs typeface="Bitstream Charter"/>
               </a:rPr>
-              <a:t>ATTAINX  /  SYNTHETIC DEMO</a:t>
+              <a:t>ATTAINX  /  DEMO DATA</a:t>
             </a:r>
           </a:p>
         </p:txBody>
@@ -4128,7 +4128,7 @@
                 <a:ea typeface="Bitstream Charter"/>
                 <a:cs typeface="Bitstream Charter"/>
               </a:rPr>
-              <a:t>ATTAINX  /  SYNTHETIC DEMO</a:t>
+              <a:t>ATTAINX  /  DEMO DATA</a:t>
             </a:r>
           </a:p>
         </p:txBody>
@@ -4534,7 +4534,7 @@
                 <a:ea typeface="Bitstream Charter"/>
                 <a:cs typeface="Bitstream Charter"/>
               </a:rPr>
-              <a:t>Synthetic test MAE is 8.85 counts; the simple five-day average has MAE 9.73 counts.</a:t>
+              <a:t>Demo test MAE is 8.85 counts; the simple five-day average has MAE 9.73 counts.</a:t>
             </a:r>
           </a:p>
         </p:txBody>
@@ -4650,7 +4650,7 @@
                 <a:ea typeface="Bitstream Charter"/>
                 <a:cs typeface="Bitstream Charter"/>
               </a:rPr>
-              <a:t>This is a one-business-day forecast. Its synthetic advantage needs prospective validation on real authorized data.</a:t>
+              <a:t>This is a one-business-day forecast. Its advantage on demo data needs prospective validation on real authorized data.</a:t>
             </a:r>
           </a:p>
         </p:txBody>
@@ -4853,7 +4853,7 @@
                 <a:ea typeface="Bitstream Charter"/>
                 <a:cs typeface="Bitstream Charter"/>
               </a:rPr>
-              <a:t>ATTAINX  /  SYNTHETIC DEMO</a:t>
+              <a:t>ATTAINX  /  DEMO DATA</a:t>
             </a:r>
           </a:p>
         </p:txBody>
@@ -5578,7 +5578,7 @@
                 <a:ea typeface="Bitstream Charter"/>
                 <a:cs typeface="Bitstream Charter"/>
               </a:rPr>
-              <a:t>ATTAINX  /  SYNTHETIC DEMO</a:t>
+              <a:t>ATTAINX  /  DEMO DATA</a:t>
             </a:r>
           </a:p>
         </p:txBody>
@@ -5984,7 +5984,7 @@
                 <a:ea typeface="Bitstream Charter"/>
                 <a:cs typeface="Bitstream Charter"/>
               </a:rPr>
-              <a:t>479 flagged windows consolidate into 30 episodes on this synthetic run. The visible queue shows 15 episodes with the latest signal dates.</a:t>
+              <a:t>479 flagged windows consolidate into 30 episodes on this demo run. The visible queue shows 15 episodes with the latest signal dates.</a:t>
             </a:r>
           </a:p>
         </p:txBody>
@@ -6303,7 +6303,7 @@
                 <a:ea typeface="Bitstream Charter"/>
                 <a:cs typeface="Bitstream Charter"/>
               </a:rPr>
-              <a:t>ATTAINX  /  SYNTHETIC DEMO</a:t>
+              <a:t>ATTAINX  /  DEMO DATA</a:t>
             </a:r>
           </a:p>
         </p:txBody>
@@ -7028,7 +7028,7 @@
                 <a:ea typeface="Bitstream Charter"/>
                 <a:cs typeface="Bitstream Charter"/>
               </a:rPr>
-              <a:t>ATTAINX  /  SYNTHETIC DEMO</a:t>
+              <a:t>ATTAINX  /  DEMO DATA</a:t>
             </a:r>
           </a:p>
         </p:txBody>
@@ -7434,7 +7434,7 @@
                 <a:ea typeface="Bitstream Charter"/>
                 <a:cs typeface="Bitstream Charter"/>
               </a:rPr>
-              <a:t>Tables are synthetic_daily, spc_signals, spc_predictions, count_forecasts, review_queue and monitoring_snapshot.</a:t>
+              <a:t>Tables are demo_daily, spc_signals, spc_predictions, count_forecasts, review_queue and monitoring_snapshot.</a:t>
             </a:r>
           </a:p>
         </p:txBody>
@@ -7695,7 +7695,7 @@
                 <a:ea typeface="Bitstream Charter"/>
                 <a:cs typeface="Bitstream Charter"/>
               </a:rPr>
-              <a:t>This synthetic run gives two different ML verdicts</a:t>
+              <a:t>This demo run gives two different ML verdicts</a:t>
             </a:r>
           </a:p>
         </p:txBody>
@@ -7753,7 +7753,7 @@
                 <a:ea typeface="Bitstream Charter"/>
                 <a:cs typeface="Bitstream Charter"/>
               </a:rPr>
-              <a:t>ATTAINX  /  SYNTHETIC DEMO</a:t>
+              <a:t>ATTAINX  /  DEMO DATA</a:t>
             </a:r>
           </a:p>
         </p:txBody>
@@ -8218,7 +8218,7 @@
                 <a:ea typeface="Bitstream Charter"/>
                 <a:cs typeface="Bitstream Charter"/>
               </a:rPr>
-              <a:t>Both comparisons use later synthetic dates with a gap between training and test windows.</a:t>
+              <a:t>Both comparisons use later demo dates with a gap between training and test windows.</a:t>
             </a:r>
           </a:p>
         </p:txBody>
@@ -8421,7 +8421,7 @@
                 <a:ea typeface="Bitstream Charter"/>
                 <a:cs typeface="Bitstream Charter"/>
               </a:rPr>
-              <a:t>ATTAINX  /  SYNTHETIC DEMO</a:t>
+              <a:t>ATTAINX  /  DEMO DATA</a:t>
             </a:r>
           </a:p>
         </p:txBody>
@@ -9030,7 +9030,7 @@
                 <a:ea typeface="Bitstream Charter"/>
                 <a:cs typeface="Bitstream Charter"/>
               </a:rPr>
-              <a:t>ATTAINX  /  SYNTHETIC DEMO</a:t>
+              <a:t>ATTAINX  /  DEMO DATA</a:t>
             </a:r>
           </a:p>
         </p:txBody>
@@ -9523,7 +9523,7 @@
                 <a:ea typeface="Bitstream Charter"/>
                 <a:cs typeface="Bitstream Charter"/>
               </a:rPr>
-              <a:t>ATTAINX  /  SYNTHETIC DEMO</a:t>
+              <a:t>ATTAINX  /  DEMO DATA</a:t>
             </a:r>
           </a:p>
         </p:txBody>
@@ -10016,7 +10016,7 @@
                 <a:ea typeface="Bitstream Charter"/>
                 <a:cs typeface="Bitstream Charter"/>
               </a:rPr>
-              <a:t>ATTAINX  /  SYNTHETIC DEMO</a:t>
+              <a:t>ATTAINX  /  DEMO DATA</a:t>
             </a:r>
           </a:p>
         </p:txBody>
@@ -10149,7 +10149,7 @@
         </p:xfrm>
         <a:graphic xmlns:a="http://schemas.openxmlformats.org/drawingml/2006/main">
           <a:graphicData uri="http://schemas.openxmlformats.org/drawingml/2006/chart">
-            <c:chart xmlns:r="http://schemas.openxmlformats.org/officeDocument/2006/relationships" xmlns:c="http://schemas.openxmlformats.org/drawingml/2006/chart" r:id="Raaafe6b311654068"/>
+            <c:chart xmlns:r="http://schemas.openxmlformats.org/officeDocument/2006/relationships" xmlns:c="http://schemas.openxmlformats.org/drawingml/2006/chart" r:id="R3ceafbce4db74a49"/>
           </a:graphicData>
         </a:graphic>
       </p:graphicFrame>
@@ -10206,7 +10206,7 @@
                 <a:ea typeface="Bitstream Charter"/>
                 <a:cs typeface="Bitstream Charter"/>
               </a:rPr>
-              <a:t>Illustrative counts and changing XmR limits from the synthetic notebook. A rule signal calls for analyst review.</a:t>
+              <a:t>Illustrative counts and changing XmR limits from the demo notebook. A rule signal calls for analyst review.</a:t>
             </a:r>
           </a:p>
         </p:txBody>
@@ -10409,7 +10409,7 @@
                 <a:ea typeface="Bitstream Charter"/>
                 <a:cs typeface="Bitstream Charter"/>
               </a:rPr>
-              <a:t>ATTAINX  /  SYNTHETIC DEMO</a:t>
+              <a:t>ATTAINX  /  DEMO DATA</a:t>
             </a:r>
           </a:p>
         </p:txBody>
@@ -11482,7 +11482,7 @@
                 <a:ea typeface="Bitstream Charter"/>
                 <a:cs typeface="Bitstream Charter"/>
               </a:rPr>
-              <a:t>ATTAINX  /  SYNTHETIC DEMO</a:t>
+              <a:t>ATTAINX  /  DEMO DATA</a:t>
             </a:r>
           </a:p>
         </p:txBody>
@@ -12555,7 +12555,7 @@
                 <a:ea typeface="Bitstream Charter"/>
                 <a:cs typeface="Bitstream Charter"/>
               </a:rPr>
-              <a:t>ATTAINX  /  SYNTHETIC DEMO</a:t>
+              <a:t>ATTAINX  /  DEMO DATA</a:t>
             </a:r>
           </a:p>
         </p:txBody>
@@ -13048,7 +13048,7 @@
                 <a:ea typeface="Bitstream Charter"/>
                 <a:cs typeface="Bitstream Charter"/>
               </a:rPr>
-              <a:t>ATTAINX  /  SYNTHETIC DEMO</a:t>
+              <a:t>ATTAINX  /  DEMO DATA</a:t>
             </a:r>
           </a:p>
         </p:txBody>
@@ -13657,7 +13657,7 @@
                 <a:ea typeface="Bitstream Charter"/>
                 <a:cs typeface="Bitstream Charter"/>
               </a:rPr>
-              <a:t>ATTAINX  /  SYNTHETIC DEMO</a:t>
+              <a:t>ATTAINX  /  DEMO DATA</a:t>
             </a:r>
           </a:p>
         </p:txBody>
@@ -14266,7 +14266,7 @@
                 <a:ea typeface="Bitstream Charter"/>
                 <a:cs typeface="Bitstream Charter"/>
               </a:rPr>
-              <a:t>ATTAINX  /  SYNTHETIC DEMO</a:t>
+              <a:t>ATTAINX  /  DEMO DATA</a:t>
             </a:r>
           </a:p>
         </p:txBody>
@@ -14759,7 +14759,7 @@
                 <a:ea typeface="Bitstream Charter"/>
                 <a:cs typeface="Bitstream Charter"/>
               </a:rPr>
-              <a:t>ATTAINX  /  SYNTHETIC DEMO</a:t>
+              <a:t>ATTAINX  /  DEMO DATA</a:t>
             </a:r>
           </a:p>
         </p:txBody>
@@ -15426,7 +15426,7 @@
                 <a:ea typeface="Bitstream Charter"/>
                 <a:cs typeface="Bitstream Charter"/>
               </a:rPr>
-              <a:t>Synthetic daily work counts</a:t>
+              <a:t>Fictional daily work counts</a:t>
             </a:r>
           </a:p>
         </p:txBody>
@@ -15484,7 +15484,7 @@
                 <a:ea typeface="Bitstream Charter"/>
                 <a:cs typeface="Bitstream Charter"/>
               </a:rPr>
-              <a:t>ATTAINX  /  SYNTHETIC DEMO</a:t>
+              <a:t>ATTAINX  /  DEMO DATA</a:t>
             </a:r>
           </a:p>
         </p:txBody>
@@ -15890,7 +15890,7 @@
                 <a:ea typeface="Bitstream Charter"/>
                 <a:cs typeface="Bitstream Charter"/>
               </a:rPr>
-              <a:t>daily_df has 1,260 observations, a fictional source name, and a synthetic dataset ID.</a:t>
+              <a:t>daily_df has 1,260 observations, a fictional source name, and a demo dataset ID.</a:t>
             </a:r>
           </a:p>
         </p:txBody>
@@ -16209,7 +16209,7 @@
                 <a:ea typeface="Bitstream Charter"/>
                 <a:cs typeface="Bitstream Charter"/>
               </a:rPr>
-              <a:t>ATTAINX  /  SYNTHETIC DEMO</a:t>
+              <a:t>ATTAINX  /  DEMO DATA</a:t>
             </a:r>
           </a:p>
         </p:txBody>
@@ -16934,7 +16934,7 @@
                 <a:ea typeface="Bitstream Charter"/>
                 <a:cs typeface="Bitstream Charter"/>
               </a:rPr>
-              <a:t>ATTAINX  /  SYNTHETIC DEMO</a:t>
+              <a:t>ATTAINX  /  DEMO DATA</a:t>
             </a:r>
           </a:p>
         </p:txBody>
@@ -17340,7 +17340,7 @@
                 <a:ea typeface="Bitstream Charter"/>
                 <a:cs typeface="Bitstream Charter"/>
               </a:rPr>
-              <a:t>signals_df contains the flags, window statistics and baseline values. Its overall synthetic signal rate is 52.3%.</a:t>
+              <a:t>signals_df contains the flags, window statistics and baseline values. Its overall demo signal rate is 52.3%.</a:t>
             </a:r>
           </a:p>
         </p:txBody>

</xml_diff>

<commit_message>
Expand SPC demo with forecasting investigation and lifecycle workflows
</commit_message>
<xml_diff>
--- a/docs/SPC_ML_Demo_Walkthrough_Ready.pptx
+++ b/docs/SPC_ML_Demo_Walkthrough_Ready.pptx
@@ -2,34 +2,34 @@
 <file path=ppt/presentation.xml><?xml version="1.0" encoding="utf-8"?>
 <p:presentation xmlns:p="http://schemas.openxmlformats.org/presentationml/2006/main">
   <p:sldMasterIdLst>
-    <p:sldMasterId xmlns:r="http://schemas.openxmlformats.org/officeDocument/2006/relationships" id="2147483648" r:id="R2f25c07c1a2340ee"/>
+    <p:sldMasterId xmlns:r="http://schemas.openxmlformats.org/officeDocument/2006/relationships" id="2147483648" r:id="Rab8a3aae5493476a"/>
   </p:sldMasterIdLst>
   <p:notesMasterIdLst>
-    <p:notesMasterId xmlns:r="http://schemas.openxmlformats.org/officeDocument/2006/relationships" r:id="R3a9327079cc44b1c"/>
+    <p:notesMasterId xmlns:r="http://schemas.openxmlformats.org/officeDocument/2006/relationships" r:id="Rfe5c1606bf0741d9"/>
   </p:notesMasterIdLst>
   <p:sldIdLst>
-    <p:sldId xmlns:r="http://schemas.openxmlformats.org/officeDocument/2006/relationships" id="256" r:id="R8ee79e8cde044011"/>
-    <p:sldId xmlns:r="http://schemas.openxmlformats.org/officeDocument/2006/relationships" id="257" r:id="Rf93e1d9679f24280"/>
-    <p:sldId xmlns:r="http://schemas.openxmlformats.org/officeDocument/2006/relationships" id="258" r:id="R9db50050c9084933"/>
-    <p:sldId xmlns:r="http://schemas.openxmlformats.org/officeDocument/2006/relationships" id="259" r:id="R54f535a73d2646d7"/>
-    <p:sldId xmlns:r="http://schemas.openxmlformats.org/officeDocument/2006/relationships" id="260" r:id="R912bbff34e8440e6"/>
-    <p:sldId xmlns:r="http://schemas.openxmlformats.org/officeDocument/2006/relationships" id="261" r:id="R9fcea69722e446d3"/>
-    <p:sldId xmlns:r="http://schemas.openxmlformats.org/officeDocument/2006/relationships" id="262" r:id="R06bf748d1c2c4238"/>
-    <p:sldId xmlns:r="http://schemas.openxmlformats.org/officeDocument/2006/relationships" id="263" r:id="R37a62a0f2f384fca"/>
-    <p:sldId xmlns:r="http://schemas.openxmlformats.org/officeDocument/2006/relationships" id="264" r:id="R330f5c706934457b"/>
-    <p:sldId xmlns:r="http://schemas.openxmlformats.org/officeDocument/2006/relationships" id="265" r:id="R20de8bc11ce24ac1"/>
-    <p:sldId xmlns:r="http://schemas.openxmlformats.org/officeDocument/2006/relationships" id="266" r:id="R3e278e6bad6f4ad8"/>
-    <p:sldId xmlns:r="http://schemas.openxmlformats.org/officeDocument/2006/relationships" id="267" r:id="R609d1837c0f94f48"/>
-    <p:sldId xmlns:r="http://schemas.openxmlformats.org/officeDocument/2006/relationships" id="268" r:id="Rd5b73fc641b84c01"/>
-    <p:sldId xmlns:r="http://schemas.openxmlformats.org/officeDocument/2006/relationships" id="269" r:id="R2b7ac97444ee4ea5"/>
-    <p:sldId xmlns:r="http://schemas.openxmlformats.org/officeDocument/2006/relationships" id="270" r:id="R8eda9a6f94154851"/>
-    <p:sldId xmlns:r="http://schemas.openxmlformats.org/officeDocument/2006/relationships" id="271" r:id="R938d7ea6e8d64ca7"/>
-    <p:sldId xmlns:r="http://schemas.openxmlformats.org/officeDocument/2006/relationships" id="272" r:id="R820ed1f7147e42a9"/>
-    <p:sldId xmlns:r="http://schemas.openxmlformats.org/officeDocument/2006/relationships" id="273" r:id="Rcc85f048204e4ac3"/>
-    <p:sldId xmlns:r="http://schemas.openxmlformats.org/officeDocument/2006/relationships" id="274" r:id="Ra0805976a14c473d"/>
-    <p:sldId xmlns:r="http://schemas.openxmlformats.org/officeDocument/2006/relationships" id="275" r:id="R6eb9450bd63c4b76"/>
-    <p:sldId xmlns:r="http://schemas.openxmlformats.org/officeDocument/2006/relationships" id="276" r:id="Rd943ce67ba2e4b2a"/>
-    <p:sldId xmlns:r="http://schemas.openxmlformats.org/officeDocument/2006/relationships" id="277" r:id="Reedc166d97d04fb6"/>
+    <p:sldId xmlns:r="http://schemas.openxmlformats.org/officeDocument/2006/relationships" id="256" r:id="R6f2a97461a8d452a"/>
+    <p:sldId xmlns:r="http://schemas.openxmlformats.org/officeDocument/2006/relationships" id="257" r:id="R3f6c8c5e16184740"/>
+    <p:sldId xmlns:r="http://schemas.openxmlformats.org/officeDocument/2006/relationships" id="258" r:id="R824bcb1b164d4caa"/>
+    <p:sldId xmlns:r="http://schemas.openxmlformats.org/officeDocument/2006/relationships" id="259" r:id="R44037779af374f81"/>
+    <p:sldId xmlns:r="http://schemas.openxmlformats.org/officeDocument/2006/relationships" id="260" r:id="R086c10e6884846b8"/>
+    <p:sldId xmlns:r="http://schemas.openxmlformats.org/officeDocument/2006/relationships" id="261" r:id="R7d17a97a59294249"/>
+    <p:sldId xmlns:r="http://schemas.openxmlformats.org/officeDocument/2006/relationships" id="262" r:id="R7274cf153f474f3f"/>
+    <p:sldId xmlns:r="http://schemas.openxmlformats.org/officeDocument/2006/relationships" id="263" r:id="Rb73323299fbd432e"/>
+    <p:sldId xmlns:r="http://schemas.openxmlformats.org/officeDocument/2006/relationships" id="264" r:id="R8b0f2fa756c34704"/>
+    <p:sldId xmlns:r="http://schemas.openxmlformats.org/officeDocument/2006/relationships" id="265" r:id="Rf025394a6e9648dc"/>
+    <p:sldId xmlns:r="http://schemas.openxmlformats.org/officeDocument/2006/relationships" id="266" r:id="R2e440ea178924539"/>
+    <p:sldId xmlns:r="http://schemas.openxmlformats.org/officeDocument/2006/relationships" id="267" r:id="R741aae5eb0d647be"/>
+    <p:sldId xmlns:r="http://schemas.openxmlformats.org/officeDocument/2006/relationships" id="268" r:id="R0d692d859064427a"/>
+    <p:sldId xmlns:r="http://schemas.openxmlformats.org/officeDocument/2006/relationships" id="269" r:id="R928ea9a9966c43dd"/>
+    <p:sldId xmlns:r="http://schemas.openxmlformats.org/officeDocument/2006/relationships" id="270" r:id="R6c1f3b7976654b6f"/>
+    <p:sldId xmlns:r="http://schemas.openxmlformats.org/officeDocument/2006/relationships" id="271" r:id="R6376810d06c94ef5"/>
+    <p:sldId xmlns:r="http://schemas.openxmlformats.org/officeDocument/2006/relationships" id="272" r:id="Rf242c9f7bd1c4a89"/>
+    <p:sldId xmlns:r="http://schemas.openxmlformats.org/officeDocument/2006/relationships" id="273" r:id="Rde8d4346afe8428f"/>
+    <p:sldId xmlns:r="http://schemas.openxmlformats.org/officeDocument/2006/relationships" id="274" r:id="R616cdee22ffc46ed"/>
+    <p:sldId xmlns:r="http://schemas.openxmlformats.org/officeDocument/2006/relationships" id="275" r:id="R3321097b468b4f91"/>
+    <p:sldId xmlns:r="http://schemas.openxmlformats.org/officeDocument/2006/relationships" id="276" r:id="R385f1ed27f5f4047"/>
+    <p:sldId xmlns:r="http://schemas.openxmlformats.org/officeDocument/2006/relationships" id="277" r:id="R3204dd587cbd4d60"/>
   </p:sldIdLst>
   <p:sldSz cx="12192000" cy="6858000"/>
   <p:notesSz cx="6858000" cy="9144000"/>
@@ -463,7 +463,7 @@
           <a:lstStyle xmlns:a="http://schemas.openxmlformats.org/drawingml/2006/main"/>
           <a:p xmlns:a="http://schemas.openxmlformats.org/drawingml/2006/main">
             <a:r>
-              <a:t>Open with the distinction: this deck explains a working AttainX demo notebook. It is a companion to a live Databricks run, not proof of production results. No USCIS data or production artifact is used.</a:t>
+              <a:t>Opening: These are fictional counts and fixture metadata. We demonstrate decisions and execution, not USCIS outcomes. Start with the rules, compare forecasts, then investigate and review. Twenty code cells are grouped across these 22 slides.</a:t>
             </a:r>
           </a:p>
         </p:txBody>
@@ -533,7 +533,7 @@
           <a:lstStyle xmlns:a="http://schemas.openxmlformats.org/drawingml/2006/main"/>
           <a:p xmlns:a="http://schemas.openxmlformats.org/drawingml/2006/main">
             <a:r>
-              <a:t>Show the training/test dates and the assert that windows do not overlap. Explain base rates: 78.1 percent of test windows are signal. The 0.917 AUC measures ranking; it does not override the baseline or the fact that the label is deterministic from the same window. The 50 quiet windows include 4 false positives and 46 true negatives; 53 of 178 rule signals are missed by the classifier. The split separates 25-day measurement windows. Earlier 90-day reference histories can overlap training history. All inputs still precede the run date. Local Python 3.12.14, scikit-learn 1.9.1, NumPy 2.5.3, pandas 2.3.3. See requirements-demo-lock.txt. Use the actual presentation run if its results differ.</a:t>
+              <a:t>Show zone_df and both exploration figures. The office split is fictional, with a planted North workload shift. Lagged subgroup means and standard deviations support anomaly evidence. Office forecasts later are independent and need not reconcile to the total.</a:t>
             </a:r>
           </a:p>
         </p:txBody>
@@ -603,7 +603,7 @@
           <a:lstStyle xmlns:a="http://schemas.openxmlformats.org/drawingml/2006/main"/>
           <a:p xmlns:a="http://schemas.openxmlformats.org/drawingml/2006/main">
             <a:r>
-              <a:t>Point to the absence of today's target from the input features, to the gap assertion, and to the MAE comparison. MAE is average absolute error in counts. The oral response may mention five-day forecasting in the USCIS reference; this specific AttainX notebook implements one day.</a:t>
+              <a:t>Fold averages differ from Cell 5's single holdout and must not be presented as the same experiment. Labels remain direct-rule labels. Logistic regression is useful as a simpler comparison, not a reason to replace rules. Feature importance is predictive association.</a:t>
             </a:r>
           </a:p>
         </p:txBody>
@@ -673,7 +673,7 @@
           <a:lstStyle xmlns:a="http://schemas.openxmlformats.org/drawingml/2006/main"/>
           <a:p xmlns:a="http://schemas.openxmlformats.org/drawingml/2006/main">
             <a:r>
-              <a:t>Show the three figures during the demo. On the control chart, distinguish a flagged window from a single-point XmR breach. On the confusion matrix, explain false negatives and false positives. On the forecast plot, compare observed and predicted values without presenting it as real agency evidence.</a:t>
+              <a:t>ARIMA is selected using only the first five origins. The final origin is held out for lifecycle advice; pooled chart metrics include all six origins and are descriptive, not the selection score. Forecast dates exclude U.S. federal holidays. Office predictions are independent, not reconciled.</a:t>
             </a:r>
           </a:p>
         </p:txBody>
@@ -743,7 +743,7 @@
           <a:lstStyle xmlns:a="http://schemas.openxmlformats.org/drawingml/2006/main"/>
           <a:p xmlns:a="http://schemas.openxmlformats.org/drawingml/2006/main">
             <a:r>
-              <a:t>Point to review_df and monitoring_df. Explain that episode grouping helps keep repeated 25-day windows from becoming separate notifications. An analyst still needs the underlying series, source checks, context and a disposition record. The example only stages the review queue.</a:t>
+              <a:t>Show scores and rule/model disagreement. Disagreement can focus analyst review. The final model uses a fixed 8% contamination setting and the time folds explore bounded settings. It does not discover an objectively correct anomaly rate.</a:t>
             </a:r>
           </a:p>
         </p:txBody>
@@ -813,7 +813,7 @@
           <a:lstStyle xmlns:a="http://schemas.openxmlformats.org/drawingml/2006/main"/>
           <a:p xmlns:a="http://schemas.openxmlformats.org/drawingml/2006/main">
             <a:r>
-              <a:t>Show the MLflow run after executing the notebook in Databricks. The local smoke test reports MLflow unavailable, so this deck does not assert the Databricks write was verified. The optional model name must be a permitted three-part identifier.</a:t>
+              <a:t>Show lineage_df, column_lineage_df and upstream_profile_df. Trace the daily-count table to its source export and office lookup branch. A late upstream table provides a possible explanation to investigate, not proof that the count signal is caused by ingestion.</a:t>
             </a:r>
           </a:p>
         </p:txBody>
@@ -883,7 +883,7 @@
           <a:lstStyle xmlns:a="http://schemas.openxmlformats.org/drawingml/2006/main"/>
           <a:p xmlns:a="http://schemas.openxmlformats.org/drawingml/2006/main">
             <a:r>
-              <a:t>Show OUTPUT_SCHEMA at the top, then this cell. With an empty setting, it prints that output is off. If a permitted demo schema is available, set it and rerun, then inspect the six tables. Do not point the setting at production tables.</a:t>
+              <a:t>Show the generated operational events and hypotheses_df. Time matching prevents a recent freshness issue from explaining every older episode. Explain alternative causes and the need to inspect the source before recording a real disposition.</a:t>
             </a:r>
           </a:p>
         </p:txBody>
@@ -953,7 +953,7 @@
           <a:lstStyle xmlns:a="http://schemas.openxmlformats.org/drawingml/2006/main"/>
           <a:p xmlns:a="http://schemas.openxmlformats.org/drawingml/2006/main">
             <a:r>
-              <a:t>Read these scores from the reproducible seeded notebook. Classifier test labels are 78.1 percent positive, so the always-signal baseline is strong. Accuracy 75.0 percent fails that comparison despite AUC 0.917. The one-day forecast MAE 8.85 counts beats the five-day trailing mean MAE 9.73 counts on held-out demo dates only. Neither comparison proves operational benefit at USCIS. Local Python 3.12.14, scikit-learn 1.9.1, NumPy 2.5.3, pandas 2.3.3. See requirements-demo-lock.txt. Use the actual presentation run if its results differ.</a:t>
+              <a:t>Show forecast_ledger_df and assessment_df. A one-observation partial result is explicitly insufficient. Only the latest origin can drive current advice. A very poor worsening result suggests architecture review, while improvement should not trigger retraining. Direction compares target movement with its origin count.</a:t>
             </a:r>
           </a:p>
         </p:txBody>
@@ -1023,7 +1023,7 @@
           <a:lstStyle xmlns:a="http://schemas.openxmlformats.org/drawingml/2006/main"/>
           <a:p xmlns:a="http://schemas.openxmlformats.org/drawingml/2006/main">
             <a:r>
-              <a:t>Narrate the pipeline from the point of view of an analyst. The fictional input yields daily counts. Rules compute observations and a signal. The classifier is tested against the rules and the baseline, and is not needed when it loses. The separate count forecast may help planning if validated. Repeated signals are grouped for pending review. MLflow and optional tables record the run. In a pilot, a person would investigate and record whether to act. This notebook does not record that decision.</a:t>
+              <a:t>Show lifecycle_df and the registry exercise. The candidate was chosen before this final forecast origin. This small example demonstrates the decision record and a rollback sequence, not a verified registry transaction or real human approval.</a:t>
             </a:r>
           </a:p>
         </p:txBody>
@@ -1093,7 +1093,7 @@
           <a:lstStyle xmlns:a="http://schemas.openxmlformats.org/drawingml/2006/main"/>
           <a:p xmlns:a="http://schemas.openxmlformats.org/drawingml/2006/main">
             <a:r>
-              <a:t>The supplied private SPC Predictive Modeling reference documents five-day forecasting, rule-label classification, anomaly detection and upstream lineage. Section 11 and the closing Phase 11/Phase 12 notes describe assessment and stale retraining-trigger fixes, but explicitly list downstream alert consolidation and suppression as future work. These are statements in the reference, not independently verified deployment evidence. No measured postchange alert reduction or staff time saved was supplied. The reference stays outside this public repository. The AttainX notebook illustrates a smaller demo workflow.</a:t>
+              <a:t>Show outbox_df: two prepared notices and four suppressed repeats. Show operator_disposition_df and the dashboard figure. Replay deduplication is local to this run; durable delivery idempotency and live scheduling need platform implementation and verification.</a:t>
             </a:r>
           </a:p>
         </p:txBody>
@@ -1163,7 +1163,7 @@
           <a:lstStyle xmlns:a="http://schemas.openxmlformats.org/drawingml/2006/main"/>
           <a:p xmlns:a="http://schemas.openxmlformats.org/drawingml/2006/main">
             <a:r>
-              <a:t>Use neutral examples like daily intake volumes or completion counts only after an agency confirms definitions and authority to use data. They could see unusual variation earlier, compare forecast workload with actual capacity, and keep a review trail. Those are possible benefits, not established outcomes. First ask whether simple rules solve the problem. Agree on acceptable alert volume and prospective forecast error. Build permissions, data-quality checks, human ownership and an audit trail before an operational pilot.</a:t>
+              <a:t>Four model artifacts: rule classifier, one-day regressor, logistic classifier and Isolation Forest. Five-day statsmodels fits are not logged as model artifacts; their predictions and assessments are tables. Local stub tests verify API and SQL contracts, not actual service acceptance.</a:t>
             </a:r>
           </a:p>
         </p:txBody>
@@ -1233,7 +1233,7 @@
           <a:lstStyle xmlns:a="http://schemas.openxmlformats.org/drawingml/2006/main"/>
           <a:p xmlns:a="http://schemas.openxmlformats.org/drawingml/2006/main">
             <a:r>
-              <a:t>Explain it like a thermometer for a work process. Daily numbers naturally bounce around. Control rules ask whether a change is unusual enough to investigate. A statistical signal is evidence for a question, not confirmation of an operational problem.</a:t>
+              <a:t>SPC asks whether observed movement deserves investigation. This editable chart is an illustrative example retained from the deck. Current run charts are in the notebook. A signal does not establish cause.</a:t>
             </a:r>
           </a:p>
         </p:txBody>
@@ -1303,7 +1303,7 @@
           <a:lstStyle xmlns:a="http://schemas.openxmlformats.org/drawingml/2006/main"/>
           <a:p xmlns:a="http://schemas.openxmlformats.org/drawingml/2006/main">
             <a:r>
-              <a:t>This slide is an aid for the oral responses, not a claim that a prototype alone satisfies every governance requirement. Q1 lifecycle is shown by the live notebook. Q2 is the documented AI-vs-rules decision. Q3 readiness requires agency decisions and permissions. Q4 pilot acceptance must distinguish a working implementation from a useful model. Q5 governance and Q6 risk need policy and operational evidence outside the demo. Q7 security requires the agency boundary and incident process.</a:t>
+              <a:t>These questions follow the supplied oral handoff, not an independently verified solicitation. Local execution is demonstrated. A pilot still needs owners, approved real data and prospective success and stop criteria.</a:t>
             </a:r>
           </a:p>
         </p:txBody>
@@ -1373,7 +1373,7 @@
           <a:lstStyle xmlns:a="http://schemas.openxmlformats.org/drawingml/2006/main"/>
           <a:p xmlns:a="http://schemas.openxmlformats.org/drawingml/2006/main">
             <a:r>
-              <a:t>Q8 and Q9 need reproducible code, data format and platform migration plan, not a neutrality claim. Q10 model promotion and rollback are procedures to implement and test. Q11 analyst override and disposition must be demonstrated if claimed. Q12 asks for an actual prior engagement where AI was rejected, which this demonstration using fictional counts cannot replace; obtain a verified example from the team. Q13 ATO requires agency review and continuous monitoring within the appropriate boundary. Q14 knowledge transfer should be an exercise run by the receiving team.</a:t>
+              <a:t>Do not invent a historical engagement for question 12. The current classifier decision is only a current demo example. No agency approval, staffing assignment, contract term or production deployment is established here.</a:t>
             </a:r>
           </a:p>
         </p:txBody>
@@ -1443,7 +1443,7 @@
           <a:lstStyle xmlns:a="http://schemas.openxmlformats.org/drawingml/2006/main"/>
           <a:p xmlns:a="http://schemas.openxmlformats.org/drawingml/2006/main">
             <a:r>
-              <a:t>Suggested sequence: state that the counts are fictional; execute notebook from the top; pause at rule flags, ML baselines, forecast MAE, review queue, and MLflow/Delta if configured. The classifier does not merit replacing the known rules on this test. The one-day forecast has a small advantage on demo data that invites a bounded pilot, not deployment. Emphasize the USCIS reference as the source of design ideas and a distinct environment. No additional claim of measured USCIS benefit has been supplied. Separate documented retraining-trigger fixes from downstream alert consolidation and suppression, which the reference lists as future work.</a:t>
+              <a:t>Close: The expanded demo now represents the major reference workflow areas. The remaining differences are depth, exact agency algorithms and live integrations. Do not claim identical results, complete production parity or verified operational benefit.</a:t>
             </a:r>
           </a:p>
         </p:txBody>
@@ -1513,7 +1513,7 @@
           <a:lstStyle xmlns:a="http://schemas.openxmlformats.org/drawingml/2006/main"/>
           <a:p xmlns:a="http://schemas.openxmlformats.org/drawingml/2006/main">
             <a:r>
-              <a:t>XmR uses each individual observation and its moving range to find conspicuous jumps. CUSUM accumulates small deviations from a reference level. EWMA smooths the series with more weight on recent counts. The demo marks a 25-day window if any of these checks fires within the window. The rule thresholds are fixed demo choices and would require domain calibration in practice.</a:t>
+              <a:t>Cell 3 computes the three original checks. Cell 9 adds critical, warning, watch and normal zones from simple point and run rules. Zone thresholds are demo settings requiring calibration; they are not universal alert policies.</a:t>
             </a:r>
           </a:p>
         </p:txBody>
@@ -1583,7 +1583,7 @@
           <a:lstStyle xmlns:a="http://schemas.openxmlformats.org/drawingml/2006/main"/>
           <a:p xmlns:a="http://schemas.openxmlformats.org/drawingml/2006/main">
             <a:r>
-              <a:t>Keep two models separate. The classifier estimates a label produced by the SPC rules on the same historical window. It is an experiment in rule imitation, not advance warning. The regressor predicts the next business day's count using yesterday's known information. That second task is genuinely forward-looking but only validated on fictional data.</a:t>
+              <a:t>We separate a rule label, an unusualness score, a future workload estimate and an investigation hypothesis. Those outputs answer different questions. None authorizes operational action.</a:t>
             </a:r>
           </a:p>
         </p:txBody>
@@ -1653,7 +1653,7 @@
           <a:lstStyle xmlns:a="http://schemas.openxmlformats.org/drawingml/2006/main"/>
           <a:p xmlns:a="http://schemas.openxmlformats.org/drawingml/2006/main">
             <a:r>
-              <a:t>This is fabricated operational data in an AttainX notebook. It runs locally with the optional MLflow and Spark cells skipped; in Databricks, MLflow and managed Delta need access and a separate live verification. The reference USCIS notebook shows a broader design. Do not use this demo score as a real USCIS outcome. A live run and comparison with baselines are the relevant evidence.</a:t>
+              <a:t>Show configuration then daily_df. The dataset ID is attainx_demo_v2_seed42. Last observed date is September 8, 2026. Installing the locked dependencies reproduces this local environment; target compute still requires a full rehearsal.</a:t>
             </a:r>
           </a:p>
         </p:txBody>
@@ -1723,7 +1723,7 @@
           <a:lstStyle xmlns:a="http://schemas.openxmlformats.org/drawingml/2006/main"/>
           <a:p xmlns:a="http://schemas.openxmlformats.org/drawingml/2006/main">
             <a:r>
-              <a:t>Point to SEED, WINDOW, BASELINE_DAYS, OUTPUT_SCHEMA and UC_MODEL_NAME. Empty destination names disable Delta writes and model registration. MLflow still needs experiment write access when installed. The rules are demo parameters requiring calibration for an actual mission series. Databricks experiment guidance: https://docs.databricks.com/aws/en/mlflow/experiments</a:t>
+              <a:t>Show signals_df, the three flags, logical OR, and feature columns. The overall rule-positive share is 52.3%. Window boundaries are separated in evaluation, while earlier reference histories may overlap. Explain that distinction before citing metrics.</a:t>
             </a:r>
           </a:p>
         </p:txBody>
@@ -1793,7 +1793,7 @@
           <a:lstStyle xmlns:a="http://schemas.openxmlformats.org/drawingml/2006/main"/>
           <a:p xmlns:a="http://schemas.openxmlformats.org/drawingml/2006/main">
             <a:r>
-              <a:t>Show the first five rows and the assertions. Explain that no external source is read. The three series are Intake A, Completions A and Intake B, all fabricated.</a:t>
+              <a:t>The holdout contains 46 true negatives, 4 false positives, 53 false negatives and 125 true positives relative to the rule label. It does not represent confirmed operational incidents. Class mix explains why accuracy needs a baseline.</a:t>
             </a:r>
           </a:p>
         </p:txBody>
@@ -1863,7 +1863,7 @@
           <a:lstStyle xmlns:a="http://schemas.openxmlformats.org/drawingml/2006/main"/>
           <a:p xmlns:a="http://schemas.openxmlformats.org/drawingml/2006/main">
             <a:r>
-              <a:t>Point to the three function definitions. Use a simple analogy: XmR notices a shout, CUSUM hears repeated whispers, EWMA keeps a rolling impression. Avoid claiming these independent methods identify root cause.</a:t>
+              <a:t>Use the actual-versus-predicted chart. Previous-count baseline MAE is 10.99. The federal-holiday calendar changed weekday features, so the updated result is 8.99 rather than the old 8.85. This is separate from the five-day statistical forecasts.</a:t>
             </a:r>
           </a:p>
         </p:txBody>
@@ -1933,7 +1933,7 @@
           <a:lstStyle xmlns:a="http://schemas.openxmlformats.org/drawingml/2006/main"/>
           <a:p xmlns:a="http://schemas.openxmlformats.org/drawingml/2006/main">
             <a:r>
-              <a:t>Point to the slice selecting prior values, baseline slice, and signal_detected = xmr or cusum or ewma. The script checks the OR invariant. A 52.3 percent overall rate means a signal is a triage input here, not a rare alarm. XmR estimates limits from the 25-day measurement window. CUSUM and EWMA use the earlier 90-day reference.</a:t>
+              <a:t>Use the three initial figures. Consecutive rule-positive dates form episodes. Later cells add a separate fictional reviewer exercise and prepared notice outbox; they do not turn this queue into completed operational decisions.</a:t>
             </a:r>
           </a:p>
         </p:txBody>
@@ -2001,7 +2001,7 @@
   </p:cSld>
   <p:clrMap bg1="lt1" tx1="dk1" bg2="lt2" tx2="dk2" accent1="accent1" accent2="accent2" accent3="accent3" accent4="accent4" accent5="accent5" accent6="accent6" hlink="hlink" folHlink="folHlink"/>
   <p:sldLayoutIdLst>
-    <p:sldLayoutId xmlns:r="http://schemas.openxmlformats.org/officeDocument/2006/relationships" id="2147483649" r:id="R3d1e22bdcdaa488e"/>
+    <p:sldLayoutId xmlns:r="http://schemas.openxmlformats.org/officeDocument/2006/relationships" id="2147483649" r:id="R12d590ca465c4792"/>
   </p:sldLayoutIdLst>
   <p:txStyles>
     <p:titleStyle>
@@ -3120,7 +3120,7 @@
                 <a:ea typeface="Bitstream Charter"/>
                 <a:cs typeface="Bitstream Charter"/>
               </a:rPr>
-              <a:t>A plain-English walkthrough of the ten-cell Databricks notebook</a:t>
+              <a:t>A plain-English walkthrough of the expanded Databricks notebook</a:t>
             </a:r>
           </a:p>
         </p:txBody>
@@ -3178,7 +3178,7 @@
                 <a:ea typeface="Bitstream Charter"/>
                 <a:cs typeface="Bitstream Charter"/>
               </a:rPr>
-              <a:t>AttainX example with fictional data  •  Presenter companion for the live oral demo</a:t>
+              <a:t>AttainX fictional-data demonstration  •  20 cells  •  Presenter companion</a:t>
             </a:r>
           </a:p>
         </p:txBody>
@@ -3265,7 +3265,7 @@
                 <a:ea typeface="Bitstream Charter"/>
                 <a:cs typeface="Bitstream Charter"/>
               </a:rPr>
-              <a:t>NOTEBOOK / CELL 5 OF 10</a:t>
+              <a:t>NOTEBOOK / CELLS 9–10</a:t>
             </a:r>
           </a:p>
         </p:txBody>
@@ -3323,7 +3323,7 @@
                 <a:ea typeface="Bitstream Charter"/>
                 <a:cs typeface="Bitstream Charter"/>
               </a:rPr>
-              <a:t>Classify the rule label</a:t>
+              <a:t>Severity, distribution and subgroups</a:t>
             </a:r>
           </a:p>
         </p:txBody>
@@ -3497,7 +3497,7 @@
                 <a:ea typeface="Bitstream Charter"/>
                 <a:cs typeface="Bitstream Charter"/>
               </a:rPr>
-              <a:t>What it does</a:t>
+              <a:t>Zones</a:t>
             </a:r>
           </a:p>
         </p:txBody>
@@ -3555,7 +3555,7 @@
                 <a:ea typeface="Bitstream Charter"/>
                 <a:cs typeface="Bitstream Charter"/>
               </a:rPr>
-              <a:t>Train a random forest to guess whether the rules fired, then compare it with easy guesses.</a:t>
+              <a:t>Critical, warning, watch and normal states make the signal easier to inspect.</a:t>
             </a:r>
           </a:p>
         </p:txBody>
@@ -3613,7 +3613,7 @@
                 <a:ea typeface="Bitstream Charter"/>
                 <a:cs typeface="Bitstream Charter"/>
               </a:rPr>
-              <a:t>Technology / data science</a:t>
+              <a:t>Profiles</a:t>
             </a:r>
           </a:p>
         </p:txBody>
@@ -3671,7 +3671,7 @@
                 <a:ea typeface="Bitstream Charter"/>
                 <a:cs typeface="Bitstream Charter"/>
               </a:rPr>
-              <a:t>Classification, chronological holdout, a 25-business-day gap, accuracy, precision, recall, F1 and ROC AUC.</a:t>
+              <a:t>Distribution plots and correlations expose scale and redundant inputs.</a:t>
             </a:r>
           </a:p>
         </p:txBody>
@@ -3729,7 +3729,7 @@
                 <a:ea typeface="Bitstream Charter"/>
                 <a:cs typeface="Bitstream Charter"/>
               </a:rPr>
-              <a:t>What to inspect</a:t>
+              <a:t>Subgroups</a:t>
             </a:r>
           </a:p>
         </p:txBody>
@@ -3787,29 +3787,7 @@
                 <a:ea typeface="Bitstream Charter"/>
                 <a:cs typeface="Bitstream Charter"/>
               </a:rPr>
-              <a:t>The held-out set has 228 labeled windows. Accuracy is </a:t>
-            </a:r>
-            <a:r>
-              <a:rPr sz="1950" b="0">
-                <a:solidFill>
-                  <a:srgbClr val="153246"/>
-                </a:solidFill>
-                <a:latin typeface="Bitstream Charter"/>
-                <a:ea typeface="Bitstream Charter"/>
-                <a:cs typeface="Bitstream Charter"/>
-              </a:rPr>
-              <a:t>75.0%</a:t>
-            </a:r>
-            <a:r>
-              <a:rPr sz="1950" b="0">
-                <a:solidFill>
-                  <a:srgbClr val="153246"/>
-                </a:solidFill>
-                <a:latin typeface="Bitstream Charter"/>
-                <a:ea typeface="Bitstream Charter"/>
-                <a:cs typeface="Bitstream Charter"/>
-              </a:rPr>
-              <a:t>, while always predicting signal scores 78.1%.</a:t>
+              <a:t>North and South counts reconcile to each parent series; inspect changing workload shares.</a:t>
             </a:r>
           </a:p>
         </p:txBody>
@@ -3867,7 +3845,7 @@
                 <a:ea typeface="Bitstream Charter"/>
                 <a:cs typeface="Bitstream Charter"/>
               </a:rPr>
-              <a:t>Interpretation</a:t>
+              <a:t>Quality</a:t>
             </a:r>
           </a:p>
         </p:txBody>
@@ -3925,7 +3903,7 @@
                 <a:ea typeface="Bitstream Charter"/>
                 <a:cs typeface="Bitstream Charter"/>
               </a:rPr>
-              <a:t>The classifier loses to a trivial baseline on accuracy. For this label, directly running the known rules is the sound recommendation.</a:t>
+              <a:t>Measure missing values, cardinality and placeholder counts. The redundant channel is excluded from modeling.</a:t>
             </a:r>
           </a:p>
         </p:txBody>
@@ -4012,7 +3990,7 @@
                 <a:ea typeface="Bitstream Charter"/>
                 <a:cs typeface="Bitstream Charter"/>
               </a:rPr>
-              <a:t>NOTEBOOK / CELL 6 OF 10</a:t>
+              <a:t>NOTEBOOK / CELL 11</a:t>
             </a:r>
           </a:p>
         </p:txBody>
@@ -4070,7 +4048,7 @@
                 <a:ea typeface="Bitstream Charter"/>
                 <a:cs typeface="Bitstream Charter"/>
               </a:rPr>
-              <a:t>Forecast tomorrow’s count</a:t>
+              <a:t>Compare models across five time folds</a:t>
             </a:r>
           </a:p>
         </p:txBody>
@@ -4244,7 +4222,7 @@
                 <a:ea typeface="Bitstream Charter"/>
                 <a:cs typeface="Bitstream Charter"/>
               </a:rPr>
-              <a:t>What it does</a:t>
+              <a:t>Comparison</a:t>
             </a:r>
           </a:p>
         </p:txBody>
@@ -4302,7 +4280,7 @@
                 <a:ea typeface="Bitstream Charter"/>
                 <a:cs typeface="Bitstream Charter"/>
               </a:rPr>
-              <a:t>Use yesterday’s information to estimate the next business day’s workload.</a:t>
+              <a:t>Random forest versus scaled logistic regression across five chronological test folds.</a:t>
             </a:r>
           </a:p>
         </p:txBody>
@@ -4360,7 +4338,7 @@
                 <a:ea typeface="Bitstream Charter"/>
                 <a:cs typeface="Bitstream Charter"/>
               </a:rPr>
-              <a:t>Technology / data science</a:t>
+              <a:t>Validation</a:t>
             </a:r>
           </a:p>
         </p:txBody>
@@ -4418,7 +4396,7 @@
                 <a:ea typeface="Bitstream Charter"/>
                 <a:cs typeface="Bitstream Charter"/>
               </a:rPr>
-              <a:t>Random forest regression, categorical series indicators, a later-date holdout, mean absolute error.</a:t>
+              <a:t>Each fold keeps a gap between training and test windows.</a:t>
             </a:r>
           </a:p>
         </p:txBody>
@@ -4476,7 +4454,7 @@
                 <a:ea typeface="Bitstream Charter"/>
                 <a:cs typeface="Bitstream Charter"/>
               </a:rPr>
-              <a:t>What to inspect</a:t>
+              <a:t>Result</a:t>
             </a:r>
           </a:p>
         </p:txBody>
@@ -4534,7 +4512,7 @@
                 <a:ea typeface="Bitstream Charter"/>
                 <a:cs typeface="Bitstream Charter"/>
               </a:rPr>
-              <a:t>Demo test MAE is 8.85 counts; the simple five-day average has MAE 9.73 counts.</a:t>
+              <a:t>Mean fold accuracy: logistic 81.3%; forest 78.4%. Inspect each fold and its majority baseline.</a:t>
             </a:r>
           </a:p>
         </p:txBody>
@@ -4592,7 +4570,7 @@
                 <a:ea typeface="Bitstream Charter"/>
                 <a:cs typeface="Bitstream Charter"/>
               </a:rPr>
-              <a:t>Interpretation</a:t>
+              <a:t>Explanation</a:t>
             </a:r>
           </a:p>
         </p:txBody>
@@ -4650,7 +4628,7 @@
                 <a:ea typeface="Bitstream Charter"/>
                 <a:cs typeface="Bitstream Charter"/>
               </a:rPr>
-              <a:t>This is a one-business-day forecast. Its advantage on demo data needs prospective validation on real authorized data.</a:t>
+              <a:t>Permutation importance shows which features the fitted forest relies on, not causes.</a:t>
             </a:r>
           </a:p>
         </p:txBody>
@@ -4737,7 +4715,7 @@
                 <a:ea typeface="Bitstream Charter"/>
                 <a:cs typeface="Bitstream Charter"/>
               </a:rPr>
-              <a:t>NOTEBOOK / CELL 7 OF 10</a:t>
+              <a:t>NOTEBOOK / CELL 12</a:t>
             </a:r>
           </a:p>
         </p:txBody>
@@ -4795,7 +4773,7 @@
                 <a:ea typeface="Bitstream Charter"/>
                 <a:cs typeface="Bitstream Charter"/>
               </a:rPr>
-              <a:t>Visual evidence</a:t>
+              <a:t>Five-day forecasts and future dates</a:t>
             </a:r>
           </a:p>
         </p:txBody>
@@ -4969,7 +4947,7 @@
                 <a:ea typeface="Bitstream Charter"/>
                 <a:cs typeface="Bitstream Charter"/>
               </a:rPr>
-              <a:t>What it does</a:t>
+              <a:t>Candidates</a:t>
             </a:r>
           </a:p>
         </p:txBody>
@@ -5027,7 +5005,7 @@
                 <a:ea typeface="Bitstream Charter"/>
                 <a:cs typeface="Bitstream Charter"/>
               </a:rPr>
-              <a:t>Draw the control chart, a confusion matrix of classifier hits and misses, and actual versus predicted counts.</a:t>
+              <a:t>ARIMA and Holt-Winters compete against a seasonal-naive baseline.</a:t>
             </a:r>
           </a:p>
         </p:txBody>
@@ -5085,7 +5063,7 @@
                 <a:ea typeface="Bitstream Charter"/>
                 <a:cs typeface="Bitstream Charter"/>
               </a:rPr>
-              <a:t>Technology / data science</a:t>
+              <a:t>Backtest</a:t>
             </a:r>
           </a:p>
         </p:txBody>
@@ -5143,7 +5121,7 @@
                 <a:ea typeface="Bitstream Charter"/>
                 <a:cs typeface="Bitstream Charter"/>
               </a:rPr>
-              <a:t>Matplotlib time-series plots and a held-out confusion matrix.</a:t>
+              <a:t>Six historical origins per series, five steps per origin: 270 scored predictions.</a:t>
             </a:r>
           </a:p>
         </p:txBody>
@@ -5201,7 +5179,7 @@
                 <a:ea typeface="Bitstream Charter"/>
                 <a:cs typeface="Bitstream Charter"/>
               </a:rPr>
-              <a:t>What to inspect</a:t>
+              <a:t>Result</a:t>
             </a:r>
           </a:p>
         </p:txBody>
@@ -5259,7 +5237,7 @@
                 <a:ea typeface="Bitstream Charter"/>
                 <a:cs typeface="Bitstream Charter"/>
               </a:rPr>
-              <a:t>Three notebook figures. The charts use fabricated series; they appear during the live run.</a:t>
+              <a:t>Pooled MAE: ARIMA 10.15; Holt-Winters 10.38; seasonal baseline 12.92.</a:t>
             </a:r>
           </a:p>
         </p:txBody>
@@ -5317,7 +5295,7 @@
                 <a:ea typeface="Bitstream Charter"/>
                 <a:cs typeface="Bitstream Charter"/>
               </a:rPr>
-              <a:t>Interpretation</a:t>
+              <a:t>Future</a:t>
             </a:r>
           </a:p>
         </p:txBody>
@@ -5375,7 +5353,7 @@
                 <a:ea typeface="Bitstream Charter"/>
                 <a:cs typeface="Bitstream Charter"/>
               </a:rPr>
-              <a:t>A circled point means a rule fired somewhere in the previous window; it need not cross the XmR line shown.</a:t>
+              <a:t>75 dated future predictions cover totals and offices. First five origins select; the last origin checks the choice.</a:t>
             </a:r>
           </a:p>
         </p:txBody>
@@ -5462,7 +5440,7 @@
                 <a:ea typeface="Bitstream Charter"/>
                 <a:cs typeface="Bitstream Charter"/>
               </a:rPr>
-              <a:t>NOTEBOOK / CELL 8 OF 10</a:t>
+              <a:t>NOTEBOOK / CELL 13</a:t>
             </a:r>
           </a:p>
         </p:txBody>
@@ -5520,7 +5498,7 @@
                 <a:ea typeface="Bitstream Charter"/>
                 <a:cs typeface="Bitstream Charter"/>
               </a:rPr>
-              <a:t>Analyst review episodes</a:t>
+              <a:t>A separate unusualness signal</a:t>
             </a:r>
           </a:p>
         </p:txBody>
@@ -5694,7 +5672,7 @@
                 <a:ea typeface="Bitstream Charter"/>
                 <a:cs typeface="Bitstream Charter"/>
               </a:rPr>
-              <a:t>What it does</a:t>
+              <a:t>Method</a:t>
             </a:r>
           </a:p>
         </p:txBody>
@@ -5752,7 +5730,7 @@
                 <a:ea typeface="Bitstream Charter"/>
                 <a:cs typeface="Bitstream Charter"/>
               </a:rPr>
-              <a:t>Group consecutive flagged days into a smaller list for a person to inspect.</a:t>
+              <a:t>Isolation Forest spots feature combinations that differ from its training history.</a:t>
             </a:r>
           </a:p>
         </p:txBody>
@@ -5810,7 +5788,7 @@
                 <a:ea typeface="Bitstream Charter"/>
                 <a:cs typeface="Bitstream Charter"/>
               </a:rPr>
-              <a:t>Technology / data science</a:t>
+              <a:t>Calibration</a:t>
             </a:r>
           </a:p>
         </p:txBody>
@@ -5868,7 +5846,7 @@
                 <a:ea typeface="Bitstream Charter"/>
                 <a:cs typeface="Bitstream Charter"/>
               </a:rPr>
-              <a:t>Group-by, change detection, cumulative episode IDs, and a one-row monitoring snapshot.</a:t>
+              <a:t>Each time fold sets its contamination from training data only, within bounded demo limits.</a:t>
             </a:r>
           </a:p>
         </p:txBody>
@@ -5926,7 +5904,7 @@
                 <a:ea typeface="Bitstream Charter"/>
                 <a:cs typeface="Bitstream Charter"/>
               </a:rPr>
-              <a:t>What to inspect</a:t>
+              <a:t>Inspect</a:t>
             </a:r>
           </a:p>
         </p:txBody>
@@ -5984,7 +5962,7 @@
                 <a:ea typeface="Bitstream Charter"/>
                 <a:cs typeface="Bitstream Charter"/>
               </a:rPr>
-              <a:t>479 flagged windows consolidate into 30 episodes on this demo run. The visible queue shows 15 episodes with the latest signal dates.</a:t>
+              <a:t>25 of 228 held-out windows are flagged by the final anomaly model.</a:t>
             </a:r>
           </a:p>
         </p:txBody>
@@ -6042,7 +6020,7 @@
                 <a:ea typeface="Bitstream Charter"/>
                 <a:cs typeface="Bitstream Charter"/>
               </a:rPr>
-              <a:t>Interpretation</a:t>
+              <a:t>Boundary</a:t>
             </a:r>
           </a:p>
         </p:txBody>
@@ -6100,7 +6078,7 @@
                 <a:ea typeface="Bitstream Charter"/>
                 <a:cs typeface="Bitstream Charter"/>
               </a:rPr>
-              <a:t>These entries stay pending. No notification, recorded disposition, or operational action is implemented.</a:t>
+              <a:t>Rule agreement is a comparison proxy. It is not incident-detection accuracy or validated truth.</a:t>
             </a:r>
           </a:p>
         </p:txBody>
@@ -6187,7 +6165,7 @@
                 <a:ea typeface="Bitstream Charter"/>
                 <a:cs typeface="Bitstream Charter"/>
               </a:rPr>
-              <a:t>NOTEBOOK / CELL 9 OF 10</a:t>
+              <a:t>NOTEBOOK / CELL 14</a:t>
             </a:r>
           </a:p>
         </p:txBody>
@@ -6245,7 +6223,7 @@
                 <a:ea typeface="Bitstream Charter"/>
                 <a:cs typeface="Bitstream Charter"/>
               </a:rPr>
-              <a:t>MLflow record</a:t>
+              <a:t>Follow upstream dependencies</a:t>
             </a:r>
           </a:p>
         </p:txBody>
@@ -6419,7 +6397,7 @@
                 <a:ea typeface="Bitstream Charter"/>
                 <a:cs typeface="Bitstream Charter"/>
               </a:rPr>
-              <a:t>What it does</a:t>
+              <a:t>Lineage</a:t>
             </a:r>
           </a:p>
         </p:txBody>
@@ -6477,7 +6455,7 @@
                 <a:ea typeface="Bitstream Charter"/>
                 <a:cs typeface="Bitstream Charter"/>
               </a:rPr>
-              <a:t>Write down the settings, test scores and model files for this run.</a:t>
+              <a:t>Traverse a branching fixture graph up to five upstream hops, with cycle protection.</a:t>
             </a:r>
           </a:p>
         </p:txBody>
@@ -6535,7 +6513,7 @@
                 <a:ea typeface="Bitstream Charter"/>
                 <a:cs typeface="Bitstream Charter"/>
               </a:rPr>
-              <a:t>Technology / data science</a:t>
+              <a:t>Columns</a:t>
             </a:r>
           </a:p>
         </p:txBody>
@@ -6593,7 +6571,7 @@
                 <a:ea typeface="Bitstream Charter"/>
                 <a:cs typeface="Bitstream Charter"/>
               </a:rPr>
-              <a:t>MLflow experiment tracking and optional Unity Catalog model registration.</a:t>
+              <a:t>Inspect example source-to-target column mappings and inferred table roles.</a:t>
             </a:r>
           </a:p>
         </p:txBody>
@@ -6651,7 +6629,7 @@
                 <a:ea typeface="Bitstream Charter"/>
                 <a:cs typeface="Bitstream Charter"/>
               </a:rPr>
-              <a:t>What to inspect</a:t>
+              <a:t>Freshness</a:t>
             </a:r>
           </a:p>
         </p:txBody>
@@ -6709,7 +6687,7 @@
                 <a:ea typeface="Bitstream Charter"/>
                 <a:cs typeface="Bitstream Charter"/>
               </a:rPr>
-              <a:t>In Databricks, look for a run ID and two logged model URIs. Registration only happens if UC_MODEL_NAME is filled in.</a:t>
+              <a:t>Compare update ages with a demo threshold; one upstream source is deliberately late.</a:t>
             </a:r>
           </a:p>
         </p:txBody>
@@ -6767,7 +6745,7 @@
                 <a:ea typeface="Bitstream Charter"/>
                 <a:cs typeface="Bitstream Charter"/>
               </a:rPr>
-              <a:t>Interpretation</a:t>
+              <a:t>Boundary</a:t>
             </a:r>
           </a:p>
         </p:txBody>
@@ -6825,7 +6803,7 @@
                 <a:ea typeface="Bitstream Charter"/>
                 <a:cs typeface="Bitstream Charter"/>
               </a:rPr>
-              <a:t>A logged run aids inspection; full reproducibility also needs the notebook revision, dependencies and input ID.</a:t>
+              <a:t>These are fixture metadata. Live Unity Catalog discovery and permissions remain unverified.</a:t>
             </a:r>
           </a:p>
         </p:txBody>
@@ -6912,7 +6890,7 @@
                 <a:ea typeface="Bitstream Charter"/>
                 <a:cs typeface="Bitstream Charter"/>
               </a:rPr>
-              <a:t>NOTEBOOK / CELL 10 OF 10</a:t>
+              <a:t>NOTEBOOK / CELL 15</a:t>
             </a:r>
           </a:p>
         </p:txBody>
@@ -6970,7 +6948,7 @@
                 <a:ea typeface="Bitstream Charter"/>
                 <a:cs typeface="Bitstream Charter"/>
               </a:rPr>
-              <a:t>Optional Delta tables</a:t>
+              <a:t>Make a hypothesis, then verify it</a:t>
             </a:r>
           </a:p>
         </p:txBody>
@@ -7144,7 +7122,7 @@
                 <a:ea typeface="Bitstream Charter"/>
                 <a:cs typeface="Bitstream Charter"/>
               </a:rPr>
-              <a:t>What it does</a:t>
+              <a:t>Context</a:t>
             </a:r>
           </a:p>
         </p:txBody>
@@ -7202,7 +7180,7 @@
                 <a:ea typeface="Bitstream Charter"/>
                 <a:cs typeface="Bitstream Charter"/>
               </a:rPr>
-              <a:t>Save the fictional source and calculated results to tables for later queries or a dashboard.</a:t>
+              <a:t>Attach nearby fictional events and matching subgroup evidence to a review episode.</a:t>
             </a:r>
           </a:p>
         </p:txBody>
@@ -7260,7 +7238,7 @@
                 <a:ea typeface="Bitstream Charter"/>
                 <a:cs typeface="Bitstream Charter"/>
               </a:rPr>
-              <a:t>Technology / data science</a:t>
+              <a:t>Investigation</a:t>
             </a:r>
           </a:p>
         </p:txBody>
@@ -7318,7 +7296,7 @@
                 <a:ea typeface="Bitstream Charter"/>
                 <a:cs typeface="Bitstream Charter"/>
               </a:rPr>
-              <a:t>Spark DataFrame writes to six managed Delta tables in an existing Unity Catalog schema.</a:t>
+              <a:t>Combine the rule, top office deviation and relevant upstream freshness.</a:t>
             </a:r>
           </a:p>
         </p:txBody>
@@ -7376,7 +7354,7 @@
                 <a:ea typeface="Bitstream Charter"/>
                 <a:cs typeface="Bitstream Charter"/>
               </a:rPr>
-              <a:t>What to inspect</a:t>
+              <a:t>Output</a:t>
             </a:r>
           </a:p>
         </p:txBody>
@@ -7434,7 +7412,7 @@
                 <a:ea typeface="Bitstream Charter"/>
                 <a:cs typeface="Bitstream Charter"/>
               </a:rPr>
-              <a:t>Tables are demo_daily, spc_signals, spc_predictions, count_forecasts, review_queue and monitoring_snapshot.</a:t>
+              <a:t>A traceable hypothesis identifies the evidence that informed it.</a:t>
             </a:r>
           </a:p>
         </p:txBody>
@@ -7492,7 +7470,7 @@
                 <a:ea typeface="Bitstream Charter"/>
                 <a:cs typeface="Bitstream Charter"/>
               </a:rPr>
-              <a:t>Interpretation</a:t>
+              <a:t>Boundary</a:t>
             </a:r>
           </a:p>
         </p:txBody>
@@ -7550,7 +7528,7 @@
                 <a:ea typeface="Bitstream Charter"/>
                 <a:cs typeface="Bitstream Charter"/>
               </a:rPr>
-              <a:t>Default is off. Overwrite mode belongs only in a dedicated demo schema, after permissions are confirmed.</a:t>
+              <a:t>Every result is labeled unverified. No causal model or automatic operational remedy is claimed.</a:t>
             </a:r>
           </a:p>
         </p:txBody>
@@ -7637,7 +7615,7 @@
                 <a:ea typeface="Bitstream Charter"/>
                 <a:cs typeface="Bitstream Charter"/>
               </a:rPr>
-              <a:t>MEASURED RESULT</a:t>
+              <a:t>NOTEBOOK / CELL 16</a:t>
             </a:r>
           </a:p>
         </p:txBody>
@@ -7695,7 +7673,7 @@
                 <a:ea typeface="Bitstream Charter"/>
                 <a:cs typeface="Bitstream Charter"/>
               </a:rPr>
-              <a:t>This demo run gives two different ML verdicts</a:t>
+              <a:t>Keep history; assess only mature evidence</a:t>
             </a:r>
           </a:p>
         </p:txBody>
@@ -7869,7 +7847,7 @@
                 <a:ea typeface="Bitstream Charter"/>
                 <a:cs typeface="Bitstream Charter"/>
               </a:rPr>
-              <a:t>Rule-label classifier</a:t>
+              <a:t>Forecast ledger</a:t>
             </a:r>
           </a:p>
         </p:txBody>
@@ -7909,6 +7887,30 @@
           <a:p xmlns:a="http://schemas.openxmlformats.org/drawingml/2006/main">
             <a:pPr>
               <a:buNone/>
+              <a:defRPr sz="1900" b="0">
+                <a:solidFill>
+                  <a:srgbClr val="173447"/>
+                </a:solidFill>
+                <a:latin typeface="Aptos"/>
+                <a:ea typeface="Aptos"/>
+                <a:cs typeface="Aptos"/>
+              </a:defRPr>
+            </a:pPr>
+            <a:r>
+              <a:rPr sz="1900" b="0">
+                <a:solidFill>
+                  <a:srgbClr val="173447"/>
+                </a:solidFill>
+                <a:latin typeface="Aptos"/>
+                <a:ea typeface="Aptos"/>
+                <a:cs typeface="Aptos"/>
+              </a:rPr>
+              <a:t>270 historical predictions retain model, origin and target date.</a:t>
+            </a:r>
+          </a:p>
+          <a:p xmlns:a="http://schemas.openxmlformats.org/drawingml/2006/main">
+            <a:pPr>
+              <a:buNone/>
               <a:defRPr sz="2025" b="0">
                 <a:solidFill>
                   <a:srgbClr val="153246"/>
@@ -7927,71 +7929,30 @@
                 <a:ea typeface="Bitstream Charter"/>
                 <a:cs typeface="Bitstream Charter"/>
               </a:rPr>
-              <a:t>75.0%</a:t>
-            </a:r>
-            <a:r>
-              <a:rPr sz="2025" b="0">
-                <a:solidFill>
-                  <a:srgbClr val="153246"/>
-                </a:solidFill>
-                <a:latin typeface="Bitstream Charter"/>
-                <a:ea typeface="Bitstream Charter"/>
-                <a:cs typeface="Bitstream Charter"/>
-              </a:rPr>
-              <a:t> accuracy</a:t>
-            </a:r>
-          </a:p>
-          <a:p xmlns:a="http://schemas.openxmlformats.org/drawingml/2006/main">
-            <a:pPr>
-              <a:buNone/>
-              <a:defRPr sz="2025" b="0">
-                <a:solidFill>
-                  <a:srgbClr val="153246"/>
-                </a:solidFill>
-                <a:latin typeface="Bitstream Charter"/>
-                <a:ea typeface="Bitstream Charter"/>
-                <a:cs typeface="Bitstream Charter"/>
-              </a:defRPr>
-            </a:pPr>
-            <a:r>
-              <a:rPr sz="2025" b="0">
-                <a:solidFill>
-                  <a:srgbClr val="153246"/>
-                </a:solidFill>
-                <a:latin typeface="Bitstream Charter"/>
-                <a:ea typeface="Bitstream Charter"/>
-                <a:cs typeface="Bitstream Charter"/>
-              </a:rPr>
-              <a:t>78.1% always-signal baseline</a:t>
-            </a:r>
-          </a:p>
-          <a:p xmlns:a="http://schemas.openxmlformats.org/drawingml/2006/main">
-            <a:r>
               <a:t/>
             </a:r>
           </a:p>
           <a:p xmlns:a="http://schemas.openxmlformats.org/drawingml/2006/main">
             <a:pPr>
-              <a:buNone/>
-              <a:defRPr sz="2025" b="0">
-                <a:solidFill>
-                  <a:srgbClr val="153246"/>
-                </a:solidFill>
-                <a:latin typeface="Bitstream Charter"/>
-                <a:ea typeface="Bitstream Charter"/>
-                <a:cs typeface="Bitstream Charter"/>
-              </a:defRPr>
-            </a:pPr>
-            <a:r>
-              <a:rPr sz="2025" b="0">
-                <a:solidFill>
-                  <a:srgbClr val="153246"/>
-                </a:solidFill>
-                <a:latin typeface="Bitstream Charter"/>
-                <a:ea typeface="Bitstream Charter"/>
-                <a:cs typeface="Bitstream Charter"/>
-              </a:rPr>
-              <a:t>Use the known SPC rules.</a:t>
+              <a:defRPr sz="1900">
+                <a:solidFill>
+                  <a:srgbClr val="173447"/>
+                </a:solidFill>
+                <a:latin typeface="Aptos"/>
+                <a:ea typeface="Aptos"/>
+                <a:cs typeface="Aptos"/>
+              </a:defRPr>
+            </a:pPr>
+            <a:r>
+              <a:rPr sz="1900">
+                <a:solidFill>
+                  <a:srgbClr val="173447"/>
+                </a:solidFill>
+                <a:latin typeface="Aptos"/>
+                <a:ea typeface="Aptos"/>
+                <a:cs typeface="Aptos"/>
+              </a:rPr>
+              <a:t>Replaying the same keys updates a row; different origins remain.</a:t>
             </a:r>
           </a:p>
         </p:txBody>
@@ -8049,7 +8010,7 @@
                 <a:ea typeface="Bitstream Charter"/>
                 <a:cs typeface="Bitstream Charter"/>
               </a:rPr>
-              <a:t>One-day count forecast</a:t>
+              <a:t>Assessment safeguards</a:t>
             </a:r>
           </a:p>
         </p:txBody>
@@ -8089,6 +8050,30 @@
           <a:p xmlns:a="http://schemas.openxmlformats.org/drawingml/2006/main">
             <a:pPr>
               <a:buNone/>
+              <a:defRPr sz="1900" b="0">
+                <a:solidFill>
+                  <a:srgbClr val="173447"/>
+                </a:solidFill>
+                <a:latin typeface="Aptos"/>
+                <a:ea typeface="Aptos"/>
+                <a:cs typeface="Aptos"/>
+              </a:defRPr>
+            </a:pPr>
+            <a:r>
+              <a:rPr sz="1900" b="0">
+                <a:solidFill>
+                  <a:srgbClr val="173447"/>
+                </a:solidFill>
+                <a:latin typeface="Aptos"/>
+                <a:ea typeface="Aptos"/>
+                <a:cs typeface="Aptos"/>
+              </a:rPr>
+              <a:t>MAE, RMSE, sMAPE, bias and direction.</a:t>
+            </a:r>
+          </a:p>
+          <a:p xmlns:a="http://schemas.openxmlformats.org/drawingml/2006/main">
+            <a:pPr>
+              <a:buNone/>
               <a:defRPr sz="2025" b="0">
                 <a:solidFill>
                   <a:srgbClr val="153246"/>
@@ -8107,60 +8092,30 @@
                 <a:ea typeface="Bitstream Charter"/>
                 <a:cs typeface="Bitstream Charter"/>
               </a:rPr>
-              <a:t>8.85 counts MAE</a:t>
-            </a:r>
-          </a:p>
-          <a:p xmlns:a="http://schemas.openxmlformats.org/drawingml/2006/main">
-            <a:pPr>
-              <a:buNone/>
-              <a:defRPr sz="2025" b="0">
-                <a:solidFill>
-                  <a:srgbClr val="153246"/>
-                </a:solidFill>
-                <a:latin typeface="Bitstream Charter"/>
-                <a:ea typeface="Bitstream Charter"/>
-                <a:cs typeface="Bitstream Charter"/>
-              </a:defRPr>
-            </a:pPr>
-            <a:r>
-              <a:rPr sz="2025" b="0">
-                <a:solidFill>
-                  <a:srgbClr val="153246"/>
-                </a:solidFill>
-                <a:latin typeface="Bitstream Charter"/>
-                <a:ea typeface="Bitstream Charter"/>
-                <a:cs typeface="Bitstream Charter"/>
-              </a:rPr>
-              <a:t>9.73 counts simple-average MAE</a:t>
-            </a:r>
-          </a:p>
-          <a:p xmlns:a="http://schemas.openxmlformats.org/drawingml/2006/main">
-            <a:r>
               <a:t/>
             </a:r>
           </a:p>
           <a:p xmlns:a="http://schemas.openxmlformats.org/drawingml/2006/main">
             <a:pPr>
-              <a:buNone/>
-              <a:defRPr sz="2025" b="0">
-                <a:solidFill>
-                  <a:srgbClr val="153246"/>
-                </a:solidFill>
-                <a:latin typeface="Bitstream Charter"/>
-                <a:ea typeface="Bitstream Charter"/>
-                <a:cs typeface="Bitstream Charter"/>
-              </a:defRPr>
-            </a:pPr>
-            <a:r>
-              <a:rPr sz="2025" b="0">
-                <a:solidFill>
-                  <a:srgbClr val="153246"/>
-                </a:solidFill>
-                <a:latin typeface="Bitstream Charter"/>
-                <a:ea typeface="Bitstream Charter"/>
-                <a:cs typeface="Bitstream Charter"/>
-              </a:rPr>
-              <a:t>Candidate for further validation.</a:t>
+              <a:defRPr sz="1900">
+                <a:solidFill>
+                  <a:srgbClr val="173447"/>
+                </a:solidFill>
+                <a:latin typeface="Aptos"/>
+                <a:ea typeface="Aptos"/>
+                <a:cs typeface="Aptos"/>
+              </a:defRPr>
+            </a:pPr>
+            <a:r>
+              <a:rPr sz="1900">
+                <a:solidFill>
+                  <a:srgbClr val="173447"/>
+                </a:solidFill>
+                <a:latin typeface="Aptos"/>
+                <a:ea typeface="Aptos"/>
+                <a:cs typeface="Aptos"/>
+              </a:rPr>
+              <a:t>Insufficient samples, superseded runs and deteriorating error receive distinct advice.</a:t>
             </a:r>
           </a:p>
         </p:txBody>
@@ -8218,7 +8173,7 @@
                 <a:ea typeface="Bitstream Charter"/>
                 <a:cs typeface="Bitstream Charter"/>
               </a:rPr>
-              <a:t>Both comparisons use later demo dates with a gap between training and test windows.</a:t>
+              <a:t>Retraining recommendations remain advisory. A threshold breach does not trigger model replacement.</a:t>
             </a:r>
           </a:p>
         </p:txBody>
@@ -8305,7 +8260,7 @@
                 <a:ea typeface="Bitstream Charter"/>
                 <a:cs typeface="Bitstream Charter"/>
               </a:rPr>
-              <a:t>OPERATING MODEL</a:t>
+              <a:t>NOTEBOOK / CELL 17</a:t>
             </a:r>
           </a:p>
         </p:txBody>
@@ -8363,7 +8318,7 @@
                 <a:ea typeface="Bitstream Charter"/>
                 <a:cs typeface="Bitstream Charter"/>
               </a:rPr>
-              <a:t>How the parts work together</a:t>
+              <a:t>Candidate review and rollback exercise</a:t>
             </a:r>
           </a:p>
         </p:txBody>
@@ -8537,7 +8492,7 @@
                 <a:ea typeface="Bitstream Charter"/>
                 <a:cs typeface="Bitstream Charter"/>
               </a:rPr>
-              <a:t>1  Observe and check</a:t>
+              <a:t>1  Compare</a:t>
             </a:r>
           </a:p>
         </p:txBody>
@@ -8595,7 +8550,7 @@
                 <a:ea typeface="Bitstream Charter"/>
                 <a:cs typeface="Bitstream Charter"/>
               </a:rPr>
-              <a:t>Validate a daily count, compare recent behavior with a reference period, and retain the rule that fired.</a:t>
+              <a:t>The final forecast origin gives ARIMA a 22.9% MAE improvement over the seasonal baseline.</a:t>
             </a:r>
           </a:p>
         </p:txBody>
@@ -8653,7 +8608,7 @@
                 <a:ea typeface="Bitstream Charter"/>
                 <a:cs typeface="Bitstream Charter"/>
               </a:rPr>
-              <a:t>2  Evaluate ML separately</a:t>
+              <a:t>2  Keep judgment</a:t>
             </a:r>
           </a:p>
         </p:txBody>
@@ -8711,7 +8666,7 @@
                 <a:ea typeface="Bitstream Charter"/>
                 <a:cs typeface="Bitstream Charter"/>
               </a:rPr>
-              <a:t>Test label imitation against direct rules; test the future count forecast against a simple moving average.</a:t>
+              <a:t>Only 15 held-out observations support this check. The result is advice, not a production promotion.</a:t>
             </a:r>
           </a:p>
         </p:txBody>
@@ -8769,7 +8724,7 @@
                 <a:ea typeface="Bitstream Charter"/>
                 <a:cs typeface="Bitstream Charter"/>
               </a:rPr>
-              <a:t>3  Review and record</a:t>
+              <a:t>3  Practice withdrawal</a:t>
             </a:r>
           </a:p>
         </p:txBody>
@@ -8827,7 +8782,7 @@
                 <a:ea typeface="Bitstream Charter"/>
                 <a:cs typeface="Bitstream Charter"/>
               </a:rPr>
-              <a:t>Group persistent flags into a pending review list. A pilot would add analyst investigation and recorded dispositions.</a:t>
+              <a:t>A fictional registry sequence selects a candidate, then restores the baseline. The classifier is marked for withdrawal.</a:t>
             </a:r>
           </a:p>
         </p:txBody>
@@ -8914,7 +8869,7 @@
                 <a:ea typeface="Bitstream Charter"/>
                 <a:cs typeface="Bitstream Charter"/>
               </a:rPr>
-              <a:t>USCIS REFERENCE</a:t>
+              <a:t>NOTEBOOK / CELL 18</a:t>
             </a:r>
           </a:p>
         </p:txBody>
@@ -8972,7 +8927,7 @@
                 <a:ea typeface="Bitstream Charter"/>
                 <a:cs typeface="Bitstream Charter"/>
               </a:rPr>
-              <a:t>What the USCIS design contributed</a:t>
+              <a:t>Replay daily review and suppress repeats</a:t>
             </a:r>
           </a:p>
         </p:txBody>
@@ -9146,7 +9101,7 @@
                 <a:ea typeface="Bitstream Charter"/>
                 <a:cs typeface="Bitstream Charter"/>
               </a:rPr>
-              <a:t>Documented reference design</a:t>
+              <a:t>Executable local replay</a:t>
             </a:r>
           </a:p>
         </p:txBody>
@@ -9204,7 +9159,7 @@
                 <a:ea typeface="Bitstream Charter"/>
                 <a:cs typeface="Bitstream Charter"/>
               </a:rPr>
-              <a:t>Forecasting and anomaly analysis alongside upstream lineage, which gives analysts more context for investigating a signal.</a:t>
+              <a:t>Three recent business dates produce prepared notices and suppress repeats for the same episode. The dashboard summarizes rules, reviews and outbox volume.</a:t>
             </a:r>
           </a:p>
         </p:txBody>
@@ -9262,7 +9217,7 @@
                 <a:ea typeface="Bitstream Charter"/>
                 <a:cs typeface="Bitstream Charter"/>
               </a:rPr>
-              <a:t>Claim boundary</a:t>
+              <a:t>Human and delivery boundary</a:t>
             </a:r>
           </a:p>
         </p:txBody>
@@ -9320,7 +9275,7 @@
                 <a:ea typeface="Bitstream Charter"/>
                 <a:cs typeface="Bitstream Charter"/>
               </a:rPr>
-              <a:t>The reference documents stale retraining-trigger fixes. Downstream alert grouping remains planned. No measured alert reduction or staff time saved was supplied.</a:t>
+              <a:t>A separate fictional disposition demonstrates analyst context. Original queue rows remain pending. Notices are never sent; schedule and external connectors are not enabled.</a:t>
             </a:r>
           </a:p>
         </p:txBody>
@@ -9407,7 +9362,7 @@
                 <a:ea typeface="Bitstream Charter"/>
                 <a:cs typeface="Bitstream Charter"/>
               </a:rPr>
-              <a:t>TRANSFER</a:t>
+              <a:t>NOTEBOOK / CELLS 19–20</a:t>
             </a:r>
           </a:p>
         </p:txBody>
@@ -9465,7 +9420,7 @@
                 <a:ea typeface="Bitstream Charter"/>
                 <a:cs typeface="Bitstream Charter"/>
               </a:rPr>
-              <a:t>Where another agency could use this pattern</a:t>
+              <a:t>Record models and retain Delta history</a:t>
             </a:r>
           </a:p>
         </p:txBody>
@@ -9639,7 +9594,7 @@
                 <a:ea typeface="Bitstream Charter"/>
                 <a:cs typeface="Bitstream Charter"/>
               </a:rPr>
-              <a:t>Suitable starting point</a:t>
+              <a:t>MLflow and candidate registration</a:t>
             </a:r>
           </a:p>
         </p:txBody>
@@ -9697,7 +9652,7 @@
                 <a:ea typeface="Bitstream Charter"/>
                 <a:cs typeface="Bitstream Charter"/>
               </a:rPr>
-              <a:t>A recurring count with a stable definition, enough history, and an owner who can investigate exceptions.</a:t>
+              <a:t>Log four sklearn models and evaluation metrics. Optional registry tags and demo_candidate aliases label the versions without changing a production alias.</a:t>
             </a:r>
           </a:p>
         </p:txBody>
@@ -9755,7 +9710,7 @@
                 <a:ea typeface="Bitstream Charter"/>
                 <a:cs typeface="Bitstream Charter"/>
               </a:rPr>
-              <a:t>Evidence required before use</a:t>
+              <a:t>Queryable history</a:t>
             </a:r>
           </a:p>
         </p:txBody>
@@ -9813,7 +9768,7 @@
                 <a:ea typeface="Bitstream Charter"/>
                 <a:cs typeface="Bitstream Charter"/>
               </a:rPr>
-              <a:t>Calibrate limits, check false alarms and subgroup effects, test forecasts on later real dates, define action and rollback.</a:t>
+              <a:t>Nineteen optional Delta tables use keyed MERGE. Forecast origins remain distinct. Writes default off; real MLflow, Spark and schema compatibility need workspace checks.</a:t>
             </a:r>
           </a:p>
         </p:txBody>
@@ -10149,7 +10104,7 @@
         </p:xfrm>
         <a:graphic xmlns:a="http://schemas.openxmlformats.org/drawingml/2006/main">
           <a:graphicData uri="http://schemas.openxmlformats.org/drawingml/2006/chart">
-            <c:chart xmlns:r="http://schemas.openxmlformats.org/officeDocument/2006/relationships" xmlns:c="http://schemas.openxmlformats.org/drawingml/2006/chart" r:id="R3ceafbce4db74a49"/>
+            <c:chart xmlns:r="http://schemas.openxmlformats.org/officeDocument/2006/relationships" xmlns:c="http://schemas.openxmlformats.org/drawingml/2006/chart" r:id="Re88c49691e6e4982"/>
           </a:graphicData>
         </a:graphic>
       </p:graphicFrame>
@@ -10206,7 +10161,7 @@
                 <a:ea typeface="Bitstream Charter"/>
                 <a:cs typeface="Bitstream Charter"/>
               </a:rPr>
-              <a:t>Illustrative counts and changing XmR limits from the demo notebook. A rule signal calls for analyst review.</a:t>
+              <a:t>Illustrative count pattern and XmR limits. Inspect the current notebook charts during the live demonstration.</a:t>
             </a:r>
           </a:p>
         </p:txBody>
@@ -10583,7 +10538,7 @@
                 <a:ea typeface="Bitstream Charter"/>
                 <a:cs typeface="Bitstream Charter"/>
               </a:rPr>
-              <a:t>Run cells 1–10 live; show outputs, model comparison and review queue.</a:t>
+              <a:t>Run 20 cells; inspect ten figures, forecasts and review evidence.</a:t>
             </a:r>
           </a:p>
         </p:txBody>
@@ -10699,7 +10654,7 @@
                 <a:ea typeface="Bitstream Charter"/>
                 <a:cs typeface="Bitstream Charter"/>
               </a:rPr>
-              <a:t>Classifier loses the baseline; use the direct SPC rules for that label.</a:t>
+              <a:t>Keep direct rules; assess forecasts against simple baselines.</a:t>
             </a:r>
           </a:p>
         </p:txBody>
@@ -10815,7 +10770,7 @@
                 <a:ea typeface="Bitstream Charter"/>
                 <a:cs typeface="Bitstream Charter"/>
               </a:rPr>
-              <a:t>Data definitions, owners, tool approval, access, telemetry and baseline.</a:t>
+              <a:t>Confirm data definitions, owners, access and acceptance criteria.</a:t>
             </a:r>
           </a:p>
         </p:txBody>
@@ -10931,7 +10886,7 @@
                 <a:ea typeface="Bitstream Charter"/>
                 <a:cs typeface="Bitstream Charter"/>
               </a:rPr>
-              <a:t>Separate reproducible execution from measurable mission value.</a:t>
+              <a:t>Bound scope, cost and duration; require prospective evidence.</a:t>
             </a:r>
           </a:p>
         </p:txBody>
@@ -11047,7 +11002,7 @@
                 <a:ea typeface="Bitstream Charter"/>
                 <a:cs typeface="Bitstream Charter"/>
               </a:rPr>
-              <a:t>Track data health, model error, review volume and retraining decisions.</a:t>
+              <a:t>Show error history, review advice and candidate withdrawal.</a:t>
             </a:r>
           </a:p>
         </p:txBody>
@@ -11163,7 +11118,7 @@
                 <a:ea typeface="Bitstream Charter"/>
                 <a:cs typeface="Bitstream Charter"/>
               </a:rPr>
-              <a:t>Check inherited rule bias and false alarms; this numeric demo has no LLM.</a:t>
+              <a:t>Inspect subgroups, false signals and uncertainty in proxy labels.</a:t>
             </a:r>
           </a:p>
         </p:txBody>
@@ -11279,7 +11234,7 @@
                 <a:ea typeface="Bitstream Charter"/>
                 <a:cs typeface="Bitstream Charter"/>
               </a:rPr>
-              <a:t>Explain access, retention and agency incident-response boundary.</a:t>
+              <a:t>Fictional data does not prove agency authorization or controls.</a:t>
             </a:r>
           </a:p>
         </p:txBody>
@@ -11656,7 +11611,7 @@
                 <a:ea typeface="Bitstream Charter"/>
                 <a:cs typeface="Bitstream Charter"/>
               </a:rPr>
-              <a:t>Python source and portable data help; platform services need replacement.</a:t>
+              <a:t>Python and tabular outputs; verify actual platform interfaces.</a:t>
             </a:r>
           </a:p>
         </p:txBody>
@@ -11772,7 +11727,7 @@
                 <a:ea typeface="Bitstream Charter"/>
                 <a:cs typeface="Bitstream Charter"/>
               </a:rPr>
-              <a:t>Government-owned code, exportable artifacts, reproducible run history.</a:t>
+              <a:t>Source and exports help; rights and replacement must be tested.</a:t>
             </a:r>
           </a:p>
         </p:txBody>
@@ -11888,7 +11843,7 @@
                 <a:ea typeface="Bitstream Charter"/>
                 <a:cs typeface="Bitstream Charter"/>
               </a:rPr>
-              <a:t>Record promotion, retraining criteria, version selection and rollback.</a:t>
+              <a:t>Use the candidate and rollback exercise; verify live registry later.</a:t>
             </a:r>
           </a:p>
         </p:txBody>
@@ -12004,7 +11959,7 @@
                 <a:ea typeface="Bitstream Charter"/>
                 <a:cs typeface="Bitstream Charter"/>
               </a:rPr>
-              <a:t>Analyst reviews evidence; pending queue is not a completed disposition.</a:t>
+              <a:t>Show hypotheses and a fictional disposition; real review is pending.</a:t>
             </a:r>
           </a:p>
         </p:txBody>
@@ -12120,7 +12075,7 @@
                 <a:ea typeface="Bitstream Charter"/>
                 <a:cs typeface="Bitstream Charter"/>
               </a:rPr>
-              <a:t>Need a verified past-client example; this classifier is only a live case.</a:t>
+              <a:t>A verified past-client example is still needed from leadership.</a:t>
             </a:r>
           </a:p>
         </p:txBody>
@@ -12236,7 +12191,7 @@
                 <a:ea typeface="Bitstream Charter"/>
                 <a:cs typeface="Bitstream Charter"/>
               </a:rPr>
-              <a:t>Assess the agency boundary, privacy, controls and monitoring cadence.</a:t>
+              <a:t>Agency boundary, controls and approval require separate evidence.</a:t>
             </a:r>
           </a:p>
         </p:txBody>
@@ -12352,7 +12307,7 @@
                 <a:ea typeface="Bitstream Charter"/>
                 <a:cs typeface="Bitstream Charter"/>
               </a:rPr>
-              <a:t>Receiving team reruns, investigates failure and practices rollback.</a:t>
+              <a:t>Receiving team reruns, investigates and practices withdrawal.</a:t>
             </a:r>
           </a:p>
         </p:txBody>
@@ -12497,7 +12452,7 @@
                 <a:ea typeface="Bitstream Charter"/>
                 <a:cs typeface="Bitstream Charter"/>
               </a:rPr>
-              <a:t>The demo’s useful decision is visible</a:t>
+              <a:t>The useful decisions are visible</a:t>
             </a:r>
           </a:p>
         </p:txBody>
@@ -12671,7 +12626,7 @@
                 <a:ea typeface="Bitstream Charter"/>
                 <a:cs typeface="Bitstream Charter"/>
               </a:rPr>
-              <a:t>SPC makes unusual movement visible.</a:t>
+              <a:t>Rules identify change; context guides review.</a:t>
             </a:r>
           </a:p>
         </p:txBody>
@@ -12729,7 +12684,7 @@
                 <a:ea typeface="Bitstream Charter"/>
                 <a:cs typeface="Bitstream Charter"/>
               </a:rPr>
-              <a:t>The classifier adds no value to a label the rules already compute.</a:t>
+              <a:t>Forecasts compete with simple baselines; model novelty is not the goal.</a:t>
             </a:r>
           </a:p>
         </p:txBody>
@@ -12787,7 +12742,7 @@
                 <a:ea typeface="Bitstream Charter"/>
                 <a:cs typeface="Bitstream Charter"/>
               </a:rPr>
-              <a:t>The forecast merits further testing. The reference offers lineage and retraining design ideas, with alert grouping still planned.</a:t>
+              <a:t>History and human judgment control the next step. Local exercises make the workflow inspectable; live services still need verification.</a:t>
             </a:r>
           </a:p>
         </p:txBody>
@@ -12845,7 +12800,7 @@
                 <a:ea typeface="Bitstream Charter"/>
                 <a:cs typeface="Bitstream Charter"/>
               </a:rPr>
-              <a:t>Live notebook first. Oral explanation and evidence afterward.</a:t>
+              <a:t>Run the notebook. Explain the evidence. State the remaining boundary.</a:t>
             </a:r>
           </a:p>
         </p:txBody>
@@ -12990,7 +12945,7 @@
                 <a:ea typeface="Bitstream Charter"/>
                 <a:cs typeface="Bitstream Charter"/>
               </a:rPr>
-              <a:t>Three checks cover different kinds of change</a:t>
+              <a:t>Three checks, plus severity zones</a:t>
             </a:r>
           </a:p>
         </p:txBody>
@@ -13222,7 +13177,7 @@
                 <a:ea typeface="Bitstream Charter"/>
                 <a:cs typeface="Bitstream Charter"/>
               </a:rPr>
-              <a:t>A big single jump against a limit derived from the moving range.</a:t>
+              <a:t>Large jumps against limits derived from moving ranges.</a:t>
             </a:r>
           </a:p>
         </p:txBody>
@@ -13338,7 +13293,7 @@
                 <a:ea typeface="Bitstream Charter"/>
                 <a:cs typeface="Bitstream Charter"/>
               </a:rPr>
-              <a:t>Small deviations add up until a sustained shift becomes visible.</a:t>
+              <a:t>Small deviations accumulate to reveal sustained shifts.</a:t>
             </a:r>
           </a:p>
         </p:txBody>
@@ -13454,7 +13409,7 @@
                 <a:ea typeface="Bitstream Charter"/>
                 <a:cs typeface="Bitstream Charter"/>
               </a:rPr>
-              <a:t>Recent counts receive more weight, helping reveal moderate shifts.</a:t>
+              <a:t>Recent counts carry more weight. Zone checks add severity context.</a:t>
             </a:r>
           </a:p>
         </p:txBody>
@@ -13541,7 +13496,7 @@
                 <a:ea typeface="Bitstream Charter"/>
                 <a:cs typeface="Bitstream Charter"/>
               </a:rPr>
-              <a:t>DESIGN</a:t>
+              <a:t>WORKFLOW</a:t>
             </a:r>
           </a:p>
         </p:txBody>
@@ -13599,7 +13554,7 @@
                 <a:ea typeface="Bitstream Charter"/>
                 <a:cs typeface="Bitstream Charter"/>
               </a:rPr>
-              <a:t>SPC and the two ML questions</a:t>
+              <a:t>Detect, forecast, investigate, review</a:t>
             </a:r>
           </a:p>
         </p:txBody>
@@ -13773,7 +13728,7 @@
                 <a:ea typeface="Bitstream Charter"/>
                 <a:cs typeface="Bitstream Charter"/>
               </a:rPr>
-              <a:t>Rule-label classifier</a:t>
+              <a:t>Understand the observation</a:t>
             </a:r>
           </a:p>
         </p:txBody>
@@ -13813,25 +13768,25 @@
           <a:p xmlns:a="http://schemas.openxmlformats.org/drawingml/2006/main">
             <a:pPr>
               <a:buNone/>
-              <a:defRPr sz="2025" b="0">
-                <a:solidFill>
-                  <a:srgbClr val="153246"/>
-                </a:solidFill>
-                <a:latin typeface="Bitstream Charter"/>
-                <a:ea typeface="Bitstream Charter"/>
-                <a:cs typeface="Bitstream Charter"/>
-              </a:defRPr>
-            </a:pPr>
-            <a:r>
-              <a:rPr sz="2025" b="0">
-                <a:solidFill>
-                  <a:srgbClr val="153246"/>
-                </a:solidFill>
-                <a:latin typeface="Bitstream Charter"/>
-                <a:ea typeface="Bitstream Charter"/>
-                <a:cs typeface="Bitstream Charter"/>
-              </a:rPr>
-              <a:t>Inputs: statistics from a finished 25-day window.</a:t>
+              <a:defRPr sz="1900" b="0">
+                <a:solidFill>
+                  <a:srgbClr val="173447"/>
+                </a:solidFill>
+                <a:latin typeface="Aptos"/>
+                <a:ea typeface="Aptos"/>
+                <a:cs typeface="Aptos"/>
+              </a:defRPr>
+            </a:pPr>
+            <a:r>
+              <a:rPr sz="1900" b="0">
+                <a:solidFill>
+                  <a:srgbClr val="173447"/>
+                </a:solidFill>
+                <a:latin typeface="Aptos"/>
+                <a:ea typeface="Aptos"/>
+                <a:cs typeface="Aptos"/>
+              </a:rPr>
+              <a:t>SPC and zones flag change.</a:t>
             </a:r>
           </a:p>
           <a:p xmlns:a="http://schemas.openxmlformats.org/drawingml/2006/main">
@@ -13842,25 +13797,25 @@
           <a:p xmlns:a="http://schemas.openxmlformats.org/drawingml/2006/main">
             <a:pPr>
               <a:buNone/>
-              <a:defRPr sz="2025" b="0">
-                <a:solidFill>
-                  <a:srgbClr val="153246"/>
-                </a:solidFill>
-                <a:latin typeface="Bitstream Charter"/>
-                <a:ea typeface="Bitstream Charter"/>
-                <a:cs typeface="Bitstream Charter"/>
-              </a:defRPr>
-            </a:pPr>
-            <a:r>
-              <a:rPr sz="2025" b="0">
-                <a:solidFill>
-                  <a:srgbClr val="153246"/>
-                </a:solidFill>
-                <a:latin typeface="Bitstream Charter"/>
-                <a:ea typeface="Bitstream Charter"/>
-                <a:cs typeface="Bitstream Charter"/>
-              </a:rPr>
-              <a:t>Target: did any SPC rule fire in that window?</a:t>
+              <a:defRPr sz="1900" b="0">
+                <a:solidFill>
+                  <a:srgbClr val="173447"/>
+                </a:solidFill>
+                <a:latin typeface="Aptos"/>
+                <a:ea typeface="Aptos"/>
+                <a:cs typeface="Aptos"/>
+              </a:defRPr>
+            </a:pPr>
+            <a:r>
+              <a:rPr sz="1900" b="0">
+                <a:solidFill>
+                  <a:srgbClr val="173447"/>
+                </a:solidFill>
+                <a:latin typeface="Aptos"/>
+                <a:ea typeface="Aptos"/>
+                <a:cs typeface="Aptos"/>
+              </a:rPr>
+              <a:t>A separate anomaly model highlights unusual combinations of features.</a:t>
             </a:r>
           </a:p>
         </p:txBody>
@@ -13918,7 +13873,7 @@
                 <a:ea typeface="Bitstream Charter"/>
                 <a:cs typeface="Bitstream Charter"/>
               </a:rPr>
-              <a:t>Count forecast</a:t>
+              <a:t>Understand the next step</a:t>
             </a:r>
           </a:p>
         </p:txBody>
@@ -13958,25 +13913,25 @@
           <a:p xmlns:a="http://schemas.openxmlformats.org/drawingml/2006/main">
             <a:pPr>
               <a:buNone/>
-              <a:defRPr sz="2025" b="0">
-                <a:solidFill>
-                  <a:srgbClr val="153246"/>
-                </a:solidFill>
-                <a:latin typeface="Bitstream Charter"/>
-                <a:ea typeface="Bitstream Charter"/>
-                <a:cs typeface="Bitstream Charter"/>
-              </a:defRPr>
-            </a:pPr>
-            <a:r>
-              <a:rPr sz="2025" b="0">
-                <a:solidFill>
-                  <a:srgbClr val="153246"/>
-                </a:solidFill>
-                <a:latin typeface="Bitstream Charter"/>
-                <a:ea typeface="Bitstream Charter"/>
-                <a:cs typeface="Bitstream Charter"/>
-              </a:rPr>
-              <a:t>Inputs: counts and features known the day before.</a:t>
+              <a:defRPr sz="1900" b="0">
+                <a:solidFill>
+                  <a:srgbClr val="173447"/>
+                </a:solidFill>
+                <a:latin typeface="Aptos"/>
+                <a:ea typeface="Aptos"/>
+                <a:cs typeface="Aptos"/>
+              </a:defRPr>
+            </a:pPr>
+            <a:r>
+              <a:rPr sz="1900" b="0">
+                <a:solidFill>
+                  <a:srgbClr val="173447"/>
+                </a:solidFill>
+                <a:latin typeface="Aptos"/>
+                <a:ea typeface="Aptos"/>
+                <a:cs typeface="Aptos"/>
+              </a:rPr>
+              <a:t>Forecast future counts.</a:t>
             </a:r>
           </a:p>
           <a:p xmlns:a="http://schemas.openxmlformats.org/drawingml/2006/main">
@@ -13987,25 +13942,25 @@
           <a:p xmlns:a="http://schemas.openxmlformats.org/drawingml/2006/main">
             <a:pPr>
               <a:buNone/>
-              <a:defRPr sz="2025" b="0">
-                <a:solidFill>
-                  <a:srgbClr val="153246"/>
-                </a:solidFill>
-                <a:latin typeface="Bitstream Charter"/>
-                <a:ea typeface="Bitstream Charter"/>
-                <a:cs typeface="Bitstream Charter"/>
-              </a:defRPr>
-            </a:pPr>
-            <a:r>
-              <a:rPr sz="2025" b="0">
-                <a:solidFill>
-                  <a:srgbClr val="153246"/>
-                </a:solidFill>
-                <a:latin typeface="Bitstream Charter"/>
-                <a:ea typeface="Bitstream Charter"/>
-                <a:cs typeface="Bitstream Charter"/>
-              </a:rPr>
-              <a:t>Target: the next business day's count.</a:t>
+              <a:defRPr sz="1900" b="0">
+                <a:solidFill>
+                  <a:srgbClr val="173447"/>
+                </a:solidFill>
+                <a:latin typeface="Aptos"/>
+                <a:ea typeface="Aptos"/>
+                <a:cs typeface="Aptos"/>
+              </a:defRPr>
+            </a:pPr>
+            <a:r>
+              <a:rPr sz="1900" b="0">
+                <a:solidFill>
+                  <a:srgbClr val="173447"/>
+                </a:solidFill>
+                <a:latin typeface="Aptos"/>
+                <a:ea typeface="Aptos"/>
+                <a:cs typeface="Aptos"/>
+              </a:rPr>
+              <a:t>Use subgroup changes, lineage and events to form reviewable hypotheses.</a:t>
             </a:r>
           </a:p>
         </p:txBody>
@@ -14063,7 +14018,7 @@
                 <a:ea typeface="Bitstream Charter"/>
                 <a:cs typeface="Bitstream Charter"/>
               </a:rPr>
-              <a:t>Keep the rule output available even if either model is withdrawn.</a:t>
+              <a:t>Compare simple baselines. Preserve human review and a way to withdraw a model.</a:t>
             </a:r>
           </a:p>
         </p:txBody>
@@ -14150,7 +14105,7 @@
                 <a:ea typeface="Bitstream Charter"/>
                 <a:cs typeface="Bitstream Charter"/>
               </a:rPr>
-              <a:t>SCOPE</a:t>
+              <a:t>NOTEBOOK / CELLS 1–2</a:t>
             </a:r>
           </a:p>
         </p:txBody>
@@ -14208,7 +14163,7 @@
                 <a:ea typeface="Bitstream Charter"/>
                 <a:cs typeface="Bitstream Charter"/>
               </a:rPr>
-              <a:t>What the live example proves</a:t>
+              <a:t>Fictional counts, explicit calendar</a:t>
             </a:r>
           </a:p>
         </p:txBody>
@@ -14382,7 +14337,7 @@
                 <a:ea typeface="Bitstream Charter"/>
                 <a:cs typeface="Bitstream Charter"/>
               </a:rPr>
-              <a:t>In the working notebook</a:t>
+              <a:t>What runs locally</a:t>
             </a:r>
           </a:p>
         </p:txBody>
@@ -14440,7 +14395,7 @@
                 <a:ea typeface="Bitstream Charter"/>
                 <a:cs typeface="Bitstream Charter"/>
               </a:rPr>
-              <a:t>Three imaginary series over 420 business days. Seeded shifts and spikes, rule flags, a held-out test, charts, a review queue, and optional MLflow / Delta outputs.</a:t>
+              <a:t>Three queues across 420 business days: 1,260 counts, planted shifts and spikes. Fixed seed 42 supports repeatable inspection.</a:t>
             </a:r>
           </a:p>
         </p:txBody>
@@ -14498,7 +14453,7 @@
                 <a:ea typeface="Bitstream Charter"/>
                 <a:cs typeface="Bitstream Charter"/>
               </a:rPr>
-              <a:t>Boundary for the oral</a:t>
+              <a:t>Calendar and boundaries</a:t>
             </a:r>
           </a:p>
         </p:txBody>
@@ -14556,7 +14511,7 @@
                 <a:ea typeface="Bitstream Charter"/>
                 <a:cs typeface="Bitstream Charter"/>
               </a:rPr>
-              <a:t>No real records, real alerts, operational actions, agency performance claim, or authorization decision. Show the actual notebook run rather than describing a screen.</a:t>
+              <a:t>Weekends and U.S. federal holidays are excluded. This is a demo calendar, not an agency-specific operating calendar. Delta and registry destinations begin empty.</a:t>
             </a:r>
           </a:p>
         </p:txBody>
@@ -14643,7 +14598,7 @@
                 <a:ea typeface="Bitstream Charter"/>
                 <a:cs typeface="Bitstream Charter"/>
               </a:rPr>
-              <a:t>NOTEBOOK / CELL 1 OF 10</a:t>
+              <a:t>NOTEBOOK / CELLS 3–4</a:t>
             </a:r>
           </a:p>
         </p:txBody>
@@ -14701,7 +14656,7 @@
                 <a:ea typeface="Bitstream Charter"/>
                 <a:cs typeface="Bitstream Charter"/>
               </a:rPr>
-              <a:t>Settings and imports</a:t>
+              <a:t>Historical rules become labels</a:t>
             </a:r>
           </a:p>
         </p:txBody>
@@ -14875,7 +14830,7 @@
                 <a:ea typeface="Bitstream Charter"/>
                 <a:cs typeface="Bitstream Charter"/>
               </a:rPr>
-              <a:t>What it does</a:t>
+              <a:t>Compute</a:t>
             </a:r>
           </a:p>
         </p:txBody>
@@ -14933,7 +14888,7 @@
                 <a:ea typeface="Bitstream Charter"/>
                 <a:cs typeface="Bitstream Charter"/>
               </a:rPr>
-              <a:t>Set the history length and optional Delta or registry destinations. MLflow logs models when available.</a:t>
+              <a:t>Apply XmR, CUSUM and EWMA to completed 25-day windows.</a:t>
             </a:r>
           </a:p>
         </p:txBody>
@@ -14991,7 +14946,7 @@
                 <a:ea typeface="Bitstream Charter"/>
                 <a:cs typeface="Bitstream Charter"/>
               </a:rPr>
-              <a:t>Technology / data science</a:t>
+              <a:t>Build features</a:t>
             </a:r>
           </a:p>
         </p:txBody>
@@ -15049,7 +15004,7 @@
                 <a:ea typeface="Bitstream Charter"/>
                 <a:cs typeface="Bitstream Charter"/>
               </a:rPr>
-              <a:t>Python, NumPy, pandas, scikit-learn, Matplotlib. Fixed random seed and named rule thresholds.</a:t>
+              <a:t>Summarize each window against an earlier 90-day reference.</a:t>
             </a:r>
           </a:p>
         </p:txBody>
@@ -15107,7 +15062,7 @@
                 <a:ea typeface="Bitstream Charter"/>
                 <a:cs typeface="Bitstream Charter"/>
               </a:rPr>
-              <a:t>What to inspect</a:t>
+              <a:t>Inspect</a:t>
             </a:r>
           </a:p>
         </p:txBody>
@@ -15165,7 +15120,7 @@
                 <a:ea typeface="Bitstream Charter"/>
                 <a:cs typeface="Bitstream Charter"/>
               </a:rPr>
-              <a:t>WINDOW = 25; BASELINE_DAYS = 90. The two optional destination names start empty.</a:t>
+              <a:t>915 labeled windows; any rule flag creates a review candidate.</a:t>
             </a:r>
           </a:p>
         </p:txBody>
@@ -15223,7 +15178,7 @@
                 <a:ea typeface="Bitstream Charter"/>
                 <a:cs typeface="Bitstream Charter"/>
               </a:rPr>
-              <a:t>Interpretation</a:t>
+              <a:t>Interpret</a:t>
             </a:r>
           </a:p>
         </p:txBody>
@@ -15281,7 +15236,7 @@
                 <a:ea typeface="Bitstream Charter"/>
                 <a:cs typeface="Bitstream Charter"/>
               </a:rPr>
-              <a:t>Change parameters here and rerun every later cell so all outputs refer to one consistent run.</a:t>
+              <a:t>The classifier imitates rules on past windows. It is not an early-warning outcome model.</a:t>
             </a:r>
           </a:p>
         </p:txBody>
@@ -15368,7 +15323,7 @@
                 <a:ea typeface="Bitstream Charter"/>
                 <a:cs typeface="Bitstream Charter"/>
               </a:rPr>
-              <a:t>NOTEBOOK / CELL 2 OF 10</a:t>
+              <a:t>NOTEBOOK / CELL 5</a:t>
             </a:r>
           </a:p>
         </p:txBody>
@@ -15426,7 +15381,7 @@
                 <a:ea typeface="Bitstream Charter"/>
                 <a:cs typeface="Bitstream Charter"/>
               </a:rPr>
-              <a:t>Fictional daily work counts</a:t>
+              <a:t>Keep the direct rules</a:t>
             </a:r>
           </a:p>
         </p:txBody>
@@ -15600,7 +15555,7 @@
                 <a:ea typeface="Bitstream Charter"/>
                 <a:cs typeface="Bitstream Charter"/>
               </a:rPr>
-              <a:t>What it does</a:t>
+              <a:t>Model</a:t>
             </a:r>
           </a:p>
         </p:txBody>
@@ -15658,7 +15613,7 @@
                 <a:ea typeface="Bitstream Charter"/>
                 <a:cs typeface="Bitstream Charter"/>
               </a:rPr>
-              <a:t>Make three imaginary queues and put a few unusual changes into their histories.</a:t>
+              <a:t>Random forest classifies the historical SPC label.</a:t>
             </a:r>
           </a:p>
         </p:txBody>
@@ -15716,7 +15671,7 @@
                 <a:ea typeface="Bitstream Charter"/>
                 <a:cs typeface="Bitstream Charter"/>
               </a:rPr>
-              <a:t>Technology / data science</a:t>
+              <a:t>Evaluation</a:t>
             </a:r>
           </a:p>
         </p:txBody>
@@ -15774,7 +15729,7 @@
                 <a:ea typeface="Bitstream Charter"/>
                 <a:cs typeface="Bitstream Charter"/>
               </a:rPr>
-              <a:t>Seeded time-series simulation, business-day calendar, uniqueness and nonnegative-count checks.</a:t>
+              <a:t>Chronological holdout with a gap; 228 windows and ROC AUC 0.917.</a:t>
             </a:r>
           </a:p>
         </p:txBody>
@@ -15832,7 +15787,7 @@
                 <a:ea typeface="Bitstream Charter"/>
                 <a:cs typeface="Bitstream Charter"/>
               </a:rPr>
-              <a:t>What to inspect</a:t>
+              <a:t>Result</a:t>
             </a:r>
           </a:p>
         </p:txBody>
@@ -15890,7 +15845,7 @@
                 <a:ea typeface="Bitstream Charter"/>
                 <a:cs typeface="Bitstream Charter"/>
               </a:rPr>
-              <a:t>daily_df has 1,260 observations, a fictional source name, and a demo dataset ID.</a:t>
+              <a:t>75.0% accuracy versus 78.1% from always predicting a signal.</a:t>
             </a:r>
           </a:p>
         </p:txBody>
@@ -15948,7 +15903,7 @@
                 <a:ea typeface="Bitstream Charter"/>
                 <a:cs typeface="Bitstream Charter"/>
               </a:rPr>
-              <a:t>Interpretation</a:t>
+              <a:t>Decision</a:t>
             </a:r>
           </a:p>
         </p:txBody>
@@ -16006,7 +15961,7 @@
                 <a:ea typeface="Bitstream Charter"/>
                 <a:cs typeface="Bitstream Charter"/>
               </a:rPr>
-              <a:t>The planted shifts test the demonstration path. They do not establish a real false-alarm rate.</a:t>
+              <a:t>Use the known rules for their own label. High AUC alone does not establish mission value.</a:t>
             </a:r>
           </a:p>
         </p:txBody>
@@ -16093,7 +16048,7 @@
                 <a:ea typeface="Bitstream Charter"/>
                 <a:cs typeface="Bitstream Charter"/>
               </a:rPr>
-              <a:t>NOTEBOOK / CELL 3 OF 10</a:t>
+              <a:t>NOTEBOOK / CELL 6</a:t>
             </a:r>
           </a:p>
         </p:txBody>
@@ -16151,7 +16106,7 @@
                 <a:ea typeface="Bitstream Charter"/>
                 <a:cs typeface="Bitstream Charter"/>
               </a:rPr>
-              <a:t>XmR, CUSUM, and EWMA rules</a:t>
+              <a:t>Forecast the next business day</a:t>
             </a:r>
           </a:p>
         </p:txBody>
@@ -16325,7 +16280,7 @@
                 <a:ea typeface="Bitstream Charter"/>
                 <a:cs typeface="Bitstream Charter"/>
               </a:rPr>
-              <a:t>What it does</a:t>
+              <a:t>Model</a:t>
             </a:r>
           </a:p>
         </p:txBody>
@@ -16383,7 +16338,7 @@
                 <a:ea typeface="Bitstream Charter"/>
                 <a:cs typeface="Bitstream Charter"/>
               </a:rPr>
-              <a:t>Write three checks that look for jumps or changes that persist over time.</a:t>
+              <a:t>A separate random forest predicts the next count from information already known.</a:t>
             </a:r>
           </a:p>
         </p:txBody>
@@ -16441,7 +16396,7 @@
                 <a:ea typeface="Bitstream Charter"/>
                 <a:cs typeface="Bitstream Charter"/>
               </a:rPr>
-              <a:t>Technology / data science</a:t>
+              <a:t>Evaluation</a:t>
             </a:r>
           </a:p>
         </p:txBody>
@@ -16499,7 +16454,7 @@
                 <a:ea typeface="Bitstream Charter"/>
                 <a:cs typeface="Bitstream Charter"/>
               </a:rPr>
-              <a:t>Moving-range limits, cumulative deviation, and exponentially weighted smoothing.</a:t>
+              <a:t>Later-date holdout, 225 forecasts; mean absolute error is measured in counts.</a:t>
             </a:r>
           </a:p>
         </p:txBody>
@@ -16557,7 +16512,7 @@
                 <a:ea typeface="Bitstream Charter"/>
                 <a:cs typeface="Bitstream Charter"/>
               </a:rPr>
-              <a:t>What to inspect</a:t>
+              <a:t>Result</a:t>
             </a:r>
           </a:p>
         </p:txBody>
@@ -16615,7 +16570,7 @@
                 <a:ea typeface="Bitstream Charter"/>
                 <a:cs typeface="Bitstream Charter"/>
               </a:rPr>
-              <a:t>Each function returns a Boolean. XmR also gives center and limits for the chart.</a:t>
+              <a:t>8.99 counts MAE versus 9.73 for the trailing-five-day mean.</a:t>
             </a:r>
           </a:p>
         </p:txBody>
@@ -16673,7 +16628,7 @@
                 <a:ea typeface="Bitstream Charter"/>
                 <a:cs typeface="Bitstream Charter"/>
               </a:rPr>
-              <a:t>Interpretation</a:t>
+              <a:t>Decision</a:t>
             </a:r>
           </a:p>
         </p:txBody>
@@ -16731,7 +16686,7 @@
                 <a:ea typeface="Bitstream Charter"/>
                 <a:cs typeface="Bitstream Charter"/>
               </a:rPr>
-              <a:t>The checks scan the entire previous window, so one unusual event can keep a window flagged on later run dates.</a:t>
+              <a:t>A candidate for further evaluation. This advantage is measured only on fictional data.</a:t>
             </a:r>
           </a:p>
         </p:txBody>
@@ -16818,7 +16773,7 @@
                 <a:ea typeface="Bitstream Charter"/>
                 <a:cs typeface="Bitstream Charter"/>
               </a:rPr>
-              <a:t>NOTEBOOK / CELL 4 OF 10</a:t>
+              <a:t>NOTEBOOK / CELLS 7–8</a:t>
             </a:r>
           </a:p>
         </p:txBody>
@@ -16876,7 +16831,7 @@
                 <a:ea typeface="Bitstream Charter"/>
                 <a:cs typeface="Bitstream Charter"/>
               </a:rPr>
-              <a:t>Labels and features</a:t>
+              <a:t>Visual evidence and review episodes</a:t>
             </a:r>
           </a:p>
         </p:txBody>
@@ -17050,7 +17005,7 @@
                 <a:ea typeface="Bitstream Charter"/>
                 <a:cs typeface="Bitstream Charter"/>
               </a:rPr>
-              <a:t>What it does</a:t>
+              <a:t>Charts</a:t>
             </a:r>
           </a:p>
         </p:txBody>
@@ -17108,7 +17063,7 @@
                 <a:ea typeface="Bitstream Charter"/>
                 <a:cs typeface="Bitstream Charter"/>
               </a:rPr>
-              <a:t>At each eligible date, summarize the preceding 25 days and apply the rules.</a:t>
+              <a:t>Show the control chart, confusion matrix and one-day forecast.</a:t>
             </a:r>
           </a:p>
         </p:txBody>
@@ -17166,7 +17121,7 @@
                 <a:ea typeface="Bitstream Charter"/>
                 <a:cs typeface="Bitstream Charter"/>
               </a:rPr>
-              <a:t>Technology / data science</a:t>
+              <a:t>Grouping</a:t>
             </a:r>
           </a:p>
         </p:txBody>
@@ -17224,7 +17179,7 @@
                 <a:ea typeface="Bitstream Charter"/>
                 <a:cs typeface="Bitstream Charter"/>
               </a:rPr>
-              <a:t>Rolling windows with an earlier 90-day reference, descriptive statistics, and a logical OR.</a:t>
+              <a:t>479 flagged windows consolidate into 30 episodes.</a:t>
             </a:r>
           </a:p>
         </p:txBody>
@@ -17282,7 +17237,7 @@
                 <a:ea typeface="Bitstream Charter"/>
                 <a:cs typeface="Bitstream Charter"/>
               </a:rPr>
-              <a:t>What to inspect</a:t>
+              <a:t>Queue</a:t>
             </a:r>
           </a:p>
         </p:txBody>
@@ -17340,7 +17295,7 @@
                 <a:ea typeface="Bitstream Charter"/>
                 <a:cs typeface="Bitstream Charter"/>
               </a:rPr>
-              <a:t>signals_df contains the flags, window statistics and baseline values. Its overall demo signal rate is 52.3%.</a:t>
+              <a:t>Display the 15 episodes with the latest signal dates; all remain pending.</a:t>
             </a:r>
           </a:p>
         </p:txBody>
@@ -17398,7 +17353,7 @@
                 <a:ea typeface="Bitstream Charter"/>
                 <a:cs typeface="Bitstream Charter"/>
               </a:rPr>
-              <a:t>Interpretation</a:t>
+              <a:t>Interpret</a:t>
             </a:r>
           </a:p>
         </p:txBody>
@@ -17456,7 +17411,7 @@
                 <a:ea typeface="Bitstream Charter"/>
                 <a:cs typeface="Bitstream Charter"/>
               </a:rPr>
-              <a:t>The label and many model inputs come from the same historical window. This is why classifier accuracy alone does not establish future warning.</a:t>
+              <a:t>A circled point reflects a preceding-window signal. Grouping is not a measured labor saving.</a:t>
             </a:r>
           </a:p>
         </p:txBody>

</xml_diff>

<commit_message>
Harden demo monitoring, model reuse, and presentation validation
</commit_message>
<xml_diff>
--- a/docs/SPC_ML_Demo_Walkthrough_Ready.pptx
+++ b/docs/SPC_ML_Demo_Walkthrough_Ready.pptx
@@ -2,30 +2,30 @@
 <file path=ppt/presentation.xml><?xml version="1.0" encoding="utf-8"?>
 <p:presentation xmlns:p="http://schemas.openxmlformats.org/presentationml/2006/main">
   <p:sldMasterIdLst>
-    <p:sldMasterId xmlns:r="http://schemas.openxmlformats.org/officeDocument/2006/relationships" id="2147483648" r:id="R165a0e56534f44d2"/>
+    <p:sldMasterId xmlns:r="http://schemas.openxmlformats.org/officeDocument/2006/relationships" id="2147483648" r:id="R776a3a026e8b496a"/>
   </p:sldMasterIdLst>
   <p:notesMasterIdLst>
-    <p:notesMasterId xmlns:r="http://schemas.openxmlformats.org/officeDocument/2006/relationships" r:id="R51df67a2373d430a"/>
+    <p:notesMasterId xmlns:r="http://schemas.openxmlformats.org/officeDocument/2006/relationships" r:id="Rb0fb56bd5b414761"/>
   </p:notesMasterIdLst>
   <p:sldIdLst>
-    <p:sldId xmlns:r="http://schemas.openxmlformats.org/officeDocument/2006/relationships" id="256" r:id="R7f7f54e49fdd4d4b"/>
-    <p:sldId xmlns:r="http://schemas.openxmlformats.org/officeDocument/2006/relationships" id="257" r:id="R9a74e5091e6f456f"/>
-    <p:sldId xmlns:r="http://schemas.openxmlformats.org/officeDocument/2006/relationships" id="258" r:id="Reafdec071e3b40e8"/>
-    <p:sldId xmlns:r="http://schemas.openxmlformats.org/officeDocument/2006/relationships" id="259" r:id="Raef2af48d1a54707"/>
-    <p:sldId xmlns:r="http://schemas.openxmlformats.org/officeDocument/2006/relationships" id="260" r:id="R4385e4fceb134ed8"/>
-    <p:sldId xmlns:r="http://schemas.openxmlformats.org/officeDocument/2006/relationships" id="261" r:id="R1fec628b4d0a4bd9"/>
-    <p:sldId xmlns:r="http://schemas.openxmlformats.org/officeDocument/2006/relationships" id="262" r:id="R6067f91759d24d31"/>
-    <p:sldId xmlns:r="http://schemas.openxmlformats.org/officeDocument/2006/relationships" id="263" r:id="R8268007b99fe417a"/>
-    <p:sldId xmlns:r="http://schemas.openxmlformats.org/officeDocument/2006/relationships" id="264" r:id="R093abc2d70834434"/>
-    <p:sldId xmlns:r="http://schemas.openxmlformats.org/officeDocument/2006/relationships" id="265" r:id="Ra6b743605e514c97"/>
-    <p:sldId xmlns:r="http://schemas.openxmlformats.org/officeDocument/2006/relationships" id="266" r:id="Ra8ae9c1243e84be2"/>
-    <p:sldId xmlns:r="http://schemas.openxmlformats.org/officeDocument/2006/relationships" id="267" r:id="R75579efb389f4683"/>
-    <p:sldId xmlns:r="http://schemas.openxmlformats.org/officeDocument/2006/relationships" id="268" r:id="Rdeefb21d9fa84e72"/>
-    <p:sldId xmlns:r="http://schemas.openxmlformats.org/officeDocument/2006/relationships" id="269" r:id="Ree60d321391f47bb"/>
-    <p:sldId xmlns:r="http://schemas.openxmlformats.org/officeDocument/2006/relationships" id="270" r:id="R464ba584c8b74bb7"/>
-    <p:sldId xmlns:r="http://schemas.openxmlformats.org/officeDocument/2006/relationships" id="271" r:id="R8dcd62b2fb244203"/>
-    <p:sldId xmlns:r="http://schemas.openxmlformats.org/officeDocument/2006/relationships" id="272" r:id="R92a67a10482045b4"/>
-    <p:sldId xmlns:r="http://schemas.openxmlformats.org/officeDocument/2006/relationships" id="273" r:id="R3e4a88deaab14bfc"/>
+    <p:sldId xmlns:r="http://schemas.openxmlformats.org/officeDocument/2006/relationships" id="256" r:id="Reecaf2b13cf9454c"/>
+    <p:sldId xmlns:r="http://schemas.openxmlformats.org/officeDocument/2006/relationships" id="257" r:id="Rbfdc01744701414c"/>
+    <p:sldId xmlns:r="http://schemas.openxmlformats.org/officeDocument/2006/relationships" id="258" r:id="Ra09ba13d372a4943"/>
+    <p:sldId xmlns:r="http://schemas.openxmlformats.org/officeDocument/2006/relationships" id="259" r:id="R08cbb9d212454191"/>
+    <p:sldId xmlns:r="http://schemas.openxmlformats.org/officeDocument/2006/relationships" id="260" r:id="R05c29574fd024aa6"/>
+    <p:sldId xmlns:r="http://schemas.openxmlformats.org/officeDocument/2006/relationships" id="261" r:id="Re5209ade26b241f7"/>
+    <p:sldId xmlns:r="http://schemas.openxmlformats.org/officeDocument/2006/relationships" id="262" r:id="R64fe8a9a304643d2"/>
+    <p:sldId xmlns:r="http://schemas.openxmlformats.org/officeDocument/2006/relationships" id="263" r:id="R889b219a9ca9423d"/>
+    <p:sldId xmlns:r="http://schemas.openxmlformats.org/officeDocument/2006/relationships" id="264" r:id="Rf153db9ac5114b24"/>
+    <p:sldId xmlns:r="http://schemas.openxmlformats.org/officeDocument/2006/relationships" id="265" r:id="R687eff03d7534aa0"/>
+    <p:sldId xmlns:r="http://schemas.openxmlformats.org/officeDocument/2006/relationships" id="266" r:id="R09ccef39055244bf"/>
+    <p:sldId xmlns:r="http://schemas.openxmlformats.org/officeDocument/2006/relationships" id="267" r:id="Rd2340f970a834d6b"/>
+    <p:sldId xmlns:r="http://schemas.openxmlformats.org/officeDocument/2006/relationships" id="268" r:id="R664bddaee9504a5f"/>
+    <p:sldId xmlns:r="http://schemas.openxmlformats.org/officeDocument/2006/relationships" id="269" r:id="Rb486d90aea5b43c4"/>
+    <p:sldId xmlns:r="http://schemas.openxmlformats.org/officeDocument/2006/relationships" id="270" r:id="R5388cfeb96954330"/>
+    <p:sldId xmlns:r="http://schemas.openxmlformats.org/officeDocument/2006/relationships" id="271" r:id="R184accdf67d14583"/>
+    <p:sldId xmlns:r="http://schemas.openxmlformats.org/officeDocument/2006/relationships" id="272" r:id="R1cc4b0deccaa458e"/>
+    <p:sldId xmlns:r="http://schemas.openxmlformats.org/officeDocument/2006/relationships" id="273" r:id="Rb18c132e861d4aa5"/>
   </p:sldIdLst>
   <p:sldSz cx="12192000" cy="6858000"/>
   <p:notesSz cx="6858000" cy="9144000"/>
@@ -534,7 +534,7 @@
           <a:lstStyle xmlns:a="http://schemas.openxmlformats.org/drawingml/2006/main"/>
           <a:p xmlns:a="http://schemas.openxmlformats.org/drawingml/2006/main">
             <a:r>
-              <a:t>Explain training versus inference. Training learns parameters from the permitted earlier history. A persisted artifact stores the model. Loading it later and calling predict reuses those parameters without fitting again. Demonstrated local persistence and target-platform MLflow logging are separate proof levels.</a:t>
+              <a:t>Explain training versus inference. Training learns parameters from the permitted earlier history. A persisted artifact stores the model. Loading it later and calling predict reuses those parameters without fitting again. The scorer replays saved, already engineered inputs; a feature pipeline for new days is separate work. Demonstrated local persistence and target-platform MLflow logging are separate proof levels.</a:t>
             </a:r>
           </a:p>
           <a:p xmlns:a="http://schemas.openxmlformats.org/drawingml/2006/main">
@@ -609,7 +609,7 @@
           <a:lstStyle xmlns:a="http://schemas.openxmlformats.org/drawingml/2006/main"/>
           <a:p xmlns:a="http://schemas.openxmlformats.org/drawingml/2006/main">
             <a:r>
-              <a:t>Input drift means feature distributions changed. Performance drift means error changes after actual outcomes arrive. Either can motivate investigation. Neither proves the cause. Demonstration thresholds are illustrative. A controlled exercise perturbs outcomes while retaining predictions to show watch and review states. No automatic retraining or deployment occurs.</a:t>
+              <a:t>Input drift means feature distributions changed. Performance drift means error changes after actual outcomes arrive. Either can motivate investigation. Neither proves the cause. Demonstration thresholds are illustrative: input change above 0.5 training standard deviations prompts investigation, and two consecutive 25-day windows above 1.25 times the reference MAE, each with at least 20 actuals, request review. A controlled exercise perturbs outcomes while retaining predictions to show watch and review states. No automatic retraining or deployment occurs.</a:t>
             </a:r>
           </a:p>
           <a:p xmlns:a="http://schemas.openxmlformats.org/drawingml/2006/main">
@@ -834,7 +834,7 @@
           <a:lstStyle xmlns:a="http://schemas.openxmlformats.org/drawingml/2006/main"/>
           <a:p xmlns:a="http://schemas.openxmlformats.org/drawingml/2006/main">
             <a:r>
-              <a:t>All settings here match the notebook. The holdout classifier and rolling-fold candidates use different settings, so keep their experiments separate. Logistic regression standardizes inputs. Isolation Forest does not train on incident labels and its training-derived contamination heuristic does not reveal a true incident rate.</a:t>
+              <a:t>All settings here match the notebook. The holdout and rolling-fold random forests share one configuration; the folds are a separate later-period experiment. Logistic regression standardizes inputs. Isolation Forest does not train on incident labels and its training-derived contamination heuristic does not reveal a true incident rate. ARIMA and Holt-Winters refit at each forecast origin.</a:t>
             </a:r>
           </a:p>
           <a:p xmlns:a="http://schemas.openxmlformats.org/drawingml/2006/main">
@@ -909,7 +909,7 @@
           <a:lstStyle xmlns:a="http://schemas.openxmlformats.org/drawingml/2006/main"/>
           <a:p xmlns:a="http://schemas.openxmlformats.org/drawingml/2006/main">
             <a:r>
-              <a:t>Describe limitations before generalizing results. Synthetic labels and generation patterns are simplified. Chronological tests support ordering but do not establish broad external validity. Class imbalance makes accuracy insufficient. Prediction intervals and calibration require separate assessment where absent. Five-day subgroup forecasts are independent and need not reconcile to the aggregate.</a:t>
+              <a:t>Describe limitations before generalizing results. Synthetic labels and generation patterns are simplified. Chronological tests support ordering but do not establish broad external validity. Class imbalance makes accuracy insufficient. The illustrative limits flag most windows; calibrating them against confirmed outcomes is pilot work. Prediction intervals and calibration require separate assessment where absent. Five-day subgroup forecasts are independent and need not reconcile to the aggregate.</a:t>
             </a:r>
           </a:p>
           <a:p xmlns:a="http://schemas.openxmlformats.org/drawingml/2006/main">
@@ -1434,7 +1434,7 @@
           <a:lstStyle xmlns:a="http://schemas.openxmlformats.org/drawingml/2006/main"/>
           <a:p xmlns:a="http://schemas.openxmlformats.org/drawingml/2006/main">
             <a:r>
-              <a:t>Keep the distinction explicit. SPC is direct deterministic logic. The classifier learns a proxy label generated by that logic. Isolation Forest learns unusual feature patterns without incident labels. Regression and statistical time-series methods estimate future counts. None determines a root cause or authorizes action.</a:t>
+              <a:t>Keep the distinction explicit. SPC is direct deterministic logic. The classifier learns a proxy label generated by that logic. Isolation Forest learns unusual feature patterns without incident labels. Regression and statistical time-series methods estimate future counts. None determines a root cause or authorizes action. SPC label construction finishes in notebook Cell 4 and machine learning first appears in Cell 5; each notebook cell names its method type.</a:t>
             </a:r>
           </a:p>
           <a:p xmlns:a="http://schemas.openxmlformats.org/drawingml/2006/main">
@@ -1584,7 +1584,7 @@
           <a:lstStyle xmlns:a="http://schemas.openxmlformats.org/drawingml/2006/main"/>
           <a:p xmlns:a="http://schemas.openxmlformats.org/drawingml/2006/main">
             <a:r>
-              <a:t>These are executed synthetic-run results. The classification target is the rule label, not a confirmed incident. Report precision and recall with F1, plus the constant baseline. The rolling-fold comparison is a separate experiment from the single holdout. Do not assume that a more complex algorithm wins.</a:t>
+              <a:t>These are executed synthetic-run results. The classification target is the rule label, not a confirmed incident. Each experiment reports its always-signal constant beside the models, on the same metric. The rolling-fold comparison is a separate experiment from the single holdout. Do not assume that a more complex algorithm wins.</a:t>
             </a:r>
           </a:p>
           <a:p xmlns:a="http://schemas.openxmlformats.org/drawingml/2006/main">
@@ -1734,7 +1734,7 @@
           <a:lstStyle xmlns:a="http://schemas.openxmlformats.org/drawingml/2006/main"/>
           <a:p xmlns:a="http://schemas.openxmlformats.org/drawingml/2006/main">
             <a:r>
-              <a:t>Show one episode and its lineage, source freshness and possible operational events. An automatically proposed hypothesis is a prompt to investigate. The notebook replay contains fictional dispositions and a prepared outbox. It does not send messages or establish real human review. A production reviewer can acknowledge, investigate, request data correction or close with evidence.</a:t>
+              <a:t>Show one episode and its lineage, source freshness and possible operational events. An automatically proposed hypothesis is a prompt to investigate. The notebook replay contains simulated dispositions and a prepared outbox. It does not send messages or establish real human review. A production reviewer can acknowledge, investigate, request data correction or close with evidence.</a:t>
             </a:r>
           </a:p>
           <a:p xmlns:a="http://schemas.openxmlformats.org/drawingml/2006/main">
@@ -1807,7 +1807,7 @@
   </p:cSld>
   <p:clrMap bg1="lt1" tx1="dk1" bg2="lt2" tx2="dk2" accent1="accent1" accent2="accent2" accent3="accent3" accent4="accent4" accent5="accent5" accent6="accent6" hlink="hlink" folHlink="folHlink"/>
   <p:sldLayoutIdLst>
-    <p:sldLayoutId xmlns:r="http://schemas.openxmlformats.org/officeDocument/2006/relationships" id="2147483649" r:id="R5d8a2319178f4b07"/>
+    <p:sldLayoutId xmlns:r="http://schemas.openxmlformats.org/officeDocument/2006/relationships" id="2147483649" r:id="R36bea75a9e41455c"/>
   </p:sldLayoutIdLst>
   <p:txStyles>
     <p:titleStyle>
@@ -3198,7 +3198,7 @@
           <p:cNvPr id="5" name="">
             <a:extLst xmlns:a="http://schemas.openxmlformats.org/drawingml/2006/main">
               <a:ext uri="{FF2B5EF4-FFF2-40B4-BE49-F238E27FC236}">
-                <a16:creationId xmlns:a16="http://schemas.microsoft.com/office/drawing/2014/main" id="{C0E9DF6D-CFB3-4463-84F6-D945A6A5E109}"/>
+                <a16:creationId xmlns:a16="http://schemas.microsoft.com/office/drawing/2014/main" id="{CD8414CF-9F8A-4224-B64F-6A0455E0C95E}"/>
               </a:ext>
             </a:extLst>
           </p:cNvPr>
@@ -3278,7 +3278,7 @@
           <p:cNvPr id="2" name="">
             <a:extLst xmlns:a="http://schemas.openxmlformats.org/drawingml/2006/main">
               <a:ext uri="{FF2B5EF4-FFF2-40B4-BE49-F238E27FC236}">
-                <a16:creationId xmlns:a16="http://schemas.microsoft.com/office/drawing/2014/main" id="{8A97C45E-DECC-4611-82B7-E66B10A005AE}"/>
+                <a16:creationId xmlns:a16="http://schemas.microsoft.com/office/drawing/2014/main" id="{5C60A983-89C0-45A0-A2EF-A99590C229C4}"/>
               </a:ext>
             </a:extLst>
           </p:cNvPr>
@@ -3335,7 +3335,7 @@
           <p:cNvPr id="3" name="">
             <a:extLst xmlns:a="http://schemas.openxmlformats.org/drawingml/2006/main">
               <a:ext uri="{FF2B5EF4-FFF2-40B4-BE49-F238E27FC236}">
-                <a16:creationId xmlns:a16="http://schemas.microsoft.com/office/drawing/2014/main" id="{8A8D6C8A-1D55-4F52-B33F-AE0E73B07772}"/>
+                <a16:creationId xmlns:a16="http://schemas.microsoft.com/office/drawing/2014/main" id="{AB81A02A-7E79-4487-84B7-1B0A34BC826D}"/>
               </a:ext>
             </a:extLst>
           </p:cNvPr>
@@ -3392,7 +3392,7 @@
           <p:cNvPr id="4" name="">
             <a:extLst xmlns:a="http://schemas.openxmlformats.org/drawingml/2006/main">
               <a:ext uri="{FF2B5EF4-FFF2-40B4-BE49-F238E27FC236}">
-                <a16:creationId xmlns:a16="http://schemas.microsoft.com/office/drawing/2014/main" id="{CC3039FD-32D4-4EA1-A27D-48060258A8FC}"/>
+                <a16:creationId xmlns:a16="http://schemas.microsoft.com/office/drawing/2014/main" id="{8900166D-2075-4181-B188-72D62119E321}"/>
               </a:ext>
             </a:extLst>
           </p:cNvPr>
@@ -3470,7 +3470,7 @@
     </p:spTree>
     <p:extLst>
       <p:ext uri="{BB962C8B-B14F-4D97-AF65-F5344CB8AC3E}">
-        <p14:creationId xmlns:p14="http://schemas.microsoft.com/office/powerpoint/2010/main" val="46765423"/>
+        <p14:creationId xmlns:p14="http://schemas.microsoft.com/office/powerpoint/2010/main" val="1015003483"/>
       </p:ext>
     </p:extLst>
   </p:cSld>
@@ -3501,7 +3501,7 @@
           <p:cNvPr id="7" name="">
             <a:extLst xmlns:a="http://schemas.openxmlformats.org/drawingml/2006/main">
               <a:ext uri="{FF2B5EF4-FFF2-40B4-BE49-F238E27FC236}">
-                <a16:creationId xmlns:a16="http://schemas.microsoft.com/office/drawing/2014/main" id="{183CC607-24DE-4F8C-8985-28548ED03285}"/>
+                <a16:creationId xmlns:a16="http://schemas.microsoft.com/office/drawing/2014/main" id="{15E4F440-889B-4E61-A17C-4F62E645B10A}"/>
               </a:ext>
             </a:extLst>
           </p:cNvPr>
@@ -3548,7 +3548,7 @@
                 <a:ea typeface="Helvetica Neue"/>
                 <a:cs typeface="Helvetica Neue"/>
               </a:rPr>
-              <a:t>Saved models can score later data</a:t>
+              <a:t>A saved model is reused without retraining</a:t>
             </a:r>
           </a:p>
         </p:txBody>
@@ -3558,7 +3558,7 @@
           <p:cNvPr id="2" name="">
             <a:extLst xmlns:a="http://schemas.openxmlformats.org/drawingml/2006/main">
               <a:ext uri="{FF2B5EF4-FFF2-40B4-BE49-F238E27FC236}">
-                <a16:creationId xmlns:a16="http://schemas.microsoft.com/office/drawing/2014/main" id="{68E8D138-B0FA-4AED-8822-2C91FC3BA8A9}"/>
+                <a16:creationId xmlns:a16="http://schemas.microsoft.com/office/drawing/2014/main" id="{BD957091-D639-4B8F-9C65-C6169BA06B1C}"/>
               </a:ext>
             </a:extLst>
           </p:cNvPr>
@@ -3615,7 +3615,7 @@
           <p:cNvPr id="3" name="">
             <a:extLst xmlns:a="http://schemas.openxmlformats.org/drawingml/2006/main">
               <a:ext uri="{FF2B5EF4-FFF2-40B4-BE49-F238E27FC236}">
-                <a16:creationId xmlns:a16="http://schemas.microsoft.com/office/drawing/2014/main" id="{1094476A-E5D5-4281-B630-4E4FE24A6689}"/>
+                <a16:creationId xmlns:a16="http://schemas.microsoft.com/office/drawing/2014/main" id="{71B36D50-423D-455E-B7C6-A1CB499A31B6}"/>
               </a:ext>
             </a:extLst>
           </p:cNvPr>
@@ -3662,7 +3662,7 @@
                 <a:ea typeface="Helvetica Neue"/>
                 <a:cs typeface="Helvetica Neue"/>
               </a:rPr>
-              <a:t>Fresh processes reload joblib and local MLflow models with identical predictions.</a:t>
+              <a:t>Fresh processes reload joblib and local MLflow models with matching predictions.</a:t>
             </a:r>
           </a:p>
         </p:txBody>
@@ -3672,7 +3672,7 @@
           <p:cNvPr id="4" name="">
             <a:extLst xmlns:a="http://schemas.openxmlformats.org/drawingml/2006/main">
               <a:ext uri="{FF2B5EF4-FFF2-40B4-BE49-F238E27FC236}">
-                <a16:creationId xmlns:a16="http://schemas.microsoft.com/office/drawing/2014/main" id="{AFC17B33-687F-4D74-AEE5-687C014192D0}"/>
+                <a16:creationId xmlns:a16="http://schemas.microsoft.com/office/drawing/2014/main" id="{E5BFCA6A-E521-44BC-BCFD-873E2EBA4A5B}"/>
               </a:ext>
             </a:extLst>
           </p:cNvPr>
@@ -3729,7 +3729,7 @@
           <p:cNvPr id="5" name="">
             <a:extLst xmlns:a="http://schemas.openxmlformats.org/drawingml/2006/main">
               <a:ext uri="{FF2B5EF4-FFF2-40B4-BE49-F238E27FC236}">
-                <a16:creationId xmlns:a16="http://schemas.microsoft.com/office/drawing/2014/main" id="{2C65EF18-6B43-412F-AEA5-ABE6177274CB}"/>
+                <a16:creationId xmlns:a16="http://schemas.microsoft.com/office/drawing/2014/main" id="{4C352E9E-B1FB-42D3-881E-A26940769B88}"/>
               </a:ext>
             </a:extLst>
           </p:cNvPr>
@@ -3786,7 +3786,7 @@
           <p:cNvPr id="6" name="">
             <a:extLst xmlns:a="http://schemas.openxmlformats.org/drawingml/2006/main">
               <a:ext uri="{FF2B5EF4-FFF2-40B4-BE49-F238E27FC236}">
-                <a16:creationId xmlns:a16="http://schemas.microsoft.com/office/drawing/2014/main" id="{2362FBCD-A653-41D1-BE04-C8CA66E5B938}"/>
+                <a16:creationId xmlns:a16="http://schemas.microsoft.com/office/drawing/2014/main" id="{ABF21283-C728-40A2-8A54-5DCF63ADFF6A}"/>
               </a:ext>
             </a:extLst>
           </p:cNvPr>
@@ -3841,7 +3841,7 @@
     </p:spTree>
     <p:extLst>
       <p:ext uri="{BB962C8B-B14F-4D97-AF65-F5344CB8AC3E}">
-        <p14:creationId xmlns:p14="http://schemas.microsoft.com/office/powerpoint/2010/main" val="672017372"/>
+        <p14:creationId xmlns:p14="http://schemas.microsoft.com/office/powerpoint/2010/main" val="662775334"/>
       </p:ext>
     </p:extLst>
   </p:cSld>
@@ -3872,7 +3872,7 @@
           <p:cNvPr id="7" name="">
             <a:extLst xmlns:a="http://schemas.openxmlformats.org/drawingml/2006/main">
               <a:ext uri="{FF2B5EF4-FFF2-40B4-BE49-F238E27FC236}">
-                <a16:creationId xmlns:a16="http://schemas.microsoft.com/office/drawing/2014/main" id="{4AB9ECEE-CA20-4890-AB08-4EA2D73E5E42}"/>
+                <a16:creationId xmlns:a16="http://schemas.microsoft.com/office/drawing/2014/main" id="{3E7EF375-9987-45B5-A31B-6CF6799572C4}"/>
               </a:ext>
             </a:extLst>
           </p:cNvPr>
@@ -3929,7 +3929,7 @@
           <p:cNvPr id="2" name="">
             <a:extLst xmlns:a="http://schemas.openxmlformats.org/drawingml/2006/main">
               <a:ext uri="{FF2B5EF4-FFF2-40B4-BE49-F238E27FC236}">
-                <a16:creationId xmlns:a16="http://schemas.microsoft.com/office/drawing/2014/main" id="{3E90205F-79E8-4D3F-8198-FCC02EEB4D94}"/>
+                <a16:creationId xmlns:a16="http://schemas.microsoft.com/office/drawing/2014/main" id="{910D0298-5DDA-4B9E-A96A-C5B6F71D50C4}"/>
               </a:ext>
             </a:extLst>
           </p:cNvPr>
@@ -3986,7 +3986,7 @@
           <p:cNvPr id="3" name="">
             <a:extLst xmlns:a="http://schemas.openxmlformats.org/drawingml/2006/main">
               <a:ext uri="{FF2B5EF4-FFF2-40B4-BE49-F238E27FC236}">
-                <a16:creationId xmlns:a16="http://schemas.microsoft.com/office/drawing/2014/main" id="{B4CA472C-C4F6-4EBE-8C5A-FC51D333D37B}"/>
+                <a16:creationId xmlns:a16="http://schemas.microsoft.com/office/drawing/2014/main" id="{8DAAEB2D-02ED-4360-9B9A-30D9BA904858}"/>
               </a:ext>
             </a:extLst>
           </p:cNvPr>
@@ -4043,7 +4043,7 @@
           <p:cNvPr id="4" name="">
             <a:extLst xmlns:a="http://schemas.openxmlformats.org/drawingml/2006/main">
               <a:ext uri="{FF2B5EF4-FFF2-40B4-BE49-F238E27FC236}">
-                <a16:creationId xmlns:a16="http://schemas.microsoft.com/office/drawing/2014/main" id="{353846EC-9440-4D98-B120-1CC20A7B30FF}"/>
+                <a16:creationId xmlns:a16="http://schemas.microsoft.com/office/drawing/2014/main" id="{545270F2-84DC-4037-9DEC-64936BD21E69}"/>
               </a:ext>
             </a:extLst>
           </p:cNvPr>
@@ -4100,7 +4100,7 @@
           <p:cNvPr id="5" name="">
             <a:extLst xmlns:a="http://schemas.openxmlformats.org/drawingml/2006/main">
               <a:ext uri="{FF2B5EF4-FFF2-40B4-BE49-F238E27FC236}">
-                <a16:creationId xmlns:a16="http://schemas.microsoft.com/office/drawing/2014/main" id="{C9B560DA-6FFB-4A6C-8919-EF0ABD06CC13}"/>
+                <a16:creationId xmlns:a16="http://schemas.microsoft.com/office/drawing/2014/main" id="{A089B3DE-6B88-45B9-8FDE-91F4E7EA8F6B}"/>
               </a:ext>
             </a:extLst>
           </p:cNvPr>
@@ -4157,7 +4157,7 @@
           <p:cNvPr id="6" name="">
             <a:extLst xmlns:a="http://schemas.openxmlformats.org/drawingml/2006/main">
               <a:ext uri="{FF2B5EF4-FFF2-40B4-BE49-F238E27FC236}">
-                <a16:creationId xmlns:a16="http://schemas.microsoft.com/office/drawing/2014/main" id="{D257AF78-E33F-4F07-921A-6D9B5FEDB9F4}"/>
+                <a16:creationId xmlns:a16="http://schemas.microsoft.com/office/drawing/2014/main" id="{02FDC424-84EA-4950-BEA8-BFF35912C6DB}"/>
               </a:ext>
             </a:extLst>
           </p:cNvPr>
@@ -4212,7 +4212,7 @@
     </p:spTree>
     <p:extLst>
       <p:ext uri="{BB962C8B-B14F-4D97-AF65-F5344CB8AC3E}">
-        <p14:creationId xmlns:p14="http://schemas.microsoft.com/office/powerpoint/2010/main" val="1591514808"/>
+        <p14:creationId xmlns:p14="http://schemas.microsoft.com/office/powerpoint/2010/main" val="1351220037"/>
       </p:ext>
     </p:extLst>
   </p:cSld>
@@ -4243,7 +4243,7 @@
           <p:cNvPr id="7" name="">
             <a:extLst xmlns:a="http://schemas.openxmlformats.org/drawingml/2006/main">
               <a:ext uri="{FF2B5EF4-FFF2-40B4-BE49-F238E27FC236}">
-                <a16:creationId xmlns:a16="http://schemas.microsoft.com/office/drawing/2014/main" id="{5542E029-EA98-4770-9D3E-9827B7D43E86}"/>
+                <a16:creationId xmlns:a16="http://schemas.microsoft.com/office/drawing/2014/main" id="{622D3DF6-804F-45D9-B55C-5EB56035E862}"/>
               </a:ext>
             </a:extLst>
           </p:cNvPr>
@@ -4300,7 +4300,7 @@
           <p:cNvPr id="2" name="">
             <a:extLst xmlns:a="http://schemas.openxmlformats.org/drawingml/2006/main">
               <a:ext uri="{FF2B5EF4-FFF2-40B4-BE49-F238E27FC236}">
-                <a16:creationId xmlns:a16="http://schemas.microsoft.com/office/drawing/2014/main" id="{DB8655A3-BAC3-4374-9315-A674936ADE70}"/>
+                <a16:creationId xmlns:a16="http://schemas.microsoft.com/office/drawing/2014/main" id="{1D9EF24A-4B96-4C36-A94B-5F698060EEA2}"/>
               </a:ext>
             </a:extLst>
           </p:cNvPr>
@@ -4357,7 +4357,7 @@
           <p:cNvPr id="3" name="">
             <a:extLst xmlns:a="http://schemas.openxmlformats.org/drawingml/2006/main">
               <a:ext uri="{FF2B5EF4-FFF2-40B4-BE49-F238E27FC236}">
-                <a16:creationId xmlns:a16="http://schemas.microsoft.com/office/drawing/2014/main" id="{C0D133E4-5026-4D8C-9A52-AF0632C79678}"/>
+                <a16:creationId xmlns:a16="http://schemas.microsoft.com/office/drawing/2014/main" id="{D42B624E-B199-4632-9F39-CA886281107B}"/>
               </a:ext>
             </a:extLst>
           </p:cNvPr>
@@ -4414,7 +4414,7 @@
           <p:cNvPr id="4" name="">
             <a:extLst xmlns:a="http://schemas.openxmlformats.org/drawingml/2006/main">
               <a:ext uri="{FF2B5EF4-FFF2-40B4-BE49-F238E27FC236}">
-                <a16:creationId xmlns:a16="http://schemas.microsoft.com/office/drawing/2014/main" id="{A93E40C0-737E-44A9-8831-4738BD69A1DB}"/>
+                <a16:creationId xmlns:a16="http://schemas.microsoft.com/office/drawing/2014/main" id="{8406DFE5-6FB0-4D74-8DC0-0439D8B51418}"/>
               </a:ext>
             </a:extLst>
           </p:cNvPr>
@@ -4471,7 +4471,7 @@
           <p:cNvPr id="5" name="">
             <a:extLst xmlns:a="http://schemas.openxmlformats.org/drawingml/2006/main">
               <a:ext uri="{FF2B5EF4-FFF2-40B4-BE49-F238E27FC236}">
-                <a16:creationId xmlns:a16="http://schemas.microsoft.com/office/drawing/2014/main" id="{8426A0F5-0116-4D68-915C-44E542DA0D94}"/>
+                <a16:creationId xmlns:a16="http://schemas.microsoft.com/office/drawing/2014/main" id="{9F17EFE8-517B-44E7-A8E6-CBF04ED41A53}"/>
               </a:ext>
             </a:extLst>
           </p:cNvPr>
@@ -4528,7 +4528,7 @@
           <p:cNvPr id="6" name="">
             <a:extLst xmlns:a="http://schemas.openxmlformats.org/drawingml/2006/main">
               <a:ext uri="{FF2B5EF4-FFF2-40B4-BE49-F238E27FC236}">
-                <a16:creationId xmlns:a16="http://schemas.microsoft.com/office/drawing/2014/main" id="{DFD29F7F-9EAA-4CE1-A494-523D9ABB026F}"/>
+                <a16:creationId xmlns:a16="http://schemas.microsoft.com/office/drawing/2014/main" id="{EC9B1DB4-545E-4B82-A10B-C67A8D2646BB}"/>
               </a:ext>
             </a:extLst>
           </p:cNvPr>
@@ -4583,7 +4583,7 @@
     </p:spTree>
     <p:extLst>
       <p:ext uri="{BB962C8B-B14F-4D97-AF65-F5344CB8AC3E}">
-        <p14:creationId xmlns:p14="http://schemas.microsoft.com/office/powerpoint/2010/main" val="552262572"/>
+        <p14:creationId xmlns:p14="http://schemas.microsoft.com/office/powerpoint/2010/main" val="34747114"/>
       </p:ext>
     </p:extLst>
   </p:cSld>
@@ -4614,7 +4614,7 @@
           <p:cNvPr id="7" name="">
             <a:extLst xmlns:a="http://schemas.openxmlformats.org/drawingml/2006/main">
               <a:ext uri="{FF2B5EF4-FFF2-40B4-BE49-F238E27FC236}">
-                <a16:creationId xmlns:a16="http://schemas.microsoft.com/office/drawing/2014/main" id="{FC76C602-1DD1-4FC4-B5E8-F30F5D71A69A}"/>
+                <a16:creationId xmlns:a16="http://schemas.microsoft.com/office/drawing/2014/main" id="{81F3B4D8-FBF9-406C-8957-C1589669A965}"/>
               </a:ext>
             </a:extLst>
           </p:cNvPr>
@@ -4671,7 +4671,7 @@
           <p:cNvPr id="2" name="">
             <a:extLst xmlns:a="http://schemas.openxmlformats.org/drawingml/2006/main">
               <a:ext uri="{FF2B5EF4-FFF2-40B4-BE49-F238E27FC236}">
-                <a16:creationId xmlns:a16="http://schemas.microsoft.com/office/drawing/2014/main" id="{48D09172-EA7C-40EC-B468-FC5A7953EB74}"/>
+                <a16:creationId xmlns:a16="http://schemas.microsoft.com/office/drawing/2014/main" id="{9A0C99FC-23CA-4FAC-A60C-998BB7CB07F8}"/>
               </a:ext>
             </a:extLst>
           </p:cNvPr>
@@ -4728,7 +4728,7 @@
           <p:cNvPr id="3" name="">
             <a:extLst xmlns:a="http://schemas.openxmlformats.org/drawingml/2006/main">
               <a:ext uri="{FF2B5EF4-FFF2-40B4-BE49-F238E27FC236}">
-                <a16:creationId xmlns:a16="http://schemas.microsoft.com/office/drawing/2014/main" id="{5875D60A-9982-4096-8236-A809640B3156}"/>
+                <a16:creationId xmlns:a16="http://schemas.microsoft.com/office/drawing/2014/main" id="{DADD0DB5-21B1-4FE0-9C50-184F3B00CE33}"/>
               </a:ext>
             </a:extLst>
           </p:cNvPr>
@@ -4785,7 +4785,7 @@
           <p:cNvPr id="4" name="">
             <a:extLst xmlns:a="http://schemas.openxmlformats.org/drawingml/2006/main">
               <a:ext uri="{FF2B5EF4-FFF2-40B4-BE49-F238E27FC236}">
-                <a16:creationId xmlns:a16="http://schemas.microsoft.com/office/drawing/2014/main" id="{C51CA00D-830D-4BF8-8573-D36F1A03B03F}"/>
+                <a16:creationId xmlns:a16="http://schemas.microsoft.com/office/drawing/2014/main" id="{6D5AC4E2-FC8F-4B19-BC26-AAE04C8D3EC7}"/>
               </a:ext>
             </a:extLst>
           </p:cNvPr>
@@ -4842,7 +4842,7 @@
           <p:cNvPr id="5" name="">
             <a:extLst xmlns:a="http://schemas.openxmlformats.org/drawingml/2006/main">
               <a:ext uri="{FF2B5EF4-FFF2-40B4-BE49-F238E27FC236}">
-                <a16:creationId xmlns:a16="http://schemas.microsoft.com/office/drawing/2014/main" id="{AF82176B-4251-48D2-97C8-E586D0506803}"/>
+                <a16:creationId xmlns:a16="http://schemas.microsoft.com/office/drawing/2014/main" id="{924A6C26-EE50-4A44-B6F5-E1112ABBDEF2}"/>
               </a:ext>
             </a:extLst>
           </p:cNvPr>
@@ -4899,7 +4899,7 @@
           <p:cNvPr id="6" name="">
             <a:extLst xmlns:a="http://schemas.openxmlformats.org/drawingml/2006/main">
               <a:ext uri="{FF2B5EF4-FFF2-40B4-BE49-F238E27FC236}">
-                <a16:creationId xmlns:a16="http://schemas.microsoft.com/office/drawing/2014/main" id="{7825CD61-A9CC-451A-9294-03FAE961D641}"/>
+                <a16:creationId xmlns:a16="http://schemas.microsoft.com/office/drawing/2014/main" id="{2676AA1F-F727-4DB8-90F3-505A32C6B704}"/>
               </a:ext>
             </a:extLst>
           </p:cNvPr>
@@ -4954,7 +4954,7 @@
     </p:spTree>
     <p:extLst>
       <p:ext uri="{BB962C8B-B14F-4D97-AF65-F5344CB8AC3E}">
-        <p14:creationId xmlns:p14="http://schemas.microsoft.com/office/powerpoint/2010/main" val="195366635"/>
+        <p14:creationId xmlns:p14="http://schemas.microsoft.com/office/powerpoint/2010/main" val="74583981"/>
       </p:ext>
     </p:extLst>
   </p:cSld>
@@ -4985,7 +4985,7 @@
           <p:cNvPr id="4" name="">
             <a:extLst xmlns:a="http://schemas.openxmlformats.org/drawingml/2006/main">
               <a:ext uri="{FF2B5EF4-FFF2-40B4-BE49-F238E27FC236}">
-                <a16:creationId xmlns:a16="http://schemas.microsoft.com/office/drawing/2014/main" id="{C65CA4DF-7825-4153-BFF4-2A08817F1CEB}"/>
+                <a16:creationId xmlns:a16="http://schemas.microsoft.com/office/drawing/2014/main" id="{A81604A2-7784-4F53-83AD-41E6698FDC32}"/>
               </a:ext>
             </a:extLst>
           </p:cNvPr>
@@ -5042,7 +5042,7 @@
           <p:cNvPr id="2" name="">
             <a:extLst xmlns:a="http://schemas.openxmlformats.org/drawingml/2006/main">
               <a:ext uri="{FF2B5EF4-FFF2-40B4-BE49-F238E27FC236}">
-                <a16:creationId xmlns:a16="http://schemas.microsoft.com/office/drawing/2014/main" id="{57143447-8AD3-4037-A486-357E67BB3F57}"/>
+                <a16:creationId xmlns:a16="http://schemas.microsoft.com/office/drawing/2014/main" id="{1ADCEA88-77F7-4485-8EE8-5A691AE1ADAD}"/>
               </a:ext>
             </a:extLst>
           </p:cNvPr>
@@ -5177,7 +5177,7 @@
                           <a:ea typeface="Helvetica Neue"/>
                           <a:cs typeface="Helvetica Neue"/>
                         </a:rPr>
-                        <a:t>Holdout RF classifier</a:t>
+                        <a:t>RF classifier (holdout and folds)</a:t>
                       </a:r>
                     </a:p>
                   </a:txBody>
@@ -5227,7 +5227,7 @@
                           <a:ea typeface="Helvetica Neue"/>
                           <a:cs typeface="Helvetica Neue"/>
                         </a:rPr>
-                        <a:t>Rolling-fold RF classifier</a:t>
+                        <a:t>Logistic regression</a:t>
                       </a:r>
                     </a:p>
                   </a:txBody>
@@ -5251,7 +5251,7 @@
                           <a:ea typeface="Helvetica Neue"/>
                           <a:cs typeface="Helvetica Neue"/>
                         </a:rPr>
-                        <a:t>60 trees, depth 7, leaf minimum 3</a:t>
+                        <a:t>StandardScaler, max_iter 1000</a:t>
                       </a:r>
                     </a:p>
                   </a:txBody>
@@ -5277,7 +5277,7 @@
                           <a:ea typeface="Helvetica Neue"/>
                           <a:cs typeface="Helvetica Neue"/>
                         </a:rPr>
-                        <a:t>Logistic regression</a:t>
+                        <a:t>Isolation Forest</a:t>
                       </a:r>
                     </a:p>
                   </a:txBody>
@@ -5301,7 +5301,7 @@
                           <a:ea typeface="Helvetica Neue"/>
                           <a:cs typeface="Helvetica Neue"/>
                         </a:rPr>
-                        <a:t>StandardScaler, max_iter 1000</a:t>
+                        <a:t>100 trees, train-derived contamination 0.0446</a:t>
                       </a:r>
                     </a:p>
                   </a:txBody>
@@ -5327,7 +5327,7 @@
                           <a:ea typeface="Helvetica Neue"/>
                           <a:cs typeface="Helvetica Neue"/>
                         </a:rPr>
-                        <a:t>Isolation Forest</a:t>
+                        <a:t>Next-day RF regressor</a:t>
                       </a:r>
                     </a:p>
                   </a:txBody>
@@ -5351,7 +5351,7 @@
                           <a:ea typeface="Helvetica Neue"/>
                           <a:cs typeface="Helvetica Neue"/>
                         </a:rPr>
-                        <a:t>100 trees, train-derived contamination 0.0446</a:t>
+                        <a:t>120 trees, depth 7, leaf minimum 4</a:t>
                       </a:r>
                     </a:p>
                   </a:txBody>
@@ -5377,7 +5377,7 @@
                           <a:ea typeface="Helvetica Neue"/>
                           <a:cs typeface="Helvetica Neue"/>
                         </a:rPr>
-                        <a:t>Next-day RF regressor</a:t>
+                        <a:t>ARIMA / Holt-Winters</a:t>
                       </a:r>
                     </a:p>
                   </a:txBody>
@@ -5401,7 +5401,7 @@
                           <a:ea typeface="Helvetica Neue"/>
                           <a:cs typeface="Helvetica Neue"/>
                         </a:rPr>
-                        <a:t>120 trees, depth 7, leaf minimum 4</a:t>
+                        <a:t>AR(1) with constant; damped trend, 5-day seasonality; last 180 days</a:t>
                       </a:r>
                     </a:p>
                   </a:txBody>
@@ -5419,7 +5419,7 @@
     </p:spTree>
     <p:extLst>
       <p:ext uri="{BB962C8B-B14F-4D97-AF65-F5344CB8AC3E}">
-        <p14:creationId xmlns:p14="http://schemas.microsoft.com/office/powerpoint/2010/main" val="1388361970"/>
+        <p14:creationId xmlns:p14="http://schemas.microsoft.com/office/powerpoint/2010/main" val="807500140"/>
       </p:ext>
     </p:extLst>
   </p:cSld>
@@ -5450,7 +5450,7 @@
           <p:cNvPr id="7" name="">
             <a:extLst xmlns:a="http://schemas.openxmlformats.org/drawingml/2006/main">
               <a:ext uri="{FF2B5EF4-FFF2-40B4-BE49-F238E27FC236}">
-                <a16:creationId xmlns:a16="http://schemas.microsoft.com/office/drawing/2014/main" id="{F0762216-4936-48D1-83CA-8D36985AA8DB}"/>
+                <a16:creationId xmlns:a16="http://schemas.microsoft.com/office/drawing/2014/main" id="{00BE6BC1-A0D8-4917-9475-D71775CA756D}"/>
               </a:ext>
             </a:extLst>
           </p:cNvPr>
@@ -5507,7 +5507,7 @@
           <p:cNvPr id="2" name="">
             <a:extLst xmlns:a="http://schemas.openxmlformats.org/drawingml/2006/main">
               <a:ext uri="{FF2B5EF4-FFF2-40B4-BE49-F238E27FC236}">
-                <a16:creationId xmlns:a16="http://schemas.microsoft.com/office/drawing/2014/main" id="{C397FD16-5F41-4928-9D35-D1487901AF5B}"/>
+                <a16:creationId xmlns:a16="http://schemas.microsoft.com/office/drawing/2014/main" id="{DD1FC31E-1C73-43DA-AC95-B30441326F6C}"/>
               </a:ext>
             </a:extLst>
           </p:cNvPr>
@@ -5564,7 +5564,7 @@
           <p:cNvPr id="3" name="">
             <a:extLst xmlns:a="http://schemas.openxmlformats.org/drawingml/2006/main">
               <a:ext uri="{FF2B5EF4-FFF2-40B4-BE49-F238E27FC236}">
-                <a16:creationId xmlns:a16="http://schemas.microsoft.com/office/drawing/2014/main" id="{88BF0ADC-1846-4AA0-87CE-1CEFDF376463}"/>
+                <a16:creationId xmlns:a16="http://schemas.microsoft.com/office/drawing/2014/main" id="{F7D47398-E6BB-453E-AAC7-3C1ACB09FD6F}"/>
               </a:ext>
             </a:extLst>
           </p:cNvPr>
@@ -5621,7 +5621,7 @@
           <p:cNvPr id="4" name="">
             <a:extLst xmlns:a="http://schemas.openxmlformats.org/drawingml/2006/main">
               <a:ext uri="{FF2B5EF4-FFF2-40B4-BE49-F238E27FC236}">
-                <a16:creationId xmlns:a16="http://schemas.microsoft.com/office/drawing/2014/main" id="{EA733881-B591-42F3-BDCA-7AB1DB392089}"/>
+                <a16:creationId xmlns:a16="http://schemas.microsoft.com/office/drawing/2014/main" id="{6CCF17A0-CEDC-4699-97E2-B858CB8CB81F}"/>
               </a:ext>
             </a:extLst>
           </p:cNvPr>
@@ -5678,7 +5678,7 @@
           <p:cNvPr id="5" name="">
             <a:extLst xmlns:a="http://schemas.openxmlformats.org/drawingml/2006/main">
               <a:ext uri="{FF2B5EF4-FFF2-40B4-BE49-F238E27FC236}">
-                <a16:creationId xmlns:a16="http://schemas.microsoft.com/office/drawing/2014/main" id="{D8BAC7BB-67C8-447D-82C0-13308E3B119B}"/>
+                <a16:creationId xmlns:a16="http://schemas.microsoft.com/office/drawing/2014/main" id="{D04A8B5C-CDDE-422D-B29D-4E76FF61DB76}"/>
               </a:ext>
             </a:extLst>
           </p:cNvPr>
@@ -5725,7 +5725,7 @@
                 <a:ea typeface="Helvetica Neue"/>
                 <a:cs typeface="Helvetica Neue"/>
               </a:rPr>
-              <a:t>Holdout signal share 78.1%. Isolation Forest flags 18 of 228 windows.</a:t>
+              <a:t>Rules flag 52.3% of windows (78.1% of the holdout). Isolation Forest flags 18 of 228.</a:t>
             </a:r>
           </a:p>
         </p:txBody>
@@ -5735,7 +5735,7 @@
           <p:cNvPr id="6" name="">
             <a:extLst xmlns:a="http://schemas.openxmlformats.org/drawingml/2006/main">
               <a:ext uri="{FF2B5EF4-FFF2-40B4-BE49-F238E27FC236}">
-                <a16:creationId xmlns:a16="http://schemas.microsoft.com/office/drawing/2014/main" id="{1B42840A-2F52-402D-B4D1-4166AC350411}"/>
+                <a16:creationId xmlns:a16="http://schemas.microsoft.com/office/drawing/2014/main" id="{7F0A0AA5-72B0-451A-84CD-499588BB99CC}"/>
               </a:ext>
             </a:extLst>
           </p:cNvPr>
@@ -5790,7 +5790,7 @@
     </p:spTree>
     <p:extLst>
       <p:ext uri="{BB962C8B-B14F-4D97-AF65-F5344CB8AC3E}">
-        <p14:creationId xmlns:p14="http://schemas.microsoft.com/office/powerpoint/2010/main" val="1073366732"/>
+        <p14:creationId xmlns:p14="http://schemas.microsoft.com/office/powerpoint/2010/main" val="1718407843"/>
       </p:ext>
     </p:extLst>
   </p:cSld>
@@ -5821,7 +5821,7 @@
           <p:cNvPr id="7" name="">
             <a:extLst xmlns:a="http://schemas.openxmlformats.org/drawingml/2006/main">
               <a:ext uri="{FF2B5EF4-FFF2-40B4-BE49-F238E27FC236}">
-                <a16:creationId xmlns:a16="http://schemas.microsoft.com/office/drawing/2014/main" id="{BE5786AC-302E-42E0-88EE-A5F546E548CB}"/>
+                <a16:creationId xmlns:a16="http://schemas.microsoft.com/office/drawing/2014/main" id="{00FBAEFA-3344-41EE-A0CE-70F263A70033}"/>
               </a:ext>
             </a:extLst>
           </p:cNvPr>
@@ -5878,7 +5878,7 @@
           <p:cNvPr id="2" name="">
             <a:extLst xmlns:a="http://schemas.openxmlformats.org/drawingml/2006/main">
               <a:ext uri="{FF2B5EF4-FFF2-40B4-BE49-F238E27FC236}">
-                <a16:creationId xmlns:a16="http://schemas.microsoft.com/office/drawing/2014/main" id="{AA63F5C2-28D3-480F-9900-22F4491BAB71}"/>
+                <a16:creationId xmlns:a16="http://schemas.microsoft.com/office/drawing/2014/main" id="{FD6D3CCD-1A70-4519-858E-64A1BA30CDE7}"/>
               </a:ext>
             </a:extLst>
           </p:cNvPr>
@@ -5935,7 +5935,7 @@
           <p:cNvPr id="3" name="">
             <a:extLst xmlns:a="http://schemas.openxmlformats.org/drawingml/2006/main">
               <a:ext uri="{FF2B5EF4-FFF2-40B4-BE49-F238E27FC236}">
-                <a16:creationId xmlns:a16="http://schemas.microsoft.com/office/drawing/2014/main" id="{3B9140CB-5F6B-4B48-A748-FDAC8350DC22}"/>
+                <a16:creationId xmlns:a16="http://schemas.microsoft.com/office/drawing/2014/main" id="{A6438635-252A-4665-B044-9C270E7684EE}"/>
               </a:ext>
             </a:extLst>
           </p:cNvPr>
@@ -5992,7 +5992,7 @@
           <p:cNvPr id="4" name="">
             <a:extLst xmlns:a="http://schemas.openxmlformats.org/drawingml/2006/main">
               <a:ext uri="{FF2B5EF4-FFF2-40B4-BE49-F238E27FC236}">
-                <a16:creationId xmlns:a16="http://schemas.microsoft.com/office/drawing/2014/main" id="{51C17A80-28CF-4D62-AD15-095D6A1F62DD}"/>
+                <a16:creationId xmlns:a16="http://schemas.microsoft.com/office/drawing/2014/main" id="{70A681D6-DB26-4298-A72C-A01ED2615677}"/>
               </a:ext>
             </a:extLst>
           </p:cNvPr>
@@ -6049,7 +6049,7 @@
           <p:cNvPr id="5" name="">
             <a:extLst xmlns:a="http://schemas.openxmlformats.org/drawingml/2006/main">
               <a:ext uri="{FF2B5EF4-FFF2-40B4-BE49-F238E27FC236}">
-                <a16:creationId xmlns:a16="http://schemas.microsoft.com/office/drawing/2014/main" id="{720C49B3-51D2-48EF-A288-DE4825F4E5F3}"/>
+                <a16:creationId xmlns:a16="http://schemas.microsoft.com/office/drawing/2014/main" id="{80F5B134-4C62-418C-B13B-CD0C107E88D2}"/>
               </a:ext>
             </a:extLst>
           </p:cNvPr>
@@ -6106,7 +6106,7 @@
           <p:cNvPr id="6" name="">
             <a:extLst xmlns:a="http://schemas.openxmlformats.org/drawingml/2006/main">
               <a:ext uri="{FF2B5EF4-FFF2-40B4-BE49-F238E27FC236}">
-                <a16:creationId xmlns:a16="http://schemas.microsoft.com/office/drawing/2014/main" id="{90F498AD-E042-426E-8D30-0E99664828B3}"/>
+                <a16:creationId xmlns:a16="http://schemas.microsoft.com/office/drawing/2014/main" id="{F5464089-1A1D-4081-B61F-3D968AC1BFE4}"/>
               </a:ext>
             </a:extLst>
           </p:cNvPr>
@@ -6161,7 +6161,7 @@
     </p:spTree>
     <p:extLst>
       <p:ext uri="{BB962C8B-B14F-4D97-AF65-F5344CB8AC3E}">
-        <p14:creationId xmlns:p14="http://schemas.microsoft.com/office/powerpoint/2010/main" val="1685555368"/>
+        <p14:creationId xmlns:p14="http://schemas.microsoft.com/office/powerpoint/2010/main" val="1800943674"/>
       </p:ext>
     </p:extLst>
   </p:cSld>
@@ -6192,7 +6192,7 @@
           <p:cNvPr id="4" name="">
             <a:extLst xmlns:a="http://schemas.openxmlformats.org/drawingml/2006/main">
               <a:ext uri="{FF2B5EF4-FFF2-40B4-BE49-F238E27FC236}">
-                <a16:creationId xmlns:a16="http://schemas.microsoft.com/office/drawing/2014/main" id="{3506D826-69E5-4387-8047-722EF9940E90}"/>
+                <a16:creationId xmlns:a16="http://schemas.microsoft.com/office/drawing/2014/main" id="{EBA396AB-85D1-438F-99DA-63BE97BC6EA4}"/>
               </a:ext>
             </a:extLst>
           </p:cNvPr>
@@ -6249,7 +6249,7 @@
           <p:cNvPr id="2" name="">
             <a:extLst xmlns:a="http://schemas.openxmlformats.org/drawingml/2006/main">
               <a:ext uri="{FF2B5EF4-FFF2-40B4-BE49-F238E27FC236}">
-                <a16:creationId xmlns:a16="http://schemas.microsoft.com/office/drawing/2014/main" id="{70B2A99C-C975-496B-9137-64973265841F}"/>
+                <a16:creationId xmlns:a16="http://schemas.microsoft.com/office/drawing/2014/main" id="{A2E81BA6-2E61-4BE2-B43F-3C7639569D68}"/>
               </a:ext>
             </a:extLst>
           </p:cNvPr>
@@ -6626,7 +6626,7 @@
     </p:spTree>
     <p:extLst>
       <p:ext uri="{BB962C8B-B14F-4D97-AF65-F5344CB8AC3E}">
-        <p14:creationId xmlns:p14="http://schemas.microsoft.com/office/powerpoint/2010/main" val="2098278173"/>
+        <p14:creationId xmlns:p14="http://schemas.microsoft.com/office/powerpoint/2010/main" val="768928277"/>
       </p:ext>
     </p:extLst>
   </p:cSld>
@@ -6657,7 +6657,7 @@
           <p:cNvPr id="7" name="">
             <a:extLst xmlns:a="http://schemas.openxmlformats.org/drawingml/2006/main">
               <a:ext uri="{FF2B5EF4-FFF2-40B4-BE49-F238E27FC236}">
-                <a16:creationId xmlns:a16="http://schemas.microsoft.com/office/drawing/2014/main" id="{8E741A7D-3C3C-4811-A88E-C129E3599F11}"/>
+                <a16:creationId xmlns:a16="http://schemas.microsoft.com/office/drawing/2014/main" id="{059B52EB-C6B0-4E0A-B2CE-AEDDF100DD59}"/>
               </a:ext>
             </a:extLst>
           </p:cNvPr>
@@ -6714,7 +6714,7 @@
           <p:cNvPr id="2" name="">
             <a:extLst xmlns:a="http://schemas.openxmlformats.org/drawingml/2006/main">
               <a:ext uri="{FF2B5EF4-FFF2-40B4-BE49-F238E27FC236}">
-                <a16:creationId xmlns:a16="http://schemas.microsoft.com/office/drawing/2014/main" id="{47F7A829-E19F-4710-9F2F-43A1FBADCB00}"/>
+                <a16:creationId xmlns:a16="http://schemas.microsoft.com/office/drawing/2014/main" id="{FBCC05D6-4A75-40A5-A1F3-50CCA9757D10}"/>
               </a:ext>
             </a:extLst>
           </p:cNvPr>
@@ -6771,7 +6771,7 @@
           <p:cNvPr id="3" name="">
             <a:extLst xmlns:a="http://schemas.openxmlformats.org/drawingml/2006/main">
               <a:ext uri="{FF2B5EF4-FFF2-40B4-BE49-F238E27FC236}">
-                <a16:creationId xmlns:a16="http://schemas.microsoft.com/office/drawing/2014/main" id="{837599A3-3BB6-4B24-8DB3-CFE889874EDD}"/>
+                <a16:creationId xmlns:a16="http://schemas.microsoft.com/office/drawing/2014/main" id="{BFA71268-C208-4AE7-9282-F5B0C5DAF3D6}"/>
               </a:ext>
             </a:extLst>
           </p:cNvPr>
@@ -6828,7 +6828,7 @@
           <p:cNvPr id="4" name="">
             <a:extLst xmlns:a="http://schemas.openxmlformats.org/drawingml/2006/main">
               <a:ext uri="{FF2B5EF4-FFF2-40B4-BE49-F238E27FC236}">
-                <a16:creationId xmlns:a16="http://schemas.microsoft.com/office/drawing/2014/main" id="{3F6DCDB5-FB82-4FC0-B774-179501999915}"/>
+                <a16:creationId xmlns:a16="http://schemas.microsoft.com/office/drawing/2014/main" id="{55CCA7A2-91AC-405D-AA25-FABDA71CA658}"/>
               </a:ext>
             </a:extLst>
           </p:cNvPr>
@@ -6885,7 +6885,7 @@
           <p:cNvPr id="5" name="">
             <a:extLst xmlns:a="http://schemas.openxmlformats.org/drawingml/2006/main">
               <a:ext uri="{FF2B5EF4-FFF2-40B4-BE49-F238E27FC236}">
-                <a16:creationId xmlns:a16="http://schemas.microsoft.com/office/drawing/2014/main" id="{94FF93EF-A160-44DC-95EB-7B4417329114}"/>
+                <a16:creationId xmlns:a16="http://schemas.microsoft.com/office/drawing/2014/main" id="{9D4C3C00-0030-4142-B06C-366EE3D1B20B}"/>
               </a:ext>
             </a:extLst>
           </p:cNvPr>
@@ -6942,7 +6942,7 @@
           <p:cNvPr id="6" name="">
             <a:extLst xmlns:a="http://schemas.openxmlformats.org/drawingml/2006/main">
               <a:ext uri="{FF2B5EF4-FFF2-40B4-BE49-F238E27FC236}">
-                <a16:creationId xmlns:a16="http://schemas.microsoft.com/office/drawing/2014/main" id="{FB60BF5A-3FDC-4BC4-B56A-BCDEAB5B1B43}"/>
+                <a16:creationId xmlns:a16="http://schemas.microsoft.com/office/drawing/2014/main" id="{C95DBAE5-9A54-4BC6-A0B0-DA8C9DDD83B0}"/>
               </a:ext>
             </a:extLst>
           </p:cNvPr>
@@ -6997,7 +6997,7 @@
     </p:spTree>
     <p:extLst>
       <p:ext uri="{BB962C8B-B14F-4D97-AF65-F5344CB8AC3E}">
-        <p14:creationId xmlns:p14="http://schemas.microsoft.com/office/powerpoint/2010/main" val="560578671"/>
+        <p14:creationId xmlns:p14="http://schemas.microsoft.com/office/powerpoint/2010/main" val="182171288"/>
       </p:ext>
     </p:extLst>
   </p:cSld>
@@ -7028,7 +7028,7 @@
           <p:cNvPr id="7" name="">
             <a:extLst xmlns:a="http://schemas.openxmlformats.org/drawingml/2006/main">
               <a:ext uri="{FF2B5EF4-FFF2-40B4-BE49-F238E27FC236}">
-                <a16:creationId xmlns:a16="http://schemas.microsoft.com/office/drawing/2014/main" id="{330B74DF-EA76-42E7-A85B-F4E9129F6A86}"/>
+                <a16:creationId xmlns:a16="http://schemas.microsoft.com/office/drawing/2014/main" id="{5B6D0D02-EB54-4EA6-8254-991CA768EB60}"/>
               </a:ext>
             </a:extLst>
           </p:cNvPr>
@@ -7085,7 +7085,7 @@
           <p:cNvPr id="2" name="">
             <a:extLst xmlns:a="http://schemas.openxmlformats.org/drawingml/2006/main">
               <a:ext uri="{FF2B5EF4-FFF2-40B4-BE49-F238E27FC236}">
-                <a16:creationId xmlns:a16="http://schemas.microsoft.com/office/drawing/2014/main" id="{ECF06EA2-5C87-4A24-97B6-77A9D9D54DA7}"/>
+                <a16:creationId xmlns:a16="http://schemas.microsoft.com/office/drawing/2014/main" id="{D80F4C4F-7271-4AAD-8434-AEFC1A1A3561}"/>
               </a:ext>
             </a:extLst>
           </p:cNvPr>
@@ -7142,7 +7142,7 @@
           <p:cNvPr id="3" name="">
             <a:extLst xmlns:a="http://schemas.openxmlformats.org/drawingml/2006/main">
               <a:ext uri="{FF2B5EF4-FFF2-40B4-BE49-F238E27FC236}">
-                <a16:creationId xmlns:a16="http://schemas.microsoft.com/office/drawing/2014/main" id="{C51B387E-BFBE-42CF-B19C-19E98A4B42BC}"/>
+                <a16:creationId xmlns:a16="http://schemas.microsoft.com/office/drawing/2014/main" id="{84F47168-301E-46BD-B2B0-12E0BCD674A5}"/>
               </a:ext>
             </a:extLst>
           </p:cNvPr>
@@ -7199,7 +7199,7 @@
           <p:cNvPr id="4" name="">
             <a:extLst xmlns:a="http://schemas.openxmlformats.org/drawingml/2006/main">
               <a:ext uri="{FF2B5EF4-FFF2-40B4-BE49-F238E27FC236}">
-                <a16:creationId xmlns:a16="http://schemas.microsoft.com/office/drawing/2014/main" id="{65758F96-0472-4C12-9BD3-E43736457DD4}"/>
+                <a16:creationId xmlns:a16="http://schemas.microsoft.com/office/drawing/2014/main" id="{54C0B579-793E-438B-97F9-58540306CF04}"/>
               </a:ext>
             </a:extLst>
           </p:cNvPr>
@@ -7256,7 +7256,7 @@
           <p:cNvPr id="5" name="">
             <a:extLst xmlns:a="http://schemas.openxmlformats.org/drawingml/2006/main">
               <a:ext uri="{FF2B5EF4-FFF2-40B4-BE49-F238E27FC236}">
-                <a16:creationId xmlns:a16="http://schemas.microsoft.com/office/drawing/2014/main" id="{9EF74A31-EB00-48C5-B3EA-F4167AA097AE}"/>
+                <a16:creationId xmlns:a16="http://schemas.microsoft.com/office/drawing/2014/main" id="{4EF8EC88-11BE-446C-B24E-343B16F571F1}"/>
               </a:ext>
             </a:extLst>
           </p:cNvPr>
@@ -7313,7 +7313,7 @@
           <p:cNvPr id="6" name="">
             <a:extLst xmlns:a="http://schemas.openxmlformats.org/drawingml/2006/main">
               <a:ext uri="{FF2B5EF4-FFF2-40B4-BE49-F238E27FC236}">
-                <a16:creationId xmlns:a16="http://schemas.microsoft.com/office/drawing/2014/main" id="{B0B86CE9-B4AB-4600-88E9-0293F4D53245}"/>
+                <a16:creationId xmlns:a16="http://schemas.microsoft.com/office/drawing/2014/main" id="{1337C6A4-2AEA-494C-903F-1C1F16996D05}"/>
               </a:ext>
             </a:extLst>
           </p:cNvPr>
@@ -7368,7 +7368,7 @@
     </p:spTree>
     <p:extLst>
       <p:ext uri="{BB962C8B-B14F-4D97-AF65-F5344CB8AC3E}">
-        <p14:creationId xmlns:p14="http://schemas.microsoft.com/office/powerpoint/2010/main" val="1459225761"/>
+        <p14:creationId xmlns:p14="http://schemas.microsoft.com/office/powerpoint/2010/main" val="38971648"/>
       </p:ext>
     </p:extLst>
   </p:cSld>
@@ -7399,7 +7399,7 @@
           <p:cNvPr id="5" name="">
             <a:extLst xmlns:a="http://schemas.openxmlformats.org/drawingml/2006/main">
               <a:ext uri="{FF2B5EF4-FFF2-40B4-BE49-F238E27FC236}">
-                <a16:creationId xmlns:a16="http://schemas.microsoft.com/office/drawing/2014/main" id="{6E203C31-3AF6-4A3E-A356-D09F0504BE12}"/>
+                <a16:creationId xmlns:a16="http://schemas.microsoft.com/office/drawing/2014/main" id="{BC08A529-66CA-4E66-907A-F6D4B58F7965}"/>
               </a:ext>
             </a:extLst>
           </p:cNvPr>
@@ -7456,7 +7456,7 @@
           <p:cNvPr id="2" name="">
             <a:extLst xmlns:a="http://schemas.openxmlformats.org/drawingml/2006/main">
               <a:ext uri="{FF2B5EF4-FFF2-40B4-BE49-F238E27FC236}">
-                <a16:creationId xmlns:a16="http://schemas.microsoft.com/office/drawing/2014/main" id="{5B475D8D-9765-436A-BBA1-9AB1896D4D7B}"/>
+                <a16:creationId xmlns:a16="http://schemas.microsoft.com/office/drawing/2014/main" id="{EA2DC96D-6FC5-455D-9D80-6D81738332FC}"/>
               </a:ext>
             </a:extLst>
           </p:cNvPr>
@@ -7520,7 +7520,7 @@
         </p:xfrm>
         <a:graphic xmlns:a="http://schemas.openxmlformats.org/drawingml/2006/main">
           <a:graphicData uri="http://schemas.openxmlformats.org/drawingml/2006/chart">
-            <c:chart xmlns:r="http://schemas.openxmlformats.org/officeDocument/2006/relationships" xmlns:c="http://schemas.openxmlformats.org/drawingml/2006/chart" r:id="Ra41772ae5a3a45f8"/>
+            <c:chart xmlns:r="http://schemas.openxmlformats.org/officeDocument/2006/relationships" xmlns:c="http://schemas.openxmlformats.org/drawingml/2006/chart" r:id="R4e90ef2d7f8841b2"/>
           </a:graphicData>
         </a:graphic>
       </p:graphicFrame>
@@ -7529,7 +7529,7 @@
           <p:cNvPr id="4" name="">
             <a:extLst xmlns:a="http://schemas.openxmlformats.org/drawingml/2006/main">
               <a:ext uri="{FF2B5EF4-FFF2-40B4-BE49-F238E27FC236}">
-                <a16:creationId xmlns:a16="http://schemas.microsoft.com/office/drawing/2014/main" id="{2EF50146-25C1-46A1-9E95-A7023E690A45}"/>
+                <a16:creationId xmlns:a16="http://schemas.microsoft.com/office/drawing/2014/main" id="{5B6F1F1B-66E8-4977-843E-F21511B268EE}"/>
               </a:ext>
             </a:extLst>
           </p:cNvPr>
@@ -7584,7 +7584,7 @@
     </p:spTree>
     <p:extLst>
       <p:ext uri="{BB962C8B-B14F-4D97-AF65-F5344CB8AC3E}">
-        <p14:creationId xmlns:p14="http://schemas.microsoft.com/office/powerpoint/2010/main" val="2116310611"/>
+        <p14:creationId xmlns:p14="http://schemas.microsoft.com/office/powerpoint/2010/main" val="1476096466"/>
       </p:ext>
     </p:extLst>
   </p:cSld>
@@ -7615,7 +7615,7 @@
           <p:cNvPr id="7" name="">
             <a:extLst xmlns:a="http://schemas.openxmlformats.org/drawingml/2006/main">
               <a:ext uri="{FF2B5EF4-FFF2-40B4-BE49-F238E27FC236}">
-                <a16:creationId xmlns:a16="http://schemas.microsoft.com/office/drawing/2014/main" id="{11865F79-375D-4145-8B09-D758AA5CCC58}"/>
+                <a16:creationId xmlns:a16="http://schemas.microsoft.com/office/drawing/2014/main" id="{C039DCE0-50F4-476F-97C3-AB27A2ED980B}"/>
               </a:ext>
             </a:extLst>
           </p:cNvPr>
@@ -7672,7 +7672,7 @@
           <p:cNvPr id="2" name="">
             <a:extLst xmlns:a="http://schemas.openxmlformats.org/drawingml/2006/main">
               <a:ext uri="{FF2B5EF4-FFF2-40B4-BE49-F238E27FC236}">
-                <a16:creationId xmlns:a16="http://schemas.microsoft.com/office/drawing/2014/main" id="{99251B0D-1207-4246-8B34-FF2D368F75EF}"/>
+                <a16:creationId xmlns:a16="http://schemas.microsoft.com/office/drawing/2014/main" id="{A11BAFD0-3A39-4BBE-A466-7DD727CEC94F}"/>
               </a:ext>
             </a:extLst>
           </p:cNvPr>
@@ -7729,7 +7729,7 @@
           <p:cNvPr id="3" name="">
             <a:extLst xmlns:a="http://schemas.openxmlformats.org/drawingml/2006/main">
               <a:ext uri="{FF2B5EF4-FFF2-40B4-BE49-F238E27FC236}">
-                <a16:creationId xmlns:a16="http://schemas.microsoft.com/office/drawing/2014/main" id="{78D01679-1409-4D4B-809E-A5EB82FF4378}"/>
+                <a16:creationId xmlns:a16="http://schemas.microsoft.com/office/drawing/2014/main" id="{12298653-9E2C-413C-BC93-7C83D1899561}"/>
               </a:ext>
             </a:extLst>
           </p:cNvPr>
@@ -7786,7 +7786,7 @@
           <p:cNvPr id="4" name="">
             <a:extLst xmlns:a="http://schemas.openxmlformats.org/drawingml/2006/main">
               <a:ext uri="{FF2B5EF4-FFF2-40B4-BE49-F238E27FC236}">
-                <a16:creationId xmlns:a16="http://schemas.microsoft.com/office/drawing/2014/main" id="{DCCD95D0-0F32-4F2D-810B-29D7CE293383}"/>
+                <a16:creationId xmlns:a16="http://schemas.microsoft.com/office/drawing/2014/main" id="{C595B899-FAD2-4B89-883D-3A2A9CDFCFD3}"/>
               </a:ext>
             </a:extLst>
           </p:cNvPr>
@@ -7843,7 +7843,7 @@
           <p:cNvPr id="5" name="">
             <a:extLst xmlns:a="http://schemas.openxmlformats.org/drawingml/2006/main">
               <a:ext uri="{FF2B5EF4-FFF2-40B4-BE49-F238E27FC236}">
-                <a16:creationId xmlns:a16="http://schemas.microsoft.com/office/drawing/2014/main" id="{4D190585-4FF0-4F22-8075-F5230B5D7844}"/>
+                <a16:creationId xmlns:a16="http://schemas.microsoft.com/office/drawing/2014/main" id="{D8D1E4B1-9A04-40F8-8E14-795DB59E331A}"/>
               </a:ext>
             </a:extLst>
           </p:cNvPr>
@@ -7900,7 +7900,7 @@
           <p:cNvPr id="6" name="">
             <a:extLst xmlns:a="http://schemas.openxmlformats.org/drawingml/2006/main">
               <a:ext uri="{FF2B5EF4-FFF2-40B4-BE49-F238E27FC236}">
-                <a16:creationId xmlns:a16="http://schemas.microsoft.com/office/drawing/2014/main" id="{A45C1779-0757-46C6-A85F-E46EDD00F78A}"/>
+                <a16:creationId xmlns:a16="http://schemas.microsoft.com/office/drawing/2014/main" id="{6188ED6F-6CA5-44C6-B743-88D667498B4E}"/>
               </a:ext>
             </a:extLst>
           </p:cNvPr>
@@ -7955,7 +7955,7 @@
     </p:spTree>
     <p:extLst>
       <p:ext uri="{BB962C8B-B14F-4D97-AF65-F5344CB8AC3E}">
-        <p14:creationId xmlns:p14="http://schemas.microsoft.com/office/powerpoint/2010/main" val="1349227248"/>
+        <p14:creationId xmlns:p14="http://schemas.microsoft.com/office/powerpoint/2010/main" val="683774714"/>
       </p:ext>
     </p:extLst>
   </p:cSld>
@@ -7986,7 +7986,7 @@
           <p:cNvPr id="4" name="">
             <a:extLst xmlns:a="http://schemas.openxmlformats.org/drawingml/2006/main">
               <a:ext uri="{FF2B5EF4-FFF2-40B4-BE49-F238E27FC236}">
-                <a16:creationId xmlns:a16="http://schemas.microsoft.com/office/drawing/2014/main" id="{FAE6BBF6-1EF1-4C7D-8079-8CD82A775B08}"/>
+                <a16:creationId xmlns:a16="http://schemas.microsoft.com/office/drawing/2014/main" id="{BC606BB8-E0EF-468E-9E72-648A04D0F4FC}"/>
               </a:ext>
             </a:extLst>
           </p:cNvPr>
@@ -8043,7 +8043,7 @@
           <p:cNvPr id="2" name="">
             <a:extLst xmlns:a="http://schemas.openxmlformats.org/drawingml/2006/main">
               <a:ext uri="{FF2B5EF4-FFF2-40B4-BE49-F238E27FC236}">
-                <a16:creationId xmlns:a16="http://schemas.microsoft.com/office/drawing/2014/main" id="{2EC9D6D3-BD2D-404C-9DD1-EB60FAF467DA}"/>
+                <a16:creationId xmlns:a16="http://schemas.microsoft.com/office/drawing/2014/main" id="{2C63D559-C62B-4C96-8B40-CA95E434B585}"/>
               </a:ext>
             </a:extLst>
           </p:cNvPr>
@@ -8178,7 +8178,7 @@
                           <a:ea typeface="Helvetica Neue"/>
                           <a:cs typeface="Helvetica Neue"/>
                         </a:rPr>
-                        <a:t>SPC rules</a:t>
+                        <a:t>Statistics: SPC rules</a:t>
                       </a:r>
                     </a:p>
                   </a:txBody>
@@ -8228,7 +8228,7 @@
                           <a:ea typeface="Helvetica Neue"/>
                           <a:cs typeface="Helvetica Neue"/>
                         </a:rPr>
-                        <a:t>Random forest / logistic classifier</a:t>
+                        <a:t>ML: random forest / logistic classifier</a:t>
                       </a:r>
                     </a:p>
                   </a:txBody>
@@ -8278,7 +8278,7 @@
                           <a:ea typeface="Helvetica Neue"/>
                           <a:cs typeface="Helvetica Neue"/>
                         </a:rPr>
-                        <a:t>Isolation Forest</a:t>
+                        <a:t>ML: Isolation Forest</a:t>
                       </a:r>
                     </a:p>
                   </a:txBody>
@@ -8328,7 +8328,7 @@
                           <a:ea typeface="Helvetica Neue"/>
                           <a:cs typeface="Helvetica Neue"/>
                         </a:rPr>
-                        <a:t>Random forest regression</a:t>
+                        <a:t>ML: random forest regression</a:t>
                       </a:r>
                     </a:p>
                   </a:txBody>
@@ -8378,7 +8378,7 @@
                           <a:ea typeface="Helvetica Neue"/>
                           <a:cs typeface="Helvetica Neue"/>
                         </a:rPr>
-                        <a:t>Statistical forecasts</a:t>
+                        <a:t>Statistics: ARIMA / Holt-Winters</a:t>
                       </a:r>
                     </a:p>
                   </a:txBody>
@@ -8420,7 +8420,7 @@
     </p:spTree>
     <p:extLst>
       <p:ext uri="{BB962C8B-B14F-4D97-AF65-F5344CB8AC3E}">
-        <p14:creationId xmlns:p14="http://schemas.microsoft.com/office/powerpoint/2010/main" val="1837915526"/>
+        <p14:creationId xmlns:p14="http://schemas.microsoft.com/office/powerpoint/2010/main" val="1932689175"/>
       </p:ext>
     </p:extLst>
   </p:cSld>
@@ -8451,7 +8451,7 @@
           <p:cNvPr id="7" name="">
             <a:extLst xmlns:a="http://schemas.openxmlformats.org/drawingml/2006/main">
               <a:ext uri="{FF2B5EF4-FFF2-40B4-BE49-F238E27FC236}">
-                <a16:creationId xmlns:a16="http://schemas.microsoft.com/office/drawing/2014/main" id="{BBF1D103-5A1F-4BE0-B2D5-804E38AD15B7}"/>
+                <a16:creationId xmlns:a16="http://schemas.microsoft.com/office/drawing/2014/main" id="{9634AF39-4962-48A9-AAA8-F984031CF41F}"/>
               </a:ext>
             </a:extLst>
           </p:cNvPr>
@@ -8508,7 +8508,7 @@
           <p:cNvPr id="2" name="">
             <a:extLst xmlns:a="http://schemas.openxmlformats.org/drawingml/2006/main">
               <a:ext uri="{FF2B5EF4-FFF2-40B4-BE49-F238E27FC236}">
-                <a16:creationId xmlns:a16="http://schemas.microsoft.com/office/drawing/2014/main" id="{B0C3BF85-CE0E-45D0-84F1-0C816D40110F}"/>
+                <a16:creationId xmlns:a16="http://schemas.microsoft.com/office/drawing/2014/main" id="{6D0EB3BF-EE38-4117-A465-0F04F94A6481}"/>
               </a:ext>
             </a:extLst>
           </p:cNvPr>
@@ -8565,7 +8565,7 @@
           <p:cNvPr id="3" name="">
             <a:extLst xmlns:a="http://schemas.openxmlformats.org/drawingml/2006/main">
               <a:ext uri="{FF2B5EF4-FFF2-40B4-BE49-F238E27FC236}">
-                <a16:creationId xmlns:a16="http://schemas.microsoft.com/office/drawing/2014/main" id="{F2344370-6549-46BD-96B9-F9FD2F8C2C48}"/>
+                <a16:creationId xmlns:a16="http://schemas.microsoft.com/office/drawing/2014/main" id="{AC1D57C6-FB24-4381-9785-A7F524484867}"/>
               </a:ext>
             </a:extLst>
           </p:cNvPr>
@@ -8622,7 +8622,7 @@
           <p:cNvPr id="4" name="">
             <a:extLst xmlns:a="http://schemas.openxmlformats.org/drawingml/2006/main">
               <a:ext uri="{FF2B5EF4-FFF2-40B4-BE49-F238E27FC236}">
-                <a16:creationId xmlns:a16="http://schemas.microsoft.com/office/drawing/2014/main" id="{7C403F70-39FA-432E-B1B1-1F428F601E19}"/>
+                <a16:creationId xmlns:a16="http://schemas.microsoft.com/office/drawing/2014/main" id="{04FAA352-22FA-4F8B-BF81-A5709967B0C1}"/>
               </a:ext>
             </a:extLst>
           </p:cNvPr>
@@ -8679,7 +8679,7 @@
           <p:cNvPr id="5" name="">
             <a:extLst xmlns:a="http://schemas.openxmlformats.org/drawingml/2006/main">
               <a:ext uri="{FF2B5EF4-FFF2-40B4-BE49-F238E27FC236}">
-                <a16:creationId xmlns:a16="http://schemas.microsoft.com/office/drawing/2014/main" id="{BCE2A7A4-B98C-4A5B-A510-7ACC5097FF97}"/>
+                <a16:creationId xmlns:a16="http://schemas.microsoft.com/office/drawing/2014/main" id="{BABB2E1F-2C57-4B72-9BC3-4448B01A0B06}"/>
               </a:ext>
             </a:extLst>
           </p:cNvPr>
@@ -8736,7 +8736,7 @@
           <p:cNvPr id="6" name="">
             <a:extLst xmlns:a="http://schemas.openxmlformats.org/drawingml/2006/main">
               <a:ext uri="{FF2B5EF4-FFF2-40B4-BE49-F238E27FC236}">
-                <a16:creationId xmlns:a16="http://schemas.microsoft.com/office/drawing/2014/main" id="{E5E3D04D-92ED-4181-9C9D-115A7A733C44}"/>
+                <a16:creationId xmlns:a16="http://schemas.microsoft.com/office/drawing/2014/main" id="{14E8311F-76F2-4307-B3BA-F5751F4EF137}"/>
               </a:ext>
             </a:extLst>
           </p:cNvPr>
@@ -8791,7 +8791,7 @@
     </p:spTree>
     <p:extLst>
       <p:ext uri="{BB962C8B-B14F-4D97-AF65-F5344CB8AC3E}">
-        <p14:creationId xmlns:p14="http://schemas.microsoft.com/office/powerpoint/2010/main" val="1428105169"/>
+        <p14:creationId xmlns:p14="http://schemas.microsoft.com/office/powerpoint/2010/main" val="1936485712"/>
       </p:ext>
     </p:extLst>
   </p:cSld>
@@ -8822,7 +8822,7 @@
           <p:cNvPr id="5" name="">
             <a:extLst xmlns:a="http://schemas.openxmlformats.org/drawingml/2006/main">
               <a:ext uri="{FF2B5EF4-FFF2-40B4-BE49-F238E27FC236}">
-                <a16:creationId xmlns:a16="http://schemas.microsoft.com/office/drawing/2014/main" id="{4E5BB7BF-A574-48E4-9146-A20BDEB6C81B}"/>
+                <a16:creationId xmlns:a16="http://schemas.microsoft.com/office/drawing/2014/main" id="{9EB4474F-2125-42DC-A85D-FCAB1B38A508}"/>
               </a:ext>
             </a:extLst>
           </p:cNvPr>
@@ -8879,7 +8879,7 @@
           <p:cNvPr id="2" name="">
             <a:extLst xmlns:a="http://schemas.openxmlformats.org/drawingml/2006/main">
               <a:ext uri="{FF2B5EF4-FFF2-40B4-BE49-F238E27FC236}">
-                <a16:creationId xmlns:a16="http://schemas.microsoft.com/office/drawing/2014/main" id="{7FAC98E9-961B-4BDD-9D0B-ECC008456A8E}"/>
+                <a16:creationId xmlns:a16="http://schemas.microsoft.com/office/drawing/2014/main" id="{466DCE50-EE62-4FEA-A1C0-DE529EC26E51}"/>
               </a:ext>
             </a:extLst>
           </p:cNvPr>
@@ -9063,7 +9063,7 @@
                           <a:ea typeface="Helvetica Neue"/>
                           <a:cs typeface="Helvetica Neue"/>
                         </a:rPr>
-                        <a:t>Random forest</a:t>
+                        <a:t>Random forest / always signal</a:t>
                       </a:r>
                     </a:p>
                   </a:txBody>
@@ -9087,7 +9087,7 @@
                           <a:ea typeface="Helvetica Neue"/>
                           <a:cs typeface="Helvetica Neue"/>
                         </a:rPr>
-                        <a:t>75.0%</a:t>
+                        <a:t>75.0% / 78.1%</a:t>
                       </a:r>
                     </a:p>
                   </a:txBody>
@@ -9113,7 +9113,7 @@
                           <a:ea typeface="Helvetica Neue"/>
                           <a:cs typeface="Helvetica Neue"/>
                         </a:rPr>
-                        <a:t>Holdout accuracy</a:t>
+                        <a:t>Holdout F1</a:t>
                       </a:r>
                     </a:p>
                   </a:txBody>
@@ -9137,7 +9137,7 @@
                           <a:ea typeface="Helvetica Neue"/>
                           <a:cs typeface="Helvetica Neue"/>
                         </a:rPr>
-                        <a:t>Always signal</a:t>
+                        <a:t>Random forest / always signal</a:t>
                       </a:r>
                     </a:p>
                   </a:txBody>
@@ -9161,7 +9161,7 @@
                           <a:ea typeface="Helvetica Neue"/>
                           <a:cs typeface="Helvetica Neue"/>
                         </a:rPr>
-                        <a:t>78.1%</a:t>
+                        <a:t>0.814 / 0.877</a:t>
                       </a:r>
                     </a:p>
                   </a:txBody>
@@ -9285,7 +9285,7 @@
                           <a:ea typeface="Helvetica Neue"/>
                           <a:cs typeface="Helvetica Neue"/>
                         </a:rPr>
-                        <a:t>Random forest</a:t>
+                        <a:t>Random forest / logistic</a:t>
                       </a:r>
                     </a:p>
                   </a:txBody>
@@ -9309,7 +9309,7 @@
                           <a:ea typeface="Helvetica Neue"/>
                           <a:cs typeface="Helvetica Neue"/>
                         </a:rPr>
-                        <a:t>0.592</a:t>
+                        <a:t>0.592 / 0.628</a:t>
                       </a:r>
                     </a:p>
                   </a:txBody>
@@ -9359,7 +9359,7 @@
                           <a:ea typeface="Helvetica Neue"/>
                           <a:cs typeface="Helvetica Neue"/>
                         </a:rPr>
-                        <a:t>Logistic regression</a:t>
+                        <a:t>Always signal</a:t>
                       </a:r>
                     </a:p>
                   </a:txBody>
@@ -9383,7 +9383,7 @@
                           <a:ea typeface="Helvetica Neue"/>
                           <a:cs typeface="Helvetica Neue"/>
                         </a:rPr>
-                        <a:t>0.628</a:t>
+                        <a:t>0.721</a:t>
                       </a:r>
                     </a:p>
                   </a:txBody>
@@ -9403,7 +9403,7 @@
           <p:cNvPr id="4" name="">
             <a:extLst xmlns:a="http://schemas.openxmlformats.org/drawingml/2006/main">
               <a:ext uri="{FF2B5EF4-FFF2-40B4-BE49-F238E27FC236}">
-                <a16:creationId xmlns:a16="http://schemas.microsoft.com/office/drawing/2014/main" id="{F6CAC3DF-7A7F-4CC5-8468-AC23EB73678C}"/>
+                <a16:creationId xmlns:a16="http://schemas.microsoft.com/office/drawing/2014/main" id="{C0E9235C-CBE5-4361-89E8-AB4A6D28D196}"/>
               </a:ext>
             </a:extLst>
           </p:cNvPr>
@@ -9450,7 +9450,7 @@
                 <a:ea typeface="Helvetica Neue"/>
                 <a:cs typeface="Helvetica Neue"/>
               </a:rPr>
-              <a:t>Logistic regression has higher mean fold F1. Keep direct rules for their known target.</a:t>
+              <a:t>Neither classifier beats always-signal on F1. Keep the direct rules for this label.</a:t>
             </a:r>
           </a:p>
         </p:txBody>
@@ -9458,7 +9458,7 @@
     </p:spTree>
     <p:extLst>
       <p:ext uri="{BB962C8B-B14F-4D97-AF65-F5344CB8AC3E}">
-        <p14:creationId xmlns:p14="http://schemas.microsoft.com/office/powerpoint/2010/main" val="1071224846"/>
+        <p14:creationId xmlns:p14="http://schemas.microsoft.com/office/powerpoint/2010/main" val="1338249118"/>
       </p:ext>
     </p:extLst>
   </p:cSld>
@@ -9489,7 +9489,7 @@
           <p:cNvPr id="5" name="">
             <a:extLst xmlns:a="http://schemas.openxmlformats.org/drawingml/2006/main">
               <a:ext uri="{FF2B5EF4-FFF2-40B4-BE49-F238E27FC236}">
-                <a16:creationId xmlns:a16="http://schemas.microsoft.com/office/drawing/2014/main" id="{ED0954B4-A572-4991-B14E-69DA35481F07}"/>
+                <a16:creationId xmlns:a16="http://schemas.microsoft.com/office/drawing/2014/main" id="{D195E3FE-CF74-401E-906F-F97A35852346}"/>
               </a:ext>
             </a:extLst>
           </p:cNvPr>
@@ -9546,7 +9546,7 @@
           <p:cNvPr id="2" name="">
             <a:extLst xmlns:a="http://schemas.openxmlformats.org/drawingml/2006/main">
               <a:ext uri="{FF2B5EF4-FFF2-40B4-BE49-F238E27FC236}">
-                <a16:creationId xmlns:a16="http://schemas.microsoft.com/office/drawing/2014/main" id="{2349DB31-EBF3-4BCB-AAB4-8892858B1871}"/>
+                <a16:creationId xmlns:a16="http://schemas.microsoft.com/office/drawing/2014/main" id="{5A82D939-341C-4349-8746-32FB0031A91B}"/>
               </a:ext>
             </a:extLst>
           </p:cNvPr>
@@ -10144,7 +10144,7 @@
           <p:cNvPr id="4" name="">
             <a:extLst xmlns:a="http://schemas.openxmlformats.org/drawingml/2006/main">
               <a:ext uri="{FF2B5EF4-FFF2-40B4-BE49-F238E27FC236}">
-                <a16:creationId xmlns:a16="http://schemas.microsoft.com/office/drawing/2014/main" id="{41844819-EED8-4519-BB06-9009F295DA65}"/>
+                <a16:creationId xmlns:a16="http://schemas.microsoft.com/office/drawing/2014/main" id="{73C7C4FC-97DE-4638-B387-B195157E628C}"/>
               </a:ext>
             </a:extLst>
           </p:cNvPr>
@@ -10199,7 +10199,7 @@
     </p:spTree>
     <p:extLst>
       <p:ext uri="{BB962C8B-B14F-4D97-AF65-F5344CB8AC3E}">
-        <p14:creationId xmlns:p14="http://schemas.microsoft.com/office/powerpoint/2010/main" val="1826692363"/>
+        <p14:creationId xmlns:p14="http://schemas.microsoft.com/office/powerpoint/2010/main" val="1622200247"/>
       </p:ext>
     </p:extLst>
   </p:cSld>
@@ -10230,7 +10230,7 @@
           <p:cNvPr id="7" name="">
             <a:extLst xmlns:a="http://schemas.openxmlformats.org/drawingml/2006/main">
               <a:ext uri="{FF2B5EF4-FFF2-40B4-BE49-F238E27FC236}">
-                <a16:creationId xmlns:a16="http://schemas.microsoft.com/office/drawing/2014/main" id="{57943724-043B-424A-811D-0095053BDC69}"/>
+                <a16:creationId xmlns:a16="http://schemas.microsoft.com/office/drawing/2014/main" id="{4D377C50-84C5-4A25-9B9C-C25C70414055}"/>
               </a:ext>
             </a:extLst>
           </p:cNvPr>
@@ -10287,7 +10287,7 @@
           <p:cNvPr id="2" name="">
             <a:extLst xmlns:a="http://schemas.openxmlformats.org/drawingml/2006/main">
               <a:ext uri="{FF2B5EF4-FFF2-40B4-BE49-F238E27FC236}">
-                <a16:creationId xmlns:a16="http://schemas.microsoft.com/office/drawing/2014/main" id="{87DC8D0C-020D-429F-8031-CE04B7E29E29}"/>
+                <a16:creationId xmlns:a16="http://schemas.microsoft.com/office/drawing/2014/main" id="{F7B3D04F-D36E-4135-A5C0-A63B39E5D7D1}"/>
               </a:ext>
             </a:extLst>
           </p:cNvPr>
@@ -10344,7 +10344,7 @@
           <p:cNvPr id="3" name="">
             <a:extLst xmlns:a="http://schemas.openxmlformats.org/drawingml/2006/main">
               <a:ext uri="{FF2B5EF4-FFF2-40B4-BE49-F238E27FC236}">
-                <a16:creationId xmlns:a16="http://schemas.microsoft.com/office/drawing/2014/main" id="{13BDD163-22E3-4877-B7E2-163B815689A3}"/>
+                <a16:creationId xmlns:a16="http://schemas.microsoft.com/office/drawing/2014/main" id="{5BE6C3AE-8342-4361-A373-17ABB2E68F50}"/>
               </a:ext>
             </a:extLst>
           </p:cNvPr>
@@ -10401,7 +10401,7 @@
           <p:cNvPr id="4" name="">
             <a:extLst xmlns:a="http://schemas.openxmlformats.org/drawingml/2006/main">
               <a:ext uri="{FF2B5EF4-FFF2-40B4-BE49-F238E27FC236}">
-                <a16:creationId xmlns:a16="http://schemas.microsoft.com/office/drawing/2014/main" id="{7A0FD5F6-F3BE-4031-82F2-0289DAC7B007}"/>
+                <a16:creationId xmlns:a16="http://schemas.microsoft.com/office/drawing/2014/main" id="{3A25B7B5-E97C-46A2-8CDA-C4123C560E70}"/>
               </a:ext>
             </a:extLst>
           </p:cNvPr>
@@ -10458,7 +10458,7 @@
           <p:cNvPr id="5" name="">
             <a:extLst xmlns:a="http://schemas.openxmlformats.org/drawingml/2006/main">
               <a:ext uri="{FF2B5EF4-FFF2-40B4-BE49-F238E27FC236}">
-                <a16:creationId xmlns:a16="http://schemas.microsoft.com/office/drawing/2014/main" id="{8830B95E-1BC7-47E8-8A1B-FCE361423FE3}"/>
+                <a16:creationId xmlns:a16="http://schemas.microsoft.com/office/drawing/2014/main" id="{BFA3870B-4C7A-45FA-ABF7-619C82BE4A95}"/>
               </a:ext>
             </a:extLst>
           </p:cNvPr>
@@ -10515,7 +10515,7 @@
           <p:cNvPr id="6" name="">
             <a:extLst xmlns:a="http://schemas.openxmlformats.org/drawingml/2006/main">
               <a:ext uri="{FF2B5EF4-FFF2-40B4-BE49-F238E27FC236}">
-                <a16:creationId xmlns:a16="http://schemas.microsoft.com/office/drawing/2014/main" id="{D8ADBB1A-89D6-4DE4-A94C-8759523B8528}"/>
+                <a16:creationId xmlns:a16="http://schemas.microsoft.com/office/drawing/2014/main" id="{F03BE677-20FE-4E7A-8E0A-7D17D43048CD}"/>
               </a:ext>
             </a:extLst>
           </p:cNvPr>
@@ -10570,7 +10570,7 @@
     </p:spTree>
     <p:extLst>
       <p:ext uri="{BB962C8B-B14F-4D97-AF65-F5344CB8AC3E}">
-        <p14:creationId xmlns:p14="http://schemas.microsoft.com/office/powerpoint/2010/main" val="712706034"/>
+        <p14:creationId xmlns:p14="http://schemas.microsoft.com/office/powerpoint/2010/main" val="1411228150"/>
       </p:ext>
     </p:extLst>
   </p:cSld>

</xml_diff>